<commit_message>
Clase 8: la construccion de una componente antes de usarla (28 slides)
Revision de Daniela: el grafico de las dos direcciones aparecia antes de
definir que es una componente y sin decir como se construyo. Ahora la
seccion 1 solo plantea el problema (dos variables con r = 0,995 y la
pregunta destacada al lado del grafico); la definicion va seguida de la
figura de las cuatro direcciones candidatas con su dispersion, de la
cuenta del puntaje ponderado con tres jugadores reales y de los pasos
de construccion. El notebook agrega la misma cuenta a mano.

Co-Authored-By: Claude Fable 5.1 <noreply@anthropic.com>
</commit_message>
<xml_diff>
--- a/presentaciones/clase08_componentes_principales.pptx
+++ b/presentaciones/clase08_componentes_principales.pptx
@@ -30,6 +30,9 @@
     <p:sldId id="278" r:id="rId29"/>
     <p:sldId id="279" r:id="rId30"/>
     <p:sldId id="280" r:id="rId31"/>
+    <p:sldId id="281" r:id="rId32"/>
+    <p:sldId id="282" r:id="rId33"/>
+    <p:sldId id="283" r:id="rId34"/>
   </p:sldIdLst>
   <p:sldSz cx="9144000" cy="5138928" type="screen4x3"/>
   <p:notesSz cx="6858000" cy="9144000"/>
@@ -3447,21 +3450,45 @@
                 </a:solidFill>
                 <a:latin typeface="Fira Sans"/>
               </a:rPr>
-              <a:t>¿Para qué sirve?</a:t>
-            </a:r>
-          </a:p>
-        </p:txBody>
-      </p:sp>
-      <p:sp>
-        <p:nvSpPr>
-          <p:cNvPr id="4" name="TextBox 3"/>
+              <a:t>La dirección en que los datos más varían</a:t>
+            </a:r>
+          </a:p>
+        </p:txBody>
+      </p:sp>
+      <p:pic>
+        <p:nvPicPr>
+          <p:cNvPr id="4" name="Picture 3" descr="c8_01_dos_variables.png"/>
+          <p:cNvPicPr>
+            <a:picLocks noChangeAspect="1"/>
+          </p:cNvPicPr>
+          <p:nvPr/>
+        </p:nvPicPr>
+        <p:blipFill>
+          <a:blip r:embed="rId2"/>
+          <a:stretch>
+            <a:fillRect/>
+          </a:stretch>
+        </p:blipFill>
+        <p:spPr>
+          <a:xfrm>
+            <a:off x="2282292" y="1143000"/>
+            <a:ext cx="4579414" cy="2331720"/>
+          </a:xfrm>
+          <a:prstGeom prst="rect">
+            <a:avLst/>
+          </a:prstGeom>
+        </p:spPr>
+      </p:pic>
+      <p:sp>
+        <p:nvSpPr>
+          <p:cNvPr id="5" name="TextBox 4"/>
           <p:cNvSpPr txBox="1"/>
           <p:nvPr/>
         </p:nvSpPr>
         <p:spPr>
           <a:xfrm>
-            <a:off x="704088" y="1353312"/>
-            <a:ext cx="7744968" cy="3300984"/>
+            <a:off x="704088" y="3611879"/>
+            <a:ext cx="7744968" cy="1280160"/>
           </a:xfrm>
           <a:prstGeom prst="rect">
             <a:avLst/>
@@ -3474,115 +3501,14 @@
           </a:bodyPr>
           <a:lstStyle/>
           <a:p>
-            <a:pPr>
-              <a:lnSpc>
-                <a:spcPct val="112000"/>
-              </a:lnSpc>
-              <a:spcAft>
-                <a:spcPts val="900"/>
-              </a:spcAft>
-            </a:pPr>
-            <a:r>
-              <a:rPr sz="1800" b="1">
-                <a:solidFill>
-                  <a:srgbClr val="E0A437"/>
-                </a:solidFill>
-                <a:latin typeface="Fira Sans"/>
-              </a:rPr>
-              <a:t>▸ </a:t>
-            </a:r>
-            <a:r>
-              <a:rPr sz="1800" b="1">
-                <a:solidFill>
-                  <a:srgbClr val="1D3557"/>
-                </a:solidFill>
-                <a:latin typeface="Fira Sans"/>
-              </a:rPr>
-              <a:t>Para mirar los datos: con 16 variables hay 120 gráficos de dispersión posibles; con dos componentes, uno solo.</a:t>
-            </a:r>
-          </a:p>
-          <a:p>
-            <a:pPr>
-              <a:lnSpc>
-                <a:spcPct val="112000"/>
-              </a:lnSpc>
-              <a:spcAft>
-                <a:spcPts val="900"/>
-              </a:spcAft>
-            </a:pPr>
-            <a:r>
-              <a:rPr sz="1800" b="1">
-                <a:solidFill>
-                  <a:srgbClr val="E0A437"/>
-                </a:solidFill>
-                <a:latin typeface="Fira Sans"/>
-              </a:rPr>
-              <a:t>▸ </a:t>
-            </a:r>
-            <a:r>
-              <a:rPr sz="1800" b="0">
-                <a:solidFill>
-                  <a:srgbClr val="000000"/>
-                </a:solidFill>
-                <a:latin typeface="Fira Sans"/>
-              </a:rPr>
-              <a:t>Para entregarle a un modelo menos entradas: las componentes reemplazan a un grupo de variables que se repiten (regresión sobre componentes principales).</a:t>
-            </a:r>
-          </a:p>
-          <a:p>
-            <a:pPr>
-              <a:lnSpc>
-                <a:spcPct val="112000"/>
-              </a:lnSpc>
-              <a:spcAft>
-                <a:spcPts val="900"/>
-              </a:spcAft>
-            </a:pPr>
-            <a:r>
-              <a:rPr sz="1800" b="1">
-                <a:solidFill>
-                  <a:srgbClr val="E0A437"/>
-                </a:solidFill>
-                <a:latin typeface="Fira Sans"/>
-              </a:rPr>
-              <a:t>▸ </a:t>
-            </a:r>
-            <a:r>
-              <a:rPr sz="1800" b="0">
-                <a:solidFill>
-                  <a:srgbClr val="000000"/>
-                </a:solidFill>
-                <a:latin typeface="Fira Sans"/>
-              </a:rPr>
-              <a:t>Para entender de qué está hecha la variación: qué variables se mueven juntas y cuánto pesa cada grupo.</a:t>
-            </a:r>
-          </a:p>
-          <a:p>
-            <a:pPr>
-              <a:lnSpc>
-                <a:spcPct val="112000"/>
-              </a:lnSpc>
-              <a:spcAft>
-                <a:spcPts val="900"/>
-              </a:spcAft>
-            </a:pPr>
-            <a:r>
-              <a:rPr sz="1800" b="1">
-                <a:solidFill>
-                  <a:srgbClr val="E0A437"/>
-                </a:solidFill>
-                <a:latin typeface="Fira Sans"/>
-              </a:rPr>
-              <a:t>▸ </a:t>
-            </a:r>
-            <a:r>
-              <a:rPr sz="1800" b="0">
-                <a:solidFill>
-                  <a:srgbClr val="000000"/>
-                </a:solidFill>
-                <a:latin typeface="Fira Sans"/>
-              </a:rPr>
-              <a:t>Lo que no hace: no elige variables ni las descarta, y no sabe qué se quiere predecir.</a:t>
+            <a:r>
+              <a:rPr sz="1300" b="0">
+                <a:solidFill>
+                  <a:srgbClr val="333333"/>
+                </a:solidFill>
+                <a:latin typeface="Fira Sans"/>
+              </a:rPr>
+              <a:t>Los mismos jugadores, con las dos variables estandarizadas, y cuatro direcciones que pasan por el centro. Para cada una se mide cuánto se dispersan las posiciones de los puntos a lo largo de ella: 1,00 en la horizontal y en la vertical, 1,41 en la diagonal y 0,07 en su perpendicular. La diagonal gana: es la primera componente y recoge el 99,8% de la variación; su perpendicular es la segunda, con el 0,2%.</a:t>
             </a:r>
           </a:p>
         </p:txBody>
@@ -3678,14 +3604,14 @@
                 </a:solidFill>
                 <a:latin typeface="Fira Sans"/>
               </a:rPr>
-              <a:t>Antes de calcular: estandarizar cada variable</a:t>
+              <a:t>En la práctica: un puntaje ponderado por jugador</a:t>
             </a:r>
           </a:p>
         </p:txBody>
       </p:sp>
       <p:pic>
         <p:nvPicPr>
-          <p:cNvPr id="4" name="Picture 3" descr="c8_02_estandarizar.png"/>
+          <p:cNvPr id="4" name="Picture 3" descr="c8_01b_puntaje_ponderado.png"/>
           <p:cNvPicPr>
             <a:picLocks noChangeAspect="1"/>
           </p:cNvPicPr>
@@ -3699,8 +3625,8 @@
         </p:blipFill>
         <p:spPr>
           <a:xfrm>
-            <a:off x="2421351" y="1143000"/>
-            <a:ext cx="4301297" cy="2331720"/>
+            <a:off x="728851" y="1143000"/>
+            <a:ext cx="7686296" cy="2587752"/>
           </a:xfrm>
           <a:prstGeom prst="rect">
             <a:avLst/>
@@ -3715,8 +3641,8 @@
         </p:nvSpPr>
         <p:spPr>
           <a:xfrm>
-            <a:off x="704088" y="3611879"/>
-            <a:ext cx="7744968" cy="1280160"/>
+            <a:off x="704088" y="3867912"/>
+            <a:ext cx="7744968" cy="1024128"/>
           </a:xfrm>
           <a:prstGeom prst="rect">
             <a:avLst/>
@@ -3736,7 +3662,7 @@
                 </a:solidFill>
                 <a:latin typeface="Fira Sans"/>
               </a:rPr>
-              <a:t>Con las variables en sus unidades, la primera componente es casi solo turnos_carrera, porque su desviación estándar (2.287) es 476 veces la de temporadas (4,8): PCA sigue a la variable que más varía en sus unidades. Con cada variable estandarizada (media 0 y desviación 1, como en las clases 2 y 7) todas parten iguales. El libro recomienda estandarizar, salvo que las variables compartan unidad (James et al., 2013, p. 381).</a:t>
+              <a:t>Como el puntaje ponderado de la admisión universitaria: cada variable entra con un peso y sale un número por jugador, que es su valor en la componente. La diferencia es que aquí los pesos no los fija nadie: se calculan para que ese número separe a los jugadores lo más posible, con la condición de que los pesos al cuadrado sumen 1.</a:t>
             </a:r>
           </a:p>
         </p:txBody>
@@ -3774,7 +3700,7 @@
             <a:avLst/>
           </a:prstGeom>
           <a:solidFill>
-            <a:srgbClr val="1D3557"/>
+            <a:srgbClr val="FAFBFC"/>
           </a:solidFill>
           <a:ln>
             <a:noFill/>
@@ -3811,8 +3737,8 @@
         </p:nvSpPr>
         <p:spPr>
           <a:xfrm>
-            <a:off x="603504" y="1847088"/>
-            <a:ext cx="7946136" cy="1399032"/>
+            <a:off x="402336" y="301752"/>
+            <a:ext cx="8348472" cy="795528"/>
           </a:xfrm>
           <a:prstGeom prst="rect">
             <a:avLst/>
@@ -3826,24 +3752,148 @@
           <a:lstStyle/>
           <a:p>
             <a:r>
-              <a:rPr sz="3400" b="1">
-                <a:solidFill>
-                  <a:srgbClr val="FFFFFF"/>
-                </a:solidFill>
-                <a:latin typeface="Fira Sans"/>
-              </a:rPr>
-              <a:t>3. Cómo se leen</a:t>
-            </a:r>
-          </a:p>
-          <a:p>
+              <a:rPr sz="2800" b="1">
+                <a:solidFill>
+                  <a:srgbClr val="0F0F0F"/>
+                </a:solidFill>
+                <a:latin typeface="Fira Sans"/>
+              </a:rPr>
+              <a:t>¿Para qué sirve?</a:t>
+            </a:r>
+          </a:p>
+        </p:txBody>
+      </p:sp>
+      <p:sp>
+        <p:nvSpPr>
+          <p:cNvPr id="4" name="TextBox 3"/>
+          <p:cNvSpPr txBox="1"/>
+          <p:nvPr/>
+        </p:nvSpPr>
+        <p:spPr>
+          <a:xfrm>
+            <a:off x="704088" y="1353312"/>
+            <a:ext cx="7744968" cy="3300984"/>
+          </a:xfrm>
+          <a:prstGeom prst="rect">
+            <a:avLst/>
+          </a:prstGeom>
+          <a:noFill/>
+        </p:spPr>
+        <p:txBody>
+          <a:bodyPr wrap="square">
+            <a:spAutoFit/>
+          </a:bodyPr>
+          <a:lstStyle/>
+          <a:p>
+            <a:pPr>
+              <a:lnSpc>
+                <a:spcPct val="112000"/>
+              </a:lnSpc>
+              <a:spcAft>
+                <a:spcPts val="900"/>
+              </a:spcAft>
+            </a:pPr>
+            <a:r>
+              <a:rPr sz="1800" b="1">
+                <a:solidFill>
+                  <a:srgbClr val="E0A437"/>
+                </a:solidFill>
+                <a:latin typeface="Fira Sans"/>
+              </a:rPr>
+              <a:t>▸ </a:t>
+            </a:r>
+            <a:r>
+              <a:rPr sz="1800" b="1">
+                <a:solidFill>
+                  <a:srgbClr val="1D3557"/>
+                </a:solidFill>
+                <a:latin typeface="Fira Sans"/>
+              </a:rPr>
+              <a:t>Para mirar los datos: con 16 variables hay 120 gráficos de dispersión posibles; con dos componentes, uno solo.</a:t>
+            </a:r>
+          </a:p>
+          <a:p>
+            <a:pPr>
+              <a:lnSpc>
+                <a:spcPct val="112000"/>
+              </a:lnSpc>
+              <a:spcAft>
+                <a:spcPts val="900"/>
+              </a:spcAft>
+            </a:pPr>
+            <a:r>
+              <a:rPr sz="1800" b="1">
+                <a:solidFill>
+                  <a:srgbClr val="E0A437"/>
+                </a:solidFill>
+                <a:latin typeface="Fira Sans"/>
+              </a:rPr>
+              <a:t>▸ </a:t>
+            </a:r>
             <a:r>
               <a:rPr sz="1800" b="0">
                 <a:solidFill>
+                  <a:srgbClr val="000000"/>
+                </a:solidFill>
+                <a:latin typeface="Fira Sans"/>
+              </a:rPr>
+              <a:t>Para entregarle a un modelo menos entradas: las componentes reemplazan a un grupo de variables que se repiten (regresión sobre componentes principales).</a:t>
+            </a:r>
+          </a:p>
+          <a:p>
+            <a:pPr>
+              <a:lnSpc>
+                <a:spcPct val="112000"/>
+              </a:lnSpc>
+              <a:spcAft>
+                <a:spcPts val="900"/>
+              </a:spcAft>
+            </a:pPr>
+            <a:r>
+              <a:rPr sz="1800" b="1">
+                <a:solidFill>
                   <a:srgbClr val="E0A437"/>
                 </a:solidFill>
                 <a:latin typeface="Fira Sans"/>
               </a:rPr>
-              <a:t>Cuánta variación explica cada componente y de qué está hecha</a:t>
+              <a:t>▸ </a:t>
+            </a:r>
+            <a:r>
+              <a:rPr sz="1800" b="0">
+                <a:solidFill>
+                  <a:srgbClr val="000000"/>
+                </a:solidFill>
+                <a:latin typeface="Fira Sans"/>
+              </a:rPr>
+              <a:t>Para entender de qué está hecha la variación: qué variables se mueven juntas y cuánto pesa cada grupo.</a:t>
+            </a:r>
+          </a:p>
+          <a:p>
+            <a:pPr>
+              <a:lnSpc>
+                <a:spcPct val="112000"/>
+              </a:lnSpc>
+              <a:spcAft>
+                <a:spcPts val="900"/>
+              </a:spcAft>
+            </a:pPr>
+            <a:r>
+              <a:rPr sz="1800" b="1">
+                <a:solidFill>
+                  <a:srgbClr val="E0A437"/>
+                </a:solidFill>
+                <a:latin typeface="Fira Sans"/>
+              </a:rPr>
+              <a:t>▸ </a:t>
+            </a:r>
+            <a:r>
+              <a:rPr sz="1800" b="0">
+                <a:solidFill>
+                  <a:srgbClr val="000000"/>
+                </a:solidFill>
+                <a:latin typeface="Fira Sans"/>
+              </a:rPr>
+              <a:t>Lo que no hace: no elige variables ni las descarta, y no sabe qué se quiere predecir.</a:t>
             </a:r>
           </a:p>
         </p:txBody>
@@ -3939,45 +3989,21 @@
                 </a:solidFill>
                 <a:latin typeface="Fira Sans"/>
               </a:rPr>
-              <a:t>Cuánta variación explica cada componente</a:t>
-            </a:r>
-          </a:p>
-        </p:txBody>
-      </p:sp>
-      <p:pic>
-        <p:nvPicPr>
-          <p:cNvPr id="4" name="Picture 3" descr="c8_03_scree.png"/>
-          <p:cNvPicPr>
-            <a:picLocks noChangeAspect="1"/>
-          </p:cNvPicPr>
-          <p:nvPr/>
-        </p:nvPicPr>
-        <p:blipFill>
-          <a:blip r:embed="rId2"/>
-          <a:stretch>
-            <a:fillRect/>
-          </a:stretch>
-        </p:blipFill>
-        <p:spPr>
-          <a:xfrm>
-            <a:off x="2337301" y="1143000"/>
-            <a:ext cx="4469397" cy="2587752"/>
-          </a:xfrm>
-          <a:prstGeom prst="rect">
-            <a:avLst/>
-          </a:prstGeom>
-        </p:spPr>
-      </p:pic>
-      <p:sp>
-        <p:nvSpPr>
-          <p:cNvPr id="5" name="TextBox 4"/>
+              <a:t>Cómo se construye, paso a paso</a:t>
+            </a:r>
+          </a:p>
+        </p:txBody>
+      </p:sp>
+      <p:sp>
+        <p:nvSpPr>
+          <p:cNvPr id="4" name="TextBox 3"/>
           <p:cNvSpPr txBox="1"/>
           <p:nvPr/>
         </p:nvSpPr>
         <p:spPr>
           <a:xfrm>
-            <a:off x="704088" y="3867912"/>
-            <a:ext cx="7744968" cy="1024128"/>
+            <a:off x="704088" y="1353312"/>
+            <a:ext cx="7744968" cy="3300984"/>
           </a:xfrm>
           <a:prstGeom prst="rect">
             <a:avLst/>
@@ -3990,14 +4016,143 @@
           </a:bodyPr>
           <a:lstStyle/>
           <a:p>
-            <a:r>
-              <a:rPr sz="1300" b="0">
-                <a:solidFill>
-                  <a:srgbClr val="333333"/>
-                </a:solidFill>
-                <a:latin typeface="Fira Sans"/>
-              </a:rPr>
-              <a:t>La primera componente explica el 45,3% de la variación de las 16 variables; la segunda, el 25,7%; la tercera, el 10,8%. Dos componentes reúnen el 71% y tres, el 82%. Para decidir cuántas conservar, el libro sugiere mirar dónde la curva deja de caer (el codo) y advierte que no hay una regla objetiva: depende del uso (James et al., 2013, p. 384).</a:t>
+            <a:pPr>
+              <a:lnSpc>
+                <a:spcPct val="112000"/>
+              </a:lnSpc>
+              <a:spcAft>
+                <a:spcPts val="900"/>
+              </a:spcAft>
+            </a:pPr>
+            <a:r>
+              <a:rPr sz="1800" b="1">
+                <a:solidFill>
+                  <a:srgbClr val="E0A437"/>
+                </a:solidFill>
+                <a:latin typeface="Fira Sans"/>
+              </a:rPr>
+              <a:t>▸ </a:t>
+            </a:r>
+            <a:r>
+              <a:rPr sz="1800" b="1">
+                <a:solidFill>
+                  <a:srgbClr val="1D3557"/>
+                </a:solidFill>
+                <a:latin typeface="Fira Sans"/>
+              </a:rPr>
+              <a:t>Se estandariza cada variable: se le resta su media y se divide por su desviación estándar (el puntaje z de la clase 2).</a:t>
+            </a:r>
+          </a:p>
+          <a:p>
+            <a:pPr>
+              <a:lnSpc>
+                <a:spcPct val="112000"/>
+              </a:lnSpc>
+              <a:spcAft>
+                <a:spcPts val="900"/>
+              </a:spcAft>
+            </a:pPr>
+            <a:r>
+              <a:rPr sz="1800" b="1">
+                <a:solidFill>
+                  <a:srgbClr val="E0A437"/>
+                </a:solidFill>
+                <a:latin typeface="Fira Sans"/>
+              </a:rPr>
+              <a:t>▸ </a:t>
+            </a:r>
+            <a:r>
+              <a:rPr sz="1800" b="0">
+                <a:solidFill>
+                  <a:srgbClr val="000000"/>
+                </a:solidFill>
+                <a:latin typeface="Fira Sans"/>
+              </a:rPr>
+              <a:t>Cada jugador es un punto y el centro de la nube queda en el origen.</a:t>
+            </a:r>
+          </a:p>
+          <a:p>
+            <a:pPr>
+              <a:lnSpc>
+                <a:spcPct val="112000"/>
+              </a:lnSpc>
+              <a:spcAft>
+                <a:spcPts val="900"/>
+              </a:spcAft>
+            </a:pPr>
+            <a:r>
+              <a:rPr sz="1800" b="1">
+                <a:solidFill>
+                  <a:srgbClr val="E0A437"/>
+                </a:solidFill>
+                <a:latin typeface="Fira Sans"/>
+              </a:rPr>
+              <a:t>▸ </a:t>
+            </a:r>
+            <a:r>
+              <a:rPr sz="1800" b="0">
+                <a:solidFill>
+                  <a:srgbClr val="000000"/>
+                </a:solidFill>
+                <a:latin typeface="Fira Sans"/>
+              </a:rPr>
+              <a:t>Se busca la recta por el centro a lo largo de la cual los puntos están más dispersos (la diagonal roja de la figura): es la primera componente. El valor de cada jugador es su posición sobre esa recta.</a:t>
+            </a:r>
+          </a:p>
+          <a:p>
+            <a:pPr>
+              <a:lnSpc>
+                <a:spcPct val="112000"/>
+              </a:lnSpc>
+              <a:spcAft>
+                <a:spcPts val="900"/>
+              </a:spcAft>
+            </a:pPr>
+            <a:r>
+              <a:rPr sz="1800" b="1">
+                <a:solidFill>
+                  <a:srgbClr val="E0A437"/>
+                </a:solidFill>
+                <a:latin typeface="Fira Sans"/>
+              </a:rPr>
+              <a:t>▸ </a:t>
+            </a:r>
+            <a:r>
+              <a:rPr sz="1800" b="0">
+                <a:solidFill>
+                  <a:srgbClr val="000000"/>
+                </a:solidFill>
+                <a:latin typeface="Fira Sans"/>
+              </a:rPr>
+              <a:t>La perpendicular es la segunda componente; con más variables se sigue hasta tener tantas como variables.</a:t>
+            </a:r>
+          </a:p>
+          <a:p>
+            <a:pPr>
+              <a:lnSpc>
+                <a:spcPct val="112000"/>
+              </a:lnSpc>
+              <a:spcAft>
+                <a:spcPts val="900"/>
+              </a:spcAft>
+            </a:pPr>
+            <a:r>
+              <a:rPr sz="1800" b="1">
+                <a:solidFill>
+                  <a:srgbClr val="E0A437"/>
+                </a:solidFill>
+                <a:latin typeface="Fira Sans"/>
+              </a:rPr>
+              <a:t>▸ </a:t>
+            </a:r>
+            <a:r>
+              <a:rPr sz="1800" b="0">
+                <a:solidFill>
+                  <a:srgbClr val="000000"/>
+                </a:solidFill>
+                <a:latin typeface="Fira Sans"/>
+              </a:rPr>
+              <a:t>La variación total se reparte entre ellas: el porcentaje de cada una dice cuánto se conserva al quedarse con las primeras.</a:t>
             </a:r>
           </a:p>
         </p:txBody>
@@ -4093,14 +4248,14 @@
                 </a:solidFill>
                 <a:latin typeface="Fira Sans"/>
               </a:rPr>
-              <a:t>De qué está hecha cada componente: los pesos</a:t>
+              <a:t>Por qué se estandariza</a:t>
             </a:r>
           </a:p>
         </p:txBody>
       </p:sp>
       <p:pic>
         <p:nvPicPr>
-          <p:cNvPr id="4" name="Picture 3" descr="c8_04_pesos.png"/>
+          <p:cNvPr id="4" name="Picture 3" descr="c8_02_estandarizar.png"/>
           <p:cNvPicPr>
             <a:picLocks noChangeAspect="1"/>
           </p:cNvPicPr>
@@ -4114,8 +4269,8 @@
         </p:blipFill>
         <p:spPr>
           <a:xfrm>
-            <a:off x="2196563" y="1143000"/>
-            <a:ext cx="4750872" cy="2587752"/>
+            <a:off x="2421351" y="1143000"/>
+            <a:ext cx="4301297" cy="2331720"/>
           </a:xfrm>
           <a:prstGeom prst="rect">
             <a:avLst/>
@@ -4130,8 +4285,8 @@
         </p:nvSpPr>
         <p:spPr>
           <a:xfrm>
-            <a:off x="704088" y="3867912"/>
-            <a:ext cx="7744968" cy="1024128"/>
+            <a:off x="704088" y="3611879"/>
+            <a:ext cx="7744968" cy="1280160"/>
           </a:xfrm>
           <a:prstGeom prst="rect">
             <a:avLst/>
@@ -4151,7 +4306,7 @@
                 </a:solidFill>
                 <a:latin typeface="Fira Sans"/>
               </a:rPr>
-              <a:t>Primera componente: las siete variables de la carrera pesan casi lo mismo (0,29 a 0,34), las de la temporada la mitad (0,19 a 0,23) y la defensa no cuenta: mide cuánta carrera lleva el jugador. Segunda componente: la temporada 1986 pesa positivo (0,24 a 0,39) y la carrera negativo (−0,12 a −0,26): separa a quien rindió este año más de lo que dice su carrera.</a:t>
+              <a:t>Con las variables en sus unidades, la primera componente es casi solo turnos_carrera, porque su desviación estándar (2.287) es 476 veces la de temporadas (4,8): PCA sigue a la variable que más varía en sus unidades. Con cada variable estandarizada (media 0 y desviación 1, como en las clases 2 y 7) todas parten iguales. El libro recomienda estandarizar, salvo que las variables compartan unidad (James et al., 2013, p. 381).</a:t>
             </a:r>
           </a:p>
         </p:txBody>
@@ -4189,7 +4344,7 @@
             <a:avLst/>
           </a:prstGeom>
           <a:solidFill>
-            <a:srgbClr val="FAFBFC"/>
+            <a:srgbClr val="1D3557"/>
           </a:solidFill>
           <a:ln>
             <a:noFill/>
@@ -4226,8 +4381,8 @@
         </p:nvSpPr>
         <p:spPr>
           <a:xfrm>
-            <a:off x="402336" y="301752"/>
-            <a:ext cx="8348472" cy="795528"/>
+            <a:off x="603504" y="1847088"/>
+            <a:ext cx="7946136" cy="1399032"/>
           </a:xfrm>
           <a:prstGeom prst="rect">
             <a:avLst/>
@@ -4241,71 +4396,24 @@
           <a:lstStyle/>
           <a:p>
             <a:r>
-              <a:rPr sz="2800" b="1">
-                <a:solidFill>
-                  <a:srgbClr val="0F0F0F"/>
-                </a:solidFill>
-                <a:latin typeface="Fira Sans"/>
-              </a:rPr>
-              <a:t>Los 263 jugadores en dos componentes</a:t>
-            </a:r>
-          </a:p>
-        </p:txBody>
-      </p:sp>
-      <p:pic>
-        <p:nvPicPr>
-          <p:cNvPr id="4" name="Picture 3" descr="c8_05_jugadores.png"/>
-          <p:cNvPicPr>
-            <a:picLocks noChangeAspect="1"/>
-          </p:cNvPicPr>
-          <p:nvPr/>
-        </p:nvPicPr>
-        <p:blipFill>
-          <a:blip r:embed="rId2"/>
-          <a:stretch>
-            <a:fillRect/>
-          </a:stretch>
-        </p:blipFill>
-        <p:spPr>
-          <a:xfrm>
-            <a:off x="2699826" y="1143000"/>
-            <a:ext cx="3744346" cy="2587751"/>
-          </a:xfrm>
-          <a:prstGeom prst="rect">
-            <a:avLst/>
-          </a:prstGeom>
-        </p:spPr>
-      </p:pic>
-      <p:sp>
-        <p:nvSpPr>
-          <p:cNvPr id="5" name="TextBox 4"/>
-          <p:cNvSpPr txBox="1"/>
-          <p:nvPr/>
-        </p:nvSpPr>
-        <p:spPr>
-          <a:xfrm>
-            <a:off x="704088" y="3867912"/>
-            <a:ext cx="7744968" cy="1024128"/>
-          </a:xfrm>
-          <a:prstGeom prst="rect">
-            <a:avLst/>
-          </a:prstGeom>
-          <a:noFill/>
-        </p:spPr>
-        <p:txBody>
-          <a:bodyPr wrap="square">
-            <a:spAutoFit/>
-          </a:bodyPr>
-          <a:lstStyle/>
-          <a:p>
-            <a:r>
-              <a:rPr sz="1300" b="0">
-                <a:solidFill>
-                  <a:srgbClr val="333333"/>
-                </a:solidFill>
-                <a:latin typeface="Fira Sans"/>
-              </a:rPr>
-              <a:t>Cada punto es un jugador y el color, su salario de 1987, que PCA no usó. El salario crece hacia la derecha (correlación 0,64 con la primera componente) y casi nada hacia arriba (0,11 con la segunda): la carrera pesa en el salario; la última temporada, poco. Dos ejes muestran lo que en 16 variables había que leer coeficiente por coeficiente.</a:t>
+              <a:rPr sz="3400" b="1">
+                <a:solidFill>
+                  <a:srgbClr val="FFFFFF"/>
+                </a:solidFill>
+                <a:latin typeface="Fira Sans"/>
+              </a:rPr>
+              <a:t>3. Cómo se leen</a:t>
+            </a:r>
+          </a:p>
+          <a:p>
+            <a:r>
+              <a:rPr sz="1800" b="0">
+                <a:solidFill>
+                  <a:srgbClr val="E0A437"/>
+                </a:solidFill>
+                <a:latin typeface="Fira Sans"/>
+              </a:rPr>
+              <a:t>Cuánta variación explica cada componente y de qué está hecha</a:t>
             </a:r>
           </a:p>
         </p:txBody>
@@ -4401,14 +4509,14 @@
                 </a:solidFill>
                 <a:latin typeface="Fira Sans"/>
               </a:rPr>
-              <a:t>El mismo cálculo con las flores de la clase 2</a:t>
+              <a:t>Cuánta variación explica cada componente</a:t>
             </a:r>
           </a:p>
         </p:txBody>
       </p:sp>
       <p:pic>
         <p:nvPicPr>
-          <p:cNvPr id="4" name="Picture 3" descr="c8_06_iris.png"/>
+          <p:cNvPr id="4" name="Picture 3" descr="c8_03_scree.png"/>
           <p:cNvPicPr>
             <a:picLocks noChangeAspect="1"/>
           </p:cNvPicPr>
@@ -4422,8 +4530,8 @@
         </p:blipFill>
         <p:spPr>
           <a:xfrm>
-            <a:off x="2906606" y="1143000"/>
-            <a:ext cx="3330786" cy="2587751"/>
+            <a:off x="2337301" y="1143000"/>
+            <a:ext cx="4469397" cy="2587752"/>
           </a:xfrm>
           <a:prstGeom prst="rect">
             <a:avLst/>
@@ -4459,7 +4567,7 @@
                 </a:solidFill>
                 <a:latin typeface="Fira Sans"/>
               </a:rPr>
-              <a:t>Las cuatro medidas de iris se resumen en dos componentes que reúnen el 96% de la variación. La primera (73%) pesa casi igual el largo y el ancho del pétalo y el largo del sépalo (0,52 a 0,58): el tamaño de la flor. La segunda (23%) es casi solo el ancho del sépalo (0,92). PCA no conoce la especie y aun así las tres quedan separadas a lo largo de la primera componente.</a:t>
+              <a:t>La primera componente explica el 45,3% de la variación de las 16 variables; la segunda, el 25,7%; la tercera, el 10,8%. Dos componentes reúnen el 71% y tres, el 82%. Para decidir cuántas conservar, el libro sugiere mirar dónde la curva deja de caer (el codo) y advierte que no hay una regla objetiva: depende del uso (James et al., 2013, p. 384).</a:t>
             </a:r>
           </a:p>
         </p:txBody>
@@ -4497,7 +4605,7 @@
             <a:avLst/>
           </a:prstGeom>
           <a:solidFill>
-            <a:srgbClr val="1D3557"/>
+            <a:srgbClr val="FAFBFC"/>
           </a:solidFill>
           <a:ln>
             <a:noFill/>
@@ -4534,8 +4642,8 @@
         </p:nvSpPr>
         <p:spPr>
           <a:xfrm>
-            <a:off x="603504" y="1847088"/>
-            <a:ext cx="7946136" cy="1399032"/>
+            <a:off x="402336" y="301752"/>
+            <a:ext cx="8348472" cy="795528"/>
           </a:xfrm>
           <a:prstGeom prst="rect">
             <a:avLst/>
@@ -4549,24 +4657,71 @@
           <a:lstStyle/>
           <a:p>
             <a:r>
-              <a:rPr sz="3400" b="1">
-                <a:solidFill>
-                  <a:srgbClr val="FFFFFF"/>
-                </a:solidFill>
-                <a:latin typeface="Fira Sans"/>
-              </a:rPr>
-              <a:t>4. Cuándo</a:t>
-            </a:r>
-          </a:p>
-          <a:p>
-            <a:r>
-              <a:rPr sz="1800" b="0">
-                <a:solidFill>
-                  <a:srgbClr val="E0A437"/>
-                </a:solidFill>
-                <a:latin typeface="Fira Sans"/>
-              </a:rPr>
-              <a:t>Cuándo conviene y cuándo no</a:t>
+              <a:rPr sz="2800" b="1">
+                <a:solidFill>
+                  <a:srgbClr val="0F0F0F"/>
+                </a:solidFill>
+                <a:latin typeface="Fira Sans"/>
+              </a:rPr>
+              <a:t>De qué está hecha cada componente: los pesos</a:t>
+            </a:r>
+          </a:p>
+        </p:txBody>
+      </p:sp>
+      <p:pic>
+        <p:nvPicPr>
+          <p:cNvPr id="4" name="Picture 3" descr="c8_04_pesos.png"/>
+          <p:cNvPicPr>
+            <a:picLocks noChangeAspect="1"/>
+          </p:cNvPicPr>
+          <p:nvPr/>
+        </p:nvPicPr>
+        <p:blipFill>
+          <a:blip r:embed="rId2"/>
+          <a:stretch>
+            <a:fillRect/>
+          </a:stretch>
+        </p:blipFill>
+        <p:spPr>
+          <a:xfrm>
+            <a:off x="2196563" y="1143000"/>
+            <a:ext cx="4750872" cy="2587752"/>
+          </a:xfrm>
+          <a:prstGeom prst="rect">
+            <a:avLst/>
+          </a:prstGeom>
+        </p:spPr>
+      </p:pic>
+      <p:sp>
+        <p:nvSpPr>
+          <p:cNvPr id="5" name="TextBox 4"/>
+          <p:cNvSpPr txBox="1"/>
+          <p:nvPr/>
+        </p:nvSpPr>
+        <p:spPr>
+          <a:xfrm>
+            <a:off x="704088" y="3867912"/>
+            <a:ext cx="7744968" cy="1024128"/>
+          </a:xfrm>
+          <a:prstGeom prst="rect">
+            <a:avLst/>
+          </a:prstGeom>
+          <a:noFill/>
+        </p:spPr>
+        <p:txBody>
+          <a:bodyPr wrap="square">
+            <a:spAutoFit/>
+          </a:bodyPr>
+          <a:lstStyle/>
+          <a:p>
+            <a:r>
+              <a:rPr sz="1300" b="0">
+                <a:solidFill>
+                  <a:srgbClr val="333333"/>
+                </a:solidFill>
+                <a:latin typeface="Fira Sans"/>
+              </a:rPr>
+              <a:t>Primera componente: las siete variables de la carrera pesan casi lo mismo (0,29 a 0,34), las de la temporada la mitad (0,19 a 0,23) y la defensa no cuenta: mide cuánta carrera lleva el jugador. Segunda componente: la temporada 1986 pesa positivo (0,24 a 0,39) y la carrera negativo (−0,12 a −0,26): separa a quien rindió este año más de lo que dice su carrera.</a:t>
             </a:r>
           </a:p>
         </p:txBody>
@@ -4662,21 +4817,45 @@
                 </a:solidFill>
                 <a:latin typeface="Fira Sans"/>
               </a:rPr>
-              <a:t>¿Cuándo conviene?</a:t>
-            </a:r>
-          </a:p>
-        </p:txBody>
-      </p:sp>
-      <p:sp>
-        <p:nvSpPr>
-          <p:cNvPr id="4" name="TextBox 3"/>
+              <a:t>Los 263 jugadores en dos componentes</a:t>
+            </a:r>
+          </a:p>
+        </p:txBody>
+      </p:sp>
+      <p:pic>
+        <p:nvPicPr>
+          <p:cNvPr id="4" name="Picture 3" descr="c8_05_jugadores.png"/>
+          <p:cNvPicPr>
+            <a:picLocks noChangeAspect="1"/>
+          </p:cNvPicPr>
+          <p:nvPr/>
+        </p:nvPicPr>
+        <p:blipFill>
+          <a:blip r:embed="rId2"/>
+          <a:stretch>
+            <a:fillRect/>
+          </a:stretch>
+        </p:blipFill>
+        <p:spPr>
+          <a:xfrm>
+            <a:off x="2699826" y="1143000"/>
+            <a:ext cx="3744346" cy="2587751"/>
+          </a:xfrm>
+          <a:prstGeom prst="rect">
+            <a:avLst/>
+          </a:prstGeom>
+        </p:spPr>
+      </p:pic>
+      <p:sp>
+        <p:nvSpPr>
+          <p:cNvPr id="5" name="TextBox 4"/>
           <p:cNvSpPr txBox="1"/>
           <p:nvPr/>
         </p:nvSpPr>
         <p:spPr>
           <a:xfrm>
-            <a:off x="704088" y="1353312"/>
-            <a:ext cx="7744968" cy="3300984"/>
+            <a:off x="704088" y="3867912"/>
+            <a:ext cx="7744968" cy="1024128"/>
           </a:xfrm>
           <a:prstGeom prst="rect">
             <a:avLst/>
@@ -4689,87 +4868,14 @@
           </a:bodyPr>
           <a:lstStyle/>
           <a:p>
-            <a:pPr>
-              <a:lnSpc>
-                <a:spcPct val="112000"/>
-              </a:lnSpc>
-              <a:spcAft>
-                <a:spcPts val="900"/>
-              </a:spcAft>
-            </a:pPr>
-            <a:r>
-              <a:rPr sz="1800" b="1">
-                <a:solidFill>
-                  <a:srgbClr val="E0A437"/>
-                </a:solidFill>
-                <a:latin typeface="Fira Sans"/>
-              </a:rPr>
-              <a:t>▸ </a:t>
-            </a:r>
-            <a:r>
-              <a:rPr sz="1800" b="1">
-                <a:solidFill>
-                  <a:srgbClr val="1D3557"/>
-                </a:solidFill>
-                <a:latin typeface="Fira Sans"/>
-              </a:rPr>
-              <a:t>Con muchas variables numéricas que se correlacionan en bloques, como en la matriz de la clase 7.</a:t>
-            </a:r>
-          </a:p>
-          <a:p>
-            <a:pPr>
-              <a:lnSpc>
-                <a:spcPct val="112000"/>
-              </a:lnSpc>
-              <a:spcAft>
-                <a:spcPts val="900"/>
-              </a:spcAft>
-            </a:pPr>
-            <a:r>
-              <a:rPr sz="1800" b="1">
-                <a:solidFill>
-                  <a:srgbClr val="E0A437"/>
-                </a:solidFill>
-                <a:latin typeface="Fira Sans"/>
-              </a:rPr>
-              <a:t>▸ </a:t>
-            </a:r>
-            <a:r>
-              <a:rPr sz="1800" b="0">
-                <a:solidFill>
-                  <a:srgbClr val="000000"/>
-                </a:solidFill>
-                <a:latin typeface="Fira Sans"/>
-              </a:rPr>
-              <a:t>Para mirar los datos en un plano, o para entregarle a un modelo menos entradas.</a:t>
-            </a:r>
-          </a:p>
-          <a:p>
-            <a:pPr>
-              <a:lnSpc>
-                <a:spcPct val="112000"/>
-              </a:lnSpc>
-              <a:spcAft>
-                <a:spcPts val="900"/>
-              </a:spcAft>
-            </a:pPr>
-            <a:r>
-              <a:rPr sz="1800" b="1">
-                <a:solidFill>
-                  <a:srgbClr val="E0A437"/>
-                </a:solidFill>
-                <a:latin typeface="Fira Sans"/>
-              </a:rPr>
-              <a:t>▸ </a:t>
-            </a:r>
-            <a:r>
-              <a:rPr sz="1800" b="0">
-                <a:solidFill>
-                  <a:srgbClr val="000000"/>
-                </a:solidFill>
-                <a:latin typeface="Fira Sans"/>
-              </a:rPr>
-              <a:t>No aporta si las variables son pocas y distintas entre sí: no hay nada que resumir.</a:t>
+            <a:r>
+              <a:rPr sz="1300" b="0">
+                <a:solidFill>
+                  <a:srgbClr val="333333"/>
+                </a:solidFill>
+                <a:latin typeface="Fira Sans"/>
+              </a:rPr>
+              <a:t>Cada punto es un jugador y el color, su salario de 1987, que PCA no usó. El salario crece hacia la derecha (correlación 0,64 con la primera componente) y casi nada hacia arriba (0,11 con la segunda): la carrera pesa en el salario; la última temporada, poco. Dos ejes muestran lo que en 16 variables había que leer coeficiente por coeficiente.</a:t>
             </a:r>
           </a:p>
         </p:txBody>
@@ -4865,21 +4971,45 @@
                 </a:solidFill>
                 <a:latin typeface="Fira Sans"/>
               </a:rPr>
-              <a:t>Tres precauciones</a:t>
-            </a:r>
-          </a:p>
-        </p:txBody>
-      </p:sp>
-      <p:sp>
-        <p:nvSpPr>
-          <p:cNvPr id="4" name="TextBox 3"/>
+              <a:t>El mismo cálculo con las flores de la clase 2</a:t>
+            </a:r>
+          </a:p>
+        </p:txBody>
+      </p:sp>
+      <p:pic>
+        <p:nvPicPr>
+          <p:cNvPr id="4" name="Picture 3" descr="c8_06_iris.png"/>
+          <p:cNvPicPr>
+            <a:picLocks noChangeAspect="1"/>
+          </p:cNvPicPr>
+          <p:nvPr/>
+        </p:nvPicPr>
+        <p:blipFill>
+          <a:blip r:embed="rId2"/>
+          <a:stretch>
+            <a:fillRect/>
+          </a:stretch>
+        </p:blipFill>
+        <p:spPr>
+          <a:xfrm>
+            <a:off x="2906606" y="1143000"/>
+            <a:ext cx="3330786" cy="2587751"/>
+          </a:xfrm>
+          <a:prstGeom prst="rect">
+            <a:avLst/>
+          </a:prstGeom>
+        </p:spPr>
+      </p:pic>
+      <p:sp>
+        <p:nvSpPr>
+          <p:cNvPr id="5" name="TextBox 4"/>
           <p:cNvSpPr txBox="1"/>
           <p:nvPr/>
         </p:nvSpPr>
         <p:spPr>
           <a:xfrm>
-            <a:off x="704088" y="1353312"/>
-            <a:ext cx="7744968" cy="3300984"/>
+            <a:off x="704088" y="3867912"/>
+            <a:ext cx="7744968" cy="1024128"/>
           </a:xfrm>
           <a:prstGeom prst="rect">
             <a:avLst/>
@@ -4892,87 +5022,14 @@
           </a:bodyPr>
           <a:lstStyle/>
           <a:p>
-            <a:pPr>
-              <a:lnSpc>
-                <a:spcPct val="112000"/>
-              </a:lnSpc>
-              <a:spcAft>
-                <a:spcPts val="900"/>
-              </a:spcAft>
-            </a:pPr>
-            <a:r>
-              <a:rPr sz="1800" b="1">
-                <a:solidFill>
-                  <a:srgbClr val="E0A437"/>
-                </a:solidFill>
-                <a:latin typeface="Fira Sans"/>
-              </a:rPr>
-              <a:t>▸ </a:t>
-            </a:r>
-            <a:r>
-              <a:rPr sz="1800" b="1">
-                <a:solidFill>
-                  <a:srgbClr val="1D3557"/>
-                </a:solidFill>
-                <a:latin typeface="Fira Sans"/>
-              </a:rPr>
-              <a:t>Las variables categóricas (las dummies de la clase 6) no entran bien en el cálculo: se dejan fuera o se tratan aparte.</a:t>
-            </a:r>
-          </a:p>
-          <a:p>
-            <a:pPr>
-              <a:lnSpc>
-                <a:spcPct val="112000"/>
-              </a:lnSpc>
-              <a:spcAft>
-                <a:spcPts val="900"/>
-              </a:spcAft>
-            </a:pPr>
-            <a:r>
-              <a:rPr sz="1800" b="1">
-                <a:solidFill>
-                  <a:srgbClr val="E0A437"/>
-                </a:solidFill>
-                <a:latin typeface="Fira Sans"/>
-              </a:rPr>
-              <a:t>▸ </a:t>
-            </a:r>
-            <a:r>
-              <a:rPr sz="1800" b="0">
-                <a:solidFill>
-                  <a:srgbClr val="000000"/>
-                </a:solidFill>
-                <a:latin typeface="Fira Sans"/>
-              </a:rPr>
-              <a:t>Las componentes no siempre tienen una lectura clara. Aquí sí (la carrera; la temporada frente a la carrera), pero no está garantizado.</a:t>
-            </a:r>
-          </a:p>
-          <a:p>
-            <a:pPr>
-              <a:lnSpc>
-                <a:spcPct val="112000"/>
-              </a:lnSpc>
-              <a:spcAft>
-                <a:spcPts val="900"/>
-              </a:spcAft>
-            </a:pPr>
-            <a:r>
-              <a:rPr sz="1800" b="1">
-                <a:solidFill>
-                  <a:srgbClr val="E0A437"/>
-                </a:solidFill>
-                <a:latin typeface="Fira Sans"/>
-              </a:rPr>
-              <a:t>▸ </a:t>
-            </a:r>
-            <a:r>
-              <a:rPr sz="1800" b="0">
-                <a:solidFill>
-                  <a:srgbClr val="000000"/>
-                </a:solidFill>
-                <a:latin typeface="Fira Sans"/>
-              </a:rPr>
-              <a:t>Es no supervisado: la dirección de más variación no es necesariamente la que mejor predice la respuesta. Ridge y Lasso eligen mirando Y; PCA no la mira.</a:t>
+            <a:r>
+              <a:rPr sz="1300" b="0">
+                <a:solidFill>
+                  <a:srgbClr val="333333"/>
+                </a:solidFill>
+                <a:latin typeface="Fira Sans"/>
+              </a:rPr>
+              <a:t>Las cuatro medidas de iris se resumen en dos componentes que reúnen el 96% de la variación. La primera (73%) pesa casi igual el largo y el ancho del pétalo y el largo del sépalo (0,52 a 0,58): el tamaño de la flor. La segunda (23%) es casi solo el ancho del sépalo (0,92). PCA no conoce la especie y aun así las tres quedan separadas a lo largo de la primera componente.</a:t>
             </a:r>
           </a:p>
         </p:txBody>
@@ -5241,7 +5298,7 @@
             <a:avLst/>
           </a:prstGeom>
           <a:solidFill>
-            <a:srgbClr val="FAFBFC"/>
+            <a:srgbClr val="1D3557"/>
           </a:solidFill>
           <a:ln>
             <a:noFill/>
@@ -5278,8 +5335,8 @@
         </p:nvSpPr>
         <p:spPr>
           <a:xfrm>
-            <a:off x="402336" y="301752"/>
-            <a:ext cx="8348472" cy="795528"/>
+            <a:off x="603504" y="1847088"/>
+            <a:ext cx="7946136" cy="1399032"/>
           </a:xfrm>
           <a:prstGeom prst="rect">
             <a:avLst/>
@@ -5293,167 +5350,24 @@
           <a:lstStyle/>
           <a:p>
             <a:r>
-              <a:rPr sz="2800" b="1">
-                <a:solidFill>
-                  <a:srgbClr val="0F0F0F"/>
-                </a:solidFill>
-                <a:latin typeface="Fira Sans"/>
-              </a:rPr>
-              <a:t>En el código: cinco líneas</a:t>
-            </a:r>
-          </a:p>
-        </p:txBody>
-      </p:sp>
-      <p:sp>
-        <p:nvSpPr>
-          <p:cNvPr id="4" name="Rectangle 3"/>
-          <p:cNvSpPr/>
-          <p:nvPr/>
-        </p:nvSpPr>
-        <p:spPr>
-          <a:xfrm>
-            <a:off x="704088" y="1280160"/>
-            <a:ext cx="7744968" cy="2880360"/>
-          </a:xfrm>
-          <a:prstGeom prst="rect">
-            <a:avLst/>
-          </a:prstGeom>
-          <a:solidFill>
-            <a:srgbClr val="F0F2F5"/>
-          </a:solidFill>
-          <a:ln>
-            <a:solidFill>
-              <a:srgbClr val="D8DDE3"/>
-            </a:solidFill>
-          </a:ln>
-          <a:effectLst/>
-        </p:spPr>
-        <p:style>
-          <a:lnRef idx="1">
-            <a:schemeClr val="accent1"/>
-          </a:lnRef>
-          <a:fillRef idx="3">
-            <a:schemeClr val="accent1"/>
-          </a:fillRef>
-          <a:effectRef idx="2">
-            <a:schemeClr val="accent1"/>
-          </a:effectRef>
-          <a:fontRef idx="minor">
-            <a:schemeClr val="lt1"/>
-          </a:fontRef>
-        </p:style>
-        <p:txBody>
-          <a:bodyPr rtlCol="0" anchor="ctr" wrap="square" lIns="228600" tIns="137160"/>
-          <a:lstStyle/>
-          <a:p>
-            <a:pPr/>
-            <a:r>
-              <a:rPr sz="1500" b="0">
-                <a:solidFill>
-                  <a:srgbClr val="1D3557"/>
-                </a:solidFill>
-                <a:latin typeface="Menlo"/>
-              </a:rPr>
-              <a:t>Z = StandardScaler().fit_transform(X)  # 1. estandarizar</a:t>
-            </a:r>
-          </a:p>
-          <a:p>
-            <a:pPr/>
-            <a:r>
-              <a:rPr sz="1500" b="0">
-                <a:solidFill>
-                  <a:srgbClr val="1D3557"/>
-                </a:solidFill>
-                <a:latin typeface="Menlo"/>
-              </a:rPr>
-              <a:t>pca = PCA().fit(Z)                     # 2. las componentes</a:t>
-            </a:r>
-          </a:p>
-          <a:p>
-            <a:pPr/>
-            <a:r>
-              <a:rPr sz="1500" b="0">
-                <a:solidFill>
-                  <a:srgbClr val="1D3557"/>
-                </a:solidFill>
-                <a:latin typeface="Menlo"/>
-              </a:rPr>
-              <a:t>pca.explained_variance_ratio_          # 3. cuánto explica</a:t>
-            </a:r>
-          </a:p>
-          <a:p>
-            <a:pPr/>
-            <a:r>
-              <a:rPr sz="1500" b="0">
-                <a:solidFill>
-                  <a:srgbClr val="1D3557"/>
-                </a:solidFill>
-                <a:latin typeface="Menlo"/>
-              </a:rPr>
-              <a:t>pca.components_                        # 4. los pesos</a:t>
-            </a:r>
-          </a:p>
-          <a:p>
-            <a:pPr/>
-            <a:r>
-              <a:rPr sz="1500" b="0">
-                <a:solidFill>
-                  <a:srgbClr val="1D3557"/>
-                </a:solidFill>
-                <a:latin typeface="Menlo"/>
-              </a:rPr>
-              <a:t>puntajes = pca.transform(Z)            # 5. los puntajes</a:t>
-            </a:r>
-          </a:p>
-        </p:txBody>
-      </p:sp>
-      <p:sp>
-        <p:nvSpPr>
-          <p:cNvPr id="5" name="TextBox 4"/>
-          <p:cNvSpPr txBox="1"/>
-          <p:nvPr/>
-        </p:nvSpPr>
-        <p:spPr>
-          <a:xfrm>
-            <a:off x="704088" y="4389120"/>
-            <a:ext cx="7744968" cy="1097280"/>
-          </a:xfrm>
-          <a:prstGeom prst="rect">
-            <a:avLst/>
-          </a:prstGeom>
-          <a:noFill/>
-        </p:spPr>
-        <p:txBody>
-          <a:bodyPr wrap="square">
-            <a:spAutoFit/>
-          </a:bodyPr>
-          <a:lstStyle/>
-          <a:p>
-            <a:pPr>
-              <a:lnSpc>
-                <a:spcPct val="112000"/>
-              </a:lnSpc>
-              <a:spcAft>
-                <a:spcPts val="900"/>
-              </a:spcAft>
-            </a:pPr>
-            <a:r>
-              <a:rPr sz="1600" b="1">
+              <a:rPr sz="3400" b="1">
+                <a:solidFill>
+                  <a:srgbClr val="FFFFFF"/>
+                </a:solidFill>
+                <a:latin typeface="Fira Sans"/>
+              </a:rPr>
+              <a:t>4. Cuándo</a:t>
+            </a:r>
+          </a:p>
+          <a:p>
+            <a:r>
+              <a:rPr sz="1800" b="0">
                 <a:solidFill>
                   <a:srgbClr val="E0A437"/>
                 </a:solidFill>
                 <a:latin typeface="Fira Sans"/>
               </a:rPr>
-              <a:t>▸ </a:t>
-            </a:r>
-            <a:r>
-              <a:rPr sz="1600" b="0">
-                <a:solidFill>
-                  <a:srgbClr val="000000"/>
-                </a:solidFill>
-                <a:latin typeface="Fira Sans"/>
-              </a:rPr>
-              <a:t>El ejemplo completo, con las tablas de pesos y los gráficos de la clase, está en el notebook 08_componentes_principales.ipynb.</a:t>
+              <a:t>Cuándo conviene y cuándo no</a:t>
             </a:r>
           </a:p>
         </p:txBody>
@@ -5491,7 +5405,7 @@
             <a:avLst/>
           </a:prstGeom>
           <a:solidFill>
-            <a:srgbClr val="1D3557"/>
+            <a:srgbClr val="FAFBFC"/>
           </a:solidFill>
           <a:ln>
             <a:noFill/>
@@ -5528,8 +5442,8 @@
         </p:nvSpPr>
         <p:spPr>
           <a:xfrm>
-            <a:off x="603504" y="1847088"/>
-            <a:ext cx="7946136" cy="1399032"/>
+            <a:off x="402336" y="301752"/>
+            <a:ext cx="8348472" cy="795528"/>
           </a:xfrm>
           <a:prstGeom prst="rect">
             <a:avLst/>
@@ -5543,24 +5457,120 @@
           <a:lstStyle/>
           <a:p>
             <a:r>
-              <a:rPr sz="3400" b="1">
-                <a:solidFill>
-                  <a:srgbClr val="FFFFFF"/>
-                </a:solidFill>
-                <a:latin typeface="Fira Sans"/>
-              </a:rPr>
-              <a:t>5. Cierre del módulo</a:t>
-            </a:r>
-          </a:p>
-          <a:p>
+              <a:rPr sz="2800" b="1">
+                <a:solidFill>
+                  <a:srgbClr val="0F0F0F"/>
+                </a:solidFill>
+                <a:latin typeface="Fira Sans"/>
+              </a:rPr>
+              <a:t>¿Cuándo conviene?</a:t>
+            </a:r>
+          </a:p>
+        </p:txBody>
+      </p:sp>
+      <p:sp>
+        <p:nvSpPr>
+          <p:cNvPr id="4" name="TextBox 3"/>
+          <p:cNvSpPr txBox="1"/>
+          <p:nvPr/>
+        </p:nvSpPr>
+        <p:spPr>
+          <a:xfrm>
+            <a:off x="704088" y="1353312"/>
+            <a:ext cx="7744968" cy="3300984"/>
+          </a:xfrm>
+          <a:prstGeom prst="rect">
+            <a:avLst/>
+          </a:prstGeom>
+          <a:noFill/>
+        </p:spPr>
+        <p:txBody>
+          <a:bodyPr wrap="square">
+            <a:spAutoFit/>
+          </a:bodyPr>
+          <a:lstStyle/>
+          <a:p>
+            <a:pPr>
+              <a:lnSpc>
+                <a:spcPct val="112000"/>
+              </a:lnSpc>
+              <a:spcAft>
+                <a:spcPts val="900"/>
+              </a:spcAft>
+            </a:pPr>
+            <a:r>
+              <a:rPr sz="1800" b="1">
+                <a:solidFill>
+                  <a:srgbClr val="E0A437"/>
+                </a:solidFill>
+                <a:latin typeface="Fira Sans"/>
+              </a:rPr>
+              <a:t>▸ </a:t>
+            </a:r>
+            <a:r>
+              <a:rPr sz="1800" b="1">
+                <a:solidFill>
+                  <a:srgbClr val="1D3557"/>
+                </a:solidFill>
+                <a:latin typeface="Fira Sans"/>
+              </a:rPr>
+              <a:t>Con muchas variables numéricas que se correlacionan en bloques, como en la matriz de la clase 7.</a:t>
+            </a:r>
+          </a:p>
+          <a:p>
+            <a:pPr>
+              <a:lnSpc>
+                <a:spcPct val="112000"/>
+              </a:lnSpc>
+              <a:spcAft>
+                <a:spcPts val="900"/>
+              </a:spcAft>
+            </a:pPr>
+            <a:r>
+              <a:rPr sz="1800" b="1">
+                <a:solidFill>
+                  <a:srgbClr val="E0A437"/>
+                </a:solidFill>
+                <a:latin typeface="Fira Sans"/>
+              </a:rPr>
+              <a:t>▸ </a:t>
+            </a:r>
             <a:r>
               <a:rPr sz="1800" b="0">
                 <a:solidFill>
+                  <a:srgbClr val="000000"/>
+                </a:solidFill>
+                <a:latin typeface="Fira Sans"/>
+              </a:rPr>
+              <a:t>Para mirar los datos en un plano, o para entregarle a un modelo menos entradas.</a:t>
+            </a:r>
+          </a:p>
+          <a:p>
+            <a:pPr>
+              <a:lnSpc>
+                <a:spcPct val="112000"/>
+              </a:lnSpc>
+              <a:spcAft>
+                <a:spcPts val="900"/>
+              </a:spcAft>
+            </a:pPr>
+            <a:r>
+              <a:rPr sz="1800" b="1">
+                <a:solidFill>
                   <a:srgbClr val="E0A437"/>
                 </a:solidFill>
                 <a:latin typeface="Fira Sans"/>
               </a:rPr>
-              <a:t>Ocho clases, un hilo</a:t>
+              <a:t>▸ </a:t>
+            </a:r>
+            <a:r>
+              <a:rPr sz="1800" b="0">
+                <a:solidFill>
+                  <a:srgbClr val="000000"/>
+                </a:solidFill>
+                <a:latin typeface="Fira Sans"/>
+              </a:rPr>
+              <a:t>No aporta si las variables son pocas y distintas entre sí: no hay nada que resumir.</a:t>
             </a:r>
           </a:p>
         </p:txBody>
@@ -5656,45 +5666,21 @@
                 </a:solidFill>
                 <a:latin typeface="Fira Sans"/>
               </a:rPr>
-              <a:t>El módulo en una página</a:t>
-            </a:r>
-          </a:p>
-        </p:txBody>
-      </p:sp>
-      <p:pic>
-        <p:nvPicPr>
-          <p:cNvPr id="4" name="Picture 3" descr="c8_07_mapa_modulo.png"/>
-          <p:cNvPicPr>
-            <a:picLocks noChangeAspect="1"/>
-          </p:cNvPicPr>
-          <p:nvPr/>
-        </p:nvPicPr>
-        <p:blipFill>
-          <a:blip r:embed="rId2"/>
-          <a:stretch>
-            <a:fillRect/>
-          </a:stretch>
-        </p:blipFill>
-        <p:spPr>
-          <a:xfrm>
-            <a:off x="1029546" y="1143000"/>
-            <a:ext cx="7084906" cy="3099816"/>
-          </a:xfrm>
-          <a:prstGeom prst="rect">
-            <a:avLst/>
-          </a:prstGeom>
-        </p:spPr>
-      </p:pic>
-      <p:sp>
-        <p:nvSpPr>
-          <p:cNvPr id="5" name="TextBox 4"/>
+              <a:t>Tres precauciones</a:t>
+            </a:r>
+          </a:p>
+        </p:txBody>
+      </p:sp>
+      <p:sp>
+        <p:nvSpPr>
+          <p:cNvPr id="4" name="TextBox 3"/>
           <p:cNvSpPr txBox="1"/>
           <p:nvPr/>
         </p:nvSpPr>
         <p:spPr>
           <a:xfrm>
-            <a:off x="704088" y="4379976"/>
-            <a:ext cx="7744968" cy="512064"/>
+            <a:off x="704088" y="1353312"/>
+            <a:ext cx="7744968" cy="3300984"/>
           </a:xfrm>
           <a:prstGeom prst="rect">
             <a:avLst/>
@@ -5707,14 +5693,87 @@
           </a:bodyPr>
           <a:lstStyle/>
           <a:p>
-            <a:r>
-              <a:rPr sz="1300" b="0">
-                <a:solidFill>
-                  <a:srgbClr val="333333"/>
-                </a:solidFill>
-                <a:latin typeface="Fira Sans"/>
-              </a:rPr>
-              <a:t>Cada clase dejó una idea. Juntas, son lo que el módulo enseñó: cómo se llega de una pregunta y unos datos a un resultado, y cómo se lee ese resultado con su incertidumbre.</a:t>
+            <a:pPr>
+              <a:lnSpc>
+                <a:spcPct val="112000"/>
+              </a:lnSpc>
+              <a:spcAft>
+                <a:spcPts val="900"/>
+              </a:spcAft>
+            </a:pPr>
+            <a:r>
+              <a:rPr sz="1800" b="1">
+                <a:solidFill>
+                  <a:srgbClr val="E0A437"/>
+                </a:solidFill>
+                <a:latin typeface="Fira Sans"/>
+              </a:rPr>
+              <a:t>▸ </a:t>
+            </a:r>
+            <a:r>
+              <a:rPr sz="1800" b="1">
+                <a:solidFill>
+                  <a:srgbClr val="1D3557"/>
+                </a:solidFill>
+                <a:latin typeface="Fira Sans"/>
+              </a:rPr>
+              <a:t>Las variables categóricas (las dummies de la clase 6) no entran bien en el cálculo: se dejan fuera o se tratan aparte.</a:t>
+            </a:r>
+          </a:p>
+          <a:p>
+            <a:pPr>
+              <a:lnSpc>
+                <a:spcPct val="112000"/>
+              </a:lnSpc>
+              <a:spcAft>
+                <a:spcPts val="900"/>
+              </a:spcAft>
+            </a:pPr>
+            <a:r>
+              <a:rPr sz="1800" b="1">
+                <a:solidFill>
+                  <a:srgbClr val="E0A437"/>
+                </a:solidFill>
+                <a:latin typeface="Fira Sans"/>
+              </a:rPr>
+              <a:t>▸ </a:t>
+            </a:r>
+            <a:r>
+              <a:rPr sz="1800" b="0">
+                <a:solidFill>
+                  <a:srgbClr val="000000"/>
+                </a:solidFill>
+                <a:latin typeface="Fira Sans"/>
+              </a:rPr>
+              <a:t>Las componentes no siempre tienen una lectura clara. Aquí sí (la carrera; la temporada frente a la carrera), pero no está garantizado.</a:t>
+            </a:r>
+          </a:p>
+          <a:p>
+            <a:pPr>
+              <a:lnSpc>
+                <a:spcPct val="112000"/>
+              </a:lnSpc>
+              <a:spcAft>
+                <a:spcPts val="900"/>
+              </a:spcAft>
+            </a:pPr>
+            <a:r>
+              <a:rPr sz="1800" b="1">
+                <a:solidFill>
+                  <a:srgbClr val="E0A437"/>
+                </a:solidFill>
+                <a:latin typeface="Fira Sans"/>
+              </a:rPr>
+              <a:t>▸ </a:t>
+            </a:r>
+            <a:r>
+              <a:rPr sz="1800" b="0">
+                <a:solidFill>
+                  <a:srgbClr val="000000"/>
+                </a:solidFill>
+                <a:latin typeface="Fira Sans"/>
+              </a:rPr>
+              <a:t>Es no supervisado: la dirección de más variación no es necesariamente la que mejor predice la respuesta. Ridge y Lasso eligen mirando Y; PCA no la mira.</a:t>
             </a:r>
           </a:p>
         </p:txBody>
@@ -5810,21 +5869,124 @@
                 </a:solidFill>
                 <a:latin typeface="Fira Sans"/>
               </a:rPr>
-              <a:t>Lo que sigue en el diplomado</a:t>
-            </a:r>
-          </a:p>
-        </p:txBody>
-      </p:sp>
-      <p:sp>
-        <p:nvSpPr>
-          <p:cNvPr id="4" name="TextBox 3"/>
+              <a:t>En el código: cinco líneas</a:t>
+            </a:r>
+          </a:p>
+        </p:txBody>
+      </p:sp>
+      <p:sp>
+        <p:nvSpPr>
+          <p:cNvPr id="4" name="Rectangle 3"/>
+          <p:cNvSpPr/>
+          <p:nvPr/>
+        </p:nvSpPr>
+        <p:spPr>
+          <a:xfrm>
+            <a:off x="704088" y="1280160"/>
+            <a:ext cx="7744968" cy="2880360"/>
+          </a:xfrm>
+          <a:prstGeom prst="rect">
+            <a:avLst/>
+          </a:prstGeom>
+          <a:solidFill>
+            <a:srgbClr val="F0F2F5"/>
+          </a:solidFill>
+          <a:ln>
+            <a:solidFill>
+              <a:srgbClr val="D8DDE3"/>
+            </a:solidFill>
+          </a:ln>
+          <a:effectLst/>
+        </p:spPr>
+        <p:style>
+          <a:lnRef idx="1">
+            <a:schemeClr val="accent1"/>
+          </a:lnRef>
+          <a:fillRef idx="3">
+            <a:schemeClr val="accent1"/>
+          </a:fillRef>
+          <a:effectRef idx="2">
+            <a:schemeClr val="accent1"/>
+          </a:effectRef>
+          <a:fontRef idx="minor">
+            <a:schemeClr val="lt1"/>
+          </a:fontRef>
+        </p:style>
+        <p:txBody>
+          <a:bodyPr rtlCol="0" anchor="ctr" wrap="square" lIns="228600" tIns="137160"/>
+          <a:lstStyle/>
+          <a:p>
+            <a:pPr/>
+            <a:r>
+              <a:rPr sz="1500" b="0">
+                <a:solidFill>
+                  <a:srgbClr val="1D3557"/>
+                </a:solidFill>
+                <a:latin typeface="Menlo"/>
+              </a:rPr>
+              <a:t>Z = StandardScaler().fit_transform(X)  # 1. estandarizar</a:t>
+            </a:r>
+          </a:p>
+          <a:p>
+            <a:pPr/>
+            <a:r>
+              <a:rPr sz="1500" b="0">
+                <a:solidFill>
+                  <a:srgbClr val="1D3557"/>
+                </a:solidFill>
+                <a:latin typeface="Menlo"/>
+              </a:rPr>
+              <a:t>pca = PCA().fit(Z)                     # 2. las componentes</a:t>
+            </a:r>
+          </a:p>
+          <a:p>
+            <a:pPr/>
+            <a:r>
+              <a:rPr sz="1500" b="0">
+                <a:solidFill>
+                  <a:srgbClr val="1D3557"/>
+                </a:solidFill>
+                <a:latin typeface="Menlo"/>
+              </a:rPr>
+              <a:t>pca.explained_variance_ratio_          # 3. cuánto explica</a:t>
+            </a:r>
+          </a:p>
+          <a:p>
+            <a:pPr/>
+            <a:r>
+              <a:rPr sz="1500" b="0">
+                <a:solidFill>
+                  <a:srgbClr val="1D3557"/>
+                </a:solidFill>
+                <a:latin typeface="Menlo"/>
+              </a:rPr>
+              <a:t>pca.components_                        # 4. los pesos</a:t>
+            </a:r>
+          </a:p>
+          <a:p>
+            <a:pPr/>
+            <a:r>
+              <a:rPr sz="1500" b="0">
+                <a:solidFill>
+                  <a:srgbClr val="1D3557"/>
+                </a:solidFill>
+                <a:latin typeface="Menlo"/>
+              </a:rPr>
+              <a:t>puntajes = pca.transform(Z)            # 5. los puntajes</a:t>
+            </a:r>
+          </a:p>
+        </p:txBody>
+      </p:sp>
+      <p:sp>
+        <p:nvSpPr>
+          <p:cNvPr id="5" name="TextBox 4"/>
           <p:cNvSpPr txBox="1"/>
           <p:nvPr/>
         </p:nvSpPr>
         <p:spPr>
           <a:xfrm>
-            <a:off x="704088" y="1353312"/>
-            <a:ext cx="7744968" cy="3300984"/>
+            <a:off x="704088" y="4389120"/>
+            <a:ext cx="7744968" cy="1097280"/>
           </a:xfrm>
           <a:prstGeom prst="rect">
             <a:avLst/>
@@ -5846,7 +6008,7 @@
               </a:spcAft>
             </a:pPr>
             <a:r>
-              <a:rPr sz="1800" b="1">
+              <a:rPr sz="1600" b="1">
                 <a:solidFill>
                   <a:srgbClr val="E0A437"/>
                 </a:solidFill>
@@ -5855,97 +6017,13 @@
               <a:t>▸ </a:t>
             </a:r>
             <a:r>
-              <a:rPr sz="1800" b="1">
-                <a:solidFill>
-                  <a:srgbClr val="1D3557"/>
-                </a:solidFill>
-                <a:latin typeface="Fira Sans"/>
-              </a:rPr>
-              <a:t>Módulo 2, Visualización e Inteligencia de Negocios: visualización efectiva, narrativas con datos y métricas de negocio.</a:t>
-            </a:r>
-          </a:p>
-          <a:p>
-            <a:pPr>
-              <a:lnSpc>
-                <a:spcPct val="112000"/>
-              </a:lnSpc>
-              <a:spcAft>
-                <a:spcPts val="900"/>
-              </a:spcAft>
-            </a:pPr>
-            <a:r>
-              <a:rPr sz="1800" b="1">
-                <a:solidFill>
-                  <a:srgbClr val="E0A437"/>
-                </a:solidFill>
-                <a:latin typeface="Fira Sans"/>
-              </a:rPr>
-              <a:t>▸ </a:t>
-            </a:r>
-            <a:r>
-              <a:rPr sz="1800" b="0">
+              <a:rPr sz="1600" b="0">
                 <a:solidFill>
                   <a:srgbClr val="000000"/>
                 </a:solidFill>
                 <a:latin typeface="Fira Sans"/>
               </a:rPr>
-              <a:t>Módulo 3, Machine Learning para la Toma de Decisiones: aprendizaje supervisado y no supervisado (clustering y PCA en profundidad), evaluación de modelos, redes neuronales y explicabilidad.</a:t>
-            </a:r>
-          </a:p>
-          <a:p>
-            <a:pPr>
-              <a:lnSpc>
-                <a:spcPct val="112000"/>
-              </a:lnSpc>
-              <a:spcAft>
-                <a:spcPts val="900"/>
-              </a:spcAft>
-            </a:pPr>
-            <a:r>
-              <a:rPr sz="1800" b="1">
-                <a:solidFill>
-                  <a:srgbClr val="E0A437"/>
-                </a:solidFill>
-                <a:latin typeface="Fira Sans"/>
-              </a:rPr>
-              <a:t>▸ </a:t>
-            </a:r>
-            <a:r>
-              <a:rPr sz="1800" b="0">
-                <a:solidFill>
-                  <a:srgbClr val="000000"/>
-                </a:solidFill>
-                <a:latin typeface="Fira Sans"/>
-              </a:rPr>
-              <a:t>El Capstone continúa en esos módulos: el primer modelo de hoy es el punto de partida.</a:t>
-            </a:r>
-          </a:p>
-          <a:p>
-            <a:pPr>
-              <a:lnSpc>
-                <a:spcPct val="112000"/>
-              </a:lnSpc>
-              <a:spcAft>
-                <a:spcPts val="900"/>
-              </a:spcAft>
-            </a:pPr>
-            <a:r>
-              <a:rPr sz="1800" b="1">
-                <a:solidFill>
-                  <a:srgbClr val="E0A437"/>
-                </a:solidFill>
-                <a:latin typeface="Fira Sans"/>
-              </a:rPr>
-              <a:t>▸ </a:t>
-            </a:r>
-            <a:r>
-              <a:rPr sz="1800" b="0">
-                <a:solidFill>
-                  <a:srgbClr val="000000"/>
-                </a:solidFill>
-                <a:latin typeface="Fira Sans"/>
-              </a:rPr>
-              <a:t>Lo que se lleva de aquí: leer un resultado con su incertidumbre, juzgar un modelo en datos que no vio, y distinguir describir de encontrar una relación.</a:t>
+              <a:t>El ejemplo completo, con las tablas de pesos y los gráficos de la clase, está en el notebook 08_componentes_principales.ipynb.</a:t>
             </a:r>
           </a:p>
         </p:txBody>
@@ -5983,7 +6061,7 @@
             <a:avLst/>
           </a:prstGeom>
           <a:solidFill>
-            <a:srgbClr val="FAFBFC"/>
+            <a:srgbClr val="1D3557"/>
           </a:solidFill>
           <a:ln>
             <a:noFill/>
@@ -6020,8 +6098,8 @@
         </p:nvSpPr>
         <p:spPr>
           <a:xfrm>
-            <a:off x="402336" y="301752"/>
-            <a:ext cx="8348472" cy="795528"/>
+            <a:off x="603504" y="1847088"/>
+            <a:ext cx="7946136" cy="1399032"/>
           </a:xfrm>
           <a:prstGeom prst="rect">
             <a:avLst/>
@@ -6035,148 +6113,24 @@
           <a:lstStyle/>
           <a:p>
             <a:r>
-              <a:rPr sz="2800" b="1">
-                <a:solidFill>
-                  <a:srgbClr val="0F0F0F"/>
-                </a:solidFill>
-                <a:latin typeface="Fira Sans"/>
-              </a:rPr>
-              <a:t>Ahora: las presentaciones del avance</a:t>
-            </a:r>
-          </a:p>
-        </p:txBody>
-      </p:sp>
-      <p:sp>
-        <p:nvSpPr>
-          <p:cNvPr id="4" name="TextBox 3"/>
-          <p:cNvSpPr txBox="1"/>
-          <p:nvPr/>
-        </p:nvSpPr>
-        <p:spPr>
-          <a:xfrm>
-            <a:off x="704088" y="1353312"/>
-            <a:ext cx="7744968" cy="3300984"/>
-          </a:xfrm>
-          <a:prstGeom prst="rect">
-            <a:avLst/>
-          </a:prstGeom>
-          <a:noFill/>
-        </p:spPr>
-        <p:txBody>
-          <a:bodyPr wrap="square">
-            <a:spAutoFit/>
-          </a:bodyPr>
-          <a:lstStyle/>
-          <a:p>
-            <a:pPr>
-              <a:lnSpc>
-                <a:spcPct val="112000"/>
-              </a:lnSpc>
-              <a:spcAft>
-                <a:spcPts val="900"/>
-              </a:spcAft>
-            </a:pPr>
-            <a:r>
-              <a:rPr sz="1800" b="1">
+              <a:rPr sz="3400" b="1">
+                <a:solidFill>
+                  <a:srgbClr val="FFFFFF"/>
+                </a:solidFill>
+                <a:latin typeface="Fira Sans"/>
+              </a:rPr>
+              <a:t>5. Cierre del módulo</a:t>
+            </a:r>
+          </a:p>
+          <a:p>
+            <a:r>
+              <a:rPr sz="1800" b="0">
                 <a:solidFill>
                   <a:srgbClr val="E0A437"/>
                 </a:solidFill>
                 <a:latin typeface="Fira Sans"/>
               </a:rPr>
-              <a:t>▸ </a:t>
-            </a:r>
-            <a:r>
-              <a:rPr sz="1800" b="1">
-                <a:solidFill>
-                  <a:srgbClr val="1D3557"/>
-                </a:solidFill>
-                <a:latin typeface="Fira Sans"/>
-              </a:rPr>
-              <a:t>Ocho equipos, en el orden en que se ofrezcan. Máximo 10 minutos por equipo; el tiempo se controla. Después, preguntas de la profesora y del curso.</a:t>
-            </a:r>
-          </a:p>
-          <a:p>
-            <a:pPr>
-              <a:lnSpc>
-                <a:spcPct val="112000"/>
-              </a:lnSpc>
-              <a:spcAft>
-                <a:spcPts val="900"/>
-              </a:spcAft>
-            </a:pPr>
-            <a:r>
-              <a:rPr sz="1800" b="1">
-                <a:solidFill>
-                  <a:srgbClr val="E0A437"/>
-                </a:solidFill>
-                <a:latin typeface="Fira Sans"/>
-              </a:rPr>
-              <a:t>▸ </a:t>
-            </a:r>
-            <a:r>
-              <a:rPr sz="1800" b="0">
-                <a:solidFill>
-                  <a:srgbClr val="000000"/>
-                </a:solidFill>
-                <a:latin typeface="Fira Sans"/>
-              </a:rPr>
-              <a:t>Se evalúa el avance, no un resultado final: el modelo es un primer intento. La exigencia está en el tiempo, la claridad, la explicación de los gráficos y las relaciones, y en advertir qué falta o qué no tiene sentido.</a:t>
-            </a:r>
-          </a:p>
-          <a:p>
-            <a:pPr>
-              <a:lnSpc>
-                <a:spcPct val="112000"/>
-              </a:lnSpc>
-              <a:spcAft>
-                <a:spcPts val="900"/>
-              </a:spcAft>
-            </a:pPr>
-            <a:r>
-              <a:rPr sz="1800" b="1">
-                <a:solidFill>
-                  <a:srgbClr val="E0A437"/>
-                </a:solidFill>
-                <a:latin typeface="Fira Sans"/>
-              </a:rPr>
-              <a:t>▸ </a:t>
-            </a:r>
-            <a:r>
-              <a:rPr sz="1800" b="0">
-                <a:solidFill>
-                  <a:srgbClr val="000000"/>
-                </a:solidFill>
-                <a:latin typeface="Fira Sans"/>
-              </a:rPr>
-              <a:t>Las slides, en PDF, al Aula hasta las 20:30: un envío por equipo con los nombres.</a:t>
-            </a:r>
-          </a:p>
-          <a:p>
-            <a:pPr>
-              <a:lnSpc>
-                <a:spcPct val="112000"/>
-              </a:lnSpc>
-              <a:spcAft>
-                <a:spcPts val="900"/>
-              </a:spcAft>
-            </a:pPr>
-            <a:r>
-              <a:rPr sz="1800" b="1">
-                <a:solidFill>
-                  <a:srgbClr val="E0A437"/>
-                </a:solidFill>
-                <a:latin typeface="Fira Sans"/>
-              </a:rPr>
-              <a:t>▸ </a:t>
-            </a:r>
-            <a:r>
-              <a:rPr sz="1800" b="0">
-                <a:solidFill>
-                  <a:srgbClr val="000000"/>
-                </a:solidFill>
-                <a:latin typeface="Fira Sans"/>
-              </a:rPr>
-              <a:t>El informe escrito, el viernes 25 de septiembre por el Aula: máximo 7 páginas, con su rúbrica publicada.</a:t>
+              <a:t>Ocho clases, un hilo</a:t>
             </a:r>
           </a:p>
         </p:txBody>
@@ -6272,6 +6226,622 @@
                 </a:solidFill>
                 <a:latin typeface="Fira Sans"/>
               </a:rPr>
+              <a:t>El módulo en una página</a:t>
+            </a:r>
+          </a:p>
+        </p:txBody>
+      </p:sp>
+      <p:pic>
+        <p:nvPicPr>
+          <p:cNvPr id="4" name="Picture 3" descr="c8_07_mapa_modulo.png"/>
+          <p:cNvPicPr>
+            <a:picLocks noChangeAspect="1"/>
+          </p:cNvPicPr>
+          <p:nvPr/>
+        </p:nvPicPr>
+        <p:blipFill>
+          <a:blip r:embed="rId2"/>
+          <a:stretch>
+            <a:fillRect/>
+          </a:stretch>
+        </p:blipFill>
+        <p:spPr>
+          <a:xfrm>
+            <a:off x="1029546" y="1143000"/>
+            <a:ext cx="7084906" cy="3099816"/>
+          </a:xfrm>
+          <a:prstGeom prst="rect">
+            <a:avLst/>
+          </a:prstGeom>
+        </p:spPr>
+      </p:pic>
+      <p:sp>
+        <p:nvSpPr>
+          <p:cNvPr id="5" name="TextBox 4"/>
+          <p:cNvSpPr txBox="1"/>
+          <p:nvPr/>
+        </p:nvSpPr>
+        <p:spPr>
+          <a:xfrm>
+            <a:off x="704088" y="4379976"/>
+            <a:ext cx="7744968" cy="512064"/>
+          </a:xfrm>
+          <a:prstGeom prst="rect">
+            <a:avLst/>
+          </a:prstGeom>
+          <a:noFill/>
+        </p:spPr>
+        <p:txBody>
+          <a:bodyPr wrap="square">
+            <a:spAutoFit/>
+          </a:bodyPr>
+          <a:lstStyle/>
+          <a:p>
+            <a:r>
+              <a:rPr sz="1300" b="0">
+                <a:solidFill>
+                  <a:srgbClr val="333333"/>
+                </a:solidFill>
+                <a:latin typeface="Fira Sans"/>
+              </a:rPr>
+              <a:t>Cada clase dejó una idea. Juntas, son lo que el módulo enseñó: cómo se llega de una pregunta y unos datos a un resultado, y cómo se lee ese resultado con su incertidumbre.</a:t>
+            </a:r>
+          </a:p>
+        </p:txBody>
+      </p:sp>
+    </p:spTree>
+  </p:cSld>
+  <p:clrMapOvr>
+    <a:masterClrMapping/>
+  </p:clrMapOvr>
+</p:sld>
+</file>
+
+<file path=ppt/slides/slide26.xml><?xml version="1.0" encoding="utf-8"?>
+<p:sld xmlns:a="http://schemas.openxmlformats.org/drawingml/2006/main" xmlns:p="http://schemas.openxmlformats.org/presentationml/2006/main" xmlns:r="http://schemas.openxmlformats.org/officeDocument/2006/relationships">
+  <p:cSld>
+    <p:spTree>
+      <p:nvGrpSpPr>
+        <p:cNvPr id="1" name=""/>
+        <p:cNvGrpSpPr/>
+        <p:nvPr/>
+      </p:nvGrpSpPr>
+      <p:grpSpPr/>
+      <p:sp>
+        <p:nvSpPr>
+          <p:cNvPr id="2" name="Rectangle 1"/>
+          <p:cNvSpPr/>
+          <p:nvPr/>
+        </p:nvSpPr>
+        <p:spPr>
+          <a:xfrm>
+            <a:off x="0" y="0"/>
+            <a:ext cx="9144000" cy="5138928"/>
+          </a:xfrm>
+          <a:prstGeom prst="rect">
+            <a:avLst/>
+          </a:prstGeom>
+          <a:solidFill>
+            <a:srgbClr val="FAFBFC"/>
+          </a:solidFill>
+          <a:ln>
+            <a:noFill/>
+          </a:ln>
+          <a:effectLst/>
+        </p:spPr>
+        <p:style>
+          <a:lnRef idx="1">
+            <a:schemeClr val="accent1"/>
+          </a:lnRef>
+          <a:fillRef idx="3">
+            <a:schemeClr val="accent1"/>
+          </a:fillRef>
+          <a:effectRef idx="2">
+            <a:schemeClr val="accent1"/>
+          </a:effectRef>
+          <a:fontRef idx="minor">
+            <a:schemeClr val="lt1"/>
+          </a:fontRef>
+        </p:style>
+        <p:txBody>
+          <a:bodyPr rtlCol="0" anchor="ctr"/>
+          <a:lstStyle/>
+          <a:p>
+            <a:pPr algn="ctr"/>
+          </a:p>
+        </p:txBody>
+      </p:sp>
+      <p:sp>
+        <p:nvSpPr>
+          <p:cNvPr id="3" name="TextBox 2"/>
+          <p:cNvSpPr txBox="1"/>
+          <p:nvPr/>
+        </p:nvSpPr>
+        <p:spPr>
+          <a:xfrm>
+            <a:off x="402336" y="301752"/>
+            <a:ext cx="8348472" cy="795528"/>
+          </a:xfrm>
+          <a:prstGeom prst="rect">
+            <a:avLst/>
+          </a:prstGeom>
+          <a:noFill/>
+        </p:spPr>
+        <p:txBody>
+          <a:bodyPr wrap="square">
+            <a:spAutoFit/>
+          </a:bodyPr>
+          <a:lstStyle/>
+          <a:p>
+            <a:r>
+              <a:rPr sz="2800" b="1">
+                <a:solidFill>
+                  <a:srgbClr val="0F0F0F"/>
+                </a:solidFill>
+                <a:latin typeface="Fira Sans"/>
+              </a:rPr>
+              <a:t>Lo que sigue en el diplomado</a:t>
+            </a:r>
+          </a:p>
+        </p:txBody>
+      </p:sp>
+      <p:sp>
+        <p:nvSpPr>
+          <p:cNvPr id="4" name="TextBox 3"/>
+          <p:cNvSpPr txBox="1"/>
+          <p:nvPr/>
+        </p:nvSpPr>
+        <p:spPr>
+          <a:xfrm>
+            <a:off x="704088" y="1353312"/>
+            <a:ext cx="7744968" cy="3300984"/>
+          </a:xfrm>
+          <a:prstGeom prst="rect">
+            <a:avLst/>
+          </a:prstGeom>
+          <a:noFill/>
+        </p:spPr>
+        <p:txBody>
+          <a:bodyPr wrap="square">
+            <a:spAutoFit/>
+          </a:bodyPr>
+          <a:lstStyle/>
+          <a:p>
+            <a:pPr>
+              <a:lnSpc>
+                <a:spcPct val="112000"/>
+              </a:lnSpc>
+              <a:spcAft>
+                <a:spcPts val="900"/>
+              </a:spcAft>
+            </a:pPr>
+            <a:r>
+              <a:rPr sz="1800" b="1">
+                <a:solidFill>
+                  <a:srgbClr val="E0A437"/>
+                </a:solidFill>
+                <a:latin typeface="Fira Sans"/>
+              </a:rPr>
+              <a:t>▸ </a:t>
+            </a:r>
+            <a:r>
+              <a:rPr sz="1800" b="1">
+                <a:solidFill>
+                  <a:srgbClr val="1D3557"/>
+                </a:solidFill>
+                <a:latin typeface="Fira Sans"/>
+              </a:rPr>
+              <a:t>Módulo 2, Visualización e Inteligencia de Negocios: visualización efectiva, narrativas con datos y métricas de negocio.</a:t>
+            </a:r>
+          </a:p>
+          <a:p>
+            <a:pPr>
+              <a:lnSpc>
+                <a:spcPct val="112000"/>
+              </a:lnSpc>
+              <a:spcAft>
+                <a:spcPts val="900"/>
+              </a:spcAft>
+            </a:pPr>
+            <a:r>
+              <a:rPr sz="1800" b="1">
+                <a:solidFill>
+                  <a:srgbClr val="E0A437"/>
+                </a:solidFill>
+                <a:latin typeface="Fira Sans"/>
+              </a:rPr>
+              <a:t>▸ </a:t>
+            </a:r>
+            <a:r>
+              <a:rPr sz="1800" b="0">
+                <a:solidFill>
+                  <a:srgbClr val="000000"/>
+                </a:solidFill>
+                <a:latin typeface="Fira Sans"/>
+              </a:rPr>
+              <a:t>Módulo 3, Machine Learning para la Toma de Decisiones: aprendizaje supervisado y no supervisado (clustering y PCA en profundidad), evaluación de modelos, redes neuronales y explicabilidad.</a:t>
+            </a:r>
+          </a:p>
+          <a:p>
+            <a:pPr>
+              <a:lnSpc>
+                <a:spcPct val="112000"/>
+              </a:lnSpc>
+              <a:spcAft>
+                <a:spcPts val="900"/>
+              </a:spcAft>
+            </a:pPr>
+            <a:r>
+              <a:rPr sz="1800" b="1">
+                <a:solidFill>
+                  <a:srgbClr val="E0A437"/>
+                </a:solidFill>
+                <a:latin typeface="Fira Sans"/>
+              </a:rPr>
+              <a:t>▸ </a:t>
+            </a:r>
+            <a:r>
+              <a:rPr sz="1800" b="0">
+                <a:solidFill>
+                  <a:srgbClr val="000000"/>
+                </a:solidFill>
+                <a:latin typeface="Fira Sans"/>
+              </a:rPr>
+              <a:t>El Capstone continúa en esos módulos: el primer modelo de hoy es el punto de partida.</a:t>
+            </a:r>
+          </a:p>
+          <a:p>
+            <a:pPr>
+              <a:lnSpc>
+                <a:spcPct val="112000"/>
+              </a:lnSpc>
+              <a:spcAft>
+                <a:spcPts val="900"/>
+              </a:spcAft>
+            </a:pPr>
+            <a:r>
+              <a:rPr sz="1800" b="1">
+                <a:solidFill>
+                  <a:srgbClr val="E0A437"/>
+                </a:solidFill>
+                <a:latin typeface="Fira Sans"/>
+              </a:rPr>
+              <a:t>▸ </a:t>
+            </a:r>
+            <a:r>
+              <a:rPr sz="1800" b="0">
+                <a:solidFill>
+                  <a:srgbClr val="000000"/>
+                </a:solidFill>
+                <a:latin typeface="Fira Sans"/>
+              </a:rPr>
+              <a:t>Lo que se lleva de aquí: leer un resultado con su incertidumbre, juzgar un modelo en datos que no vio, y distinguir describir de encontrar una relación.</a:t>
+            </a:r>
+          </a:p>
+        </p:txBody>
+      </p:sp>
+    </p:spTree>
+  </p:cSld>
+  <p:clrMapOvr>
+    <a:masterClrMapping/>
+  </p:clrMapOvr>
+</p:sld>
+</file>
+
+<file path=ppt/slides/slide27.xml><?xml version="1.0" encoding="utf-8"?>
+<p:sld xmlns:a="http://schemas.openxmlformats.org/drawingml/2006/main" xmlns:p="http://schemas.openxmlformats.org/presentationml/2006/main" xmlns:r="http://schemas.openxmlformats.org/officeDocument/2006/relationships">
+  <p:cSld>
+    <p:spTree>
+      <p:nvGrpSpPr>
+        <p:cNvPr id="1" name=""/>
+        <p:cNvGrpSpPr/>
+        <p:nvPr/>
+      </p:nvGrpSpPr>
+      <p:grpSpPr/>
+      <p:sp>
+        <p:nvSpPr>
+          <p:cNvPr id="2" name="Rectangle 1"/>
+          <p:cNvSpPr/>
+          <p:nvPr/>
+        </p:nvSpPr>
+        <p:spPr>
+          <a:xfrm>
+            <a:off x="0" y="0"/>
+            <a:ext cx="9144000" cy="5138928"/>
+          </a:xfrm>
+          <a:prstGeom prst="rect">
+            <a:avLst/>
+          </a:prstGeom>
+          <a:solidFill>
+            <a:srgbClr val="FAFBFC"/>
+          </a:solidFill>
+          <a:ln>
+            <a:noFill/>
+          </a:ln>
+          <a:effectLst/>
+        </p:spPr>
+        <p:style>
+          <a:lnRef idx="1">
+            <a:schemeClr val="accent1"/>
+          </a:lnRef>
+          <a:fillRef idx="3">
+            <a:schemeClr val="accent1"/>
+          </a:fillRef>
+          <a:effectRef idx="2">
+            <a:schemeClr val="accent1"/>
+          </a:effectRef>
+          <a:fontRef idx="minor">
+            <a:schemeClr val="lt1"/>
+          </a:fontRef>
+        </p:style>
+        <p:txBody>
+          <a:bodyPr rtlCol="0" anchor="ctr"/>
+          <a:lstStyle/>
+          <a:p>
+            <a:pPr algn="ctr"/>
+          </a:p>
+        </p:txBody>
+      </p:sp>
+      <p:sp>
+        <p:nvSpPr>
+          <p:cNvPr id="3" name="TextBox 2"/>
+          <p:cNvSpPr txBox="1"/>
+          <p:nvPr/>
+        </p:nvSpPr>
+        <p:spPr>
+          <a:xfrm>
+            <a:off x="402336" y="301752"/>
+            <a:ext cx="8348472" cy="795528"/>
+          </a:xfrm>
+          <a:prstGeom prst="rect">
+            <a:avLst/>
+          </a:prstGeom>
+          <a:noFill/>
+        </p:spPr>
+        <p:txBody>
+          <a:bodyPr wrap="square">
+            <a:spAutoFit/>
+          </a:bodyPr>
+          <a:lstStyle/>
+          <a:p>
+            <a:r>
+              <a:rPr sz="2800" b="1">
+                <a:solidFill>
+                  <a:srgbClr val="0F0F0F"/>
+                </a:solidFill>
+                <a:latin typeface="Fira Sans"/>
+              </a:rPr>
+              <a:t>Ahora: las presentaciones del avance</a:t>
+            </a:r>
+          </a:p>
+        </p:txBody>
+      </p:sp>
+      <p:sp>
+        <p:nvSpPr>
+          <p:cNvPr id="4" name="TextBox 3"/>
+          <p:cNvSpPr txBox="1"/>
+          <p:nvPr/>
+        </p:nvSpPr>
+        <p:spPr>
+          <a:xfrm>
+            <a:off x="704088" y="1353312"/>
+            <a:ext cx="7744968" cy="3300984"/>
+          </a:xfrm>
+          <a:prstGeom prst="rect">
+            <a:avLst/>
+          </a:prstGeom>
+          <a:noFill/>
+        </p:spPr>
+        <p:txBody>
+          <a:bodyPr wrap="square">
+            <a:spAutoFit/>
+          </a:bodyPr>
+          <a:lstStyle/>
+          <a:p>
+            <a:pPr>
+              <a:lnSpc>
+                <a:spcPct val="112000"/>
+              </a:lnSpc>
+              <a:spcAft>
+                <a:spcPts val="900"/>
+              </a:spcAft>
+            </a:pPr>
+            <a:r>
+              <a:rPr sz="1800" b="1">
+                <a:solidFill>
+                  <a:srgbClr val="E0A437"/>
+                </a:solidFill>
+                <a:latin typeface="Fira Sans"/>
+              </a:rPr>
+              <a:t>▸ </a:t>
+            </a:r>
+            <a:r>
+              <a:rPr sz="1800" b="1">
+                <a:solidFill>
+                  <a:srgbClr val="1D3557"/>
+                </a:solidFill>
+                <a:latin typeface="Fira Sans"/>
+              </a:rPr>
+              <a:t>Ocho equipos, en el orden en que se ofrezcan. Máximo 10 minutos por equipo; el tiempo se controla. Después, preguntas de la profesora y del curso.</a:t>
+            </a:r>
+          </a:p>
+          <a:p>
+            <a:pPr>
+              <a:lnSpc>
+                <a:spcPct val="112000"/>
+              </a:lnSpc>
+              <a:spcAft>
+                <a:spcPts val="900"/>
+              </a:spcAft>
+            </a:pPr>
+            <a:r>
+              <a:rPr sz="1800" b="1">
+                <a:solidFill>
+                  <a:srgbClr val="E0A437"/>
+                </a:solidFill>
+                <a:latin typeface="Fira Sans"/>
+              </a:rPr>
+              <a:t>▸ </a:t>
+            </a:r>
+            <a:r>
+              <a:rPr sz="1800" b="0">
+                <a:solidFill>
+                  <a:srgbClr val="000000"/>
+                </a:solidFill>
+                <a:latin typeface="Fira Sans"/>
+              </a:rPr>
+              <a:t>Se evalúa el avance, no un resultado final: el modelo es un primer intento. La exigencia está en el tiempo, la claridad, la explicación de los gráficos y las relaciones, y en advertir qué falta o qué no tiene sentido.</a:t>
+            </a:r>
+          </a:p>
+          <a:p>
+            <a:pPr>
+              <a:lnSpc>
+                <a:spcPct val="112000"/>
+              </a:lnSpc>
+              <a:spcAft>
+                <a:spcPts val="900"/>
+              </a:spcAft>
+            </a:pPr>
+            <a:r>
+              <a:rPr sz="1800" b="1">
+                <a:solidFill>
+                  <a:srgbClr val="E0A437"/>
+                </a:solidFill>
+                <a:latin typeface="Fira Sans"/>
+              </a:rPr>
+              <a:t>▸ </a:t>
+            </a:r>
+            <a:r>
+              <a:rPr sz="1800" b="0">
+                <a:solidFill>
+                  <a:srgbClr val="000000"/>
+                </a:solidFill>
+                <a:latin typeface="Fira Sans"/>
+              </a:rPr>
+              <a:t>Las slides, en PDF, al Aula hasta las 20:30: un envío por equipo con los nombres.</a:t>
+            </a:r>
+          </a:p>
+          <a:p>
+            <a:pPr>
+              <a:lnSpc>
+                <a:spcPct val="112000"/>
+              </a:lnSpc>
+              <a:spcAft>
+                <a:spcPts val="900"/>
+              </a:spcAft>
+            </a:pPr>
+            <a:r>
+              <a:rPr sz="1800" b="1">
+                <a:solidFill>
+                  <a:srgbClr val="E0A437"/>
+                </a:solidFill>
+                <a:latin typeface="Fira Sans"/>
+              </a:rPr>
+              <a:t>▸ </a:t>
+            </a:r>
+            <a:r>
+              <a:rPr sz="1800" b="0">
+                <a:solidFill>
+                  <a:srgbClr val="000000"/>
+                </a:solidFill>
+                <a:latin typeface="Fira Sans"/>
+              </a:rPr>
+              <a:t>El informe escrito, el viernes 25 de septiembre por el Aula: máximo 7 páginas, con su rúbrica publicada.</a:t>
+            </a:r>
+          </a:p>
+        </p:txBody>
+      </p:sp>
+    </p:spTree>
+  </p:cSld>
+  <p:clrMapOvr>
+    <a:masterClrMapping/>
+  </p:clrMapOvr>
+</p:sld>
+</file>
+
+<file path=ppt/slides/slide28.xml><?xml version="1.0" encoding="utf-8"?>
+<p:sld xmlns:a="http://schemas.openxmlformats.org/drawingml/2006/main" xmlns:p="http://schemas.openxmlformats.org/presentationml/2006/main" xmlns:r="http://schemas.openxmlformats.org/officeDocument/2006/relationships">
+  <p:cSld>
+    <p:spTree>
+      <p:nvGrpSpPr>
+        <p:cNvPr id="1" name=""/>
+        <p:cNvGrpSpPr/>
+        <p:nvPr/>
+      </p:nvGrpSpPr>
+      <p:grpSpPr/>
+      <p:sp>
+        <p:nvSpPr>
+          <p:cNvPr id="2" name="Rectangle 1"/>
+          <p:cNvSpPr/>
+          <p:nvPr/>
+        </p:nvSpPr>
+        <p:spPr>
+          <a:xfrm>
+            <a:off x="0" y="0"/>
+            <a:ext cx="9144000" cy="5138928"/>
+          </a:xfrm>
+          <a:prstGeom prst="rect">
+            <a:avLst/>
+          </a:prstGeom>
+          <a:solidFill>
+            <a:srgbClr val="FAFBFC"/>
+          </a:solidFill>
+          <a:ln>
+            <a:noFill/>
+          </a:ln>
+          <a:effectLst/>
+        </p:spPr>
+        <p:style>
+          <a:lnRef idx="1">
+            <a:schemeClr val="accent1"/>
+          </a:lnRef>
+          <a:fillRef idx="3">
+            <a:schemeClr val="accent1"/>
+          </a:fillRef>
+          <a:effectRef idx="2">
+            <a:schemeClr val="accent1"/>
+          </a:effectRef>
+          <a:fontRef idx="minor">
+            <a:schemeClr val="lt1"/>
+          </a:fontRef>
+        </p:style>
+        <p:txBody>
+          <a:bodyPr rtlCol="0" anchor="ctr"/>
+          <a:lstStyle/>
+          <a:p>
+            <a:pPr algn="ctr"/>
+          </a:p>
+        </p:txBody>
+      </p:sp>
+      <p:sp>
+        <p:nvSpPr>
+          <p:cNvPr id="3" name="TextBox 2"/>
+          <p:cNvSpPr txBox="1"/>
+          <p:nvPr/>
+        </p:nvSpPr>
+        <p:spPr>
+          <a:xfrm>
+            <a:off x="402336" y="301752"/>
+            <a:ext cx="8348472" cy="795528"/>
+          </a:xfrm>
+          <a:prstGeom prst="rect">
+            <a:avLst/>
+          </a:prstGeom>
+          <a:noFill/>
+        </p:spPr>
+        <p:txBody>
+          <a:bodyPr wrap="square">
+            <a:spAutoFit/>
+          </a:bodyPr>
+          <a:lstStyle/>
+          <a:p>
+            <a:r>
+              <a:rPr sz="2800" b="1">
+                <a:solidFill>
+                  <a:srgbClr val="0F0F0F"/>
+                </a:solidFill>
+                <a:latin typeface="Fira Sans"/>
+              </a:rPr>
               <a:t>Referencias</a:t>
             </a:r>
           </a:p>
@@ -7218,14 +7788,14 @@
                 </a:solidFill>
                 <a:latin typeface="Fira Sans"/>
               </a:rPr>
-              <a:t>Dos variables casi iguales: una sola dirección</a:t>
+              <a:t>Dos variables que dicen casi lo mismo</a:t>
             </a:r>
           </a:p>
         </p:txBody>
       </p:sp>
       <p:pic>
         <p:nvPicPr>
-          <p:cNvPr id="4" name="Picture 3" descr="c8_01_dos_variables.png"/>
+          <p:cNvPr id="4" name="Picture 3" descr="c8_00_dos_variables_crudas.png"/>
           <p:cNvPicPr>
             <a:picLocks noChangeAspect="1"/>
           </p:cNvPicPr>
@@ -7239,8 +7809,8 @@
         </p:blipFill>
         <p:spPr>
           <a:xfrm>
-            <a:off x="3086468" y="1143000"/>
-            <a:ext cx="2971062" cy="2587751"/>
+            <a:off x="411480" y="1143000"/>
+            <a:ext cx="4572000" cy="3178396"/>
           </a:xfrm>
           <a:prstGeom prst="rect">
             <a:avLst/>
@@ -7249,14 +7819,67 @@
       </p:pic>
       <p:sp>
         <p:nvSpPr>
-          <p:cNvPr id="5" name="TextBox 4"/>
+          <p:cNvPr id="5" name="Rectangle 4"/>
+          <p:cNvSpPr/>
+          <p:nvPr/>
+        </p:nvSpPr>
+        <p:spPr>
+          <a:xfrm>
+            <a:off x="5715000" y="1600200"/>
+            <a:ext cx="3063240" cy="1920240"/>
+          </a:xfrm>
+          <a:prstGeom prst="rect">
+            <a:avLst/>
+          </a:prstGeom>
+          <a:solidFill>
+            <a:srgbClr val="E0A437"/>
+          </a:solidFill>
+          <a:ln>
+            <a:noFill/>
+          </a:ln>
+          <a:effectLst/>
+        </p:spPr>
+        <p:style>
+          <a:lnRef idx="1">
+            <a:schemeClr val="accent1"/>
+          </a:lnRef>
+          <a:fillRef idx="3">
+            <a:schemeClr val="accent1"/>
+          </a:fillRef>
+          <a:effectRef idx="2">
+            <a:schemeClr val="accent1"/>
+          </a:effectRef>
+          <a:fontRef idx="minor">
+            <a:schemeClr val="lt1"/>
+          </a:fontRef>
+        </p:style>
+        <p:txBody>
+          <a:bodyPr rtlCol="0" anchor="ctr" wrap="square" lIns="182880" rIns="182880"/>
+          <a:lstStyle/>
+          <a:p>
+            <a:pPr algn="ctr"/>
+            <a:r>
+              <a:rPr sz="1900" b="1">
+                <a:solidFill>
+                  <a:srgbClr val="1D3557"/>
+                </a:solidFill>
+                <a:latin typeface="Fira Sans"/>
+              </a:rPr>
+              <a:t>¿Cuánto se pierde si las dos variables se reemplazan por una sola?</a:t>
+            </a:r>
+          </a:p>
+        </p:txBody>
+      </p:sp>
+      <p:sp>
+        <p:nvSpPr>
+          <p:cNvPr id="6" name="TextBox 5"/>
           <p:cNvSpPr txBox="1"/>
           <p:nvPr/>
         </p:nvSpPr>
         <p:spPr>
           <a:xfrm>
-            <a:off x="704088" y="3867912"/>
-            <a:ext cx="7744968" cy="1024128"/>
+            <a:off x="704088" y="4431123"/>
+            <a:ext cx="7744968" cy="731520"/>
           </a:xfrm>
           <a:prstGeom prst="rect">
             <a:avLst/>
@@ -7276,7 +7899,7 @@
                 </a:solidFill>
                 <a:latin typeface="Fira Sans"/>
               </a:rPr>
-              <a:t>Cada punto es un jugador, con sus turnos y hits de la carrera estandarizados. Los puntos se ordenan a lo largo de la flecha roja: la posición en esa dirección recoge el 99,8% de la variación, y la flecha azul, perpendicular, el 0,2% restante. Una variable nueva, la posición a lo largo de la flecha roja, reemplaza a las dos casi sin perder información.</a:t>
+              <a:t>Cada punto es un jugador, con sus turnos al bate y sus hits acumulados en la carrera. Correlación 0,995: los puntos siguen una diagonal y saber una variable es saber casi la otra.</a:t>
             </a:r>
           </a:p>
         </p:txBody>
@@ -7558,7 +8181,7 @@
                 </a:solidFill>
                 <a:latin typeface="Fira Sans"/>
               </a:rPr>
-              <a:t>Cada componente principal es una variable nueva: una suma ponderada de las variables originales, con un peso para cada una.</a:t>
+              <a:t>La primera componente es la dirección en que los datos más varían. La segunda, la que más varía entre las perpendiculares a la primera, y así hasta tener tantas componentes como variables.</a:t>
             </a:r>
           </a:p>
           <a:p>
@@ -7586,7 +8209,7 @@
                 </a:solidFill>
                 <a:latin typeface="Fira Sans"/>
               </a:rPr>
-              <a:t>La primera componente es la dirección en que los datos más varían. La segunda, la que más varía entre las perpendiculares a la primera, y así hasta tener tantas componentes como variables.</a:t>
+              <a:t>Cada componente es una variable nueva: un puntaje ponderado de las variables originales, con un peso para cada una.</a:t>
             </a:r>
           </a:p>
           <a:p>

</xml_diff>

<commit_message>
Clase 8: la idea de una componente en diez slides de una idea cada una (32 slides)
Revision de Daniela: el nombre 'componente' aparecia de golpe y la
definicion era un bloque de texto. La seccion 2 ahora construye el
concepto desde los mismos dos graficos: estandarizar, la diagonal, la
posicion de cada jugador sobre ella (tres jugadores marcados), cuanto se
conserva, el nombre, la cuenta del puntaje ponderado, la definicion con
su figura al lado, para que sirve, los pasos con 16 variables en un
esquema y por que se estandariza.

Co-Authored-By: Claude Fable 5.1 <noreply@anthropic.com>
</commit_message>
<xml_diff>
--- a/presentaciones/clase08_componentes_principales.pptx
+++ b/presentaciones/clase08_componentes_principales.pptx
@@ -33,6 +33,10 @@
     <p:sldId id="281" r:id="rId32"/>
     <p:sldId id="282" r:id="rId33"/>
     <p:sldId id="283" r:id="rId34"/>
+    <p:sldId id="284" r:id="rId35"/>
+    <p:sldId id="285" r:id="rId36"/>
+    <p:sldId id="286" r:id="rId37"/>
+    <p:sldId id="287" r:id="rId38"/>
   </p:sldIdLst>
   <p:sldSz cx="9144000" cy="5138928" type="screen4x3"/>
   <p:notesSz cx="6858000" cy="9144000"/>
@@ -3450,14 +3454,14 @@
                 </a:solidFill>
                 <a:latin typeface="Fira Sans"/>
               </a:rPr>
-              <a:t>La dirección en que los datos más varían</a:t>
+              <a:t>Los puntos siguen una recta: la diagonal</a:t>
             </a:r>
           </a:p>
         </p:txBody>
       </p:sp>
       <p:pic>
         <p:nvPicPr>
-          <p:cNvPr id="4" name="Picture 3" descr="c8_01_dos_variables.png"/>
+          <p:cNvPr id="4" name="Picture 3" descr="c8_00c_diagonal.png"/>
           <p:cNvPicPr>
             <a:picLocks noChangeAspect="1"/>
           </p:cNvPicPr>
@@ -3471,8 +3475,8 @@
         </p:blipFill>
         <p:spPr>
           <a:xfrm>
-            <a:off x="2282292" y="1143000"/>
-            <a:ext cx="4579414" cy="2331720"/>
+            <a:off x="3105399" y="1143000"/>
+            <a:ext cx="2933200" cy="3099815"/>
           </a:xfrm>
           <a:prstGeom prst="rect">
             <a:avLst/>
@@ -3487,8 +3491,8 @@
         </p:nvSpPr>
         <p:spPr>
           <a:xfrm>
-            <a:off x="704088" y="3611879"/>
-            <a:ext cx="7744968" cy="1280160"/>
+            <a:off x="704088" y="4379976"/>
+            <a:ext cx="7744968" cy="512064"/>
           </a:xfrm>
           <a:prstGeom prst="rect">
             <a:avLst/>
@@ -3508,7 +3512,7 @@
                 </a:solidFill>
                 <a:latin typeface="Fira Sans"/>
               </a:rPr>
-              <a:t>Los mismos jugadores, con las dos variables estandarizadas, y cuatro direcciones que pasan por el centro. Para cada una se mide cuánto se dispersan las posiciones de los puntos a lo largo de ella: 1,00 en la horizontal y en la vertical, 1,41 en la diagonal y 0,07 en su perpendicular. La diagonal gana: es la primera componente y recoge el 99,8% de la variación; su perpendicular es la segunda, con el 0,2%.</a:t>
+              <a:t>La recta pasa por el centro y sigue la nube de puntos. Es la dirección en que los jugadores se diferencian: hacia arriba y a la derecha, más carrera.</a:t>
             </a:r>
           </a:p>
         </p:txBody>
@@ -3604,14 +3608,14 @@
                 </a:solidFill>
                 <a:latin typeface="Fira Sans"/>
               </a:rPr>
-              <a:t>En la práctica: un puntaje ponderado por jugador</a:t>
+              <a:t>Cada jugador queda en un solo número</a:t>
             </a:r>
           </a:p>
         </p:txBody>
       </p:sp>
       <p:pic>
         <p:nvPicPr>
-          <p:cNvPr id="4" name="Picture 3" descr="c8_01b_puntaje_ponderado.png"/>
+          <p:cNvPr id="4" name="Picture 3" descr="c8_01a_proyeccion.png"/>
           <p:cNvPicPr>
             <a:picLocks noChangeAspect="1"/>
           </p:cNvPicPr>
@@ -3625,8 +3629,8 @@
         </p:blipFill>
         <p:spPr>
           <a:xfrm>
-            <a:off x="728851" y="1143000"/>
-            <a:ext cx="7686296" cy="2587752"/>
+            <a:off x="3152663" y="1143000"/>
+            <a:ext cx="2838672" cy="2843784"/>
           </a:xfrm>
           <a:prstGeom prst="rect">
             <a:avLst/>
@@ -3641,8 +3645,8 @@
         </p:nvSpPr>
         <p:spPr>
           <a:xfrm>
-            <a:off x="704088" y="3867912"/>
-            <a:ext cx="7744968" cy="1024128"/>
+            <a:off x="704088" y="4123944"/>
+            <a:ext cx="7744968" cy="768096"/>
           </a:xfrm>
           <a:prstGeom prst="rect">
             <a:avLst/>
@@ -3662,7 +3666,7 @@
                 </a:solidFill>
                 <a:latin typeface="Fira Sans"/>
               </a:rPr>
-              <a:t>Como el puntaje ponderado de la admisión universitaria: cada variable entra con un peso y sale un número por jugador, que es su valor en la componente. La diferencia es que aquí los pesos no los fija nadie: se calculan para que ese número separe a los jugadores lo más posible, con la condición de que los pesos al cuadrado sumen 1.</a:t>
+              <a:t>A cada jugador se le marca el punto más cercano de la diagonal. Su posición sobre ella es un solo número que reemplaza a sus dos valores: A queda en −1,60, B en −0,48 y C en 2,01. Lo que se pierde es la distancia del punto a la recta, que aquí es casi nula.</a:t>
             </a:r>
           </a:p>
         </p:txBody>
@@ -3758,21 +3762,45 @@
                 </a:solidFill>
                 <a:latin typeface="Fira Sans"/>
               </a:rPr>
-              <a:t>¿Para qué sirve?</a:t>
-            </a:r>
-          </a:p>
-        </p:txBody>
-      </p:sp>
-      <p:sp>
-        <p:nvSpPr>
-          <p:cNvPr id="4" name="TextBox 3"/>
+              <a:t>Cuánto se conserva y cuánto se pierde</a:t>
+            </a:r>
+          </a:p>
+        </p:txBody>
+      </p:sp>
+      <p:pic>
+        <p:nvPicPr>
+          <p:cNvPr id="4" name="Picture 3" descr="c8_01_dos_variables.png"/>
+          <p:cNvPicPr>
+            <a:picLocks noChangeAspect="1"/>
+          </p:cNvPicPr>
+          <p:nvPr/>
+        </p:nvPicPr>
+        <p:blipFill>
+          <a:blip r:embed="rId2"/>
+          <a:stretch>
+            <a:fillRect/>
+          </a:stretch>
+        </p:blipFill>
+        <p:spPr>
+          <a:xfrm>
+            <a:off x="1779455" y="1143000"/>
+            <a:ext cx="5585089" cy="2843784"/>
+          </a:xfrm>
+          <a:prstGeom prst="rect">
+            <a:avLst/>
+          </a:prstGeom>
+        </p:spPr>
+      </p:pic>
+      <p:sp>
+        <p:nvSpPr>
+          <p:cNvPr id="5" name="TextBox 4"/>
           <p:cNvSpPr txBox="1"/>
           <p:nvPr/>
         </p:nvSpPr>
         <p:spPr>
           <a:xfrm>
-            <a:off x="704088" y="1353312"/>
-            <a:ext cx="7744968" cy="3300984"/>
+            <a:off x="704088" y="4123944"/>
+            <a:ext cx="7744968" cy="768096"/>
           </a:xfrm>
           <a:prstGeom prst="rect">
             <a:avLst/>
@@ -3785,115 +3813,14 @@
           </a:bodyPr>
           <a:lstStyle/>
           <a:p>
-            <a:pPr>
-              <a:lnSpc>
-                <a:spcPct val="112000"/>
-              </a:lnSpc>
-              <a:spcAft>
-                <a:spcPts val="900"/>
-              </a:spcAft>
-            </a:pPr>
-            <a:r>
-              <a:rPr sz="1800" b="1">
-                <a:solidFill>
-                  <a:srgbClr val="E0A437"/>
-                </a:solidFill>
-                <a:latin typeface="Fira Sans"/>
-              </a:rPr>
-              <a:t>▸ </a:t>
-            </a:r>
-            <a:r>
-              <a:rPr sz="1800" b="1">
-                <a:solidFill>
-                  <a:srgbClr val="1D3557"/>
-                </a:solidFill>
-                <a:latin typeface="Fira Sans"/>
-              </a:rPr>
-              <a:t>Para mirar los datos: con 16 variables hay 120 gráficos de dispersión posibles; con dos componentes, uno solo.</a:t>
-            </a:r>
-          </a:p>
-          <a:p>
-            <a:pPr>
-              <a:lnSpc>
-                <a:spcPct val="112000"/>
-              </a:lnSpc>
-              <a:spcAft>
-                <a:spcPts val="900"/>
-              </a:spcAft>
-            </a:pPr>
-            <a:r>
-              <a:rPr sz="1800" b="1">
-                <a:solidFill>
-                  <a:srgbClr val="E0A437"/>
-                </a:solidFill>
-                <a:latin typeface="Fira Sans"/>
-              </a:rPr>
-              <a:t>▸ </a:t>
-            </a:r>
-            <a:r>
-              <a:rPr sz="1800" b="0">
-                <a:solidFill>
-                  <a:srgbClr val="000000"/>
-                </a:solidFill>
-                <a:latin typeface="Fira Sans"/>
-              </a:rPr>
-              <a:t>Para entregarle a un modelo menos entradas: las componentes reemplazan a un grupo de variables que se repiten (regresión sobre componentes principales).</a:t>
-            </a:r>
-          </a:p>
-          <a:p>
-            <a:pPr>
-              <a:lnSpc>
-                <a:spcPct val="112000"/>
-              </a:lnSpc>
-              <a:spcAft>
-                <a:spcPts val="900"/>
-              </a:spcAft>
-            </a:pPr>
-            <a:r>
-              <a:rPr sz="1800" b="1">
-                <a:solidFill>
-                  <a:srgbClr val="E0A437"/>
-                </a:solidFill>
-                <a:latin typeface="Fira Sans"/>
-              </a:rPr>
-              <a:t>▸ </a:t>
-            </a:r>
-            <a:r>
-              <a:rPr sz="1800" b="0">
-                <a:solidFill>
-                  <a:srgbClr val="000000"/>
-                </a:solidFill>
-                <a:latin typeface="Fira Sans"/>
-              </a:rPr>
-              <a:t>Para entender de qué está hecha la variación: qué variables se mueven juntas y cuánto pesa cada grupo.</a:t>
-            </a:r>
-          </a:p>
-          <a:p>
-            <a:pPr>
-              <a:lnSpc>
-                <a:spcPct val="112000"/>
-              </a:lnSpc>
-              <a:spcAft>
-                <a:spcPts val="900"/>
-              </a:spcAft>
-            </a:pPr>
-            <a:r>
-              <a:rPr sz="1800" b="1">
-                <a:solidFill>
-                  <a:srgbClr val="E0A437"/>
-                </a:solidFill>
-                <a:latin typeface="Fira Sans"/>
-              </a:rPr>
-              <a:t>▸ </a:t>
-            </a:r>
-            <a:r>
-              <a:rPr sz="1800" b="0">
-                <a:solidFill>
-                  <a:srgbClr val="000000"/>
-                </a:solidFill>
-                <a:latin typeface="Fira Sans"/>
-              </a:rPr>
-              <a:t>Lo que no hace: no elige variables ni las descarta, y no sabe qué se quiere predecir.</a:t>
+            <a:r>
+              <a:rPr sz="1300" b="0">
+                <a:solidFill>
+                  <a:srgbClr val="333333"/>
+                </a:solidFill>
+                <a:latin typeface="Fira Sans"/>
+              </a:rPr>
+              <a:t>Se mide con la dispersión de las posiciones a lo largo de cada dirección: 1,41 sobre la diagonal, casi toda la que hay, y 0,07 en su perpendicular. Quedarse con la posición sobre la diagonal conserva el 99,8% de la variación y pierde el 0,2%.</a:t>
             </a:r>
           </a:p>
         </p:txBody>
@@ -3989,21 +3916,45 @@
                 </a:solidFill>
                 <a:latin typeface="Fira Sans"/>
               </a:rPr>
-              <a:t>Cómo se construye, paso a paso</a:t>
-            </a:r>
-          </a:p>
-        </p:txBody>
-      </p:sp>
-      <p:sp>
-        <p:nvSpPr>
-          <p:cNvPr id="4" name="TextBox 3"/>
+              <a:t>La diagonal se llama primera componente</a:t>
+            </a:r>
+          </a:p>
+        </p:txBody>
+      </p:sp>
+      <p:pic>
+        <p:nvPicPr>
+          <p:cNvPr id="4" name="Picture 3" descr="c8_01c_componentes.png"/>
+          <p:cNvPicPr>
+            <a:picLocks noChangeAspect="1"/>
+          </p:cNvPicPr>
+          <p:nvPr/>
+        </p:nvPicPr>
+        <p:blipFill>
+          <a:blip r:embed="rId2"/>
+          <a:stretch>
+            <a:fillRect/>
+          </a:stretch>
+        </p:blipFill>
+        <p:spPr>
+          <a:xfrm>
+            <a:off x="2622002" y="1143000"/>
+            <a:ext cx="3899995" cy="3099816"/>
+          </a:xfrm>
+          <a:prstGeom prst="rect">
+            <a:avLst/>
+          </a:prstGeom>
+        </p:spPr>
+      </p:pic>
+      <p:sp>
+        <p:nvSpPr>
+          <p:cNvPr id="5" name="TextBox 4"/>
           <p:cNvSpPr txBox="1"/>
           <p:nvPr/>
         </p:nvSpPr>
         <p:spPr>
           <a:xfrm>
-            <a:off x="704088" y="1353312"/>
-            <a:ext cx="7744968" cy="3300984"/>
+            <a:off x="704088" y="4379976"/>
+            <a:ext cx="7744968" cy="512064"/>
           </a:xfrm>
           <a:prstGeom prst="rect">
             <a:avLst/>
@@ -4016,143 +3967,14 @@
           </a:bodyPr>
           <a:lstStyle/>
           <a:p>
-            <a:pPr>
-              <a:lnSpc>
-                <a:spcPct val="112000"/>
-              </a:lnSpc>
-              <a:spcAft>
-                <a:spcPts val="900"/>
-              </a:spcAft>
-            </a:pPr>
-            <a:r>
-              <a:rPr sz="1800" b="1">
-                <a:solidFill>
-                  <a:srgbClr val="E0A437"/>
-                </a:solidFill>
-                <a:latin typeface="Fira Sans"/>
-              </a:rPr>
-              <a:t>▸ </a:t>
-            </a:r>
-            <a:r>
-              <a:rPr sz="1800" b="1">
-                <a:solidFill>
-                  <a:srgbClr val="1D3557"/>
-                </a:solidFill>
-                <a:latin typeface="Fira Sans"/>
-              </a:rPr>
-              <a:t>Se estandariza cada variable: se le resta su media y se divide por su desviación estándar (el puntaje z de la clase 2).</a:t>
-            </a:r>
-          </a:p>
-          <a:p>
-            <a:pPr>
-              <a:lnSpc>
-                <a:spcPct val="112000"/>
-              </a:lnSpc>
-              <a:spcAft>
-                <a:spcPts val="900"/>
-              </a:spcAft>
-            </a:pPr>
-            <a:r>
-              <a:rPr sz="1800" b="1">
-                <a:solidFill>
-                  <a:srgbClr val="E0A437"/>
-                </a:solidFill>
-                <a:latin typeface="Fira Sans"/>
-              </a:rPr>
-              <a:t>▸ </a:t>
-            </a:r>
-            <a:r>
-              <a:rPr sz="1800" b="0">
-                <a:solidFill>
-                  <a:srgbClr val="000000"/>
-                </a:solidFill>
-                <a:latin typeface="Fira Sans"/>
-              </a:rPr>
-              <a:t>Cada jugador es un punto y el centro de la nube queda en el origen.</a:t>
-            </a:r>
-          </a:p>
-          <a:p>
-            <a:pPr>
-              <a:lnSpc>
-                <a:spcPct val="112000"/>
-              </a:lnSpc>
-              <a:spcAft>
-                <a:spcPts val="900"/>
-              </a:spcAft>
-            </a:pPr>
-            <a:r>
-              <a:rPr sz="1800" b="1">
-                <a:solidFill>
-                  <a:srgbClr val="E0A437"/>
-                </a:solidFill>
-                <a:latin typeface="Fira Sans"/>
-              </a:rPr>
-              <a:t>▸ </a:t>
-            </a:r>
-            <a:r>
-              <a:rPr sz="1800" b="0">
-                <a:solidFill>
-                  <a:srgbClr val="000000"/>
-                </a:solidFill>
-                <a:latin typeface="Fira Sans"/>
-              </a:rPr>
-              <a:t>Se busca la recta por el centro a lo largo de la cual los puntos están más dispersos (la diagonal roja de la figura): es la primera componente. El valor de cada jugador es su posición sobre esa recta.</a:t>
-            </a:r>
-          </a:p>
-          <a:p>
-            <a:pPr>
-              <a:lnSpc>
-                <a:spcPct val="112000"/>
-              </a:lnSpc>
-              <a:spcAft>
-                <a:spcPts val="900"/>
-              </a:spcAft>
-            </a:pPr>
-            <a:r>
-              <a:rPr sz="1800" b="1">
-                <a:solidFill>
-                  <a:srgbClr val="E0A437"/>
-                </a:solidFill>
-                <a:latin typeface="Fira Sans"/>
-              </a:rPr>
-              <a:t>▸ </a:t>
-            </a:r>
-            <a:r>
-              <a:rPr sz="1800" b="0">
-                <a:solidFill>
-                  <a:srgbClr val="000000"/>
-                </a:solidFill>
-                <a:latin typeface="Fira Sans"/>
-              </a:rPr>
-              <a:t>La perpendicular es la segunda componente; con más variables se sigue hasta tener tantas como variables.</a:t>
-            </a:r>
-          </a:p>
-          <a:p>
-            <a:pPr>
-              <a:lnSpc>
-                <a:spcPct val="112000"/>
-              </a:lnSpc>
-              <a:spcAft>
-                <a:spcPts val="900"/>
-              </a:spcAft>
-            </a:pPr>
-            <a:r>
-              <a:rPr sz="1800" b="1">
-                <a:solidFill>
-                  <a:srgbClr val="E0A437"/>
-                </a:solidFill>
-                <a:latin typeface="Fira Sans"/>
-              </a:rPr>
-              <a:t>▸ </a:t>
-            </a:r>
-            <a:r>
-              <a:rPr sz="1800" b="0">
-                <a:solidFill>
-                  <a:srgbClr val="000000"/>
-                </a:solidFill>
-                <a:latin typeface="Fira Sans"/>
-              </a:rPr>
-              <a:t>La variación total se reparte entre ellas: el porcentaje de cada una dice cuánto se conserva al quedarse con las primeras.</a:t>
+            <a:r>
+              <a:rPr sz="1300" b="0">
+                <a:solidFill>
+                  <a:srgbClr val="333333"/>
+                </a:solidFill>
+                <a:latin typeface="Fira Sans"/>
+              </a:rPr>
+              <a:t>Ninguna otra dirección conserva más variación que la diagonal: por eso se llama primera componente principal. Su perpendicular, la que conserva el resto, es la segunda.</a:t>
             </a:r>
           </a:p>
         </p:txBody>
@@ -4248,14 +4070,14 @@
                 </a:solidFill>
                 <a:latin typeface="Fira Sans"/>
               </a:rPr>
-              <a:t>Por qué se estandariza</a:t>
+              <a:t>En la práctica: un puntaje ponderado por jugador</a:t>
             </a:r>
           </a:p>
         </p:txBody>
       </p:sp>
       <p:pic>
         <p:nvPicPr>
-          <p:cNvPr id="4" name="Picture 3" descr="c8_02_estandarizar.png"/>
+          <p:cNvPr id="4" name="Picture 3" descr="c8_01b_puntaje_ponderado.png"/>
           <p:cNvPicPr>
             <a:picLocks noChangeAspect="1"/>
           </p:cNvPicPr>
@@ -4269,8 +4091,8 @@
         </p:blipFill>
         <p:spPr>
           <a:xfrm>
-            <a:off x="2421351" y="1143000"/>
-            <a:ext cx="4301297" cy="2331720"/>
+            <a:off x="699515" y="1261139"/>
+            <a:ext cx="7744968" cy="2607505"/>
           </a:xfrm>
           <a:prstGeom prst="rect">
             <a:avLst/>
@@ -4285,8 +4107,8 @@
         </p:nvSpPr>
         <p:spPr>
           <a:xfrm>
-            <a:off x="704088" y="3611879"/>
-            <a:ext cx="7744968" cy="1280160"/>
+            <a:off x="704088" y="4005804"/>
+            <a:ext cx="7744968" cy="768096"/>
           </a:xfrm>
           <a:prstGeom prst="rect">
             <a:avLst/>
@@ -4306,7 +4128,7 @@
                 </a:solidFill>
                 <a:latin typeface="Fira Sans"/>
               </a:rPr>
-              <a:t>Con las variables en sus unidades, la primera componente es casi solo turnos_carrera, porque su desviación estándar (2.287) es 476 veces la de temporadas (4,8): PCA sigue a la variable que más varía en sus unidades. Con cada variable estandarizada (media 0 y desviación 1, como en las clases 2 y 7) todas parten iguales. El libro recomienda estandarizar, salvo que las variables compartan unidad (James et al., 2013, p. 381).</a:t>
+              <a:t>La posición sobre la diagonal se calcula como un puntaje ponderado, igual que el de la admisión universitaria: cada variable entra con un peso y sale un número por jugador. Aquí los pesos no los fija nadie: se calculan para que ese número separe a los jugadores lo más posible.</a:t>
             </a:r>
           </a:p>
         </p:txBody>
@@ -4344,7 +4166,7 @@
             <a:avLst/>
           </a:prstGeom>
           <a:solidFill>
-            <a:srgbClr val="1D3557"/>
+            <a:srgbClr val="FAFBFC"/>
           </a:solidFill>
           <a:ln>
             <a:noFill/>
@@ -4381,8 +4203,8 @@
         </p:nvSpPr>
         <p:spPr>
           <a:xfrm>
-            <a:off x="603504" y="1847088"/>
-            <a:ext cx="7946136" cy="1399032"/>
+            <a:off x="402336" y="301752"/>
+            <a:ext cx="8348472" cy="795528"/>
           </a:xfrm>
           <a:prstGeom prst="rect">
             <a:avLst/>
@@ -4396,28 +4218,148 @@
           <a:lstStyle/>
           <a:p>
             <a:r>
-              <a:rPr sz="3400" b="1">
-                <a:solidFill>
-                  <a:srgbClr val="FFFFFF"/>
-                </a:solidFill>
-                <a:latin typeface="Fira Sans"/>
-              </a:rPr>
-              <a:t>3. Cómo se leen</a:t>
-            </a:r>
-          </a:p>
-          <a:p>
-            <a:r>
-              <a:rPr sz="1800" b="0">
+              <a:rPr sz="2800" b="1">
+                <a:solidFill>
+                  <a:srgbClr val="0F0F0F"/>
+                </a:solidFill>
+                <a:latin typeface="Fira Sans"/>
+              </a:rPr>
+              <a:t>El análisis de componentes principales</a:t>
+            </a:r>
+          </a:p>
+        </p:txBody>
+      </p:sp>
+      <p:sp>
+        <p:nvSpPr>
+          <p:cNvPr id="4" name="TextBox 3"/>
+          <p:cNvSpPr txBox="1"/>
+          <p:nvPr/>
+        </p:nvSpPr>
+        <p:spPr>
+          <a:xfrm>
+            <a:off x="502920" y="1252728"/>
+            <a:ext cx="4023360" cy="3200400"/>
+          </a:xfrm>
+          <a:prstGeom prst="rect">
+            <a:avLst/>
+          </a:prstGeom>
+          <a:noFill/>
+        </p:spPr>
+        <p:txBody>
+          <a:bodyPr wrap="square">
+            <a:spAutoFit/>
+          </a:bodyPr>
+          <a:lstStyle/>
+          <a:p>
+            <a:pPr>
+              <a:lnSpc>
+                <a:spcPct val="112000"/>
+              </a:lnSpc>
+              <a:spcAft>
+                <a:spcPts val="900"/>
+              </a:spcAft>
+            </a:pPr>
+            <a:r>
+              <a:rPr sz="1500" b="1">
                 <a:solidFill>
                   <a:srgbClr val="E0A437"/>
                 </a:solidFill>
                 <a:latin typeface="Fira Sans"/>
               </a:rPr>
-              <a:t>Cuánta variación explica cada componente y de qué está hecha</a:t>
-            </a:r>
-          </a:p>
-        </p:txBody>
-      </p:sp>
+              <a:t>▸ </a:t>
+            </a:r>
+            <a:r>
+              <a:rPr sz="1500" b="1">
+                <a:solidFill>
+                  <a:srgbClr val="1D3557"/>
+                </a:solidFill>
+                <a:latin typeface="Fira Sans"/>
+              </a:rPr>
+              <a:t>Busca la dirección en que los datos más se dispersan (la primera componente), luego la que más se dispersa entre las perpendiculares (la segunda), y así hasta tener tantas como variables.</a:t>
+            </a:r>
+          </a:p>
+          <a:p>
+            <a:pPr>
+              <a:lnSpc>
+                <a:spcPct val="112000"/>
+              </a:lnSpc>
+              <a:spcAft>
+                <a:spcPts val="900"/>
+              </a:spcAft>
+            </a:pPr>
+            <a:r>
+              <a:rPr sz="1500" b="1">
+                <a:solidFill>
+                  <a:srgbClr val="E0A437"/>
+                </a:solidFill>
+                <a:latin typeface="Fira Sans"/>
+              </a:rPr>
+              <a:t>▸ </a:t>
+            </a:r>
+            <a:r>
+              <a:rPr sz="1500" b="0">
+                <a:solidFill>
+                  <a:srgbClr val="000000"/>
+                </a:solidFill>
+                <a:latin typeface="Fira Sans"/>
+              </a:rPr>
+              <a:t>Cada componente es una variable nueva: un puntaje ponderado de las originales, con una parte de la variación total.</a:t>
+            </a:r>
+          </a:p>
+          <a:p>
+            <a:pPr>
+              <a:lnSpc>
+                <a:spcPct val="112000"/>
+              </a:lnSpc>
+              <a:spcAft>
+                <a:spcPts val="900"/>
+              </a:spcAft>
+            </a:pPr>
+            <a:r>
+              <a:rPr sz="1500" b="1">
+                <a:solidFill>
+                  <a:srgbClr val="E0A437"/>
+                </a:solidFill>
+                <a:latin typeface="Fira Sans"/>
+              </a:rPr>
+              <a:t>▸ </a:t>
+            </a:r>
+            <a:r>
+              <a:rPr sz="1500" b="0">
+                <a:solidFill>
+                  <a:srgbClr val="000000"/>
+                </a:solidFill>
+                <a:latin typeface="Fira Sans"/>
+              </a:rPr>
+              <a:t>No usa ninguna respuesta Y: es un método no supervisado (James et al., 2013, p. 375).</a:t>
+            </a:r>
+          </a:p>
+        </p:txBody>
+      </p:sp>
+      <p:pic>
+        <p:nvPicPr>
+          <p:cNvPr id="5" name="Picture 4" descr="c8_01c_componentes.png"/>
+          <p:cNvPicPr>
+            <a:picLocks noChangeAspect="1"/>
+          </p:cNvPicPr>
+          <p:nvPr/>
+        </p:nvPicPr>
+        <p:blipFill>
+          <a:blip r:embed="rId2"/>
+          <a:stretch>
+            <a:fillRect/>
+          </a:stretch>
+        </p:blipFill>
+        <p:spPr>
+          <a:xfrm>
+            <a:off x="4892040" y="1371600"/>
+            <a:ext cx="3840480" cy="3052511"/>
+          </a:xfrm>
+          <a:prstGeom prst="rect">
+            <a:avLst/>
+          </a:prstGeom>
+        </p:spPr>
+      </p:pic>
     </p:spTree>
   </p:cSld>
   <p:clrMapOvr>
@@ -4509,45 +4451,21 @@
                 </a:solidFill>
                 <a:latin typeface="Fira Sans"/>
               </a:rPr>
-              <a:t>Cuánta variación explica cada componente</a:t>
-            </a:r>
-          </a:p>
-        </p:txBody>
-      </p:sp>
-      <p:pic>
-        <p:nvPicPr>
-          <p:cNvPr id="4" name="Picture 3" descr="c8_03_scree.png"/>
-          <p:cNvPicPr>
-            <a:picLocks noChangeAspect="1"/>
-          </p:cNvPicPr>
-          <p:nvPr/>
-        </p:nvPicPr>
-        <p:blipFill>
-          <a:blip r:embed="rId2"/>
-          <a:stretch>
-            <a:fillRect/>
-          </a:stretch>
-        </p:blipFill>
-        <p:spPr>
-          <a:xfrm>
-            <a:off x="2337301" y="1143000"/>
-            <a:ext cx="4469397" cy="2587752"/>
-          </a:xfrm>
-          <a:prstGeom prst="rect">
-            <a:avLst/>
-          </a:prstGeom>
-        </p:spPr>
-      </p:pic>
-      <p:sp>
-        <p:nvSpPr>
-          <p:cNvPr id="5" name="TextBox 4"/>
+              <a:t>¿Para qué sirve?</a:t>
+            </a:r>
+          </a:p>
+        </p:txBody>
+      </p:sp>
+      <p:sp>
+        <p:nvSpPr>
+          <p:cNvPr id="4" name="TextBox 3"/>
           <p:cNvSpPr txBox="1"/>
           <p:nvPr/>
         </p:nvSpPr>
         <p:spPr>
           <a:xfrm>
-            <a:off x="704088" y="3867912"/>
-            <a:ext cx="7744968" cy="1024128"/>
+            <a:off x="704088" y="1353312"/>
+            <a:ext cx="7744968" cy="3300984"/>
           </a:xfrm>
           <a:prstGeom prst="rect">
             <a:avLst/>
@@ -4560,14 +4478,115 @@
           </a:bodyPr>
           <a:lstStyle/>
           <a:p>
-            <a:r>
-              <a:rPr sz="1300" b="0">
-                <a:solidFill>
-                  <a:srgbClr val="333333"/>
-                </a:solidFill>
-                <a:latin typeface="Fira Sans"/>
-              </a:rPr>
-              <a:t>La primera componente explica el 45,3% de la variación de las 16 variables; la segunda, el 25,7%; la tercera, el 10,8%. Dos componentes reúnen el 71% y tres, el 82%. Para decidir cuántas conservar, el libro sugiere mirar dónde la curva deja de caer (el codo) y advierte que no hay una regla objetiva: depende del uso (James et al., 2013, p. 384).</a:t>
+            <a:pPr>
+              <a:lnSpc>
+                <a:spcPct val="112000"/>
+              </a:lnSpc>
+              <a:spcAft>
+                <a:spcPts val="900"/>
+              </a:spcAft>
+            </a:pPr>
+            <a:r>
+              <a:rPr sz="1800" b="1">
+                <a:solidFill>
+                  <a:srgbClr val="E0A437"/>
+                </a:solidFill>
+                <a:latin typeface="Fira Sans"/>
+              </a:rPr>
+              <a:t>▸ </a:t>
+            </a:r>
+            <a:r>
+              <a:rPr sz="1800" b="1">
+                <a:solidFill>
+                  <a:srgbClr val="1D3557"/>
+                </a:solidFill>
+                <a:latin typeface="Fira Sans"/>
+              </a:rPr>
+              <a:t>Para mirar los datos: con 16 variables hay 120 gráficos de dispersión posibles; con dos componentes, uno solo.</a:t>
+            </a:r>
+          </a:p>
+          <a:p>
+            <a:pPr>
+              <a:lnSpc>
+                <a:spcPct val="112000"/>
+              </a:lnSpc>
+              <a:spcAft>
+                <a:spcPts val="900"/>
+              </a:spcAft>
+            </a:pPr>
+            <a:r>
+              <a:rPr sz="1800" b="1">
+                <a:solidFill>
+                  <a:srgbClr val="E0A437"/>
+                </a:solidFill>
+                <a:latin typeface="Fira Sans"/>
+              </a:rPr>
+              <a:t>▸ </a:t>
+            </a:r>
+            <a:r>
+              <a:rPr sz="1800" b="0">
+                <a:solidFill>
+                  <a:srgbClr val="000000"/>
+                </a:solidFill>
+                <a:latin typeface="Fira Sans"/>
+              </a:rPr>
+              <a:t>Para entregarle a un modelo menos entradas: las componentes reemplazan a un grupo de variables que se repiten.</a:t>
+            </a:r>
+          </a:p>
+          <a:p>
+            <a:pPr>
+              <a:lnSpc>
+                <a:spcPct val="112000"/>
+              </a:lnSpc>
+              <a:spcAft>
+                <a:spcPts val="900"/>
+              </a:spcAft>
+            </a:pPr>
+            <a:r>
+              <a:rPr sz="1800" b="1">
+                <a:solidFill>
+                  <a:srgbClr val="E0A437"/>
+                </a:solidFill>
+                <a:latin typeface="Fira Sans"/>
+              </a:rPr>
+              <a:t>▸ </a:t>
+            </a:r>
+            <a:r>
+              <a:rPr sz="1800" b="0">
+                <a:solidFill>
+                  <a:srgbClr val="000000"/>
+                </a:solidFill>
+                <a:latin typeface="Fira Sans"/>
+              </a:rPr>
+              <a:t>Para entender de qué está hecha la variación: qué variables se mueven juntas y cuánto pesa cada grupo.</a:t>
+            </a:r>
+          </a:p>
+          <a:p>
+            <a:pPr>
+              <a:lnSpc>
+                <a:spcPct val="112000"/>
+              </a:lnSpc>
+              <a:spcAft>
+                <a:spcPts val="900"/>
+              </a:spcAft>
+            </a:pPr>
+            <a:r>
+              <a:rPr sz="1800" b="1">
+                <a:solidFill>
+                  <a:srgbClr val="E0A437"/>
+                </a:solidFill>
+                <a:latin typeface="Fira Sans"/>
+              </a:rPr>
+              <a:t>▸ </a:t>
+            </a:r>
+            <a:r>
+              <a:rPr sz="1800" b="0">
+                <a:solidFill>
+                  <a:srgbClr val="000000"/>
+                </a:solidFill>
+                <a:latin typeface="Fira Sans"/>
+              </a:rPr>
+              <a:t>Lo que no hace: no elige variables ni las descarta, y no sabe qué se quiere predecir.</a:t>
             </a:r>
           </a:p>
         </p:txBody>
@@ -4663,14 +4682,14 @@
                 </a:solidFill>
                 <a:latin typeface="Fira Sans"/>
               </a:rPr>
-              <a:t>De qué está hecha cada componente: los pesos</a:t>
+              <a:t>Con 16 variables, los mismos pasos</a:t>
             </a:r>
           </a:p>
         </p:txBody>
       </p:sp>
       <p:pic>
         <p:nvPicPr>
-          <p:cNvPr id="4" name="Picture 3" descr="c8_04_pesos.png"/>
+          <p:cNvPr id="4" name="Picture 3" descr="c8_08_pasos.png"/>
           <p:cNvPicPr>
             <a:picLocks noChangeAspect="1"/>
           </p:cNvPicPr>
@@ -4684,8 +4703,8 @@
         </p:blipFill>
         <p:spPr>
           <a:xfrm>
-            <a:off x="2196563" y="1143000"/>
-            <a:ext cx="4750872" cy="2587752"/>
+            <a:off x="699515" y="1531946"/>
+            <a:ext cx="7744968" cy="2065892"/>
           </a:xfrm>
           <a:prstGeom prst="rect">
             <a:avLst/>
@@ -4700,8 +4719,8 @@
         </p:nvSpPr>
         <p:spPr>
           <a:xfrm>
-            <a:off x="704088" y="3867912"/>
-            <a:ext cx="7744968" cy="1024128"/>
+            <a:off x="704088" y="3734997"/>
+            <a:ext cx="7744968" cy="768096"/>
           </a:xfrm>
           <a:prstGeom prst="rect">
             <a:avLst/>
@@ -4721,7 +4740,7 @@
                 </a:solidFill>
                 <a:latin typeface="Fira Sans"/>
               </a:rPr>
-              <a:t>Primera componente: las siete variables de la carrera pesan casi lo mismo (0,29 a 0,34), las de la temporada la mitad (0,19 a 0,23) y la defensa no cuenta: mide cuánta carrera lleva el jugador. Segunda componente: la temporada 1986 pesa positivo (0,24 a 0,39) y la carrera negativo (−0,12 a −0,26): separa a quien rindió este año más de lo que dice su carrera.</a:t>
+              <a:t>Con 16 variables la nube no se puede dibujar, pero el cálculo es el mismo: cada jugador es un punto con 16 coordenadas, se busca la dirección de mayor dispersión, luego la perpendicular que más se dispersa, y así hasta tener 16 componentes, ordenadas de la que más variación conserva a la que menos.</a:t>
             </a:r>
           </a:p>
         </p:txBody>
@@ -4817,14 +4836,14 @@
                 </a:solidFill>
                 <a:latin typeface="Fira Sans"/>
               </a:rPr>
-              <a:t>Los 263 jugadores en dos componentes</a:t>
+              <a:t>Por qué se estandariza</a:t>
             </a:r>
           </a:p>
         </p:txBody>
       </p:sp>
       <p:pic>
         <p:nvPicPr>
-          <p:cNvPr id="4" name="Picture 3" descr="c8_05_jugadores.png"/>
+          <p:cNvPr id="4" name="Picture 3" descr="c8_02_estandarizar.png"/>
           <p:cNvPicPr>
             <a:picLocks noChangeAspect="1"/>
           </p:cNvPicPr>
@@ -4838,8 +4857,8 @@
         </p:blipFill>
         <p:spPr>
           <a:xfrm>
-            <a:off x="2699826" y="1143000"/>
-            <a:ext cx="3744346" cy="2587751"/>
+            <a:off x="2421351" y="1143000"/>
+            <a:ext cx="4301297" cy="2331720"/>
           </a:xfrm>
           <a:prstGeom prst="rect">
             <a:avLst/>
@@ -4854,8 +4873,8 @@
         </p:nvSpPr>
         <p:spPr>
           <a:xfrm>
-            <a:off x="704088" y="3867912"/>
-            <a:ext cx="7744968" cy="1024128"/>
+            <a:off x="704088" y="3611879"/>
+            <a:ext cx="7744968" cy="1280160"/>
           </a:xfrm>
           <a:prstGeom prst="rect">
             <a:avLst/>
@@ -4875,7 +4894,7 @@
                 </a:solidFill>
                 <a:latin typeface="Fira Sans"/>
               </a:rPr>
-              <a:t>Cada punto es un jugador y el color, su salario de 1987, que PCA no usó. El salario crece hacia la derecha (correlación 0,64 con la primera componente) y casi nada hacia arriba (0,11 con la segunda): la carrera pesa en el salario; la última temporada, poco. Dos ejes muestran lo que en 16 variables había que leer coeficiente por coeficiente.</a:t>
+              <a:t>Con las variables en sus unidades, la primera componente es casi solo turnos_carrera, porque su desviación estándar (2.287) es 476 veces la de temporadas (4,8): PCA sigue a la variable que más varía en sus unidades. Con cada variable estandarizada (media 0 y desviación 1, como en las clases 2 y 7) todas parten iguales. El libro recomienda estandarizar, salvo que las variables compartan unidad (James et al., 2013, p. 381).</a:t>
             </a:r>
           </a:p>
         </p:txBody>
@@ -4913,7 +4932,7 @@
             <a:avLst/>
           </a:prstGeom>
           <a:solidFill>
-            <a:srgbClr val="FAFBFC"/>
+            <a:srgbClr val="1D3557"/>
           </a:solidFill>
           <a:ln>
             <a:noFill/>
@@ -4950,8 +4969,8 @@
         </p:nvSpPr>
         <p:spPr>
           <a:xfrm>
-            <a:off x="402336" y="301752"/>
-            <a:ext cx="8348472" cy="795528"/>
+            <a:off x="603504" y="1847088"/>
+            <a:ext cx="7946136" cy="1399032"/>
           </a:xfrm>
           <a:prstGeom prst="rect">
             <a:avLst/>
@@ -4965,71 +4984,24 @@
           <a:lstStyle/>
           <a:p>
             <a:r>
-              <a:rPr sz="2800" b="1">
-                <a:solidFill>
-                  <a:srgbClr val="0F0F0F"/>
-                </a:solidFill>
-                <a:latin typeface="Fira Sans"/>
-              </a:rPr>
-              <a:t>El mismo cálculo con las flores de la clase 2</a:t>
-            </a:r>
-          </a:p>
-        </p:txBody>
-      </p:sp>
-      <p:pic>
-        <p:nvPicPr>
-          <p:cNvPr id="4" name="Picture 3" descr="c8_06_iris.png"/>
-          <p:cNvPicPr>
-            <a:picLocks noChangeAspect="1"/>
-          </p:cNvPicPr>
-          <p:nvPr/>
-        </p:nvPicPr>
-        <p:blipFill>
-          <a:blip r:embed="rId2"/>
-          <a:stretch>
-            <a:fillRect/>
-          </a:stretch>
-        </p:blipFill>
-        <p:spPr>
-          <a:xfrm>
-            <a:off x="2906606" y="1143000"/>
-            <a:ext cx="3330786" cy="2587751"/>
-          </a:xfrm>
-          <a:prstGeom prst="rect">
-            <a:avLst/>
-          </a:prstGeom>
-        </p:spPr>
-      </p:pic>
-      <p:sp>
-        <p:nvSpPr>
-          <p:cNvPr id="5" name="TextBox 4"/>
-          <p:cNvSpPr txBox="1"/>
-          <p:nvPr/>
-        </p:nvSpPr>
-        <p:spPr>
-          <a:xfrm>
-            <a:off x="704088" y="3867912"/>
-            <a:ext cx="7744968" cy="1024128"/>
-          </a:xfrm>
-          <a:prstGeom prst="rect">
-            <a:avLst/>
-          </a:prstGeom>
-          <a:noFill/>
-        </p:spPr>
-        <p:txBody>
-          <a:bodyPr wrap="square">
-            <a:spAutoFit/>
-          </a:bodyPr>
-          <a:lstStyle/>
-          <a:p>
-            <a:r>
-              <a:rPr sz="1300" b="0">
-                <a:solidFill>
-                  <a:srgbClr val="333333"/>
-                </a:solidFill>
-                <a:latin typeface="Fira Sans"/>
-              </a:rPr>
-              <a:t>Las cuatro medidas de iris se resumen en dos componentes que reúnen el 96% de la variación. La primera (73%) pesa casi igual el largo y el ancho del pétalo y el largo del sépalo (0,52 a 0,58): el tamaño de la flor. La segunda (23%) es casi solo el ancho del sépalo (0,92). PCA no conoce la especie y aun así las tres quedan separadas a lo largo de la primera componente.</a:t>
+              <a:rPr sz="3400" b="1">
+                <a:solidFill>
+                  <a:srgbClr val="FFFFFF"/>
+                </a:solidFill>
+                <a:latin typeface="Fira Sans"/>
+              </a:rPr>
+              <a:t>3. Cómo se leen</a:t>
+            </a:r>
+          </a:p>
+          <a:p>
+            <a:r>
+              <a:rPr sz="1800" b="0">
+                <a:solidFill>
+                  <a:srgbClr val="E0A437"/>
+                </a:solidFill>
+                <a:latin typeface="Fira Sans"/>
+              </a:rPr>
+              <a:t>Cuánta variación explica cada componente y de qué está hecha</a:t>
             </a:r>
           </a:p>
         </p:txBody>
@@ -5298,7 +5270,7 @@
             <a:avLst/>
           </a:prstGeom>
           <a:solidFill>
-            <a:srgbClr val="1D3557"/>
+            <a:srgbClr val="FAFBFC"/>
           </a:solidFill>
           <a:ln>
             <a:noFill/>
@@ -5335,8 +5307,8 @@
         </p:nvSpPr>
         <p:spPr>
           <a:xfrm>
-            <a:off x="603504" y="1847088"/>
-            <a:ext cx="7946136" cy="1399032"/>
+            <a:off x="402336" y="301752"/>
+            <a:ext cx="8348472" cy="795528"/>
           </a:xfrm>
           <a:prstGeom prst="rect">
             <a:avLst/>
@@ -5350,24 +5322,71 @@
           <a:lstStyle/>
           <a:p>
             <a:r>
-              <a:rPr sz="3400" b="1">
-                <a:solidFill>
-                  <a:srgbClr val="FFFFFF"/>
-                </a:solidFill>
-                <a:latin typeface="Fira Sans"/>
-              </a:rPr>
-              <a:t>4. Cuándo</a:t>
-            </a:r>
-          </a:p>
-          <a:p>
-            <a:r>
-              <a:rPr sz="1800" b="0">
-                <a:solidFill>
-                  <a:srgbClr val="E0A437"/>
-                </a:solidFill>
-                <a:latin typeface="Fira Sans"/>
-              </a:rPr>
-              <a:t>Cuándo conviene y cuándo no</a:t>
+              <a:rPr sz="2800" b="1">
+                <a:solidFill>
+                  <a:srgbClr val="0F0F0F"/>
+                </a:solidFill>
+                <a:latin typeface="Fira Sans"/>
+              </a:rPr>
+              <a:t>Cuánta variación explica cada componente</a:t>
+            </a:r>
+          </a:p>
+        </p:txBody>
+      </p:sp>
+      <p:pic>
+        <p:nvPicPr>
+          <p:cNvPr id="4" name="Picture 3" descr="c8_03_scree.png"/>
+          <p:cNvPicPr>
+            <a:picLocks noChangeAspect="1"/>
+          </p:cNvPicPr>
+          <p:nvPr/>
+        </p:nvPicPr>
+        <p:blipFill>
+          <a:blip r:embed="rId2"/>
+          <a:stretch>
+            <a:fillRect/>
+          </a:stretch>
+        </p:blipFill>
+        <p:spPr>
+          <a:xfrm>
+            <a:off x="2337301" y="1143000"/>
+            <a:ext cx="4469397" cy="2587752"/>
+          </a:xfrm>
+          <a:prstGeom prst="rect">
+            <a:avLst/>
+          </a:prstGeom>
+        </p:spPr>
+      </p:pic>
+      <p:sp>
+        <p:nvSpPr>
+          <p:cNvPr id="5" name="TextBox 4"/>
+          <p:cNvSpPr txBox="1"/>
+          <p:nvPr/>
+        </p:nvSpPr>
+        <p:spPr>
+          <a:xfrm>
+            <a:off x="704088" y="3867912"/>
+            <a:ext cx="7744968" cy="1024128"/>
+          </a:xfrm>
+          <a:prstGeom prst="rect">
+            <a:avLst/>
+          </a:prstGeom>
+          <a:noFill/>
+        </p:spPr>
+        <p:txBody>
+          <a:bodyPr wrap="square">
+            <a:spAutoFit/>
+          </a:bodyPr>
+          <a:lstStyle/>
+          <a:p>
+            <a:r>
+              <a:rPr sz="1300" b="0">
+                <a:solidFill>
+                  <a:srgbClr val="333333"/>
+                </a:solidFill>
+                <a:latin typeface="Fira Sans"/>
+              </a:rPr>
+              <a:t>La primera componente explica el 45,3% de la variación de las 16 variables; la segunda, el 25,7%; la tercera, el 10,8%. Dos componentes reúnen el 71% y tres, el 82%. Para decidir cuántas conservar, el libro sugiere mirar dónde la curva deja de caer (el codo) y advierte que no hay una regla objetiva: depende del uso (James et al., 2013, p. 384).</a:t>
             </a:r>
           </a:p>
         </p:txBody>
@@ -5463,21 +5482,45 @@
                 </a:solidFill>
                 <a:latin typeface="Fira Sans"/>
               </a:rPr>
-              <a:t>¿Cuándo conviene?</a:t>
-            </a:r>
-          </a:p>
-        </p:txBody>
-      </p:sp>
-      <p:sp>
-        <p:nvSpPr>
-          <p:cNvPr id="4" name="TextBox 3"/>
+              <a:t>De qué está hecha cada componente: los pesos</a:t>
+            </a:r>
+          </a:p>
+        </p:txBody>
+      </p:sp>
+      <p:pic>
+        <p:nvPicPr>
+          <p:cNvPr id="4" name="Picture 3" descr="c8_04_pesos.png"/>
+          <p:cNvPicPr>
+            <a:picLocks noChangeAspect="1"/>
+          </p:cNvPicPr>
+          <p:nvPr/>
+        </p:nvPicPr>
+        <p:blipFill>
+          <a:blip r:embed="rId2"/>
+          <a:stretch>
+            <a:fillRect/>
+          </a:stretch>
+        </p:blipFill>
+        <p:spPr>
+          <a:xfrm>
+            <a:off x="2196563" y="1143000"/>
+            <a:ext cx="4750872" cy="2587752"/>
+          </a:xfrm>
+          <a:prstGeom prst="rect">
+            <a:avLst/>
+          </a:prstGeom>
+        </p:spPr>
+      </p:pic>
+      <p:sp>
+        <p:nvSpPr>
+          <p:cNvPr id="5" name="TextBox 4"/>
           <p:cNvSpPr txBox="1"/>
           <p:nvPr/>
         </p:nvSpPr>
         <p:spPr>
           <a:xfrm>
-            <a:off x="704088" y="1353312"/>
-            <a:ext cx="7744968" cy="3300984"/>
+            <a:off x="704088" y="3867912"/>
+            <a:ext cx="7744968" cy="1024128"/>
           </a:xfrm>
           <a:prstGeom prst="rect">
             <a:avLst/>
@@ -5490,87 +5533,14 @@
           </a:bodyPr>
           <a:lstStyle/>
           <a:p>
-            <a:pPr>
-              <a:lnSpc>
-                <a:spcPct val="112000"/>
-              </a:lnSpc>
-              <a:spcAft>
-                <a:spcPts val="900"/>
-              </a:spcAft>
-            </a:pPr>
-            <a:r>
-              <a:rPr sz="1800" b="1">
-                <a:solidFill>
-                  <a:srgbClr val="E0A437"/>
-                </a:solidFill>
-                <a:latin typeface="Fira Sans"/>
-              </a:rPr>
-              <a:t>▸ </a:t>
-            </a:r>
-            <a:r>
-              <a:rPr sz="1800" b="1">
-                <a:solidFill>
-                  <a:srgbClr val="1D3557"/>
-                </a:solidFill>
-                <a:latin typeface="Fira Sans"/>
-              </a:rPr>
-              <a:t>Con muchas variables numéricas que se correlacionan en bloques, como en la matriz de la clase 7.</a:t>
-            </a:r>
-          </a:p>
-          <a:p>
-            <a:pPr>
-              <a:lnSpc>
-                <a:spcPct val="112000"/>
-              </a:lnSpc>
-              <a:spcAft>
-                <a:spcPts val="900"/>
-              </a:spcAft>
-            </a:pPr>
-            <a:r>
-              <a:rPr sz="1800" b="1">
-                <a:solidFill>
-                  <a:srgbClr val="E0A437"/>
-                </a:solidFill>
-                <a:latin typeface="Fira Sans"/>
-              </a:rPr>
-              <a:t>▸ </a:t>
-            </a:r>
-            <a:r>
-              <a:rPr sz="1800" b="0">
-                <a:solidFill>
-                  <a:srgbClr val="000000"/>
-                </a:solidFill>
-                <a:latin typeface="Fira Sans"/>
-              </a:rPr>
-              <a:t>Para mirar los datos en un plano, o para entregarle a un modelo menos entradas.</a:t>
-            </a:r>
-          </a:p>
-          <a:p>
-            <a:pPr>
-              <a:lnSpc>
-                <a:spcPct val="112000"/>
-              </a:lnSpc>
-              <a:spcAft>
-                <a:spcPts val="900"/>
-              </a:spcAft>
-            </a:pPr>
-            <a:r>
-              <a:rPr sz="1800" b="1">
-                <a:solidFill>
-                  <a:srgbClr val="E0A437"/>
-                </a:solidFill>
-                <a:latin typeface="Fira Sans"/>
-              </a:rPr>
-              <a:t>▸ </a:t>
-            </a:r>
-            <a:r>
-              <a:rPr sz="1800" b="0">
-                <a:solidFill>
-                  <a:srgbClr val="000000"/>
-                </a:solidFill>
-                <a:latin typeface="Fira Sans"/>
-              </a:rPr>
-              <a:t>No aporta si las variables son pocas y distintas entre sí: no hay nada que resumir.</a:t>
+            <a:r>
+              <a:rPr sz="1300" b="0">
+                <a:solidFill>
+                  <a:srgbClr val="333333"/>
+                </a:solidFill>
+                <a:latin typeface="Fira Sans"/>
+              </a:rPr>
+              <a:t>Primera componente: las siete variables de la carrera pesan casi lo mismo (0,29 a 0,34), las de la temporada la mitad (0,19 a 0,23) y la defensa no cuenta: mide cuánta carrera lleva el jugador. Segunda componente: la temporada 1986 pesa positivo (0,24 a 0,39) y la carrera negativo (−0,12 a −0,26): separa a quien rindió este año más de lo que dice su carrera.</a:t>
             </a:r>
           </a:p>
         </p:txBody>
@@ -5666,21 +5636,45 @@
                 </a:solidFill>
                 <a:latin typeface="Fira Sans"/>
               </a:rPr>
-              <a:t>Tres precauciones</a:t>
-            </a:r>
-          </a:p>
-        </p:txBody>
-      </p:sp>
-      <p:sp>
-        <p:nvSpPr>
-          <p:cNvPr id="4" name="TextBox 3"/>
+              <a:t>Los 263 jugadores en dos componentes</a:t>
+            </a:r>
+          </a:p>
+        </p:txBody>
+      </p:sp>
+      <p:pic>
+        <p:nvPicPr>
+          <p:cNvPr id="4" name="Picture 3" descr="c8_05_jugadores.png"/>
+          <p:cNvPicPr>
+            <a:picLocks noChangeAspect="1"/>
+          </p:cNvPicPr>
+          <p:nvPr/>
+        </p:nvPicPr>
+        <p:blipFill>
+          <a:blip r:embed="rId2"/>
+          <a:stretch>
+            <a:fillRect/>
+          </a:stretch>
+        </p:blipFill>
+        <p:spPr>
+          <a:xfrm>
+            <a:off x="2699826" y="1143000"/>
+            <a:ext cx="3744346" cy="2587751"/>
+          </a:xfrm>
+          <a:prstGeom prst="rect">
+            <a:avLst/>
+          </a:prstGeom>
+        </p:spPr>
+      </p:pic>
+      <p:sp>
+        <p:nvSpPr>
+          <p:cNvPr id="5" name="TextBox 4"/>
           <p:cNvSpPr txBox="1"/>
           <p:nvPr/>
         </p:nvSpPr>
         <p:spPr>
           <a:xfrm>
-            <a:off x="704088" y="1353312"/>
-            <a:ext cx="7744968" cy="3300984"/>
+            <a:off x="704088" y="3867912"/>
+            <a:ext cx="7744968" cy="1024128"/>
           </a:xfrm>
           <a:prstGeom prst="rect">
             <a:avLst/>
@@ -5693,87 +5687,14 @@
           </a:bodyPr>
           <a:lstStyle/>
           <a:p>
-            <a:pPr>
-              <a:lnSpc>
-                <a:spcPct val="112000"/>
-              </a:lnSpc>
-              <a:spcAft>
-                <a:spcPts val="900"/>
-              </a:spcAft>
-            </a:pPr>
-            <a:r>
-              <a:rPr sz="1800" b="1">
-                <a:solidFill>
-                  <a:srgbClr val="E0A437"/>
-                </a:solidFill>
-                <a:latin typeface="Fira Sans"/>
-              </a:rPr>
-              <a:t>▸ </a:t>
-            </a:r>
-            <a:r>
-              <a:rPr sz="1800" b="1">
-                <a:solidFill>
-                  <a:srgbClr val="1D3557"/>
-                </a:solidFill>
-                <a:latin typeface="Fira Sans"/>
-              </a:rPr>
-              <a:t>Las variables categóricas (las dummies de la clase 6) no entran bien en el cálculo: se dejan fuera o se tratan aparte.</a:t>
-            </a:r>
-          </a:p>
-          <a:p>
-            <a:pPr>
-              <a:lnSpc>
-                <a:spcPct val="112000"/>
-              </a:lnSpc>
-              <a:spcAft>
-                <a:spcPts val="900"/>
-              </a:spcAft>
-            </a:pPr>
-            <a:r>
-              <a:rPr sz="1800" b="1">
-                <a:solidFill>
-                  <a:srgbClr val="E0A437"/>
-                </a:solidFill>
-                <a:latin typeface="Fira Sans"/>
-              </a:rPr>
-              <a:t>▸ </a:t>
-            </a:r>
-            <a:r>
-              <a:rPr sz="1800" b="0">
-                <a:solidFill>
-                  <a:srgbClr val="000000"/>
-                </a:solidFill>
-                <a:latin typeface="Fira Sans"/>
-              </a:rPr>
-              <a:t>Las componentes no siempre tienen una lectura clara. Aquí sí (la carrera; la temporada frente a la carrera), pero no está garantizado.</a:t>
-            </a:r>
-          </a:p>
-          <a:p>
-            <a:pPr>
-              <a:lnSpc>
-                <a:spcPct val="112000"/>
-              </a:lnSpc>
-              <a:spcAft>
-                <a:spcPts val="900"/>
-              </a:spcAft>
-            </a:pPr>
-            <a:r>
-              <a:rPr sz="1800" b="1">
-                <a:solidFill>
-                  <a:srgbClr val="E0A437"/>
-                </a:solidFill>
-                <a:latin typeface="Fira Sans"/>
-              </a:rPr>
-              <a:t>▸ </a:t>
-            </a:r>
-            <a:r>
-              <a:rPr sz="1800" b="0">
-                <a:solidFill>
-                  <a:srgbClr val="000000"/>
-                </a:solidFill>
-                <a:latin typeface="Fira Sans"/>
-              </a:rPr>
-              <a:t>Es no supervisado: la dirección de más variación no es necesariamente la que mejor predice la respuesta. Ridge y Lasso eligen mirando Y; PCA no la mira.</a:t>
+            <a:r>
+              <a:rPr sz="1300" b="0">
+                <a:solidFill>
+                  <a:srgbClr val="333333"/>
+                </a:solidFill>
+                <a:latin typeface="Fira Sans"/>
+              </a:rPr>
+              <a:t>Cada punto es un jugador y el color, su salario de 1987, que PCA no usó. El salario crece hacia la derecha (correlación 0,64 con la primera componente) y casi nada hacia arriba (0,11 con la segunda): la carrera pesa en el salario; la última temporada, poco. Dos ejes muestran lo que en 16 variables había que leer coeficiente por coeficiente.</a:t>
             </a:r>
           </a:p>
         </p:txBody>
@@ -5869,114 +5790,35 @@
                 </a:solidFill>
                 <a:latin typeface="Fira Sans"/>
               </a:rPr>
-              <a:t>En el código: cinco líneas</a:t>
-            </a:r>
-          </a:p>
-        </p:txBody>
-      </p:sp>
-      <p:sp>
-        <p:nvSpPr>
-          <p:cNvPr id="4" name="Rectangle 3"/>
-          <p:cNvSpPr/>
-          <p:nvPr/>
-        </p:nvSpPr>
-        <p:spPr>
-          <a:xfrm>
-            <a:off x="704088" y="1280160"/>
-            <a:ext cx="7744968" cy="2880360"/>
-          </a:xfrm>
-          <a:prstGeom prst="rect">
-            <a:avLst/>
-          </a:prstGeom>
-          <a:solidFill>
-            <a:srgbClr val="F0F2F5"/>
-          </a:solidFill>
-          <a:ln>
-            <a:solidFill>
-              <a:srgbClr val="D8DDE3"/>
-            </a:solidFill>
-          </a:ln>
-          <a:effectLst/>
-        </p:spPr>
-        <p:style>
-          <a:lnRef idx="1">
-            <a:schemeClr val="accent1"/>
-          </a:lnRef>
-          <a:fillRef idx="3">
-            <a:schemeClr val="accent1"/>
-          </a:fillRef>
-          <a:effectRef idx="2">
-            <a:schemeClr val="accent1"/>
-          </a:effectRef>
-          <a:fontRef idx="minor">
-            <a:schemeClr val="lt1"/>
-          </a:fontRef>
-        </p:style>
-        <p:txBody>
-          <a:bodyPr rtlCol="0" anchor="ctr" wrap="square" lIns="228600" tIns="137160"/>
-          <a:lstStyle/>
-          <a:p>
-            <a:pPr/>
-            <a:r>
-              <a:rPr sz="1500" b="0">
-                <a:solidFill>
-                  <a:srgbClr val="1D3557"/>
-                </a:solidFill>
-                <a:latin typeface="Menlo"/>
-              </a:rPr>
-              <a:t>Z = StandardScaler().fit_transform(X)  # 1. estandarizar</a:t>
-            </a:r>
-          </a:p>
-          <a:p>
-            <a:pPr/>
-            <a:r>
-              <a:rPr sz="1500" b="0">
-                <a:solidFill>
-                  <a:srgbClr val="1D3557"/>
-                </a:solidFill>
-                <a:latin typeface="Menlo"/>
-              </a:rPr>
-              <a:t>pca = PCA().fit(Z)                     # 2. las componentes</a:t>
-            </a:r>
-          </a:p>
-          <a:p>
-            <a:pPr/>
-            <a:r>
-              <a:rPr sz="1500" b="0">
-                <a:solidFill>
-                  <a:srgbClr val="1D3557"/>
-                </a:solidFill>
-                <a:latin typeface="Menlo"/>
-              </a:rPr>
-              <a:t>pca.explained_variance_ratio_          # 3. cuánto explica</a:t>
-            </a:r>
-          </a:p>
-          <a:p>
-            <a:pPr/>
-            <a:r>
-              <a:rPr sz="1500" b="0">
-                <a:solidFill>
-                  <a:srgbClr val="1D3557"/>
-                </a:solidFill>
-                <a:latin typeface="Menlo"/>
-              </a:rPr>
-              <a:t>pca.components_                        # 4. los pesos</a:t>
-            </a:r>
-          </a:p>
-          <a:p>
-            <a:pPr/>
-            <a:r>
-              <a:rPr sz="1500" b="0">
-                <a:solidFill>
-                  <a:srgbClr val="1D3557"/>
-                </a:solidFill>
-                <a:latin typeface="Menlo"/>
-              </a:rPr>
-              <a:t>puntajes = pca.transform(Z)            # 5. los puntajes</a:t>
-            </a:r>
-          </a:p>
-        </p:txBody>
-      </p:sp>
+              <a:t>El mismo cálculo con las flores de la clase 2</a:t>
+            </a:r>
+          </a:p>
+        </p:txBody>
+      </p:sp>
+      <p:pic>
+        <p:nvPicPr>
+          <p:cNvPr id="4" name="Picture 3" descr="c8_06_iris.png"/>
+          <p:cNvPicPr>
+            <a:picLocks noChangeAspect="1"/>
+          </p:cNvPicPr>
+          <p:nvPr/>
+        </p:nvPicPr>
+        <p:blipFill>
+          <a:blip r:embed="rId2"/>
+          <a:stretch>
+            <a:fillRect/>
+          </a:stretch>
+        </p:blipFill>
+        <p:spPr>
+          <a:xfrm>
+            <a:off x="2906606" y="1143000"/>
+            <a:ext cx="3330786" cy="2587751"/>
+          </a:xfrm>
+          <a:prstGeom prst="rect">
+            <a:avLst/>
+          </a:prstGeom>
+        </p:spPr>
+      </p:pic>
       <p:sp>
         <p:nvSpPr>
           <p:cNvPr id="5" name="TextBox 4"/>
@@ -5985,8 +5827,8 @@
         </p:nvSpPr>
         <p:spPr>
           <a:xfrm>
-            <a:off x="704088" y="4389120"/>
-            <a:ext cx="7744968" cy="1097280"/>
+            <a:off x="704088" y="3867912"/>
+            <a:ext cx="7744968" cy="1024128"/>
           </a:xfrm>
           <a:prstGeom prst="rect">
             <a:avLst/>
@@ -5999,31 +5841,14 @@
           </a:bodyPr>
           <a:lstStyle/>
           <a:p>
-            <a:pPr>
-              <a:lnSpc>
-                <a:spcPct val="112000"/>
-              </a:lnSpc>
-              <a:spcAft>
-                <a:spcPts val="900"/>
-              </a:spcAft>
-            </a:pPr>
-            <a:r>
-              <a:rPr sz="1600" b="1">
-                <a:solidFill>
-                  <a:srgbClr val="E0A437"/>
-                </a:solidFill>
-                <a:latin typeface="Fira Sans"/>
-              </a:rPr>
-              <a:t>▸ </a:t>
-            </a:r>
-            <a:r>
-              <a:rPr sz="1600" b="0">
-                <a:solidFill>
-                  <a:srgbClr val="000000"/>
-                </a:solidFill>
-                <a:latin typeface="Fira Sans"/>
-              </a:rPr>
-              <a:t>El ejemplo completo, con las tablas de pesos y los gráficos de la clase, está en el notebook 08_componentes_principales.ipynb.</a:t>
+            <a:r>
+              <a:rPr sz="1300" b="0">
+                <a:solidFill>
+                  <a:srgbClr val="333333"/>
+                </a:solidFill>
+                <a:latin typeface="Fira Sans"/>
+              </a:rPr>
+              <a:t>Las cuatro medidas de iris se resumen en dos componentes que reúnen el 96% de la variación. La primera (73%) pesa casi igual el largo y el ancho del pétalo y el largo del sépalo (0,52 a 0,58): el tamaño de la flor. La segunda (23%) es casi solo el ancho del sépalo (0,92). PCA no conoce la especie y aun así las tres quedan separadas a lo largo de la primera componente.</a:t>
             </a:r>
           </a:p>
         </p:txBody>
@@ -6119,7 +5944,7 @@
                 </a:solidFill>
                 <a:latin typeface="Fira Sans"/>
               </a:rPr>
-              <a:t>5. Cierre del módulo</a:t>
+              <a:t>4. Cuándo</a:t>
             </a:r>
           </a:p>
           <a:p>
@@ -6130,7 +5955,7 @@
                 </a:solidFill>
                 <a:latin typeface="Fira Sans"/>
               </a:rPr>
-              <a:t>Ocho clases, un hilo</a:t>
+              <a:t>Cuándo conviene y cuándo no</a:t>
             </a:r>
           </a:p>
         </p:txBody>
@@ -6226,45 +6051,21 @@
                 </a:solidFill>
                 <a:latin typeface="Fira Sans"/>
               </a:rPr>
-              <a:t>El módulo en una página</a:t>
-            </a:r>
-          </a:p>
-        </p:txBody>
-      </p:sp>
-      <p:pic>
-        <p:nvPicPr>
-          <p:cNvPr id="4" name="Picture 3" descr="c8_07_mapa_modulo.png"/>
-          <p:cNvPicPr>
-            <a:picLocks noChangeAspect="1"/>
-          </p:cNvPicPr>
-          <p:nvPr/>
-        </p:nvPicPr>
-        <p:blipFill>
-          <a:blip r:embed="rId2"/>
-          <a:stretch>
-            <a:fillRect/>
-          </a:stretch>
-        </p:blipFill>
-        <p:spPr>
-          <a:xfrm>
-            <a:off x="1029546" y="1143000"/>
-            <a:ext cx="7084906" cy="3099816"/>
-          </a:xfrm>
-          <a:prstGeom prst="rect">
-            <a:avLst/>
-          </a:prstGeom>
-        </p:spPr>
-      </p:pic>
-      <p:sp>
-        <p:nvSpPr>
-          <p:cNvPr id="5" name="TextBox 4"/>
+              <a:t>¿Cuándo conviene?</a:t>
+            </a:r>
+          </a:p>
+        </p:txBody>
+      </p:sp>
+      <p:sp>
+        <p:nvSpPr>
+          <p:cNvPr id="4" name="TextBox 3"/>
           <p:cNvSpPr txBox="1"/>
           <p:nvPr/>
         </p:nvSpPr>
         <p:spPr>
           <a:xfrm>
-            <a:off x="704088" y="4379976"/>
-            <a:ext cx="7744968" cy="512064"/>
+            <a:off x="704088" y="1353312"/>
+            <a:ext cx="7744968" cy="3300984"/>
           </a:xfrm>
           <a:prstGeom prst="rect">
             <a:avLst/>
@@ -6277,14 +6078,87 @@
           </a:bodyPr>
           <a:lstStyle/>
           <a:p>
-            <a:r>
-              <a:rPr sz="1300" b="0">
-                <a:solidFill>
-                  <a:srgbClr val="333333"/>
-                </a:solidFill>
-                <a:latin typeface="Fira Sans"/>
-              </a:rPr>
-              <a:t>Cada clase dejó una idea. Juntas, son lo que el módulo enseñó: cómo se llega de una pregunta y unos datos a un resultado, y cómo se lee ese resultado con su incertidumbre.</a:t>
+            <a:pPr>
+              <a:lnSpc>
+                <a:spcPct val="112000"/>
+              </a:lnSpc>
+              <a:spcAft>
+                <a:spcPts val="900"/>
+              </a:spcAft>
+            </a:pPr>
+            <a:r>
+              <a:rPr sz="1800" b="1">
+                <a:solidFill>
+                  <a:srgbClr val="E0A437"/>
+                </a:solidFill>
+                <a:latin typeface="Fira Sans"/>
+              </a:rPr>
+              <a:t>▸ </a:t>
+            </a:r>
+            <a:r>
+              <a:rPr sz="1800" b="1">
+                <a:solidFill>
+                  <a:srgbClr val="1D3557"/>
+                </a:solidFill>
+                <a:latin typeface="Fira Sans"/>
+              </a:rPr>
+              <a:t>Con muchas variables numéricas que se correlacionan en bloques, como en la matriz de la clase 7.</a:t>
+            </a:r>
+          </a:p>
+          <a:p>
+            <a:pPr>
+              <a:lnSpc>
+                <a:spcPct val="112000"/>
+              </a:lnSpc>
+              <a:spcAft>
+                <a:spcPts val="900"/>
+              </a:spcAft>
+            </a:pPr>
+            <a:r>
+              <a:rPr sz="1800" b="1">
+                <a:solidFill>
+                  <a:srgbClr val="E0A437"/>
+                </a:solidFill>
+                <a:latin typeface="Fira Sans"/>
+              </a:rPr>
+              <a:t>▸ </a:t>
+            </a:r>
+            <a:r>
+              <a:rPr sz="1800" b="0">
+                <a:solidFill>
+                  <a:srgbClr val="000000"/>
+                </a:solidFill>
+                <a:latin typeface="Fira Sans"/>
+              </a:rPr>
+              <a:t>Para mirar los datos en un plano, o para entregarle a un modelo menos entradas.</a:t>
+            </a:r>
+          </a:p>
+          <a:p>
+            <a:pPr>
+              <a:lnSpc>
+                <a:spcPct val="112000"/>
+              </a:lnSpc>
+              <a:spcAft>
+                <a:spcPts val="900"/>
+              </a:spcAft>
+            </a:pPr>
+            <a:r>
+              <a:rPr sz="1800" b="1">
+                <a:solidFill>
+                  <a:srgbClr val="E0A437"/>
+                </a:solidFill>
+                <a:latin typeface="Fira Sans"/>
+              </a:rPr>
+              <a:t>▸ </a:t>
+            </a:r>
+            <a:r>
+              <a:rPr sz="1800" b="0">
+                <a:solidFill>
+                  <a:srgbClr val="000000"/>
+                </a:solidFill>
+                <a:latin typeface="Fira Sans"/>
+              </a:rPr>
+              <a:t>No aporta si las variables son pocas y distintas entre sí: no hay nada que resumir.</a:t>
             </a:r>
           </a:p>
         </p:txBody>
@@ -6380,7 +6254,7 @@
                 </a:solidFill>
                 <a:latin typeface="Fira Sans"/>
               </a:rPr>
-              <a:t>Lo que sigue en el diplomado</a:t>
+              <a:t>Tres precauciones</a:t>
             </a:r>
           </a:p>
         </p:txBody>
@@ -6431,7 +6305,7 @@
                 </a:solidFill>
                 <a:latin typeface="Fira Sans"/>
               </a:rPr>
-              <a:t>Módulo 2, Visualización e Inteligencia de Negocios: visualización efectiva, narrativas con datos y métricas de negocio.</a:t>
+              <a:t>Las variables categóricas (las dummies de la clase 6) no entran bien en el cálculo: se dejan fuera o se tratan aparte.</a:t>
             </a:r>
           </a:p>
           <a:p>
@@ -6459,7 +6333,7 @@
                 </a:solidFill>
                 <a:latin typeface="Fira Sans"/>
               </a:rPr>
-              <a:t>Módulo 3, Machine Learning para la Toma de Decisiones: aprendizaje supervisado y no supervisado (clustering y PCA en profundidad), evaluación de modelos, redes neuronales y explicabilidad.</a:t>
+              <a:t>Las componentes no siempre tienen una lectura clara. Aquí sí (la carrera; la temporada frente a la carrera), pero no está garantizado.</a:t>
             </a:r>
           </a:p>
           <a:p>
@@ -6487,35 +6361,7 @@
                 </a:solidFill>
                 <a:latin typeface="Fira Sans"/>
               </a:rPr>
-              <a:t>El Capstone continúa en esos módulos: el primer modelo de hoy es el punto de partida.</a:t>
-            </a:r>
-          </a:p>
-          <a:p>
-            <a:pPr>
-              <a:lnSpc>
-                <a:spcPct val="112000"/>
-              </a:lnSpc>
-              <a:spcAft>
-                <a:spcPts val="900"/>
-              </a:spcAft>
-            </a:pPr>
-            <a:r>
-              <a:rPr sz="1800" b="1">
-                <a:solidFill>
-                  <a:srgbClr val="E0A437"/>
-                </a:solidFill>
-                <a:latin typeface="Fira Sans"/>
-              </a:rPr>
-              <a:t>▸ </a:t>
-            </a:r>
-            <a:r>
-              <a:rPr sz="1800" b="0">
-                <a:solidFill>
-                  <a:srgbClr val="000000"/>
-                </a:solidFill>
-                <a:latin typeface="Fira Sans"/>
-              </a:rPr>
-              <a:t>Lo que se lleva de aquí: leer un resultado con su incertidumbre, juzgar un modelo en datos que no vio, y distinguir describir de encontrar una relación.</a:t>
+              <a:t>Es no supervisado: la dirección de más variación no es necesariamente la que mejor predice la respuesta. Ridge y Lasso eligen mirando Y; PCA no la mira.</a:t>
             </a:r>
           </a:p>
         </p:txBody>
@@ -6611,21 +6457,124 @@
                 </a:solidFill>
                 <a:latin typeface="Fira Sans"/>
               </a:rPr>
-              <a:t>Ahora: las presentaciones del avance</a:t>
-            </a:r>
-          </a:p>
-        </p:txBody>
-      </p:sp>
-      <p:sp>
-        <p:nvSpPr>
-          <p:cNvPr id="4" name="TextBox 3"/>
+              <a:t>En el código: cinco líneas</a:t>
+            </a:r>
+          </a:p>
+        </p:txBody>
+      </p:sp>
+      <p:sp>
+        <p:nvSpPr>
+          <p:cNvPr id="4" name="Rectangle 3"/>
+          <p:cNvSpPr/>
+          <p:nvPr/>
+        </p:nvSpPr>
+        <p:spPr>
+          <a:xfrm>
+            <a:off x="704088" y="1280160"/>
+            <a:ext cx="7744968" cy="2880360"/>
+          </a:xfrm>
+          <a:prstGeom prst="rect">
+            <a:avLst/>
+          </a:prstGeom>
+          <a:solidFill>
+            <a:srgbClr val="F0F2F5"/>
+          </a:solidFill>
+          <a:ln>
+            <a:solidFill>
+              <a:srgbClr val="D8DDE3"/>
+            </a:solidFill>
+          </a:ln>
+          <a:effectLst/>
+        </p:spPr>
+        <p:style>
+          <a:lnRef idx="1">
+            <a:schemeClr val="accent1"/>
+          </a:lnRef>
+          <a:fillRef idx="3">
+            <a:schemeClr val="accent1"/>
+          </a:fillRef>
+          <a:effectRef idx="2">
+            <a:schemeClr val="accent1"/>
+          </a:effectRef>
+          <a:fontRef idx="minor">
+            <a:schemeClr val="lt1"/>
+          </a:fontRef>
+        </p:style>
+        <p:txBody>
+          <a:bodyPr rtlCol="0" anchor="ctr" wrap="square" lIns="228600" tIns="137160"/>
+          <a:lstStyle/>
+          <a:p>
+            <a:pPr/>
+            <a:r>
+              <a:rPr sz="1500" b="0">
+                <a:solidFill>
+                  <a:srgbClr val="1D3557"/>
+                </a:solidFill>
+                <a:latin typeface="Menlo"/>
+              </a:rPr>
+              <a:t>Z = StandardScaler().fit_transform(X)  # 1. estandarizar</a:t>
+            </a:r>
+          </a:p>
+          <a:p>
+            <a:pPr/>
+            <a:r>
+              <a:rPr sz="1500" b="0">
+                <a:solidFill>
+                  <a:srgbClr val="1D3557"/>
+                </a:solidFill>
+                <a:latin typeface="Menlo"/>
+              </a:rPr>
+              <a:t>pca = PCA().fit(Z)                     # 2. las componentes</a:t>
+            </a:r>
+          </a:p>
+          <a:p>
+            <a:pPr/>
+            <a:r>
+              <a:rPr sz="1500" b="0">
+                <a:solidFill>
+                  <a:srgbClr val="1D3557"/>
+                </a:solidFill>
+                <a:latin typeface="Menlo"/>
+              </a:rPr>
+              <a:t>pca.explained_variance_ratio_          # 3. cuánto explica</a:t>
+            </a:r>
+          </a:p>
+          <a:p>
+            <a:pPr/>
+            <a:r>
+              <a:rPr sz="1500" b="0">
+                <a:solidFill>
+                  <a:srgbClr val="1D3557"/>
+                </a:solidFill>
+                <a:latin typeface="Menlo"/>
+              </a:rPr>
+              <a:t>pca.components_                        # 4. los pesos</a:t>
+            </a:r>
+          </a:p>
+          <a:p>
+            <a:pPr/>
+            <a:r>
+              <a:rPr sz="1500" b="0">
+                <a:solidFill>
+                  <a:srgbClr val="1D3557"/>
+                </a:solidFill>
+                <a:latin typeface="Menlo"/>
+              </a:rPr>
+              <a:t>puntajes = pca.transform(Z)            # 5. los puntajes</a:t>
+            </a:r>
+          </a:p>
+        </p:txBody>
+      </p:sp>
+      <p:sp>
+        <p:nvSpPr>
+          <p:cNvPr id="5" name="TextBox 4"/>
           <p:cNvSpPr txBox="1"/>
           <p:nvPr/>
         </p:nvSpPr>
         <p:spPr>
           <a:xfrm>
-            <a:off x="704088" y="1353312"/>
-            <a:ext cx="7744968" cy="3300984"/>
+            <a:off x="704088" y="4389120"/>
+            <a:ext cx="7744968" cy="1097280"/>
           </a:xfrm>
           <a:prstGeom prst="rect">
             <a:avLst/>
@@ -6647,7 +6596,7 @@
               </a:spcAft>
             </a:pPr>
             <a:r>
-              <a:rPr sz="1800" b="1">
+              <a:rPr sz="1600" b="1">
                 <a:solidFill>
                   <a:srgbClr val="E0A437"/>
                 </a:solidFill>
@@ -6656,97 +6605,13 @@
               <a:t>▸ </a:t>
             </a:r>
             <a:r>
-              <a:rPr sz="1800" b="1">
-                <a:solidFill>
-                  <a:srgbClr val="1D3557"/>
-                </a:solidFill>
-                <a:latin typeface="Fira Sans"/>
-              </a:rPr>
-              <a:t>Ocho equipos, en el orden en que se ofrezcan. Máximo 10 minutos por equipo; el tiempo se controla. Después, preguntas de la profesora y del curso.</a:t>
-            </a:r>
-          </a:p>
-          <a:p>
-            <a:pPr>
-              <a:lnSpc>
-                <a:spcPct val="112000"/>
-              </a:lnSpc>
-              <a:spcAft>
-                <a:spcPts val="900"/>
-              </a:spcAft>
-            </a:pPr>
-            <a:r>
-              <a:rPr sz="1800" b="1">
-                <a:solidFill>
-                  <a:srgbClr val="E0A437"/>
-                </a:solidFill>
-                <a:latin typeface="Fira Sans"/>
-              </a:rPr>
-              <a:t>▸ </a:t>
-            </a:r>
-            <a:r>
-              <a:rPr sz="1800" b="0">
+              <a:rPr sz="1600" b="0">
                 <a:solidFill>
                   <a:srgbClr val="000000"/>
                 </a:solidFill>
                 <a:latin typeface="Fira Sans"/>
               </a:rPr>
-              <a:t>Se evalúa el avance, no un resultado final: el modelo es un primer intento. La exigencia está en el tiempo, la claridad, la explicación de los gráficos y las relaciones, y en advertir qué falta o qué no tiene sentido.</a:t>
-            </a:r>
-          </a:p>
-          <a:p>
-            <a:pPr>
-              <a:lnSpc>
-                <a:spcPct val="112000"/>
-              </a:lnSpc>
-              <a:spcAft>
-                <a:spcPts val="900"/>
-              </a:spcAft>
-            </a:pPr>
-            <a:r>
-              <a:rPr sz="1800" b="1">
-                <a:solidFill>
-                  <a:srgbClr val="E0A437"/>
-                </a:solidFill>
-                <a:latin typeface="Fira Sans"/>
-              </a:rPr>
-              <a:t>▸ </a:t>
-            </a:r>
-            <a:r>
-              <a:rPr sz="1800" b="0">
-                <a:solidFill>
-                  <a:srgbClr val="000000"/>
-                </a:solidFill>
-                <a:latin typeface="Fira Sans"/>
-              </a:rPr>
-              <a:t>Las slides, en PDF, al Aula hasta las 20:30: un envío por equipo con los nombres.</a:t>
-            </a:r>
-          </a:p>
-          <a:p>
-            <a:pPr>
-              <a:lnSpc>
-                <a:spcPct val="112000"/>
-              </a:lnSpc>
-              <a:spcAft>
-                <a:spcPts val="900"/>
-              </a:spcAft>
-            </a:pPr>
-            <a:r>
-              <a:rPr sz="1800" b="1">
-                <a:solidFill>
-                  <a:srgbClr val="E0A437"/>
-                </a:solidFill>
-                <a:latin typeface="Fira Sans"/>
-              </a:rPr>
-              <a:t>▸ </a:t>
-            </a:r>
-            <a:r>
-              <a:rPr sz="1800" b="0">
-                <a:solidFill>
-                  <a:srgbClr val="000000"/>
-                </a:solidFill>
-                <a:latin typeface="Fira Sans"/>
-              </a:rPr>
-              <a:t>El informe escrito, el viernes 25 de septiembre por el Aula: máximo 7 páginas, con su rúbrica publicada.</a:t>
+              <a:t>El ejemplo completo, con las tablas de pesos y los gráficos de la clase, está en el notebook 08_componentes_principales.ipynb.</a:t>
             </a:r>
           </a:p>
         </p:txBody>
@@ -6784,6 +6649,113 @@
             <a:avLst/>
           </a:prstGeom>
           <a:solidFill>
+            <a:srgbClr val="1D3557"/>
+          </a:solidFill>
+          <a:ln>
+            <a:noFill/>
+          </a:ln>
+          <a:effectLst/>
+        </p:spPr>
+        <p:style>
+          <a:lnRef idx="1">
+            <a:schemeClr val="accent1"/>
+          </a:lnRef>
+          <a:fillRef idx="3">
+            <a:schemeClr val="accent1"/>
+          </a:fillRef>
+          <a:effectRef idx="2">
+            <a:schemeClr val="accent1"/>
+          </a:effectRef>
+          <a:fontRef idx="minor">
+            <a:schemeClr val="lt1"/>
+          </a:fontRef>
+        </p:style>
+        <p:txBody>
+          <a:bodyPr rtlCol="0" anchor="ctr"/>
+          <a:lstStyle/>
+          <a:p>
+            <a:pPr algn="ctr"/>
+          </a:p>
+        </p:txBody>
+      </p:sp>
+      <p:sp>
+        <p:nvSpPr>
+          <p:cNvPr id="3" name="TextBox 2"/>
+          <p:cNvSpPr txBox="1"/>
+          <p:nvPr/>
+        </p:nvSpPr>
+        <p:spPr>
+          <a:xfrm>
+            <a:off x="603504" y="1847088"/>
+            <a:ext cx="7946136" cy="1399032"/>
+          </a:xfrm>
+          <a:prstGeom prst="rect">
+            <a:avLst/>
+          </a:prstGeom>
+          <a:noFill/>
+        </p:spPr>
+        <p:txBody>
+          <a:bodyPr wrap="square">
+            <a:spAutoFit/>
+          </a:bodyPr>
+          <a:lstStyle/>
+          <a:p>
+            <a:r>
+              <a:rPr sz="3400" b="1">
+                <a:solidFill>
+                  <a:srgbClr val="FFFFFF"/>
+                </a:solidFill>
+                <a:latin typeface="Fira Sans"/>
+              </a:rPr>
+              <a:t>5. Cierre del módulo</a:t>
+            </a:r>
+          </a:p>
+          <a:p>
+            <a:r>
+              <a:rPr sz="1800" b="0">
+                <a:solidFill>
+                  <a:srgbClr val="E0A437"/>
+                </a:solidFill>
+                <a:latin typeface="Fira Sans"/>
+              </a:rPr>
+              <a:t>Ocho clases, un hilo</a:t>
+            </a:r>
+          </a:p>
+        </p:txBody>
+      </p:sp>
+    </p:spTree>
+  </p:cSld>
+  <p:clrMapOvr>
+    <a:masterClrMapping/>
+  </p:clrMapOvr>
+</p:sld>
+</file>
+
+<file path=ppt/slides/slide29.xml><?xml version="1.0" encoding="utf-8"?>
+<p:sld xmlns:a="http://schemas.openxmlformats.org/drawingml/2006/main" xmlns:p="http://schemas.openxmlformats.org/presentationml/2006/main" xmlns:r="http://schemas.openxmlformats.org/officeDocument/2006/relationships">
+  <p:cSld>
+    <p:spTree>
+      <p:nvGrpSpPr>
+        <p:cNvPr id="1" name=""/>
+        <p:cNvGrpSpPr/>
+        <p:nvPr/>
+      </p:nvGrpSpPr>
+      <p:grpSpPr/>
+      <p:sp>
+        <p:nvSpPr>
+          <p:cNvPr id="2" name="Rectangle 1"/>
+          <p:cNvSpPr/>
+          <p:nvPr/>
+        </p:nvSpPr>
+        <p:spPr>
+          <a:xfrm>
+            <a:off x="0" y="0"/>
+            <a:ext cx="9144000" cy="5138928"/>
+          </a:xfrm>
+          <a:prstGeom prst="rect">
+            <a:avLst/>
+          </a:prstGeom>
+          <a:solidFill>
             <a:srgbClr val="FAFBFC"/>
           </a:solidFill>
           <a:ln>
@@ -6842,21 +6814,45 @@
                 </a:solidFill>
                 <a:latin typeface="Fira Sans"/>
               </a:rPr>
-              <a:t>Referencias</a:t>
-            </a:r>
-          </a:p>
-        </p:txBody>
-      </p:sp>
-      <p:sp>
-        <p:nvSpPr>
-          <p:cNvPr id="4" name="TextBox 3"/>
+              <a:t>El módulo en una página</a:t>
+            </a:r>
+          </a:p>
+        </p:txBody>
+      </p:sp>
+      <p:pic>
+        <p:nvPicPr>
+          <p:cNvPr id="4" name="Picture 3" descr="c8_07_mapa_modulo.png"/>
+          <p:cNvPicPr>
+            <a:picLocks noChangeAspect="1"/>
+          </p:cNvPicPr>
+          <p:nvPr/>
+        </p:nvPicPr>
+        <p:blipFill>
+          <a:blip r:embed="rId2"/>
+          <a:stretch>
+            <a:fillRect/>
+          </a:stretch>
+        </p:blipFill>
+        <p:spPr>
+          <a:xfrm>
+            <a:off x="1029546" y="1143000"/>
+            <a:ext cx="7084906" cy="3099816"/>
+          </a:xfrm>
+          <a:prstGeom prst="rect">
+            <a:avLst/>
+          </a:prstGeom>
+        </p:spPr>
+      </p:pic>
+      <p:sp>
+        <p:nvSpPr>
+          <p:cNvPr id="5" name="TextBox 4"/>
           <p:cNvSpPr txBox="1"/>
           <p:nvPr/>
         </p:nvSpPr>
         <p:spPr>
           <a:xfrm>
-            <a:off x="704088" y="1234440"/>
-            <a:ext cx="7744968" cy="3566160"/>
+            <a:off x="704088" y="4379976"/>
+            <a:ext cx="7744968" cy="512064"/>
           </a:xfrm>
           <a:prstGeom prst="rect">
             <a:avLst/>
@@ -6869,14 +6865,6 @@
           </a:bodyPr>
           <a:lstStyle/>
           <a:p>
-            <a:pPr>
-              <a:lnSpc>
-                <a:spcPct val="115000"/>
-              </a:lnSpc>
-              <a:spcAft>
-                <a:spcPts val="700"/>
-              </a:spcAft>
-            </a:pPr>
             <a:r>
               <a:rPr sz="1300" b="0">
                 <a:solidFill>
@@ -6884,64 +6872,7 @@
                 </a:solidFill>
                 <a:latin typeface="Fira Sans"/>
               </a:rPr>
-              <a:t>James, G., Witten, D., Hastie, T. y Tibshirani, R. (2013). An Introduction to Statistical Learning. Springer. Sección 10.2, pp. 374 a 385: qué es una componente principal, por qué estandarizar, la proporción de variación explicada y cuántas componentes usar. PDF gratuito en statlearning.com.</a:t>
-            </a:r>
-          </a:p>
-          <a:p>
-            <a:pPr>
-              <a:lnSpc>
-                <a:spcPct val="115000"/>
-              </a:lnSpc>
-              <a:spcAft>
-                <a:spcPts val="700"/>
-              </a:spcAft>
-            </a:pPr>
-            <a:r>
-              <a:rPr sz="1300" b="0">
-                <a:solidFill>
-                  <a:srgbClr val="333333"/>
-                </a:solidFill>
-                <a:latin typeface="Fira Sans"/>
-              </a:rPr>
-              <a:t>VanderPlas, J. (2016). Python Data Science Handbook. O'Reilly. Capítulo "In Depth: Principal Component Analysis", de acceso abierto en jakevdp.github.io/PythonDataScienceHandbook.</a:t>
-            </a:r>
-          </a:p>
-          <a:p>
-            <a:pPr>
-              <a:lnSpc>
-                <a:spcPct val="115000"/>
-              </a:lnSpc>
-              <a:spcAft>
-                <a:spcPts val="700"/>
-              </a:spcAft>
-            </a:pPr>
-            <a:r>
-              <a:rPr sz="1300" b="0">
-                <a:solidFill>
-                  <a:srgbClr val="333333"/>
-                </a:solidFill>
-                <a:latin typeface="Fira Sans"/>
-              </a:rPr>
-              <a:t>Documentación de scikit-learn, sklearn.decomposition.PCA: scikit-learn.org/stable/modules/decomposition.html</a:t>
-            </a:r>
-          </a:p>
-          <a:p>
-            <a:pPr>
-              <a:lnSpc>
-                <a:spcPct val="115000"/>
-              </a:lnSpc>
-              <a:spcAft>
-                <a:spcPts val="700"/>
-              </a:spcAft>
-            </a:pPr>
-            <a:r>
-              <a:rPr sz="1300" b="0">
-                <a:solidFill>
-                  <a:srgbClr val="333333"/>
-                </a:solidFill>
-                <a:latin typeface="Fira Sans"/>
-              </a:rPr>
-              <a:t>Datos: Hitters, del libro de James et al. (statlearning.com), e iris (Fisher, 1936), incluido en scikit-learn.</a:t>
+              <a:t>Cada clase dejó una idea. Juntas, son lo que el módulo enseñó: cómo se llega de una pregunta y unos datos a un resultado, y cómo se lee ese resultado con su incertidumbre.</a:t>
             </a:r>
           </a:p>
         </p:txBody>
@@ -7213,6 +7144,663 @@
 </p:sld>
 </file>
 
+<file path=ppt/slides/slide30.xml><?xml version="1.0" encoding="utf-8"?>
+<p:sld xmlns:a="http://schemas.openxmlformats.org/drawingml/2006/main" xmlns:p="http://schemas.openxmlformats.org/presentationml/2006/main" xmlns:r="http://schemas.openxmlformats.org/officeDocument/2006/relationships">
+  <p:cSld>
+    <p:spTree>
+      <p:nvGrpSpPr>
+        <p:cNvPr id="1" name=""/>
+        <p:cNvGrpSpPr/>
+        <p:nvPr/>
+      </p:nvGrpSpPr>
+      <p:grpSpPr/>
+      <p:sp>
+        <p:nvSpPr>
+          <p:cNvPr id="2" name="Rectangle 1"/>
+          <p:cNvSpPr/>
+          <p:nvPr/>
+        </p:nvSpPr>
+        <p:spPr>
+          <a:xfrm>
+            <a:off x="0" y="0"/>
+            <a:ext cx="9144000" cy="5138928"/>
+          </a:xfrm>
+          <a:prstGeom prst="rect">
+            <a:avLst/>
+          </a:prstGeom>
+          <a:solidFill>
+            <a:srgbClr val="FAFBFC"/>
+          </a:solidFill>
+          <a:ln>
+            <a:noFill/>
+          </a:ln>
+          <a:effectLst/>
+        </p:spPr>
+        <p:style>
+          <a:lnRef idx="1">
+            <a:schemeClr val="accent1"/>
+          </a:lnRef>
+          <a:fillRef idx="3">
+            <a:schemeClr val="accent1"/>
+          </a:fillRef>
+          <a:effectRef idx="2">
+            <a:schemeClr val="accent1"/>
+          </a:effectRef>
+          <a:fontRef idx="minor">
+            <a:schemeClr val="lt1"/>
+          </a:fontRef>
+        </p:style>
+        <p:txBody>
+          <a:bodyPr rtlCol="0" anchor="ctr"/>
+          <a:lstStyle/>
+          <a:p>
+            <a:pPr algn="ctr"/>
+          </a:p>
+        </p:txBody>
+      </p:sp>
+      <p:sp>
+        <p:nvSpPr>
+          <p:cNvPr id="3" name="TextBox 2"/>
+          <p:cNvSpPr txBox="1"/>
+          <p:nvPr/>
+        </p:nvSpPr>
+        <p:spPr>
+          <a:xfrm>
+            <a:off x="402336" y="301752"/>
+            <a:ext cx="8348472" cy="795528"/>
+          </a:xfrm>
+          <a:prstGeom prst="rect">
+            <a:avLst/>
+          </a:prstGeom>
+          <a:noFill/>
+        </p:spPr>
+        <p:txBody>
+          <a:bodyPr wrap="square">
+            <a:spAutoFit/>
+          </a:bodyPr>
+          <a:lstStyle/>
+          <a:p>
+            <a:r>
+              <a:rPr sz="2800" b="1">
+                <a:solidFill>
+                  <a:srgbClr val="0F0F0F"/>
+                </a:solidFill>
+                <a:latin typeface="Fira Sans"/>
+              </a:rPr>
+              <a:t>Lo que sigue en el diplomado</a:t>
+            </a:r>
+          </a:p>
+        </p:txBody>
+      </p:sp>
+      <p:sp>
+        <p:nvSpPr>
+          <p:cNvPr id="4" name="TextBox 3"/>
+          <p:cNvSpPr txBox="1"/>
+          <p:nvPr/>
+        </p:nvSpPr>
+        <p:spPr>
+          <a:xfrm>
+            <a:off x="704088" y="1353312"/>
+            <a:ext cx="7744968" cy="3300984"/>
+          </a:xfrm>
+          <a:prstGeom prst="rect">
+            <a:avLst/>
+          </a:prstGeom>
+          <a:noFill/>
+        </p:spPr>
+        <p:txBody>
+          <a:bodyPr wrap="square">
+            <a:spAutoFit/>
+          </a:bodyPr>
+          <a:lstStyle/>
+          <a:p>
+            <a:pPr>
+              <a:lnSpc>
+                <a:spcPct val="112000"/>
+              </a:lnSpc>
+              <a:spcAft>
+                <a:spcPts val="900"/>
+              </a:spcAft>
+            </a:pPr>
+            <a:r>
+              <a:rPr sz="1800" b="1">
+                <a:solidFill>
+                  <a:srgbClr val="E0A437"/>
+                </a:solidFill>
+                <a:latin typeface="Fira Sans"/>
+              </a:rPr>
+              <a:t>▸ </a:t>
+            </a:r>
+            <a:r>
+              <a:rPr sz="1800" b="1">
+                <a:solidFill>
+                  <a:srgbClr val="1D3557"/>
+                </a:solidFill>
+                <a:latin typeface="Fira Sans"/>
+              </a:rPr>
+              <a:t>Módulo 2, Visualización e Inteligencia de Negocios: visualización efectiva, narrativas con datos y métricas de negocio.</a:t>
+            </a:r>
+          </a:p>
+          <a:p>
+            <a:pPr>
+              <a:lnSpc>
+                <a:spcPct val="112000"/>
+              </a:lnSpc>
+              <a:spcAft>
+                <a:spcPts val="900"/>
+              </a:spcAft>
+            </a:pPr>
+            <a:r>
+              <a:rPr sz="1800" b="1">
+                <a:solidFill>
+                  <a:srgbClr val="E0A437"/>
+                </a:solidFill>
+                <a:latin typeface="Fira Sans"/>
+              </a:rPr>
+              <a:t>▸ </a:t>
+            </a:r>
+            <a:r>
+              <a:rPr sz="1800" b="0">
+                <a:solidFill>
+                  <a:srgbClr val="000000"/>
+                </a:solidFill>
+                <a:latin typeface="Fira Sans"/>
+              </a:rPr>
+              <a:t>Módulo 3, Machine Learning para la Toma de Decisiones: aprendizaje supervisado y no supervisado (clustering y PCA en profundidad), evaluación de modelos, redes neuronales y explicabilidad.</a:t>
+            </a:r>
+          </a:p>
+          <a:p>
+            <a:pPr>
+              <a:lnSpc>
+                <a:spcPct val="112000"/>
+              </a:lnSpc>
+              <a:spcAft>
+                <a:spcPts val="900"/>
+              </a:spcAft>
+            </a:pPr>
+            <a:r>
+              <a:rPr sz="1800" b="1">
+                <a:solidFill>
+                  <a:srgbClr val="E0A437"/>
+                </a:solidFill>
+                <a:latin typeface="Fira Sans"/>
+              </a:rPr>
+              <a:t>▸ </a:t>
+            </a:r>
+            <a:r>
+              <a:rPr sz="1800" b="0">
+                <a:solidFill>
+                  <a:srgbClr val="000000"/>
+                </a:solidFill>
+                <a:latin typeface="Fira Sans"/>
+              </a:rPr>
+              <a:t>El Capstone continúa en esos módulos: el primer modelo de hoy es el punto de partida.</a:t>
+            </a:r>
+          </a:p>
+          <a:p>
+            <a:pPr>
+              <a:lnSpc>
+                <a:spcPct val="112000"/>
+              </a:lnSpc>
+              <a:spcAft>
+                <a:spcPts val="900"/>
+              </a:spcAft>
+            </a:pPr>
+            <a:r>
+              <a:rPr sz="1800" b="1">
+                <a:solidFill>
+                  <a:srgbClr val="E0A437"/>
+                </a:solidFill>
+                <a:latin typeface="Fira Sans"/>
+              </a:rPr>
+              <a:t>▸ </a:t>
+            </a:r>
+            <a:r>
+              <a:rPr sz="1800" b="0">
+                <a:solidFill>
+                  <a:srgbClr val="000000"/>
+                </a:solidFill>
+                <a:latin typeface="Fira Sans"/>
+              </a:rPr>
+              <a:t>Lo que se lleva de aquí: leer un resultado con su incertidumbre, juzgar un modelo en datos que no vio, y distinguir describir de encontrar una relación.</a:t>
+            </a:r>
+          </a:p>
+        </p:txBody>
+      </p:sp>
+    </p:spTree>
+  </p:cSld>
+  <p:clrMapOvr>
+    <a:masterClrMapping/>
+  </p:clrMapOvr>
+</p:sld>
+</file>
+
+<file path=ppt/slides/slide31.xml><?xml version="1.0" encoding="utf-8"?>
+<p:sld xmlns:a="http://schemas.openxmlformats.org/drawingml/2006/main" xmlns:p="http://schemas.openxmlformats.org/presentationml/2006/main" xmlns:r="http://schemas.openxmlformats.org/officeDocument/2006/relationships">
+  <p:cSld>
+    <p:spTree>
+      <p:nvGrpSpPr>
+        <p:cNvPr id="1" name=""/>
+        <p:cNvGrpSpPr/>
+        <p:nvPr/>
+      </p:nvGrpSpPr>
+      <p:grpSpPr/>
+      <p:sp>
+        <p:nvSpPr>
+          <p:cNvPr id="2" name="Rectangle 1"/>
+          <p:cNvSpPr/>
+          <p:nvPr/>
+        </p:nvSpPr>
+        <p:spPr>
+          <a:xfrm>
+            <a:off x="0" y="0"/>
+            <a:ext cx="9144000" cy="5138928"/>
+          </a:xfrm>
+          <a:prstGeom prst="rect">
+            <a:avLst/>
+          </a:prstGeom>
+          <a:solidFill>
+            <a:srgbClr val="FAFBFC"/>
+          </a:solidFill>
+          <a:ln>
+            <a:noFill/>
+          </a:ln>
+          <a:effectLst/>
+        </p:spPr>
+        <p:style>
+          <a:lnRef idx="1">
+            <a:schemeClr val="accent1"/>
+          </a:lnRef>
+          <a:fillRef idx="3">
+            <a:schemeClr val="accent1"/>
+          </a:fillRef>
+          <a:effectRef idx="2">
+            <a:schemeClr val="accent1"/>
+          </a:effectRef>
+          <a:fontRef idx="minor">
+            <a:schemeClr val="lt1"/>
+          </a:fontRef>
+        </p:style>
+        <p:txBody>
+          <a:bodyPr rtlCol="0" anchor="ctr"/>
+          <a:lstStyle/>
+          <a:p>
+            <a:pPr algn="ctr"/>
+          </a:p>
+        </p:txBody>
+      </p:sp>
+      <p:sp>
+        <p:nvSpPr>
+          <p:cNvPr id="3" name="TextBox 2"/>
+          <p:cNvSpPr txBox="1"/>
+          <p:nvPr/>
+        </p:nvSpPr>
+        <p:spPr>
+          <a:xfrm>
+            <a:off x="402336" y="301752"/>
+            <a:ext cx="8348472" cy="795528"/>
+          </a:xfrm>
+          <a:prstGeom prst="rect">
+            <a:avLst/>
+          </a:prstGeom>
+          <a:noFill/>
+        </p:spPr>
+        <p:txBody>
+          <a:bodyPr wrap="square">
+            <a:spAutoFit/>
+          </a:bodyPr>
+          <a:lstStyle/>
+          <a:p>
+            <a:r>
+              <a:rPr sz="2800" b="1">
+                <a:solidFill>
+                  <a:srgbClr val="0F0F0F"/>
+                </a:solidFill>
+                <a:latin typeface="Fira Sans"/>
+              </a:rPr>
+              <a:t>Ahora: las presentaciones del avance</a:t>
+            </a:r>
+          </a:p>
+        </p:txBody>
+      </p:sp>
+      <p:sp>
+        <p:nvSpPr>
+          <p:cNvPr id="4" name="TextBox 3"/>
+          <p:cNvSpPr txBox="1"/>
+          <p:nvPr/>
+        </p:nvSpPr>
+        <p:spPr>
+          <a:xfrm>
+            <a:off x="704088" y="1353312"/>
+            <a:ext cx="7744968" cy="3300984"/>
+          </a:xfrm>
+          <a:prstGeom prst="rect">
+            <a:avLst/>
+          </a:prstGeom>
+          <a:noFill/>
+        </p:spPr>
+        <p:txBody>
+          <a:bodyPr wrap="square">
+            <a:spAutoFit/>
+          </a:bodyPr>
+          <a:lstStyle/>
+          <a:p>
+            <a:pPr>
+              <a:lnSpc>
+                <a:spcPct val="112000"/>
+              </a:lnSpc>
+              <a:spcAft>
+                <a:spcPts val="900"/>
+              </a:spcAft>
+            </a:pPr>
+            <a:r>
+              <a:rPr sz="1800" b="1">
+                <a:solidFill>
+                  <a:srgbClr val="E0A437"/>
+                </a:solidFill>
+                <a:latin typeface="Fira Sans"/>
+              </a:rPr>
+              <a:t>▸ </a:t>
+            </a:r>
+            <a:r>
+              <a:rPr sz="1800" b="1">
+                <a:solidFill>
+                  <a:srgbClr val="1D3557"/>
+                </a:solidFill>
+                <a:latin typeface="Fira Sans"/>
+              </a:rPr>
+              <a:t>Ocho equipos, en el orden en que se ofrezcan. Máximo 10 minutos por equipo; el tiempo se controla. Después, preguntas de la profesora y del curso.</a:t>
+            </a:r>
+          </a:p>
+          <a:p>
+            <a:pPr>
+              <a:lnSpc>
+                <a:spcPct val="112000"/>
+              </a:lnSpc>
+              <a:spcAft>
+                <a:spcPts val="900"/>
+              </a:spcAft>
+            </a:pPr>
+            <a:r>
+              <a:rPr sz="1800" b="1">
+                <a:solidFill>
+                  <a:srgbClr val="E0A437"/>
+                </a:solidFill>
+                <a:latin typeface="Fira Sans"/>
+              </a:rPr>
+              <a:t>▸ </a:t>
+            </a:r>
+            <a:r>
+              <a:rPr sz="1800" b="0">
+                <a:solidFill>
+                  <a:srgbClr val="000000"/>
+                </a:solidFill>
+                <a:latin typeface="Fira Sans"/>
+              </a:rPr>
+              <a:t>Se evalúa el avance, no un resultado final: el modelo es un primer intento. La exigencia está en el tiempo, la claridad, la explicación de los gráficos y las relaciones, y en advertir qué falta o qué no tiene sentido.</a:t>
+            </a:r>
+          </a:p>
+          <a:p>
+            <a:pPr>
+              <a:lnSpc>
+                <a:spcPct val="112000"/>
+              </a:lnSpc>
+              <a:spcAft>
+                <a:spcPts val="900"/>
+              </a:spcAft>
+            </a:pPr>
+            <a:r>
+              <a:rPr sz="1800" b="1">
+                <a:solidFill>
+                  <a:srgbClr val="E0A437"/>
+                </a:solidFill>
+                <a:latin typeface="Fira Sans"/>
+              </a:rPr>
+              <a:t>▸ </a:t>
+            </a:r>
+            <a:r>
+              <a:rPr sz="1800" b="0">
+                <a:solidFill>
+                  <a:srgbClr val="000000"/>
+                </a:solidFill>
+                <a:latin typeface="Fira Sans"/>
+              </a:rPr>
+              <a:t>Las slides, en PDF, al Aula hasta las 20:30: un envío por equipo con los nombres.</a:t>
+            </a:r>
+          </a:p>
+          <a:p>
+            <a:pPr>
+              <a:lnSpc>
+                <a:spcPct val="112000"/>
+              </a:lnSpc>
+              <a:spcAft>
+                <a:spcPts val="900"/>
+              </a:spcAft>
+            </a:pPr>
+            <a:r>
+              <a:rPr sz="1800" b="1">
+                <a:solidFill>
+                  <a:srgbClr val="E0A437"/>
+                </a:solidFill>
+                <a:latin typeface="Fira Sans"/>
+              </a:rPr>
+              <a:t>▸ </a:t>
+            </a:r>
+            <a:r>
+              <a:rPr sz="1800" b="0">
+                <a:solidFill>
+                  <a:srgbClr val="000000"/>
+                </a:solidFill>
+                <a:latin typeface="Fira Sans"/>
+              </a:rPr>
+              <a:t>El informe escrito, el viernes 25 de septiembre por el Aula: máximo 7 páginas, con su rúbrica publicada.</a:t>
+            </a:r>
+          </a:p>
+        </p:txBody>
+      </p:sp>
+    </p:spTree>
+  </p:cSld>
+  <p:clrMapOvr>
+    <a:masterClrMapping/>
+  </p:clrMapOvr>
+</p:sld>
+</file>
+
+<file path=ppt/slides/slide32.xml><?xml version="1.0" encoding="utf-8"?>
+<p:sld xmlns:a="http://schemas.openxmlformats.org/drawingml/2006/main" xmlns:p="http://schemas.openxmlformats.org/presentationml/2006/main" xmlns:r="http://schemas.openxmlformats.org/officeDocument/2006/relationships">
+  <p:cSld>
+    <p:spTree>
+      <p:nvGrpSpPr>
+        <p:cNvPr id="1" name=""/>
+        <p:cNvGrpSpPr/>
+        <p:nvPr/>
+      </p:nvGrpSpPr>
+      <p:grpSpPr/>
+      <p:sp>
+        <p:nvSpPr>
+          <p:cNvPr id="2" name="Rectangle 1"/>
+          <p:cNvSpPr/>
+          <p:nvPr/>
+        </p:nvSpPr>
+        <p:spPr>
+          <a:xfrm>
+            <a:off x="0" y="0"/>
+            <a:ext cx="9144000" cy="5138928"/>
+          </a:xfrm>
+          <a:prstGeom prst="rect">
+            <a:avLst/>
+          </a:prstGeom>
+          <a:solidFill>
+            <a:srgbClr val="FAFBFC"/>
+          </a:solidFill>
+          <a:ln>
+            <a:noFill/>
+          </a:ln>
+          <a:effectLst/>
+        </p:spPr>
+        <p:style>
+          <a:lnRef idx="1">
+            <a:schemeClr val="accent1"/>
+          </a:lnRef>
+          <a:fillRef idx="3">
+            <a:schemeClr val="accent1"/>
+          </a:fillRef>
+          <a:effectRef idx="2">
+            <a:schemeClr val="accent1"/>
+          </a:effectRef>
+          <a:fontRef idx="minor">
+            <a:schemeClr val="lt1"/>
+          </a:fontRef>
+        </p:style>
+        <p:txBody>
+          <a:bodyPr rtlCol="0" anchor="ctr"/>
+          <a:lstStyle/>
+          <a:p>
+            <a:pPr algn="ctr"/>
+          </a:p>
+        </p:txBody>
+      </p:sp>
+      <p:sp>
+        <p:nvSpPr>
+          <p:cNvPr id="3" name="TextBox 2"/>
+          <p:cNvSpPr txBox="1"/>
+          <p:nvPr/>
+        </p:nvSpPr>
+        <p:spPr>
+          <a:xfrm>
+            <a:off x="402336" y="301752"/>
+            <a:ext cx="8348472" cy="795528"/>
+          </a:xfrm>
+          <a:prstGeom prst="rect">
+            <a:avLst/>
+          </a:prstGeom>
+          <a:noFill/>
+        </p:spPr>
+        <p:txBody>
+          <a:bodyPr wrap="square">
+            <a:spAutoFit/>
+          </a:bodyPr>
+          <a:lstStyle/>
+          <a:p>
+            <a:r>
+              <a:rPr sz="2800" b="1">
+                <a:solidFill>
+                  <a:srgbClr val="0F0F0F"/>
+                </a:solidFill>
+                <a:latin typeface="Fira Sans"/>
+              </a:rPr>
+              <a:t>Referencias</a:t>
+            </a:r>
+          </a:p>
+        </p:txBody>
+      </p:sp>
+      <p:sp>
+        <p:nvSpPr>
+          <p:cNvPr id="4" name="TextBox 3"/>
+          <p:cNvSpPr txBox="1"/>
+          <p:nvPr/>
+        </p:nvSpPr>
+        <p:spPr>
+          <a:xfrm>
+            <a:off x="704088" y="1234440"/>
+            <a:ext cx="7744968" cy="3566160"/>
+          </a:xfrm>
+          <a:prstGeom prst="rect">
+            <a:avLst/>
+          </a:prstGeom>
+          <a:noFill/>
+        </p:spPr>
+        <p:txBody>
+          <a:bodyPr wrap="square">
+            <a:spAutoFit/>
+          </a:bodyPr>
+          <a:lstStyle/>
+          <a:p>
+            <a:pPr>
+              <a:lnSpc>
+                <a:spcPct val="115000"/>
+              </a:lnSpc>
+              <a:spcAft>
+                <a:spcPts val="700"/>
+              </a:spcAft>
+            </a:pPr>
+            <a:r>
+              <a:rPr sz="1300" b="0">
+                <a:solidFill>
+                  <a:srgbClr val="333333"/>
+                </a:solidFill>
+                <a:latin typeface="Fira Sans"/>
+              </a:rPr>
+              <a:t>James, G., Witten, D., Hastie, T. y Tibshirani, R. (2013). An Introduction to Statistical Learning. Springer. Sección 10.2, pp. 374 a 385: qué es una componente principal, por qué estandarizar, la proporción de variación explicada y cuántas componentes usar. PDF gratuito en statlearning.com.</a:t>
+            </a:r>
+          </a:p>
+          <a:p>
+            <a:pPr>
+              <a:lnSpc>
+                <a:spcPct val="115000"/>
+              </a:lnSpc>
+              <a:spcAft>
+                <a:spcPts val="700"/>
+              </a:spcAft>
+            </a:pPr>
+            <a:r>
+              <a:rPr sz="1300" b="0">
+                <a:solidFill>
+                  <a:srgbClr val="333333"/>
+                </a:solidFill>
+                <a:latin typeface="Fira Sans"/>
+              </a:rPr>
+              <a:t>VanderPlas, J. (2016). Python Data Science Handbook. O'Reilly. Capítulo "In Depth: Principal Component Analysis", de acceso abierto en jakevdp.github.io/PythonDataScienceHandbook.</a:t>
+            </a:r>
+          </a:p>
+          <a:p>
+            <a:pPr>
+              <a:lnSpc>
+                <a:spcPct val="115000"/>
+              </a:lnSpc>
+              <a:spcAft>
+                <a:spcPts val="700"/>
+              </a:spcAft>
+            </a:pPr>
+            <a:r>
+              <a:rPr sz="1300" b="0">
+                <a:solidFill>
+                  <a:srgbClr val="333333"/>
+                </a:solidFill>
+                <a:latin typeface="Fira Sans"/>
+              </a:rPr>
+              <a:t>Documentación de scikit-learn, sklearn.decomposition.PCA: scikit-learn.org/stable/modules/decomposition.html</a:t>
+            </a:r>
+          </a:p>
+          <a:p>
+            <a:pPr>
+              <a:lnSpc>
+                <a:spcPct val="115000"/>
+              </a:lnSpc>
+              <a:spcAft>
+                <a:spcPts val="700"/>
+              </a:spcAft>
+            </a:pPr>
+            <a:r>
+              <a:rPr sz="1300" b="0">
+                <a:solidFill>
+                  <a:srgbClr val="333333"/>
+                </a:solidFill>
+                <a:latin typeface="Fira Sans"/>
+              </a:rPr>
+              <a:t>Datos: Hitters, del libro de James et al. (statlearning.com), e iris (Fisher, 1936), incluido en scikit-learn.</a:t>
+            </a:r>
+          </a:p>
+        </p:txBody>
+      </p:sp>
+    </p:spTree>
+  </p:cSld>
+  <p:clrMapOvr>
+    <a:masterClrMapping/>
+  </p:clrMapOvr>
+</p:sld>
+</file>
+
 <file path=ppt/slides/slide4.xml><?xml version="1.0" encoding="utf-8"?>
 <p:sld xmlns:a="http://schemas.openxmlformats.org/drawingml/2006/main" xmlns:p="http://schemas.openxmlformats.org/presentationml/2006/main" xmlns:r="http://schemas.openxmlformats.org/officeDocument/2006/relationships">
   <p:cSld>
@@ -7995,7 +8583,7 @@
                 </a:solidFill>
                 <a:latin typeface="Fira Sans"/>
               </a:rPr>
-              <a:t>2. Qué es</a:t>
+              <a:t>2. La idea</a:t>
             </a:r>
           </a:p>
           <a:p>
@@ -8006,7 +8594,7 @@
                 </a:solidFill>
                 <a:latin typeface="Fira Sans"/>
               </a:rPr>
-              <a:t>El análisis de componentes principales</a:t>
+              <a:t>Reemplazar dos variables por una sola; después, 16 por pocas</a:t>
             </a:r>
           </a:p>
         </p:txBody>
@@ -8102,21 +8690,45 @@
                 </a:solidFill>
                 <a:latin typeface="Fira Sans"/>
               </a:rPr>
-              <a:t>¿Qué es una componente principal?</a:t>
-            </a:r>
-          </a:p>
-        </p:txBody>
-      </p:sp>
-      <p:sp>
-        <p:nvSpPr>
-          <p:cNvPr id="4" name="TextBox 3"/>
+              <a:t>Primero: estandarizar las dos variables</a:t>
+            </a:r>
+          </a:p>
+        </p:txBody>
+      </p:sp>
+      <p:pic>
+        <p:nvPicPr>
+          <p:cNvPr id="4" name="Picture 3" descr="c8_00b_estandarizadas.png"/>
+          <p:cNvPicPr>
+            <a:picLocks noChangeAspect="1"/>
+          </p:cNvPicPr>
+          <p:nvPr/>
+        </p:nvPicPr>
+        <p:blipFill>
+          <a:blip r:embed="rId2"/>
+          <a:stretch>
+            <a:fillRect/>
+          </a:stretch>
+        </p:blipFill>
+        <p:spPr>
+          <a:xfrm>
+            <a:off x="3105399" y="1143000"/>
+            <a:ext cx="2933200" cy="3099815"/>
+          </a:xfrm>
+          <a:prstGeom prst="rect">
+            <a:avLst/>
+          </a:prstGeom>
+        </p:spPr>
+      </p:pic>
+      <p:sp>
+        <p:nvSpPr>
+          <p:cNvPr id="5" name="TextBox 4"/>
           <p:cNvSpPr txBox="1"/>
           <p:nvPr/>
         </p:nvSpPr>
         <p:spPr>
           <a:xfrm>
-            <a:off x="704088" y="1353312"/>
-            <a:ext cx="7744968" cy="3300984"/>
+            <a:off x="704088" y="4379976"/>
+            <a:ext cx="7744968" cy="512064"/>
           </a:xfrm>
           <a:prstGeom prst="rect">
             <a:avLst/>
@@ -8129,115 +8741,14 @@
           </a:bodyPr>
           <a:lstStyle/>
           <a:p>
-            <a:pPr>
-              <a:lnSpc>
-                <a:spcPct val="112000"/>
-              </a:lnSpc>
-              <a:spcAft>
-                <a:spcPts val="900"/>
-              </a:spcAft>
-            </a:pPr>
-            <a:r>
-              <a:rPr sz="1800" b="1">
-                <a:solidFill>
-                  <a:srgbClr val="E0A437"/>
-                </a:solidFill>
-                <a:latin typeface="Fira Sans"/>
-              </a:rPr>
-              <a:t>▸ </a:t>
-            </a:r>
-            <a:r>
-              <a:rPr sz="1800" b="1">
-                <a:solidFill>
-                  <a:srgbClr val="1D3557"/>
-                </a:solidFill>
-                <a:latin typeface="Fira Sans"/>
-              </a:rPr>
-              <a:t>Un método que encuentra una representación de los datos con pocas dimensiones y que conserva la mayor parte posible de su variación (James et al., 2013, p. 375).</a:t>
-            </a:r>
-          </a:p>
-          <a:p>
-            <a:pPr>
-              <a:lnSpc>
-                <a:spcPct val="112000"/>
-              </a:lnSpc>
-              <a:spcAft>
-                <a:spcPts val="900"/>
-              </a:spcAft>
-            </a:pPr>
-            <a:r>
-              <a:rPr sz="1800" b="1">
-                <a:solidFill>
-                  <a:srgbClr val="E0A437"/>
-                </a:solidFill>
-                <a:latin typeface="Fira Sans"/>
-              </a:rPr>
-              <a:t>▸ </a:t>
-            </a:r>
-            <a:r>
-              <a:rPr sz="1800" b="0">
-                <a:solidFill>
-                  <a:srgbClr val="000000"/>
-                </a:solidFill>
-                <a:latin typeface="Fira Sans"/>
-              </a:rPr>
-              <a:t>La primera componente es la dirección en que los datos más varían. La segunda, la que más varía entre las perpendiculares a la primera, y así hasta tener tantas componentes como variables.</a:t>
-            </a:r>
-          </a:p>
-          <a:p>
-            <a:pPr>
-              <a:lnSpc>
-                <a:spcPct val="112000"/>
-              </a:lnSpc>
-              <a:spcAft>
-                <a:spcPts val="900"/>
-              </a:spcAft>
-            </a:pPr>
-            <a:r>
-              <a:rPr sz="1800" b="1">
-                <a:solidFill>
-                  <a:srgbClr val="E0A437"/>
-                </a:solidFill>
-                <a:latin typeface="Fira Sans"/>
-              </a:rPr>
-              <a:t>▸ </a:t>
-            </a:r>
-            <a:r>
-              <a:rPr sz="1800" b="0">
-                <a:solidFill>
-                  <a:srgbClr val="000000"/>
-                </a:solidFill>
-                <a:latin typeface="Fira Sans"/>
-              </a:rPr>
-              <a:t>Cada componente es una variable nueva: un puntaje ponderado de las variables originales, con un peso para cada una.</a:t>
-            </a:r>
-          </a:p>
-          <a:p>
-            <a:pPr>
-              <a:lnSpc>
-                <a:spcPct val="112000"/>
-              </a:lnSpc>
-              <a:spcAft>
-                <a:spcPts val="900"/>
-              </a:spcAft>
-            </a:pPr>
-            <a:r>
-              <a:rPr sz="1800" b="1">
-                <a:solidFill>
-                  <a:srgbClr val="E0A437"/>
-                </a:solidFill>
-                <a:latin typeface="Fira Sans"/>
-              </a:rPr>
-              <a:t>▸ </a:t>
-            </a:r>
-            <a:r>
-              <a:rPr sz="1800" b="0">
-                <a:solidFill>
-                  <a:srgbClr val="000000"/>
-                </a:solidFill>
-                <a:latin typeface="Fira Sans"/>
-              </a:rPr>
-              <a:t>No usa ninguna variable de respuesta: es un método no supervisado (James et al., 2013, p. 375).</a:t>
+            <a:r>
+              <a:rPr sz="1300" b="0">
+                <a:solidFill>
+                  <a:srgbClr val="333333"/>
+                </a:solidFill>
+                <a:latin typeface="Fira Sans"/>
+              </a:rPr>
+              <a:t>A cada variable se le resta su media y se divide por su desviación estándar (el puntaje z de la clase 2). Las dos quedan con media 0 y desviación 1, y el centro de la nube en el origen.</a:t>
             </a:r>
           </a:p>
         </p:txBody>

</xml_diff>

<commit_message>
Clase 8: la posicion sobre la diagonal como regla y el cambio de ejes con las coordenadas nuevas
Revision de Daniela: no se entendia que era 'A queda en -1,60' ni que
significaba 'lo que se pierde es la distancia del punto'. La diagonal se
dibuja como una regla con el 0 en el centro; la slide del cambio de ejes
muestra las dos coordenadas nuevas de A, B y C, y la segunda, casi 0
para todos, es lo que se descarta. Figuras de las slides 11, 12 y 13 a
toda la altura, con el texto al lado.

Co-Authored-By: Claude Fable 5.1 <noreply@anthropic.com>
</commit_message>
<xml_diff>
--- a/presentaciones/clase08_componentes_principales.pptx
+++ b/presentaciones/clase08_componentes_principales.pptx
@@ -3629,8 +3629,8 @@
         </p:blipFill>
         <p:spPr>
           <a:xfrm>
-            <a:off x="3152663" y="1143000"/>
-            <a:ext cx="2838672" cy="2843784"/>
+            <a:off x="320040" y="1097280"/>
+            <a:ext cx="3689622" cy="3886200"/>
           </a:xfrm>
           <a:prstGeom prst="rect">
             <a:avLst/>
@@ -3645,8 +3645,8 @@
         </p:nvSpPr>
         <p:spPr>
           <a:xfrm>
-            <a:off x="704088" y="4123944"/>
-            <a:ext cx="7744968" cy="768096"/>
+            <a:off x="4238261" y="1325880"/>
+            <a:ext cx="4585698" cy="3566160"/>
           </a:xfrm>
           <a:prstGeom prst="rect">
             <a:avLst/>
@@ -3659,14 +3659,87 @@
           </a:bodyPr>
           <a:lstStyle/>
           <a:p>
-            <a:r>
-              <a:rPr sz="1300" b="0">
-                <a:solidFill>
-                  <a:srgbClr val="333333"/>
-                </a:solidFill>
-                <a:latin typeface="Fira Sans"/>
-              </a:rPr>
-              <a:t>A cada jugador se le marca el punto más cercano de la diagonal. Su posición sobre ella es un solo número que reemplaza a sus dos valores: A queda en −1,60, B en −0,48 y C en 2,01. Lo que se pierde es la distancia del punto a la recta, que aquí es casi nula.</a:t>
+            <a:pPr>
+              <a:lnSpc>
+                <a:spcPct val="112000"/>
+              </a:lnSpc>
+              <a:spcAft>
+                <a:spcPts val="900"/>
+              </a:spcAft>
+            </a:pPr>
+            <a:r>
+              <a:rPr sz="1500" b="1">
+                <a:solidFill>
+                  <a:srgbClr val="E0A437"/>
+                </a:solidFill>
+                <a:latin typeface="Fira Sans"/>
+              </a:rPr>
+              <a:t>▸ </a:t>
+            </a:r>
+            <a:r>
+              <a:rPr sz="1500" b="1">
+                <a:solidFill>
+                  <a:srgbClr val="1D3557"/>
+                </a:solidFill>
+                <a:latin typeface="Fira Sans"/>
+              </a:rPr>
+              <a:t>La diagonal es una regla: el 0 en el centro de la nube, en las unidades de los ejes, positivo hacia arriba y a la derecha.</a:t>
+            </a:r>
+          </a:p>
+          <a:p>
+            <a:pPr>
+              <a:lnSpc>
+                <a:spcPct val="112000"/>
+              </a:lnSpc>
+              <a:spcAft>
+                <a:spcPts val="900"/>
+              </a:spcAft>
+            </a:pPr>
+            <a:r>
+              <a:rPr sz="1500" b="1">
+                <a:solidFill>
+                  <a:srgbClr val="E0A437"/>
+                </a:solidFill>
+                <a:latin typeface="Fira Sans"/>
+              </a:rPr>
+              <a:t>▸ </a:t>
+            </a:r>
+            <a:r>
+              <a:rPr sz="1500" b="0">
+                <a:solidFill>
+                  <a:srgbClr val="000000"/>
+                </a:solidFill>
+                <a:latin typeface="Fira Sans"/>
+              </a:rPr>
+              <a:t>A cada jugador se le marca el punto de la regla más cercano y se lee el número: A cae en −1,60, B en −0,48 y C en 2,01.</a:t>
+            </a:r>
+          </a:p>
+          <a:p>
+            <a:pPr>
+              <a:lnSpc>
+                <a:spcPct val="112000"/>
+              </a:lnSpc>
+              <a:spcAft>
+                <a:spcPts val="900"/>
+              </a:spcAft>
+            </a:pPr>
+            <a:r>
+              <a:rPr sz="1500" b="1">
+                <a:solidFill>
+                  <a:srgbClr val="E0A437"/>
+                </a:solidFill>
+                <a:latin typeface="Fira Sans"/>
+              </a:rPr>
+              <a:t>▸ </a:t>
+            </a:r>
+            <a:r>
+              <a:rPr sz="1500" b="0">
+                <a:solidFill>
+                  <a:srgbClr val="000000"/>
+                </a:solidFill>
+                <a:latin typeface="Fira Sans"/>
+              </a:rPr>
+              <a:t>Ese número es la variable nueva: reemplaza a los dos valores de cada jugador, sus turnos y sus hits.</a:t>
             </a:r>
           </a:p>
         </p:txBody>
@@ -3783,8 +3856,8 @@
         </p:blipFill>
         <p:spPr>
           <a:xfrm>
-            <a:off x="1779455" y="1143000"/>
-            <a:ext cx="5585089" cy="2843784"/>
+            <a:off x="320040" y="1097280"/>
+            <a:ext cx="3689622" cy="3886200"/>
           </a:xfrm>
           <a:prstGeom prst="rect">
             <a:avLst/>
@@ -3799,8 +3872,8 @@
         </p:nvSpPr>
         <p:spPr>
           <a:xfrm>
-            <a:off x="704088" y="4123944"/>
-            <a:ext cx="7744968" cy="768096"/>
+            <a:off x="4238261" y="1325880"/>
+            <a:ext cx="4585698" cy="3566160"/>
           </a:xfrm>
           <a:prstGeom prst="rect">
             <a:avLst/>
@@ -3813,14 +3886,87 @@
           </a:bodyPr>
           <a:lstStyle/>
           <a:p>
-            <a:r>
-              <a:rPr sz="1300" b="0">
-                <a:solidFill>
-                  <a:srgbClr val="333333"/>
-                </a:solidFill>
-                <a:latin typeface="Fira Sans"/>
-              </a:rPr>
-              <a:t>Se mide con la dispersión de las posiciones a lo largo de cada dirección: 1,41 sobre la diagonal, casi toda la que hay, y 0,07 en su perpendicular. Quedarse con la posición sobre la diagonal conserva el 99,8% de la variación y pierde el 0,2%.</a:t>
+            <a:pPr>
+              <a:lnSpc>
+                <a:spcPct val="112000"/>
+              </a:lnSpc>
+              <a:spcAft>
+                <a:spcPts val="900"/>
+              </a:spcAft>
+            </a:pPr>
+            <a:r>
+              <a:rPr sz="1500" b="1">
+                <a:solidFill>
+                  <a:srgbClr val="E0A437"/>
+                </a:solidFill>
+                <a:latin typeface="Fira Sans"/>
+              </a:rPr>
+              <a:t>▸ </a:t>
+            </a:r>
+            <a:r>
+              <a:rPr sz="1500" b="1">
+                <a:solidFill>
+                  <a:srgbClr val="1D3557"/>
+                </a:solidFill>
+                <a:latin typeface="Fira Sans"/>
+              </a:rPr>
+              <a:t>Para cada dirección que pasa por el centro se mide cuánto se dispersan los puntos a lo largo de ella.</a:t>
+            </a:r>
+          </a:p>
+          <a:p>
+            <a:pPr>
+              <a:lnSpc>
+                <a:spcPct val="112000"/>
+              </a:lnSpc>
+              <a:spcAft>
+                <a:spcPts val="900"/>
+              </a:spcAft>
+            </a:pPr>
+            <a:r>
+              <a:rPr sz="1500" b="1">
+                <a:solidFill>
+                  <a:srgbClr val="E0A437"/>
+                </a:solidFill>
+                <a:latin typeface="Fira Sans"/>
+              </a:rPr>
+              <a:t>▸ </a:t>
+            </a:r>
+            <a:r>
+              <a:rPr sz="1500" b="0">
+                <a:solidFill>
+                  <a:srgbClr val="000000"/>
+                </a:solidFill>
+                <a:latin typeface="Fira Sans"/>
+              </a:rPr>
+              <a:t>Horizontal 1,00; vertical 1,00; diagonal 1,41, la mayor de todas; perpendicular a la diagonal 0,07.</a:t>
+            </a:r>
+          </a:p>
+          <a:p>
+            <a:pPr>
+              <a:lnSpc>
+                <a:spcPct val="112000"/>
+              </a:lnSpc>
+              <a:spcAft>
+                <a:spcPts val="900"/>
+              </a:spcAft>
+            </a:pPr>
+            <a:r>
+              <a:rPr sz="1500" b="1">
+                <a:solidFill>
+                  <a:srgbClr val="E0A437"/>
+                </a:solidFill>
+                <a:latin typeface="Fira Sans"/>
+              </a:rPr>
+              <a:t>▸ </a:t>
+            </a:r>
+            <a:r>
+              <a:rPr sz="1500" b="0">
+                <a:solidFill>
+                  <a:srgbClr val="000000"/>
+                </a:solidFill>
+                <a:latin typeface="Fira Sans"/>
+              </a:rPr>
+              <a:t>Quedarse con la posición sobre la diagonal conserva el 99,8% de la variación de los datos y pierde el 0,2%.</a:t>
             </a:r>
           </a:p>
         </p:txBody>
@@ -3916,7 +4062,7 @@
                 </a:solidFill>
                 <a:latin typeface="Fira Sans"/>
               </a:rPr>
-              <a:t>La diagonal se llama primera componente</a:t>
+              <a:t>Es un cambio de ejes: las dos componentes</a:t>
             </a:r>
           </a:p>
         </p:txBody>
@@ -3937,8 +4083,8 @@
         </p:blipFill>
         <p:spPr>
           <a:xfrm>
-            <a:off x="2622002" y="1143000"/>
-            <a:ext cx="3899995" cy="3099816"/>
+            <a:off x="320040" y="1097280"/>
+            <a:ext cx="4032615" cy="3886200"/>
           </a:xfrm>
           <a:prstGeom prst="rect">
             <a:avLst/>
@@ -3953,8 +4099,8 @@
         </p:nvSpPr>
         <p:spPr>
           <a:xfrm>
-            <a:off x="704088" y="4379976"/>
-            <a:ext cx="7744968" cy="512064"/>
+            <a:off x="4581254" y="1325880"/>
+            <a:ext cx="4242705" cy="3566160"/>
           </a:xfrm>
           <a:prstGeom prst="rect">
             <a:avLst/>
@@ -3967,14 +4113,115 @@
           </a:bodyPr>
           <a:lstStyle/>
           <a:p>
-            <a:r>
-              <a:rPr sz="1300" b="0">
-                <a:solidFill>
-                  <a:srgbClr val="333333"/>
-                </a:solidFill>
-                <a:latin typeface="Fira Sans"/>
-              </a:rPr>
-              <a:t>Ninguna otra dirección conserva más variación que la diagonal: por eso se llama primera componente principal. Su perpendicular, la que conserva el resto, es la segunda.</a:t>
+            <a:pPr>
+              <a:lnSpc>
+                <a:spcPct val="112000"/>
+              </a:lnSpc>
+              <a:spcAft>
+                <a:spcPts val="900"/>
+              </a:spcAft>
+            </a:pPr>
+            <a:r>
+              <a:rPr sz="1500" b="1">
+                <a:solidFill>
+                  <a:srgbClr val="E0A437"/>
+                </a:solidFill>
+                <a:latin typeface="Fira Sans"/>
+              </a:rPr>
+              <a:t>▸ </a:t>
+            </a:r>
+            <a:r>
+              <a:rPr sz="1500" b="1">
+                <a:solidFill>
+                  <a:srgbClr val="1D3557"/>
+                </a:solidFill>
+                <a:latin typeface="Fira Sans"/>
+              </a:rPr>
+              <a:t>Un cambio de sistema de referencia: en vez de turnos y hits, dos ejes nuevos girados 45°, la diagonal y su perpendicular, con el mismo centro.</a:t>
+            </a:r>
+          </a:p>
+          <a:p>
+            <a:pPr>
+              <a:lnSpc>
+                <a:spcPct val="112000"/>
+              </a:lnSpc>
+              <a:spcAft>
+                <a:spcPts val="900"/>
+              </a:spcAft>
+            </a:pPr>
+            <a:r>
+              <a:rPr sz="1500" b="1">
+                <a:solidFill>
+                  <a:srgbClr val="E0A437"/>
+                </a:solidFill>
+                <a:latin typeface="Fira Sans"/>
+              </a:rPr>
+              <a:t>▸ </a:t>
+            </a:r>
+            <a:r>
+              <a:rPr sz="1500" b="0">
+                <a:solidFill>
+                  <a:srgbClr val="000000"/>
+                </a:solidFill>
+                <a:latin typeface="Fira Sans"/>
+              </a:rPr>
+              <a:t>Cada jugador tiene dos coordenadas nuevas. A pasa de (−1,16; −1,11) a (−1,60; 0,03); C, de (1,51; 1,33) a (2,01; −0,13).</a:t>
+            </a:r>
+          </a:p>
+          <a:p>
+            <a:pPr>
+              <a:lnSpc>
+                <a:spcPct val="112000"/>
+              </a:lnSpc>
+              <a:spcAft>
+                <a:spcPts val="900"/>
+              </a:spcAft>
+            </a:pPr>
+            <a:r>
+              <a:rPr sz="1500" b="1">
+                <a:solidFill>
+                  <a:srgbClr val="E0A437"/>
+                </a:solidFill>
+                <a:latin typeface="Fira Sans"/>
+              </a:rPr>
+              <a:t>▸ </a:t>
+            </a:r>
+            <a:r>
+              <a:rPr sz="1500" b="0">
+                <a:solidFill>
+                  <a:srgbClr val="000000"/>
+                </a:solidFill>
+                <a:latin typeface="Fira Sans"/>
+              </a:rPr>
+              <a:t>La segunda coordenada es casi 0 para todos: es lo que se descarta al quedarse con un solo número.</a:t>
+            </a:r>
+          </a:p>
+          <a:p>
+            <a:pPr>
+              <a:lnSpc>
+                <a:spcPct val="112000"/>
+              </a:lnSpc>
+              <a:spcAft>
+                <a:spcPts val="900"/>
+              </a:spcAft>
+            </a:pPr>
+            <a:r>
+              <a:rPr sz="1500" b="1">
+                <a:solidFill>
+                  <a:srgbClr val="E0A437"/>
+                </a:solidFill>
+                <a:latin typeface="Fira Sans"/>
+              </a:rPr>
+              <a:t>▸ </a:t>
+            </a:r>
+            <a:r>
+              <a:rPr sz="1500" b="0">
+                <a:solidFill>
+                  <a:srgbClr val="000000"/>
+                </a:solidFill>
+                <a:latin typeface="Fira Sans"/>
+              </a:rPr>
+              <a:t>El primer eje se llama primera componente principal; el segundo, segunda.</a:t>
             </a:r>
           </a:p>
         </p:txBody>
@@ -4353,7 +4600,7 @@
         <p:spPr>
           <a:xfrm>
             <a:off x="4892040" y="1371600"/>
-            <a:ext cx="3840480" cy="3052511"/>
+            <a:ext cx="3840480" cy="3701041"/>
           </a:xfrm>
           <a:prstGeom prst="rect">
             <a:avLst/>

</xml_diff>

<commit_message>
Clase 8: de donde sale el 99,8% (33 slides) y citas sin 'el libro dice'
Revision de Daniela: pidio ver como se calculo el 99,8% y quitar las
frases 'el libro recomienda' y 'el libro dice' manteniendo la cita.
Slide nueva con las varianzas de las coordenadas originales (1 + 1 = 2)
y de las nuevas (1,995 + 0,005 = 2) y las proporciones; la misma cuenta
en el notebook, ejecutado.

Co-Authored-By: Claude Fable 5.1 <noreply@anthropic.com>
</commit_message>
<xml_diff>
--- a/presentaciones/clase08_componentes_principales.pptx
+++ b/presentaciones/clase08_componentes_principales.pptx
@@ -37,6 +37,7 @@
     <p:sldId id="285" r:id="rId36"/>
     <p:sldId id="286" r:id="rId37"/>
     <p:sldId id="287" r:id="rId38"/>
+    <p:sldId id="288" r:id="rId39"/>
   </p:sldIdLst>
   <p:sldSz cx="9144000" cy="5138928" type="screen4x3"/>
   <p:notesSz cx="6858000" cy="9144000"/>
@@ -4317,14 +4318,14 @@
                 </a:solidFill>
                 <a:latin typeface="Fira Sans"/>
               </a:rPr>
-              <a:t>En la práctica: un puntaje ponderado por jugador</a:t>
+              <a:t>De dónde sale el 99,8%</a:t>
             </a:r>
           </a:p>
         </p:txBody>
       </p:sp>
       <p:pic>
         <p:nvPicPr>
-          <p:cNvPr id="4" name="Picture 3" descr="c8_01b_puntaje_ponderado.png"/>
+          <p:cNvPr id="4" name="Picture 3" descr="c8_01d_calculo_pve.png"/>
           <p:cNvPicPr>
             <a:picLocks noChangeAspect="1"/>
           </p:cNvPicPr>
@@ -4338,8 +4339,8 @@
         </p:blipFill>
         <p:spPr>
           <a:xfrm>
-            <a:off x="699515" y="1261139"/>
-            <a:ext cx="7744968" cy="2607505"/>
+            <a:off x="1840230" y="1143000"/>
+            <a:ext cx="5463540" cy="2331720"/>
           </a:xfrm>
           <a:prstGeom prst="rect">
             <a:avLst/>
@@ -4354,8 +4355,8 @@
         </p:nvSpPr>
         <p:spPr>
           <a:xfrm>
-            <a:off x="704088" y="4005804"/>
-            <a:ext cx="7744968" cy="768096"/>
+            <a:off x="704088" y="3611879"/>
+            <a:ext cx="7744968" cy="1280160"/>
           </a:xfrm>
           <a:prstGeom prst="rect">
             <a:avLst/>
@@ -4375,7 +4376,7 @@
                 </a:solidFill>
                 <a:latin typeface="Fira Sans"/>
               </a:rPr>
-              <a:t>La posición sobre la diagonal se calcula como un puntaje ponderado, igual que el de la admisión universitaria: cada variable entra con un peso y sale un número por jugador. Aquí los pesos no los fija nadie: se calculan para que ese número separe a los jugadores lo más posible.</a:t>
+              <a:t>La variación de una coordenada se mide con su varianza. Las dos variables estandarizadas tienen varianza 1 y 1: la variación total es 2. Las dos coordenadas nuevas reparten esa misma variación, 1,995 y 0,005, que también suman 2. La parte de la primera es 1,995 / 2 = 99,8%; la de la segunda, 0,005 / 2 = 0,2%. Con 16 variables es lo mismo: la variación total es 16 y cada componente se lleva una parte.</a:t>
             </a:r>
           </a:p>
         </p:txBody>
@@ -4471,121 +4472,14 @@
                 </a:solidFill>
                 <a:latin typeface="Fira Sans"/>
               </a:rPr>
-              <a:t>El análisis de componentes principales</a:t>
-            </a:r>
-          </a:p>
-        </p:txBody>
-      </p:sp>
-      <p:sp>
-        <p:nvSpPr>
-          <p:cNvPr id="4" name="TextBox 3"/>
-          <p:cNvSpPr txBox="1"/>
-          <p:nvPr/>
-        </p:nvSpPr>
-        <p:spPr>
-          <a:xfrm>
-            <a:off x="502920" y="1252728"/>
-            <a:ext cx="4023360" cy="3200400"/>
-          </a:xfrm>
-          <a:prstGeom prst="rect">
-            <a:avLst/>
-          </a:prstGeom>
-          <a:noFill/>
-        </p:spPr>
-        <p:txBody>
-          <a:bodyPr wrap="square">
-            <a:spAutoFit/>
-          </a:bodyPr>
-          <a:lstStyle/>
-          <a:p>
-            <a:pPr>
-              <a:lnSpc>
-                <a:spcPct val="112000"/>
-              </a:lnSpc>
-              <a:spcAft>
-                <a:spcPts val="900"/>
-              </a:spcAft>
-            </a:pPr>
-            <a:r>
-              <a:rPr sz="1500" b="1">
-                <a:solidFill>
-                  <a:srgbClr val="E0A437"/>
-                </a:solidFill>
-                <a:latin typeface="Fira Sans"/>
-              </a:rPr>
-              <a:t>▸ </a:t>
-            </a:r>
-            <a:r>
-              <a:rPr sz="1500" b="1">
-                <a:solidFill>
-                  <a:srgbClr val="1D3557"/>
-                </a:solidFill>
-                <a:latin typeface="Fira Sans"/>
-              </a:rPr>
-              <a:t>Busca la dirección en que los datos más se dispersan (la primera componente), luego la que más se dispersa entre las perpendiculares (la segunda), y así hasta tener tantas como variables.</a:t>
-            </a:r>
-          </a:p>
-          <a:p>
-            <a:pPr>
-              <a:lnSpc>
-                <a:spcPct val="112000"/>
-              </a:lnSpc>
-              <a:spcAft>
-                <a:spcPts val="900"/>
-              </a:spcAft>
-            </a:pPr>
-            <a:r>
-              <a:rPr sz="1500" b="1">
-                <a:solidFill>
-                  <a:srgbClr val="E0A437"/>
-                </a:solidFill>
-                <a:latin typeface="Fira Sans"/>
-              </a:rPr>
-              <a:t>▸ </a:t>
-            </a:r>
-            <a:r>
-              <a:rPr sz="1500" b="0">
-                <a:solidFill>
-                  <a:srgbClr val="000000"/>
-                </a:solidFill>
-                <a:latin typeface="Fira Sans"/>
-              </a:rPr>
-              <a:t>Cada componente es una variable nueva: un puntaje ponderado de las originales, con una parte de la variación total.</a:t>
-            </a:r>
-          </a:p>
-          <a:p>
-            <a:pPr>
-              <a:lnSpc>
-                <a:spcPct val="112000"/>
-              </a:lnSpc>
-              <a:spcAft>
-                <a:spcPts val="900"/>
-              </a:spcAft>
-            </a:pPr>
-            <a:r>
-              <a:rPr sz="1500" b="1">
-                <a:solidFill>
-                  <a:srgbClr val="E0A437"/>
-                </a:solidFill>
-                <a:latin typeface="Fira Sans"/>
-              </a:rPr>
-              <a:t>▸ </a:t>
-            </a:r>
-            <a:r>
-              <a:rPr sz="1500" b="0">
-                <a:solidFill>
-                  <a:srgbClr val="000000"/>
-                </a:solidFill>
-                <a:latin typeface="Fira Sans"/>
-              </a:rPr>
-              <a:t>No usa ninguna respuesta Y: es un método no supervisado (James et al., 2013, p. 375).</a:t>
+              <a:t>En la práctica: un puntaje ponderado por jugador</a:t>
             </a:r>
           </a:p>
         </p:txBody>
       </p:sp>
       <p:pic>
         <p:nvPicPr>
-          <p:cNvPr id="5" name="Picture 4" descr="c8_01c_componentes.png"/>
+          <p:cNvPr id="4" name="Picture 3" descr="c8_01b_puntaje_ponderado.png"/>
           <p:cNvPicPr>
             <a:picLocks noChangeAspect="1"/>
           </p:cNvPicPr>
@@ -4599,14 +4493,48 @@
         </p:blipFill>
         <p:spPr>
           <a:xfrm>
-            <a:off x="4892040" y="1371600"/>
-            <a:ext cx="3840480" cy="3701041"/>
+            <a:off x="699515" y="1261139"/>
+            <a:ext cx="7744968" cy="2607505"/>
           </a:xfrm>
           <a:prstGeom prst="rect">
             <a:avLst/>
           </a:prstGeom>
         </p:spPr>
       </p:pic>
+      <p:sp>
+        <p:nvSpPr>
+          <p:cNvPr id="5" name="TextBox 4"/>
+          <p:cNvSpPr txBox="1"/>
+          <p:nvPr/>
+        </p:nvSpPr>
+        <p:spPr>
+          <a:xfrm>
+            <a:off x="704088" y="4005804"/>
+            <a:ext cx="7744968" cy="768096"/>
+          </a:xfrm>
+          <a:prstGeom prst="rect">
+            <a:avLst/>
+          </a:prstGeom>
+          <a:noFill/>
+        </p:spPr>
+        <p:txBody>
+          <a:bodyPr wrap="square">
+            <a:spAutoFit/>
+          </a:bodyPr>
+          <a:lstStyle/>
+          <a:p>
+            <a:r>
+              <a:rPr sz="1300" b="0">
+                <a:solidFill>
+                  <a:srgbClr val="333333"/>
+                </a:solidFill>
+                <a:latin typeface="Fira Sans"/>
+              </a:rPr>
+              <a:t>La posición sobre la diagonal se calcula como un puntaje ponderado, igual que el de la admisión universitaria: cada variable entra con un peso y sale un número por jugador. Aquí los pesos no los fija nadie: se calculan para que ese número separe a los jugadores lo más posible.</a:t>
+            </a:r>
+          </a:p>
+        </p:txBody>
+      </p:sp>
     </p:spTree>
   </p:cSld>
   <p:clrMapOvr>
@@ -4698,7 +4626,7 @@
                 </a:solidFill>
                 <a:latin typeface="Fira Sans"/>
               </a:rPr>
-              <a:t>¿Para qué sirve?</a:t>
+              <a:t>El análisis de componentes principales</a:t>
             </a:r>
           </a:p>
         </p:txBody>
@@ -4711,8 +4639,8 @@
         </p:nvSpPr>
         <p:spPr>
           <a:xfrm>
-            <a:off x="704088" y="1353312"/>
-            <a:ext cx="7744968" cy="3300984"/>
+            <a:off x="502920" y="1252728"/>
+            <a:ext cx="4023360" cy="3200400"/>
           </a:xfrm>
           <a:prstGeom prst="rect">
             <a:avLst/>
@@ -4734,7 +4662,7 @@
               </a:spcAft>
             </a:pPr>
             <a:r>
-              <a:rPr sz="1800" b="1">
+              <a:rPr sz="1500" b="1">
                 <a:solidFill>
                   <a:srgbClr val="E0A437"/>
                 </a:solidFill>
@@ -4743,13 +4671,13 @@
               <a:t>▸ </a:t>
             </a:r>
             <a:r>
-              <a:rPr sz="1800" b="1">
+              <a:rPr sz="1500" b="1">
                 <a:solidFill>
                   <a:srgbClr val="1D3557"/>
                 </a:solidFill>
                 <a:latin typeface="Fira Sans"/>
               </a:rPr>
-              <a:t>Para mirar los datos: con 16 variables hay 120 gráficos de dispersión posibles; con dos componentes, uno solo.</a:t>
+              <a:t>Busca la dirección en que los datos más se dispersan (la primera componente), luego la que más se dispersa entre las perpendiculares (la segunda), y así hasta tener tantas como variables.</a:t>
             </a:r>
           </a:p>
           <a:p>
@@ -4762,7 +4690,7 @@
               </a:spcAft>
             </a:pPr>
             <a:r>
-              <a:rPr sz="1800" b="1">
+              <a:rPr sz="1500" b="1">
                 <a:solidFill>
                   <a:srgbClr val="E0A437"/>
                 </a:solidFill>
@@ -4771,13 +4699,13 @@
               <a:t>▸ </a:t>
             </a:r>
             <a:r>
-              <a:rPr sz="1800" b="0">
+              <a:rPr sz="1500" b="0">
                 <a:solidFill>
                   <a:srgbClr val="000000"/>
                 </a:solidFill>
                 <a:latin typeface="Fira Sans"/>
               </a:rPr>
-              <a:t>Para entregarle a un modelo menos entradas: las componentes reemplazan a un grupo de variables que se repiten.</a:t>
+              <a:t>Cada componente es una variable nueva: un puntaje ponderado de las originales, con una parte de la variación total.</a:t>
             </a:r>
           </a:p>
           <a:p>
@@ -4790,7 +4718,7 @@
               </a:spcAft>
             </a:pPr>
             <a:r>
-              <a:rPr sz="1800" b="1">
+              <a:rPr sz="1500" b="1">
                 <a:solidFill>
                   <a:srgbClr val="E0A437"/>
                 </a:solidFill>
@@ -4799,45 +4727,41 @@
               <a:t>▸ </a:t>
             </a:r>
             <a:r>
-              <a:rPr sz="1800" b="0">
+              <a:rPr sz="1500" b="0">
                 <a:solidFill>
                   <a:srgbClr val="000000"/>
                 </a:solidFill>
                 <a:latin typeface="Fira Sans"/>
               </a:rPr>
-              <a:t>Para entender de qué está hecha la variación: qué variables se mueven juntas y cuánto pesa cada grupo.</a:t>
-            </a:r>
-          </a:p>
-          <a:p>
-            <a:pPr>
-              <a:lnSpc>
-                <a:spcPct val="112000"/>
-              </a:lnSpc>
-              <a:spcAft>
-                <a:spcPts val="900"/>
-              </a:spcAft>
-            </a:pPr>
-            <a:r>
-              <a:rPr sz="1800" b="1">
-                <a:solidFill>
-                  <a:srgbClr val="E0A437"/>
-                </a:solidFill>
-                <a:latin typeface="Fira Sans"/>
-              </a:rPr>
-              <a:t>▸ </a:t>
-            </a:r>
-            <a:r>
-              <a:rPr sz="1800" b="0">
-                <a:solidFill>
-                  <a:srgbClr val="000000"/>
-                </a:solidFill>
-                <a:latin typeface="Fira Sans"/>
-              </a:rPr>
-              <a:t>Lo que no hace: no elige variables ni las descarta, y no sabe qué se quiere predecir.</a:t>
-            </a:r>
-          </a:p>
-        </p:txBody>
-      </p:sp>
+              <a:t>No usa ninguna respuesta Y: es un método no supervisado (James et al., 2013, p. 375).</a:t>
+            </a:r>
+          </a:p>
+        </p:txBody>
+      </p:sp>
+      <p:pic>
+        <p:nvPicPr>
+          <p:cNvPr id="5" name="Picture 4" descr="c8_01c_componentes.png"/>
+          <p:cNvPicPr>
+            <a:picLocks noChangeAspect="1"/>
+          </p:cNvPicPr>
+          <p:nvPr/>
+        </p:nvPicPr>
+        <p:blipFill>
+          <a:blip r:embed="rId2"/>
+          <a:stretch>
+            <a:fillRect/>
+          </a:stretch>
+        </p:blipFill>
+        <p:spPr>
+          <a:xfrm>
+            <a:off x="4892040" y="1371600"/>
+            <a:ext cx="3840480" cy="3701041"/>
+          </a:xfrm>
+          <a:prstGeom prst="rect">
+            <a:avLst/>
+          </a:prstGeom>
+        </p:spPr>
+      </p:pic>
     </p:spTree>
   </p:cSld>
   <p:clrMapOvr>
@@ -4929,45 +4853,21 @@
                 </a:solidFill>
                 <a:latin typeface="Fira Sans"/>
               </a:rPr>
-              <a:t>Con 16 variables, los mismos pasos</a:t>
-            </a:r>
-          </a:p>
-        </p:txBody>
-      </p:sp>
-      <p:pic>
-        <p:nvPicPr>
-          <p:cNvPr id="4" name="Picture 3" descr="c8_08_pasos.png"/>
-          <p:cNvPicPr>
-            <a:picLocks noChangeAspect="1"/>
-          </p:cNvPicPr>
-          <p:nvPr/>
-        </p:nvPicPr>
-        <p:blipFill>
-          <a:blip r:embed="rId2"/>
-          <a:stretch>
-            <a:fillRect/>
-          </a:stretch>
-        </p:blipFill>
-        <p:spPr>
-          <a:xfrm>
-            <a:off x="699515" y="1531946"/>
-            <a:ext cx="7744968" cy="2065892"/>
-          </a:xfrm>
-          <a:prstGeom prst="rect">
-            <a:avLst/>
-          </a:prstGeom>
-        </p:spPr>
-      </p:pic>
-      <p:sp>
-        <p:nvSpPr>
-          <p:cNvPr id="5" name="TextBox 4"/>
+              <a:t>¿Para qué sirve?</a:t>
+            </a:r>
+          </a:p>
+        </p:txBody>
+      </p:sp>
+      <p:sp>
+        <p:nvSpPr>
+          <p:cNvPr id="4" name="TextBox 3"/>
           <p:cNvSpPr txBox="1"/>
           <p:nvPr/>
         </p:nvSpPr>
         <p:spPr>
           <a:xfrm>
-            <a:off x="704088" y="3734997"/>
-            <a:ext cx="7744968" cy="768096"/>
+            <a:off x="704088" y="1353312"/>
+            <a:ext cx="7744968" cy="3300984"/>
           </a:xfrm>
           <a:prstGeom prst="rect">
             <a:avLst/>
@@ -4980,14 +4880,115 @@
           </a:bodyPr>
           <a:lstStyle/>
           <a:p>
-            <a:r>
-              <a:rPr sz="1300" b="0">
-                <a:solidFill>
-                  <a:srgbClr val="333333"/>
-                </a:solidFill>
-                <a:latin typeface="Fira Sans"/>
-              </a:rPr>
-              <a:t>Con 16 variables la nube no se puede dibujar, pero el cálculo es el mismo: cada jugador es un punto con 16 coordenadas, se busca la dirección de mayor dispersión, luego la perpendicular que más se dispersa, y así hasta tener 16 componentes, ordenadas de la que más variación conserva a la que menos.</a:t>
+            <a:pPr>
+              <a:lnSpc>
+                <a:spcPct val="112000"/>
+              </a:lnSpc>
+              <a:spcAft>
+                <a:spcPts val="900"/>
+              </a:spcAft>
+            </a:pPr>
+            <a:r>
+              <a:rPr sz="1800" b="1">
+                <a:solidFill>
+                  <a:srgbClr val="E0A437"/>
+                </a:solidFill>
+                <a:latin typeface="Fira Sans"/>
+              </a:rPr>
+              <a:t>▸ </a:t>
+            </a:r>
+            <a:r>
+              <a:rPr sz="1800" b="1">
+                <a:solidFill>
+                  <a:srgbClr val="1D3557"/>
+                </a:solidFill>
+                <a:latin typeface="Fira Sans"/>
+              </a:rPr>
+              <a:t>Para mirar los datos: con 16 variables hay 120 gráficos de dispersión posibles; con dos componentes, uno solo.</a:t>
+            </a:r>
+          </a:p>
+          <a:p>
+            <a:pPr>
+              <a:lnSpc>
+                <a:spcPct val="112000"/>
+              </a:lnSpc>
+              <a:spcAft>
+                <a:spcPts val="900"/>
+              </a:spcAft>
+            </a:pPr>
+            <a:r>
+              <a:rPr sz="1800" b="1">
+                <a:solidFill>
+                  <a:srgbClr val="E0A437"/>
+                </a:solidFill>
+                <a:latin typeface="Fira Sans"/>
+              </a:rPr>
+              <a:t>▸ </a:t>
+            </a:r>
+            <a:r>
+              <a:rPr sz="1800" b="0">
+                <a:solidFill>
+                  <a:srgbClr val="000000"/>
+                </a:solidFill>
+                <a:latin typeface="Fira Sans"/>
+              </a:rPr>
+              <a:t>Para entregarle a un modelo menos entradas: las componentes reemplazan a un grupo de variables que se repiten.</a:t>
+            </a:r>
+          </a:p>
+          <a:p>
+            <a:pPr>
+              <a:lnSpc>
+                <a:spcPct val="112000"/>
+              </a:lnSpc>
+              <a:spcAft>
+                <a:spcPts val="900"/>
+              </a:spcAft>
+            </a:pPr>
+            <a:r>
+              <a:rPr sz="1800" b="1">
+                <a:solidFill>
+                  <a:srgbClr val="E0A437"/>
+                </a:solidFill>
+                <a:latin typeface="Fira Sans"/>
+              </a:rPr>
+              <a:t>▸ </a:t>
+            </a:r>
+            <a:r>
+              <a:rPr sz="1800" b="0">
+                <a:solidFill>
+                  <a:srgbClr val="000000"/>
+                </a:solidFill>
+                <a:latin typeface="Fira Sans"/>
+              </a:rPr>
+              <a:t>Para entender de qué está hecha la variación: qué variables se mueven juntas y cuánto pesa cada grupo.</a:t>
+            </a:r>
+          </a:p>
+          <a:p>
+            <a:pPr>
+              <a:lnSpc>
+                <a:spcPct val="112000"/>
+              </a:lnSpc>
+              <a:spcAft>
+                <a:spcPts val="900"/>
+              </a:spcAft>
+            </a:pPr>
+            <a:r>
+              <a:rPr sz="1800" b="1">
+                <a:solidFill>
+                  <a:srgbClr val="E0A437"/>
+                </a:solidFill>
+                <a:latin typeface="Fira Sans"/>
+              </a:rPr>
+              <a:t>▸ </a:t>
+            </a:r>
+            <a:r>
+              <a:rPr sz="1800" b="0">
+                <a:solidFill>
+                  <a:srgbClr val="000000"/>
+                </a:solidFill>
+                <a:latin typeface="Fira Sans"/>
+              </a:rPr>
+              <a:t>Lo que no hace: no elige variables ni las descarta, y no sabe qué se quiere predecir.</a:t>
             </a:r>
           </a:p>
         </p:txBody>
@@ -5083,14 +5084,14 @@
                 </a:solidFill>
                 <a:latin typeface="Fira Sans"/>
               </a:rPr>
-              <a:t>Por qué se estandariza</a:t>
+              <a:t>Con 16 variables, los mismos pasos</a:t>
             </a:r>
           </a:p>
         </p:txBody>
       </p:sp>
       <p:pic>
         <p:nvPicPr>
-          <p:cNvPr id="4" name="Picture 3" descr="c8_02_estandarizar.png"/>
+          <p:cNvPr id="4" name="Picture 3" descr="c8_08_pasos.png"/>
           <p:cNvPicPr>
             <a:picLocks noChangeAspect="1"/>
           </p:cNvPicPr>
@@ -5104,8 +5105,8 @@
         </p:blipFill>
         <p:spPr>
           <a:xfrm>
-            <a:off x="2421351" y="1143000"/>
-            <a:ext cx="4301297" cy="2331720"/>
+            <a:off x="699515" y="1531946"/>
+            <a:ext cx="7744968" cy="2065892"/>
           </a:xfrm>
           <a:prstGeom prst="rect">
             <a:avLst/>
@@ -5120,8 +5121,8 @@
         </p:nvSpPr>
         <p:spPr>
           <a:xfrm>
-            <a:off x="704088" y="3611879"/>
-            <a:ext cx="7744968" cy="1280160"/>
+            <a:off x="704088" y="3734997"/>
+            <a:ext cx="7744968" cy="768096"/>
           </a:xfrm>
           <a:prstGeom prst="rect">
             <a:avLst/>
@@ -5141,7 +5142,7 @@
                 </a:solidFill>
                 <a:latin typeface="Fira Sans"/>
               </a:rPr>
-              <a:t>Con las variables en sus unidades, la primera componente es casi solo turnos_carrera, porque su desviación estándar (2.287) es 476 veces la de temporadas (4,8): PCA sigue a la variable que más varía en sus unidades. Con cada variable estandarizada (media 0 y desviación 1, como en las clases 2 y 7) todas parten iguales. El libro recomienda estandarizar, salvo que las variables compartan unidad (James et al., 2013, p. 381).</a:t>
+              <a:t>Con 16 variables la nube no se puede dibujar, pero el cálculo es el mismo: cada jugador es un punto con 16 coordenadas, se busca la dirección de mayor dispersión, luego la perpendicular que más se dispersa, y así hasta tener 16 componentes, ordenadas de la que más variación conserva a la que menos.</a:t>
             </a:r>
           </a:p>
         </p:txBody>
@@ -5179,7 +5180,7 @@
             <a:avLst/>
           </a:prstGeom>
           <a:solidFill>
-            <a:srgbClr val="1D3557"/>
+            <a:srgbClr val="FAFBFC"/>
           </a:solidFill>
           <a:ln>
             <a:noFill/>
@@ -5216,8 +5217,8 @@
         </p:nvSpPr>
         <p:spPr>
           <a:xfrm>
-            <a:off x="603504" y="1847088"/>
-            <a:ext cx="7946136" cy="1399032"/>
+            <a:off x="402336" y="301752"/>
+            <a:ext cx="8348472" cy="795528"/>
           </a:xfrm>
           <a:prstGeom prst="rect">
             <a:avLst/>
@@ -5231,24 +5232,71 @@
           <a:lstStyle/>
           <a:p>
             <a:r>
-              <a:rPr sz="3400" b="1">
-                <a:solidFill>
-                  <a:srgbClr val="FFFFFF"/>
-                </a:solidFill>
-                <a:latin typeface="Fira Sans"/>
-              </a:rPr>
-              <a:t>3. Cómo se leen</a:t>
-            </a:r>
-          </a:p>
-          <a:p>
-            <a:r>
-              <a:rPr sz="1800" b="0">
-                <a:solidFill>
-                  <a:srgbClr val="E0A437"/>
-                </a:solidFill>
-                <a:latin typeface="Fira Sans"/>
-              </a:rPr>
-              <a:t>Cuánta variación explica cada componente y de qué está hecha</a:t>
+              <a:rPr sz="2800" b="1">
+                <a:solidFill>
+                  <a:srgbClr val="0F0F0F"/>
+                </a:solidFill>
+                <a:latin typeface="Fira Sans"/>
+              </a:rPr>
+              <a:t>Por qué se estandariza</a:t>
+            </a:r>
+          </a:p>
+        </p:txBody>
+      </p:sp>
+      <p:pic>
+        <p:nvPicPr>
+          <p:cNvPr id="4" name="Picture 3" descr="c8_02_estandarizar.png"/>
+          <p:cNvPicPr>
+            <a:picLocks noChangeAspect="1"/>
+          </p:cNvPicPr>
+          <p:nvPr/>
+        </p:nvPicPr>
+        <p:blipFill>
+          <a:blip r:embed="rId2"/>
+          <a:stretch>
+            <a:fillRect/>
+          </a:stretch>
+        </p:blipFill>
+        <p:spPr>
+          <a:xfrm>
+            <a:off x="2421351" y="1143000"/>
+            <a:ext cx="4301297" cy="2331720"/>
+          </a:xfrm>
+          <a:prstGeom prst="rect">
+            <a:avLst/>
+          </a:prstGeom>
+        </p:spPr>
+      </p:pic>
+      <p:sp>
+        <p:nvSpPr>
+          <p:cNvPr id="5" name="TextBox 4"/>
+          <p:cNvSpPr txBox="1"/>
+          <p:nvPr/>
+        </p:nvSpPr>
+        <p:spPr>
+          <a:xfrm>
+            <a:off x="704088" y="3611879"/>
+            <a:ext cx="7744968" cy="1280160"/>
+          </a:xfrm>
+          <a:prstGeom prst="rect">
+            <a:avLst/>
+          </a:prstGeom>
+          <a:noFill/>
+        </p:spPr>
+        <p:txBody>
+          <a:bodyPr wrap="square">
+            <a:spAutoFit/>
+          </a:bodyPr>
+          <a:lstStyle/>
+          <a:p>
+            <a:r>
+              <a:rPr sz="1300" b="0">
+                <a:solidFill>
+                  <a:srgbClr val="333333"/>
+                </a:solidFill>
+                <a:latin typeface="Fira Sans"/>
+              </a:rPr>
+              <a:t>Con las variables en sus unidades, la primera componente es casi solo turnos_carrera, porque su desviación estándar (2.287) es 476 veces la de temporadas (4,8): PCA sigue a la variable que más varía en sus unidades. Con cada variable estandarizada (media 0 y desviación 1, como en las clases 2 y 7) todas parten iguales. Se estandariza salvo que las variables compartan unidad (James et al., 2013, p. 381).</a:t>
             </a:r>
           </a:p>
         </p:txBody>
@@ -5517,7 +5565,7 @@
             <a:avLst/>
           </a:prstGeom>
           <a:solidFill>
-            <a:srgbClr val="FAFBFC"/>
+            <a:srgbClr val="1D3557"/>
           </a:solidFill>
           <a:ln>
             <a:noFill/>
@@ -5554,8 +5602,8 @@
         </p:nvSpPr>
         <p:spPr>
           <a:xfrm>
-            <a:off x="402336" y="301752"/>
-            <a:ext cx="8348472" cy="795528"/>
+            <a:off x="603504" y="1847088"/>
+            <a:ext cx="7946136" cy="1399032"/>
           </a:xfrm>
           <a:prstGeom prst="rect">
             <a:avLst/>
@@ -5569,71 +5617,24 @@
           <a:lstStyle/>
           <a:p>
             <a:r>
-              <a:rPr sz="2800" b="1">
-                <a:solidFill>
-                  <a:srgbClr val="0F0F0F"/>
-                </a:solidFill>
-                <a:latin typeface="Fira Sans"/>
-              </a:rPr>
-              <a:t>Cuánta variación explica cada componente</a:t>
-            </a:r>
-          </a:p>
-        </p:txBody>
-      </p:sp>
-      <p:pic>
-        <p:nvPicPr>
-          <p:cNvPr id="4" name="Picture 3" descr="c8_03_scree.png"/>
-          <p:cNvPicPr>
-            <a:picLocks noChangeAspect="1"/>
-          </p:cNvPicPr>
-          <p:nvPr/>
-        </p:nvPicPr>
-        <p:blipFill>
-          <a:blip r:embed="rId2"/>
-          <a:stretch>
-            <a:fillRect/>
-          </a:stretch>
-        </p:blipFill>
-        <p:spPr>
-          <a:xfrm>
-            <a:off x="2337301" y="1143000"/>
-            <a:ext cx="4469397" cy="2587752"/>
-          </a:xfrm>
-          <a:prstGeom prst="rect">
-            <a:avLst/>
-          </a:prstGeom>
-        </p:spPr>
-      </p:pic>
-      <p:sp>
-        <p:nvSpPr>
-          <p:cNvPr id="5" name="TextBox 4"/>
-          <p:cNvSpPr txBox="1"/>
-          <p:nvPr/>
-        </p:nvSpPr>
-        <p:spPr>
-          <a:xfrm>
-            <a:off x="704088" y="3867912"/>
-            <a:ext cx="7744968" cy="1024128"/>
-          </a:xfrm>
-          <a:prstGeom prst="rect">
-            <a:avLst/>
-          </a:prstGeom>
-          <a:noFill/>
-        </p:spPr>
-        <p:txBody>
-          <a:bodyPr wrap="square">
-            <a:spAutoFit/>
-          </a:bodyPr>
-          <a:lstStyle/>
-          <a:p>
-            <a:r>
-              <a:rPr sz="1300" b="0">
-                <a:solidFill>
-                  <a:srgbClr val="333333"/>
-                </a:solidFill>
-                <a:latin typeface="Fira Sans"/>
-              </a:rPr>
-              <a:t>La primera componente explica el 45,3% de la variación de las 16 variables; la segunda, el 25,7%; la tercera, el 10,8%. Dos componentes reúnen el 71% y tres, el 82%. Para decidir cuántas conservar, el libro sugiere mirar dónde la curva deja de caer (el codo) y advierte que no hay una regla objetiva: depende del uso (James et al., 2013, p. 384).</a:t>
+              <a:rPr sz="3400" b="1">
+                <a:solidFill>
+                  <a:srgbClr val="FFFFFF"/>
+                </a:solidFill>
+                <a:latin typeface="Fira Sans"/>
+              </a:rPr>
+              <a:t>3. Cómo se leen</a:t>
+            </a:r>
+          </a:p>
+          <a:p>
+            <a:r>
+              <a:rPr sz="1800" b="0">
+                <a:solidFill>
+                  <a:srgbClr val="E0A437"/>
+                </a:solidFill>
+                <a:latin typeface="Fira Sans"/>
+              </a:rPr>
+              <a:t>Cuánta variación explica cada componente y de qué está hecha</a:t>
             </a:r>
           </a:p>
         </p:txBody>
@@ -5729,14 +5730,14 @@
                 </a:solidFill>
                 <a:latin typeface="Fira Sans"/>
               </a:rPr>
-              <a:t>De qué está hecha cada componente: los pesos</a:t>
+              <a:t>Cuánta variación explica cada componente</a:t>
             </a:r>
           </a:p>
         </p:txBody>
       </p:sp>
       <p:pic>
         <p:nvPicPr>
-          <p:cNvPr id="4" name="Picture 3" descr="c8_04_pesos.png"/>
+          <p:cNvPr id="4" name="Picture 3" descr="c8_03_scree.png"/>
           <p:cNvPicPr>
             <a:picLocks noChangeAspect="1"/>
           </p:cNvPicPr>
@@ -5750,8 +5751,8 @@
         </p:blipFill>
         <p:spPr>
           <a:xfrm>
-            <a:off x="2196563" y="1143000"/>
-            <a:ext cx="4750872" cy="2587752"/>
+            <a:off x="2337301" y="1143000"/>
+            <a:ext cx="4469397" cy="2587752"/>
           </a:xfrm>
           <a:prstGeom prst="rect">
             <a:avLst/>
@@ -5787,7 +5788,7 @@
                 </a:solidFill>
                 <a:latin typeface="Fira Sans"/>
               </a:rPr>
-              <a:t>Primera componente: las siete variables de la carrera pesan casi lo mismo (0,29 a 0,34), las de la temporada la mitad (0,19 a 0,23) y la defensa no cuenta: mide cuánta carrera lleva el jugador. Segunda componente: la temporada 1986 pesa positivo (0,24 a 0,39) y la carrera negativo (−0,12 a −0,26): separa a quien rindió este año más de lo que dice su carrera.</a:t>
+              <a:t>La primera componente explica el 45,3% de la variación de las 16 variables; la segunda, el 25,7%; la tercera, el 10,8%. Dos componentes reúnen el 71% y tres, el 82%. Para decidir cuántas conservar se mira dónde la curva deja de caer (el codo); no hay una regla objetiva, depende del uso (James et al., 2013, p. 384).</a:t>
             </a:r>
           </a:p>
         </p:txBody>
@@ -5883,14 +5884,14 @@
                 </a:solidFill>
                 <a:latin typeface="Fira Sans"/>
               </a:rPr>
-              <a:t>Los 263 jugadores en dos componentes</a:t>
+              <a:t>De qué está hecha cada componente: los pesos</a:t>
             </a:r>
           </a:p>
         </p:txBody>
       </p:sp>
       <p:pic>
         <p:nvPicPr>
-          <p:cNvPr id="4" name="Picture 3" descr="c8_05_jugadores.png"/>
+          <p:cNvPr id="4" name="Picture 3" descr="c8_04_pesos.png"/>
           <p:cNvPicPr>
             <a:picLocks noChangeAspect="1"/>
           </p:cNvPicPr>
@@ -5904,8 +5905,8 @@
         </p:blipFill>
         <p:spPr>
           <a:xfrm>
-            <a:off x="2699826" y="1143000"/>
-            <a:ext cx="3744346" cy="2587751"/>
+            <a:off x="2196563" y="1143000"/>
+            <a:ext cx="4750872" cy="2587752"/>
           </a:xfrm>
           <a:prstGeom prst="rect">
             <a:avLst/>
@@ -5941,7 +5942,7 @@
                 </a:solidFill>
                 <a:latin typeface="Fira Sans"/>
               </a:rPr>
-              <a:t>Cada punto es un jugador y el color, su salario de 1987, que PCA no usó. El salario crece hacia la derecha (correlación 0,64 con la primera componente) y casi nada hacia arriba (0,11 con la segunda): la carrera pesa en el salario; la última temporada, poco. Dos ejes muestran lo que en 16 variables había que leer coeficiente por coeficiente.</a:t>
+              <a:t>Primera componente: las siete variables de la carrera pesan casi lo mismo (0,29 a 0,34), las de la temporada la mitad (0,19 a 0,23) y la defensa no cuenta: mide cuánta carrera lleva el jugador. Segunda componente: la temporada 1986 pesa positivo (0,24 a 0,39) y la carrera negativo (−0,12 a −0,26): separa a quien rindió este año más de lo que dice su carrera.</a:t>
             </a:r>
           </a:p>
         </p:txBody>
@@ -6037,14 +6038,14 @@
                 </a:solidFill>
                 <a:latin typeface="Fira Sans"/>
               </a:rPr>
-              <a:t>El mismo cálculo con las flores de la clase 2</a:t>
+              <a:t>Los 263 jugadores en dos componentes</a:t>
             </a:r>
           </a:p>
         </p:txBody>
       </p:sp>
       <p:pic>
         <p:nvPicPr>
-          <p:cNvPr id="4" name="Picture 3" descr="c8_06_iris.png"/>
+          <p:cNvPr id="4" name="Picture 3" descr="c8_05_jugadores.png"/>
           <p:cNvPicPr>
             <a:picLocks noChangeAspect="1"/>
           </p:cNvPicPr>
@@ -6058,8 +6059,8 @@
         </p:blipFill>
         <p:spPr>
           <a:xfrm>
-            <a:off x="2906606" y="1143000"/>
-            <a:ext cx="3330786" cy="2587751"/>
+            <a:off x="2699826" y="1143000"/>
+            <a:ext cx="3744346" cy="2587751"/>
           </a:xfrm>
           <a:prstGeom prst="rect">
             <a:avLst/>
@@ -6095,7 +6096,7 @@
                 </a:solidFill>
                 <a:latin typeface="Fira Sans"/>
               </a:rPr>
-              <a:t>Las cuatro medidas de iris se resumen en dos componentes que reúnen el 96% de la variación. La primera (73%) pesa casi igual el largo y el ancho del pétalo y el largo del sépalo (0,52 a 0,58): el tamaño de la flor. La segunda (23%) es casi solo el ancho del sépalo (0,92). PCA no conoce la especie y aun así las tres quedan separadas a lo largo de la primera componente.</a:t>
+              <a:t>Cada punto es un jugador y el color, su salario de 1987, que PCA no usó. El salario crece hacia la derecha (correlación 0,64 con la primera componente) y casi nada hacia arriba (0,11 con la segunda): la carrera pesa en el salario; la última temporada, poco. Dos ejes muestran lo que en 16 variables había que leer coeficiente por coeficiente.</a:t>
             </a:r>
           </a:p>
         </p:txBody>
@@ -6133,7 +6134,7 @@
             <a:avLst/>
           </a:prstGeom>
           <a:solidFill>
-            <a:srgbClr val="1D3557"/>
+            <a:srgbClr val="FAFBFC"/>
           </a:solidFill>
           <a:ln>
             <a:noFill/>
@@ -6170,8 +6171,8 @@
         </p:nvSpPr>
         <p:spPr>
           <a:xfrm>
-            <a:off x="603504" y="1847088"/>
-            <a:ext cx="7946136" cy="1399032"/>
+            <a:off x="402336" y="301752"/>
+            <a:ext cx="8348472" cy="795528"/>
           </a:xfrm>
           <a:prstGeom prst="rect">
             <a:avLst/>
@@ -6185,24 +6186,71 @@
           <a:lstStyle/>
           <a:p>
             <a:r>
-              <a:rPr sz="3400" b="1">
-                <a:solidFill>
-                  <a:srgbClr val="FFFFFF"/>
-                </a:solidFill>
-                <a:latin typeface="Fira Sans"/>
-              </a:rPr>
-              <a:t>4. Cuándo</a:t>
-            </a:r>
-          </a:p>
-          <a:p>
-            <a:r>
-              <a:rPr sz="1800" b="0">
-                <a:solidFill>
-                  <a:srgbClr val="E0A437"/>
-                </a:solidFill>
-                <a:latin typeface="Fira Sans"/>
-              </a:rPr>
-              <a:t>Cuándo conviene y cuándo no</a:t>
+              <a:rPr sz="2800" b="1">
+                <a:solidFill>
+                  <a:srgbClr val="0F0F0F"/>
+                </a:solidFill>
+                <a:latin typeface="Fira Sans"/>
+              </a:rPr>
+              <a:t>El mismo cálculo con las flores de la clase 2</a:t>
+            </a:r>
+          </a:p>
+        </p:txBody>
+      </p:sp>
+      <p:pic>
+        <p:nvPicPr>
+          <p:cNvPr id="4" name="Picture 3" descr="c8_06_iris.png"/>
+          <p:cNvPicPr>
+            <a:picLocks noChangeAspect="1"/>
+          </p:cNvPicPr>
+          <p:nvPr/>
+        </p:nvPicPr>
+        <p:blipFill>
+          <a:blip r:embed="rId2"/>
+          <a:stretch>
+            <a:fillRect/>
+          </a:stretch>
+        </p:blipFill>
+        <p:spPr>
+          <a:xfrm>
+            <a:off x="2906606" y="1143000"/>
+            <a:ext cx="3330786" cy="2587751"/>
+          </a:xfrm>
+          <a:prstGeom prst="rect">
+            <a:avLst/>
+          </a:prstGeom>
+        </p:spPr>
+      </p:pic>
+      <p:sp>
+        <p:nvSpPr>
+          <p:cNvPr id="5" name="TextBox 4"/>
+          <p:cNvSpPr txBox="1"/>
+          <p:nvPr/>
+        </p:nvSpPr>
+        <p:spPr>
+          <a:xfrm>
+            <a:off x="704088" y="3867912"/>
+            <a:ext cx="7744968" cy="1024128"/>
+          </a:xfrm>
+          <a:prstGeom prst="rect">
+            <a:avLst/>
+          </a:prstGeom>
+          <a:noFill/>
+        </p:spPr>
+        <p:txBody>
+          <a:bodyPr wrap="square">
+            <a:spAutoFit/>
+          </a:bodyPr>
+          <a:lstStyle/>
+          <a:p>
+            <a:r>
+              <a:rPr sz="1300" b="0">
+                <a:solidFill>
+                  <a:srgbClr val="333333"/>
+                </a:solidFill>
+                <a:latin typeface="Fira Sans"/>
+              </a:rPr>
+              <a:t>Las cuatro medidas de iris se resumen en dos componentes que reúnen el 96% de la variación. La primera (73%) pesa casi igual el largo y el ancho del pétalo y el largo del sépalo (0,52 a 0,58): el tamaño de la flor. La segunda (23%) es casi solo el ancho del sépalo (0,92). PCA no conoce la especie y aun así las tres quedan separadas a lo largo de la primera componente.</a:t>
             </a:r>
           </a:p>
         </p:txBody>
@@ -6240,7 +6288,7 @@
             <a:avLst/>
           </a:prstGeom>
           <a:solidFill>
-            <a:srgbClr val="FAFBFC"/>
+            <a:srgbClr val="1D3557"/>
           </a:solidFill>
           <a:ln>
             <a:noFill/>
@@ -6277,8 +6325,8 @@
         </p:nvSpPr>
         <p:spPr>
           <a:xfrm>
-            <a:off x="402336" y="301752"/>
-            <a:ext cx="8348472" cy="795528"/>
+            <a:off x="603504" y="1847088"/>
+            <a:ext cx="7946136" cy="1399032"/>
           </a:xfrm>
           <a:prstGeom prst="rect">
             <a:avLst/>
@@ -6292,120 +6340,24 @@
           <a:lstStyle/>
           <a:p>
             <a:r>
-              <a:rPr sz="2800" b="1">
-                <a:solidFill>
-                  <a:srgbClr val="0F0F0F"/>
-                </a:solidFill>
-                <a:latin typeface="Fira Sans"/>
-              </a:rPr>
-              <a:t>¿Cuándo conviene?</a:t>
-            </a:r>
-          </a:p>
-        </p:txBody>
-      </p:sp>
-      <p:sp>
-        <p:nvSpPr>
-          <p:cNvPr id="4" name="TextBox 3"/>
-          <p:cNvSpPr txBox="1"/>
-          <p:nvPr/>
-        </p:nvSpPr>
-        <p:spPr>
-          <a:xfrm>
-            <a:off x="704088" y="1353312"/>
-            <a:ext cx="7744968" cy="3300984"/>
-          </a:xfrm>
-          <a:prstGeom prst="rect">
-            <a:avLst/>
-          </a:prstGeom>
-          <a:noFill/>
-        </p:spPr>
-        <p:txBody>
-          <a:bodyPr wrap="square">
-            <a:spAutoFit/>
-          </a:bodyPr>
-          <a:lstStyle/>
-          <a:p>
-            <a:pPr>
-              <a:lnSpc>
-                <a:spcPct val="112000"/>
-              </a:lnSpc>
-              <a:spcAft>
-                <a:spcPts val="900"/>
-              </a:spcAft>
-            </a:pPr>
-            <a:r>
-              <a:rPr sz="1800" b="1">
+              <a:rPr sz="3400" b="1">
+                <a:solidFill>
+                  <a:srgbClr val="FFFFFF"/>
+                </a:solidFill>
+                <a:latin typeface="Fira Sans"/>
+              </a:rPr>
+              <a:t>4. Cuándo</a:t>
+            </a:r>
+          </a:p>
+          <a:p>
+            <a:r>
+              <a:rPr sz="1800" b="0">
                 <a:solidFill>
                   <a:srgbClr val="E0A437"/>
                 </a:solidFill>
                 <a:latin typeface="Fira Sans"/>
               </a:rPr>
-              <a:t>▸ </a:t>
-            </a:r>
-            <a:r>
-              <a:rPr sz="1800" b="1">
-                <a:solidFill>
-                  <a:srgbClr val="1D3557"/>
-                </a:solidFill>
-                <a:latin typeface="Fira Sans"/>
-              </a:rPr>
-              <a:t>Con muchas variables numéricas que se correlacionan en bloques, como en la matriz de la clase 7.</a:t>
-            </a:r>
-          </a:p>
-          <a:p>
-            <a:pPr>
-              <a:lnSpc>
-                <a:spcPct val="112000"/>
-              </a:lnSpc>
-              <a:spcAft>
-                <a:spcPts val="900"/>
-              </a:spcAft>
-            </a:pPr>
-            <a:r>
-              <a:rPr sz="1800" b="1">
-                <a:solidFill>
-                  <a:srgbClr val="E0A437"/>
-                </a:solidFill>
-                <a:latin typeface="Fira Sans"/>
-              </a:rPr>
-              <a:t>▸ </a:t>
-            </a:r>
-            <a:r>
-              <a:rPr sz="1800" b="0">
-                <a:solidFill>
-                  <a:srgbClr val="000000"/>
-                </a:solidFill>
-                <a:latin typeface="Fira Sans"/>
-              </a:rPr>
-              <a:t>Para mirar los datos en un plano, o para entregarle a un modelo menos entradas.</a:t>
-            </a:r>
-          </a:p>
-          <a:p>
-            <a:pPr>
-              <a:lnSpc>
-                <a:spcPct val="112000"/>
-              </a:lnSpc>
-              <a:spcAft>
-                <a:spcPts val="900"/>
-              </a:spcAft>
-            </a:pPr>
-            <a:r>
-              <a:rPr sz="1800" b="1">
-                <a:solidFill>
-                  <a:srgbClr val="E0A437"/>
-                </a:solidFill>
-                <a:latin typeface="Fira Sans"/>
-              </a:rPr>
-              <a:t>▸ </a:t>
-            </a:r>
-            <a:r>
-              <a:rPr sz="1800" b="0">
-                <a:solidFill>
-                  <a:srgbClr val="000000"/>
-                </a:solidFill>
-                <a:latin typeface="Fira Sans"/>
-              </a:rPr>
-              <a:t>No aporta si las variables son pocas y distintas entre sí: no hay nada que resumir.</a:t>
+              <a:t>Cuándo conviene y cuándo no</a:t>
             </a:r>
           </a:p>
         </p:txBody>
@@ -6501,7 +6453,7 @@
                 </a:solidFill>
                 <a:latin typeface="Fira Sans"/>
               </a:rPr>
-              <a:t>Tres precauciones</a:t>
+              <a:t>¿Cuándo conviene?</a:t>
             </a:r>
           </a:p>
         </p:txBody>
@@ -6552,7 +6504,7 @@
                 </a:solidFill>
                 <a:latin typeface="Fira Sans"/>
               </a:rPr>
-              <a:t>Las variables categóricas (las dummies de la clase 6) no entran bien en el cálculo: se dejan fuera o se tratan aparte.</a:t>
+              <a:t>Con muchas variables numéricas que se correlacionan en bloques, como en la matriz de la clase 7.</a:t>
             </a:r>
           </a:p>
           <a:p>
@@ -6580,7 +6532,7 @@
                 </a:solidFill>
                 <a:latin typeface="Fira Sans"/>
               </a:rPr>
-              <a:t>Las componentes no siempre tienen una lectura clara. Aquí sí (la carrera; la temporada frente a la carrera), pero no está garantizado.</a:t>
+              <a:t>Para mirar los datos en un plano, o para entregarle a un modelo menos entradas.</a:t>
             </a:r>
           </a:p>
           <a:p>
@@ -6608,7 +6560,7 @@
                 </a:solidFill>
                 <a:latin typeface="Fira Sans"/>
               </a:rPr>
-              <a:t>Es no supervisado: la dirección de más variación no es necesariamente la que mejor predice la respuesta. Ridge y Lasso eligen mirando Y; PCA no la mira.</a:t>
+              <a:t>No aporta si las variables son pocas y distintas entre sí: no hay nada que resumir.</a:t>
             </a:r>
           </a:p>
         </p:txBody>
@@ -6704,124 +6656,21 @@
                 </a:solidFill>
                 <a:latin typeface="Fira Sans"/>
               </a:rPr>
-              <a:t>En el código: cinco líneas</a:t>
-            </a:r>
-          </a:p>
-        </p:txBody>
-      </p:sp>
-      <p:sp>
-        <p:nvSpPr>
-          <p:cNvPr id="4" name="Rectangle 3"/>
-          <p:cNvSpPr/>
-          <p:nvPr/>
-        </p:nvSpPr>
-        <p:spPr>
-          <a:xfrm>
-            <a:off x="704088" y="1280160"/>
-            <a:ext cx="7744968" cy="2880360"/>
-          </a:xfrm>
-          <a:prstGeom prst="rect">
-            <a:avLst/>
-          </a:prstGeom>
-          <a:solidFill>
-            <a:srgbClr val="F0F2F5"/>
-          </a:solidFill>
-          <a:ln>
-            <a:solidFill>
-              <a:srgbClr val="D8DDE3"/>
-            </a:solidFill>
-          </a:ln>
-          <a:effectLst/>
-        </p:spPr>
-        <p:style>
-          <a:lnRef idx="1">
-            <a:schemeClr val="accent1"/>
-          </a:lnRef>
-          <a:fillRef idx="3">
-            <a:schemeClr val="accent1"/>
-          </a:fillRef>
-          <a:effectRef idx="2">
-            <a:schemeClr val="accent1"/>
-          </a:effectRef>
-          <a:fontRef idx="minor">
-            <a:schemeClr val="lt1"/>
-          </a:fontRef>
-        </p:style>
-        <p:txBody>
-          <a:bodyPr rtlCol="0" anchor="ctr" wrap="square" lIns="228600" tIns="137160"/>
-          <a:lstStyle/>
-          <a:p>
-            <a:pPr/>
-            <a:r>
-              <a:rPr sz="1500" b="0">
-                <a:solidFill>
-                  <a:srgbClr val="1D3557"/>
-                </a:solidFill>
-                <a:latin typeface="Menlo"/>
-              </a:rPr>
-              <a:t>Z = StandardScaler().fit_transform(X)  # 1. estandarizar</a:t>
-            </a:r>
-          </a:p>
-          <a:p>
-            <a:pPr/>
-            <a:r>
-              <a:rPr sz="1500" b="0">
-                <a:solidFill>
-                  <a:srgbClr val="1D3557"/>
-                </a:solidFill>
-                <a:latin typeface="Menlo"/>
-              </a:rPr>
-              <a:t>pca = PCA().fit(Z)                     # 2. las componentes</a:t>
-            </a:r>
-          </a:p>
-          <a:p>
-            <a:pPr/>
-            <a:r>
-              <a:rPr sz="1500" b="0">
-                <a:solidFill>
-                  <a:srgbClr val="1D3557"/>
-                </a:solidFill>
-                <a:latin typeface="Menlo"/>
-              </a:rPr>
-              <a:t>pca.explained_variance_ratio_          # 3. cuánto explica</a:t>
-            </a:r>
-          </a:p>
-          <a:p>
-            <a:pPr/>
-            <a:r>
-              <a:rPr sz="1500" b="0">
-                <a:solidFill>
-                  <a:srgbClr val="1D3557"/>
-                </a:solidFill>
-                <a:latin typeface="Menlo"/>
-              </a:rPr>
-              <a:t>pca.components_                        # 4. los pesos</a:t>
-            </a:r>
-          </a:p>
-          <a:p>
-            <a:pPr/>
-            <a:r>
-              <a:rPr sz="1500" b="0">
-                <a:solidFill>
-                  <a:srgbClr val="1D3557"/>
-                </a:solidFill>
-                <a:latin typeface="Menlo"/>
-              </a:rPr>
-              <a:t>puntajes = pca.transform(Z)            # 5. los puntajes</a:t>
-            </a:r>
-          </a:p>
-        </p:txBody>
-      </p:sp>
-      <p:sp>
-        <p:nvSpPr>
-          <p:cNvPr id="5" name="TextBox 4"/>
+              <a:t>Tres precauciones</a:t>
+            </a:r>
+          </a:p>
+        </p:txBody>
+      </p:sp>
+      <p:sp>
+        <p:nvSpPr>
+          <p:cNvPr id="4" name="TextBox 3"/>
           <p:cNvSpPr txBox="1"/>
           <p:nvPr/>
         </p:nvSpPr>
         <p:spPr>
           <a:xfrm>
-            <a:off x="704088" y="4389120"/>
-            <a:ext cx="7744968" cy="1097280"/>
+            <a:off x="704088" y="1353312"/>
+            <a:ext cx="7744968" cy="3300984"/>
           </a:xfrm>
           <a:prstGeom prst="rect">
             <a:avLst/>
@@ -6843,7 +6692,7 @@
               </a:spcAft>
             </a:pPr>
             <a:r>
-              <a:rPr sz="1600" b="1">
+              <a:rPr sz="1800" b="1">
                 <a:solidFill>
                   <a:srgbClr val="E0A437"/>
                 </a:solidFill>
@@ -6852,13 +6701,69 @@
               <a:t>▸ </a:t>
             </a:r>
             <a:r>
-              <a:rPr sz="1600" b="0">
+              <a:rPr sz="1800" b="1">
+                <a:solidFill>
+                  <a:srgbClr val="1D3557"/>
+                </a:solidFill>
+                <a:latin typeface="Fira Sans"/>
+              </a:rPr>
+              <a:t>Las variables categóricas (las dummies de la clase 6) no entran bien en el cálculo: se dejan fuera o se tratan aparte.</a:t>
+            </a:r>
+          </a:p>
+          <a:p>
+            <a:pPr>
+              <a:lnSpc>
+                <a:spcPct val="112000"/>
+              </a:lnSpc>
+              <a:spcAft>
+                <a:spcPts val="900"/>
+              </a:spcAft>
+            </a:pPr>
+            <a:r>
+              <a:rPr sz="1800" b="1">
+                <a:solidFill>
+                  <a:srgbClr val="E0A437"/>
+                </a:solidFill>
+                <a:latin typeface="Fira Sans"/>
+              </a:rPr>
+              <a:t>▸ </a:t>
+            </a:r>
+            <a:r>
+              <a:rPr sz="1800" b="0">
                 <a:solidFill>
                   <a:srgbClr val="000000"/>
                 </a:solidFill>
                 <a:latin typeface="Fira Sans"/>
               </a:rPr>
-              <a:t>El ejemplo completo, con las tablas de pesos y los gráficos de la clase, está en el notebook 08_componentes_principales.ipynb.</a:t>
+              <a:t>Las componentes no siempre tienen una lectura clara. Aquí sí (la carrera; la temporada frente a la carrera), pero no está garantizado.</a:t>
+            </a:r>
+          </a:p>
+          <a:p>
+            <a:pPr>
+              <a:lnSpc>
+                <a:spcPct val="112000"/>
+              </a:lnSpc>
+              <a:spcAft>
+                <a:spcPts val="900"/>
+              </a:spcAft>
+            </a:pPr>
+            <a:r>
+              <a:rPr sz="1800" b="1">
+                <a:solidFill>
+                  <a:srgbClr val="E0A437"/>
+                </a:solidFill>
+                <a:latin typeface="Fira Sans"/>
+              </a:rPr>
+              <a:t>▸ </a:t>
+            </a:r>
+            <a:r>
+              <a:rPr sz="1800" b="0">
+                <a:solidFill>
+                  <a:srgbClr val="000000"/>
+                </a:solidFill>
+                <a:latin typeface="Fira Sans"/>
+              </a:rPr>
+              <a:t>Es no supervisado: la dirección de más variación no es necesariamente la que mejor predice la respuesta. Ridge y Lasso eligen mirando Y; PCA no la mira.</a:t>
             </a:r>
           </a:p>
         </p:txBody>
@@ -6896,7 +6801,7 @@
             <a:avLst/>
           </a:prstGeom>
           <a:solidFill>
-            <a:srgbClr val="1D3557"/>
+            <a:srgbClr val="FAFBFC"/>
           </a:solidFill>
           <a:ln>
             <a:noFill/>
@@ -6933,8 +6838,8 @@
         </p:nvSpPr>
         <p:spPr>
           <a:xfrm>
-            <a:off x="603504" y="1847088"/>
-            <a:ext cx="7946136" cy="1399032"/>
+            <a:off x="402336" y="301752"/>
+            <a:ext cx="8348472" cy="795528"/>
           </a:xfrm>
           <a:prstGeom prst="rect">
             <a:avLst/>
@@ -6948,24 +6853,167 @@
           <a:lstStyle/>
           <a:p>
             <a:r>
-              <a:rPr sz="3400" b="1">
-                <a:solidFill>
-                  <a:srgbClr val="FFFFFF"/>
-                </a:solidFill>
-                <a:latin typeface="Fira Sans"/>
-              </a:rPr>
-              <a:t>5. Cierre del módulo</a:t>
-            </a:r>
-          </a:p>
-          <a:p>
-            <a:r>
-              <a:rPr sz="1800" b="0">
+              <a:rPr sz="2800" b="1">
+                <a:solidFill>
+                  <a:srgbClr val="0F0F0F"/>
+                </a:solidFill>
+                <a:latin typeface="Fira Sans"/>
+              </a:rPr>
+              <a:t>En el código: cinco líneas</a:t>
+            </a:r>
+          </a:p>
+        </p:txBody>
+      </p:sp>
+      <p:sp>
+        <p:nvSpPr>
+          <p:cNvPr id="4" name="Rectangle 3"/>
+          <p:cNvSpPr/>
+          <p:nvPr/>
+        </p:nvSpPr>
+        <p:spPr>
+          <a:xfrm>
+            <a:off x="704088" y="1280160"/>
+            <a:ext cx="7744968" cy="2880360"/>
+          </a:xfrm>
+          <a:prstGeom prst="rect">
+            <a:avLst/>
+          </a:prstGeom>
+          <a:solidFill>
+            <a:srgbClr val="F0F2F5"/>
+          </a:solidFill>
+          <a:ln>
+            <a:solidFill>
+              <a:srgbClr val="D8DDE3"/>
+            </a:solidFill>
+          </a:ln>
+          <a:effectLst/>
+        </p:spPr>
+        <p:style>
+          <a:lnRef idx="1">
+            <a:schemeClr val="accent1"/>
+          </a:lnRef>
+          <a:fillRef idx="3">
+            <a:schemeClr val="accent1"/>
+          </a:fillRef>
+          <a:effectRef idx="2">
+            <a:schemeClr val="accent1"/>
+          </a:effectRef>
+          <a:fontRef idx="minor">
+            <a:schemeClr val="lt1"/>
+          </a:fontRef>
+        </p:style>
+        <p:txBody>
+          <a:bodyPr rtlCol="0" anchor="ctr" wrap="square" lIns="228600" tIns="137160"/>
+          <a:lstStyle/>
+          <a:p>
+            <a:pPr/>
+            <a:r>
+              <a:rPr sz="1500" b="0">
+                <a:solidFill>
+                  <a:srgbClr val="1D3557"/>
+                </a:solidFill>
+                <a:latin typeface="Menlo"/>
+              </a:rPr>
+              <a:t>Z = StandardScaler().fit_transform(X)  # 1. estandarizar</a:t>
+            </a:r>
+          </a:p>
+          <a:p>
+            <a:pPr/>
+            <a:r>
+              <a:rPr sz="1500" b="0">
+                <a:solidFill>
+                  <a:srgbClr val="1D3557"/>
+                </a:solidFill>
+                <a:latin typeface="Menlo"/>
+              </a:rPr>
+              <a:t>pca = PCA().fit(Z)                     # 2. las componentes</a:t>
+            </a:r>
+          </a:p>
+          <a:p>
+            <a:pPr/>
+            <a:r>
+              <a:rPr sz="1500" b="0">
+                <a:solidFill>
+                  <a:srgbClr val="1D3557"/>
+                </a:solidFill>
+                <a:latin typeface="Menlo"/>
+              </a:rPr>
+              <a:t>pca.explained_variance_ratio_          # 3. cuánto explica</a:t>
+            </a:r>
+          </a:p>
+          <a:p>
+            <a:pPr/>
+            <a:r>
+              <a:rPr sz="1500" b="0">
+                <a:solidFill>
+                  <a:srgbClr val="1D3557"/>
+                </a:solidFill>
+                <a:latin typeface="Menlo"/>
+              </a:rPr>
+              <a:t>pca.components_                        # 4. los pesos</a:t>
+            </a:r>
+          </a:p>
+          <a:p>
+            <a:pPr/>
+            <a:r>
+              <a:rPr sz="1500" b="0">
+                <a:solidFill>
+                  <a:srgbClr val="1D3557"/>
+                </a:solidFill>
+                <a:latin typeface="Menlo"/>
+              </a:rPr>
+              <a:t>puntajes = pca.transform(Z)            # 5. los puntajes</a:t>
+            </a:r>
+          </a:p>
+        </p:txBody>
+      </p:sp>
+      <p:sp>
+        <p:nvSpPr>
+          <p:cNvPr id="5" name="TextBox 4"/>
+          <p:cNvSpPr txBox="1"/>
+          <p:nvPr/>
+        </p:nvSpPr>
+        <p:spPr>
+          <a:xfrm>
+            <a:off x="704088" y="4389120"/>
+            <a:ext cx="7744968" cy="1097280"/>
+          </a:xfrm>
+          <a:prstGeom prst="rect">
+            <a:avLst/>
+          </a:prstGeom>
+          <a:noFill/>
+        </p:spPr>
+        <p:txBody>
+          <a:bodyPr wrap="square">
+            <a:spAutoFit/>
+          </a:bodyPr>
+          <a:lstStyle/>
+          <a:p>
+            <a:pPr>
+              <a:lnSpc>
+                <a:spcPct val="112000"/>
+              </a:lnSpc>
+              <a:spcAft>
+                <a:spcPts val="900"/>
+              </a:spcAft>
+            </a:pPr>
+            <a:r>
+              <a:rPr sz="1600" b="1">
                 <a:solidFill>
                   <a:srgbClr val="E0A437"/>
                 </a:solidFill>
                 <a:latin typeface="Fira Sans"/>
               </a:rPr>
-              <a:t>Ocho clases, un hilo</a:t>
+              <a:t>▸ </a:t>
+            </a:r>
+            <a:r>
+              <a:rPr sz="1600" b="0">
+                <a:solidFill>
+                  <a:srgbClr val="000000"/>
+                </a:solidFill>
+                <a:latin typeface="Fira Sans"/>
+              </a:rPr>
+              <a:t>El ejemplo completo, con las tablas de pesos y los gráficos de la clase, está en el notebook 08_componentes_principales.ipynb.</a:t>
             </a:r>
           </a:p>
         </p:txBody>
@@ -7003,7 +7051,7 @@
             <a:avLst/>
           </a:prstGeom>
           <a:solidFill>
-            <a:srgbClr val="FAFBFC"/>
+            <a:srgbClr val="1D3557"/>
           </a:solidFill>
           <a:ln>
             <a:noFill/>
@@ -7040,8 +7088,8 @@
         </p:nvSpPr>
         <p:spPr>
           <a:xfrm>
-            <a:off x="402336" y="301752"/>
-            <a:ext cx="8348472" cy="795528"/>
+            <a:off x="603504" y="1847088"/>
+            <a:ext cx="7946136" cy="1399032"/>
           </a:xfrm>
           <a:prstGeom prst="rect">
             <a:avLst/>
@@ -7055,71 +7103,24 @@
           <a:lstStyle/>
           <a:p>
             <a:r>
-              <a:rPr sz="2800" b="1">
-                <a:solidFill>
-                  <a:srgbClr val="0F0F0F"/>
-                </a:solidFill>
-                <a:latin typeface="Fira Sans"/>
-              </a:rPr>
-              <a:t>El módulo en una página</a:t>
-            </a:r>
-          </a:p>
-        </p:txBody>
-      </p:sp>
-      <p:pic>
-        <p:nvPicPr>
-          <p:cNvPr id="4" name="Picture 3" descr="c8_07_mapa_modulo.png"/>
-          <p:cNvPicPr>
-            <a:picLocks noChangeAspect="1"/>
-          </p:cNvPicPr>
-          <p:nvPr/>
-        </p:nvPicPr>
-        <p:blipFill>
-          <a:blip r:embed="rId2"/>
-          <a:stretch>
-            <a:fillRect/>
-          </a:stretch>
-        </p:blipFill>
-        <p:spPr>
-          <a:xfrm>
-            <a:off x="1029546" y="1143000"/>
-            <a:ext cx="7084906" cy="3099816"/>
-          </a:xfrm>
-          <a:prstGeom prst="rect">
-            <a:avLst/>
-          </a:prstGeom>
-        </p:spPr>
-      </p:pic>
-      <p:sp>
-        <p:nvSpPr>
-          <p:cNvPr id="5" name="TextBox 4"/>
-          <p:cNvSpPr txBox="1"/>
-          <p:nvPr/>
-        </p:nvSpPr>
-        <p:spPr>
-          <a:xfrm>
-            <a:off x="704088" y="4379976"/>
-            <a:ext cx="7744968" cy="512064"/>
-          </a:xfrm>
-          <a:prstGeom prst="rect">
-            <a:avLst/>
-          </a:prstGeom>
-          <a:noFill/>
-        </p:spPr>
-        <p:txBody>
-          <a:bodyPr wrap="square">
-            <a:spAutoFit/>
-          </a:bodyPr>
-          <a:lstStyle/>
-          <a:p>
-            <a:r>
-              <a:rPr sz="1300" b="0">
-                <a:solidFill>
-                  <a:srgbClr val="333333"/>
-                </a:solidFill>
-                <a:latin typeface="Fira Sans"/>
-              </a:rPr>
-              <a:t>Cada clase dejó una idea. Juntas, son lo que el módulo enseñó: cómo se llega de una pregunta y unos datos a un resultado, y cómo se lee ese resultado con su incertidumbre.</a:t>
+              <a:rPr sz="3400" b="1">
+                <a:solidFill>
+                  <a:srgbClr val="FFFFFF"/>
+                </a:solidFill>
+                <a:latin typeface="Fira Sans"/>
+              </a:rPr>
+              <a:t>5. Cierre del módulo</a:t>
+            </a:r>
+          </a:p>
+          <a:p>
+            <a:r>
+              <a:rPr sz="1800" b="0">
+                <a:solidFill>
+                  <a:srgbClr val="E0A437"/>
+                </a:solidFill>
+                <a:latin typeface="Fira Sans"/>
+              </a:rPr>
+              <a:t>Ocho clases, un hilo</a:t>
             </a:r>
           </a:p>
         </p:txBody>
@@ -7474,21 +7475,45 @@
                 </a:solidFill>
                 <a:latin typeface="Fira Sans"/>
               </a:rPr>
-              <a:t>Lo que sigue en el diplomado</a:t>
-            </a:r>
-          </a:p>
-        </p:txBody>
-      </p:sp>
-      <p:sp>
-        <p:nvSpPr>
-          <p:cNvPr id="4" name="TextBox 3"/>
+              <a:t>El módulo en una página</a:t>
+            </a:r>
+          </a:p>
+        </p:txBody>
+      </p:sp>
+      <p:pic>
+        <p:nvPicPr>
+          <p:cNvPr id="4" name="Picture 3" descr="c8_07_mapa_modulo.png"/>
+          <p:cNvPicPr>
+            <a:picLocks noChangeAspect="1"/>
+          </p:cNvPicPr>
+          <p:nvPr/>
+        </p:nvPicPr>
+        <p:blipFill>
+          <a:blip r:embed="rId2"/>
+          <a:stretch>
+            <a:fillRect/>
+          </a:stretch>
+        </p:blipFill>
+        <p:spPr>
+          <a:xfrm>
+            <a:off x="1029546" y="1143000"/>
+            <a:ext cx="7084906" cy="3099816"/>
+          </a:xfrm>
+          <a:prstGeom prst="rect">
+            <a:avLst/>
+          </a:prstGeom>
+        </p:spPr>
+      </p:pic>
+      <p:sp>
+        <p:nvSpPr>
+          <p:cNvPr id="5" name="TextBox 4"/>
           <p:cNvSpPr txBox="1"/>
           <p:nvPr/>
         </p:nvSpPr>
         <p:spPr>
           <a:xfrm>
-            <a:off x="704088" y="1353312"/>
-            <a:ext cx="7744968" cy="3300984"/>
+            <a:off x="704088" y="4379976"/>
+            <a:ext cx="7744968" cy="512064"/>
           </a:xfrm>
           <a:prstGeom prst="rect">
             <a:avLst/>
@@ -7501,115 +7526,14 @@
           </a:bodyPr>
           <a:lstStyle/>
           <a:p>
-            <a:pPr>
-              <a:lnSpc>
-                <a:spcPct val="112000"/>
-              </a:lnSpc>
-              <a:spcAft>
-                <a:spcPts val="900"/>
-              </a:spcAft>
-            </a:pPr>
-            <a:r>
-              <a:rPr sz="1800" b="1">
-                <a:solidFill>
-                  <a:srgbClr val="E0A437"/>
-                </a:solidFill>
-                <a:latin typeface="Fira Sans"/>
-              </a:rPr>
-              <a:t>▸ </a:t>
-            </a:r>
-            <a:r>
-              <a:rPr sz="1800" b="1">
-                <a:solidFill>
-                  <a:srgbClr val="1D3557"/>
-                </a:solidFill>
-                <a:latin typeface="Fira Sans"/>
-              </a:rPr>
-              <a:t>Módulo 2, Visualización e Inteligencia de Negocios: visualización efectiva, narrativas con datos y métricas de negocio.</a:t>
-            </a:r>
-          </a:p>
-          <a:p>
-            <a:pPr>
-              <a:lnSpc>
-                <a:spcPct val="112000"/>
-              </a:lnSpc>
-              <a:spcAft>
-                <a:spcPts val="900"/>
-              </a:spcAft>
-            </a:pPr>
-            <a:r>
-              <a:rPr sz="1800" b="1">
-                <a:solidFill>
-                  <a:srgbClr val="E0A437"/>
-                </a:solidFill>
-                <a:latin typeface="Fira Sans"/>
-              </a:rPr>
-              <a:t>▸ </a:t>
-            </a:r>
-            <a:r>
-              <a:rPr sz="1800" b="0">
-                <a:solidFill>
-                  <a:srgbClr val="000000"/>
-                </a:solidFill>
-                <a:latin typeface="Fira Sans"/>
-              </a:rPr>
-              <a:t>Módulo 3, Machine Learning para la Toma de Decisiones: aprendizaje supervisado y no supervisado (clustering y PCA en profundidad), evaluación de modelos, redes neuronales y explicabilidad.</a:t>
-            </a:r>
-          </a:p>
-          <a:p>
-            <a:pPr>
-              <a:lnSpc>
-                <a:spcPct val="112000"/>
-              </a:lnSpc>
-              <a:spcAft>
-                <a:spcPts val="900"/>
-              </a:spcAft>
-            </a:pPr>
-            <a:r>
-              <a:rPr sz="1800" b="1">
-                <a:solidFill>
-                  <a:srgbClr val="E0A437"/>
-                </a:solidFill>
-                <a:latin typeface="Fira Sans"/>
-              </a:rPr>
-              <a:t>▸ </a:t>
-            </a:r>
-            <a:r>
-              <a:rPr sz="1800" b="0">
-                <a:solidFill>
-                  <a:srgbClr val="000000"/>
-                </a:solidFill>
-                <a:latin typeface="Fira Sans"/>
-              </a:rPr>
-              <a:t>El Capstone continúa en esos módulos: el primer modelo de hoy es el punto de partida.</a:t>
-            </a:r>
-          </a:p>
-          <a:p>
-            <a:pPr>
-              <a:lnSpc>
-                <a:spcPct val="112000"/>
-              </a:lnSpc>
-              <a:spcAft>
-                <a:spcPts val="900"/>
-              </a:spcAft>
-            </a:pPr>
-            <a:r>
-              <a:rPr sz="1800" b="1">
-                <a:solidFill>
-                  <a:srgbClr val="E0A437"/>
-                </a:solidFill>
-                <a:latin typeface="Fira Sans"/>
-              </a:rPr>
-              <a:t>▸ </a:t>
-            </a:r>
-            <a:r>
-              <a:rPr sz="1800" b="0">
-                <a:solidFill>
-                  <a:srgbClr val="000000"/>
-                </a:solidFill>
-                <a:latin typeface="Fira Sans"/>
-              </a:rPr>
-              <a:t>Lo que se lleva de aquí: leer un resultado con su incertidumbre, juzgar un modelo en datos que no vio, y distinguir describir de encontrar una relación.</a:t>
+            <a:r>
+              <a:rPr sz="1300" b="0">
+                <a:solidFill>
+                  <a:srgbClr val="333333"/>
+                </a:solidFill>
+                <a:latin typeface="Fira Sans"/>
+              </a:rPr>
+              <a:t>Cada clase dejó una idea. Juntas, son lo que el módulo enseñó: cómo se llega de una pregunta y unos datos a un resultado, y cómo se lee ese resultado con su incertidumbre.</a:t>
             </a:r>
           </a:p>
         </p:txBody>
@@ -7705,7 +7629,7 @@
                 </a:solidFill>
                 <a:latin typeface="Fira Sans"/>
               </a:rPr>
-              <a:t>Ahora: las presentaciones del avance</a:t>
+              <a:t>Lo que sigue en el diplomado</a:t>
             </a:r>
           </a:p>
         </p:txBody>
@@ -7756,7 +7680,7 @@
                 </a:solidFill>
                 <a:latin typeface="Fira Sans"/>
               </a:rPr>
-              <a:t>Ocho equipos, en el orden en que se ofrezcan. Máximo 10 minutos por equipo; el tiempo se controla. Después, preguntas de la profesora y del curso.</a:t>
+              <a:t>Módulo 2, Visualización e Inteligencia de Negocios: visualización efectiva, narrativas con datos y métricas de negocio.</a:t>
             </a:r>
           </a:p>
           <a:p>
@@ -7784,7 +7708,7 @@
                 </a:solidFill>
                 <a:latin typeface="Fira Sans"/>
               </a:rPr>
-              <a:t>Se evalúa el avance, no un resultado final: el modelo es un primer intento. La exigencia está en el tiempo, la claridad, la explicación de los gráficos y las relaciones, y en advertir qué falta o qué no tiene sentido.</a:t>
+              <a:t>Módulo 3, Machine Learning para la Toma de Decisiones: aprendizaje supervisado y no supervisado (clustering y PCA en profundidad), evaluación de modelos, redes neuronales y explicabilidad.</a:t>
             </a:r>
           </a:p>
           <a:p>
@@ -7812,7 +7736,7 @@
                 </a:solidFill>
                 <a:latin typeface="Fira Sans"/>
               </a:rPr>
-              <a:t>Las slides, en PDF, al Aula hasta las 20:30: un envío por equipo con los nombres.</a:t>
+              <a:t>El Capstone continúa en esos módulos: el primer modelo de hoy es el punto de partida.</a:t>
             </a:r>
           </a:p>
           <a:p>
@@ -7840,7 +7764,7 @@
                 </a:solidFill>
                 <a:latin typeface="Fira Sans"/>
               </a:rPr>
-              <a:t>El informe escrito, el viernes 25 de septiembre por el Aula: máximo 7 páginas, con su rúbrica publicada.</a:t>
+              <a:t>Lo que se lleva de aquí: leer un resultado con su incertidumbre, juzgar un modelo en datos que no vio, y distinguir describir de encontrar una relación.</a:t>
             </a:r>
           </a:p>
         </p:txBody>
@@ -7854,6 +7778,237 @@
 </file>
 
 <file path=ppt/slides/slide32.xml><?xml version="1.0" encoding="utf-8"?>
+<p:sld xmlns:a="http://schemas.openxmlformats.org/drawingml/2006/main" xmlns:p="http://schemas.openxmlformats.org/presentationml/2006/main" xmlns:r="http://schemas.openxmlformats.org/officeDocument/2006/relationships">
+  <p:cSld>
+    <p:spTree>
+      <p:nvGrpSpPr>
+        <p:cNvPr id="1" name=""/>
+        <p:cNvGrpSpPr/>
+        <p:nvPr/>
+      </p:nvGrpSpPr>
+      <p:grpSpPr/>
+      <p:sp>
+        <p:nvSpPr>
+          <p:cNvPr id="2" name="Rectangle 1"/>
+          <p:cNvSpPr/>
+          <p:nvPr/>
+        </p:nvSpPr>
+        <p:spPr>
+          <a:xfrm>
+            <a:off x="0" y="0"/>
+            <a:ext cx="9144000" cy="5138928"/>
+          </a:xfrm>
+          <a:prstGeom prst="rect">
+            <a:avLst/>
+          </a:prstGeom>
+          <a:solidFill>
+            <a:srgbClr val="FAFBFC"/>
+          </a:solidFill>
+          <a:ln>
+            <a:noFill/>
+          </a:ln>
+          <a:effectLst/>
+        </p:spPr>
+        <p:style>
+          <a:lnRef idx="1">
+            <a:schemeClr val="accent1"/>
+          </a:lnRef>
+          <a:fillRef idx="3">
+            <a:schemeClr val="accent1"/>
+          </a:fillRef>
+          <a:effectRef idx="2">
+            <a:schemeClr val="accent1"/>
+          </a:effectRef>
+          <a:fontRef idx="minor">
+            <a:schemeClr val="lt1"/>
+          </a:fontRef>
+        </p:style>
+        <p:txBody>
+          <a:bodyPr rtlCol="0" anchor="ctr"/>
+          <a:lstStyle/>
+          <a:p>
+            <a:pPr algn="ctr"/>
+          </a:p>
+        </p:txBody>
+      </p:sp>
+      <p:sp>
+        <p:nvSpPr>
+          <p:cNvPr id="3" name="TextBox 2"/>
+          <p:cNvSpPr txBox="1"/>
+          <p:nvPr/>
+        </p:nvSpPr>
+        <p:spPr>
+          <a:xfrm>
+            <a:off x="402336" y="301752"/>
+            <a:ext cx="8348472" cy="795528"/>
+          </a:xfrm>
+          <a:prstGeom prst="rect">
+            <a:avLst/>
+          </a:prstGeom>
+          <a:noFill/>
+        </p:spPr>
+        <p:txBody>
+          <a:bodyPr wrap="square">
+            <a:spAutoFit/>
+          </a:bodyPr>
+          <a:lstStyle/>
+          <a:p>
+            <a:r>
+              <a:rPr sz="2800" b="1">
+                <a:solidFill>
+                  <a:srgbClr val="0F0F0F"/>
+                </a:solidFill>
+                <a:latin typeface="Fira Sans"/>
+              </a:rPr>
+              <a:t>Ahora: las presentaciones del avance</a:t>
+            </a:r>
+          </a:p>
+        </p:txBody>
+      </p:sp>
+      <p:sp>
+        <p:nvSpPr>
+          <p:cNvPr id="4" name="TextBox 3"/>
+          <p:cNvSpPr txBox="1"/>
+          <p:nvPr/>
+        </p:nvSpPr>
+        <p:spPr>
+          <a:xfrm>
+            <a:off x="704088" y="1353312"/>
+            <a:ext cx="7744968" cy="3300984"/>
+          </a:xfrm>
+          <a:prstGeom prst="rect">
+            <a:avLst/>
+          </a:prstGeom>
+          <a:noFill/>
+        </p:spPr>
+        <p:txBody>
+          <a:bodyPr wrap="square">
+            <a:spAutoFit/>
+          </a:bodyPr>
+          <a:lstStyle/>
+          <a:p>
+            <a:pPr>
+              <a:lnSpc>
+                <a:spcPct val="112000"/>
+              </a:lnSpc>
+              <a:spcAft>
+                <a:spcPts val="900"/>
+              </a:spcAft>
+            </a:pPr>
+            <a:r>
+              <a:rPr sz="1800" b="1">
+                <a:solidFill>
+                  <a:srgbClr val="E0A437"/>
+                </a:solidFill>
+                <a:latin typeface="Fira Sans"/>
+              </a:rPr>
+              <a:t>▸ </a:t>
+            </a:r>
+            <a:r>
+              <a:rPr sz="1800" b="1">
+                <a:solidFill>
+                  <a:srgbClr val="1D3557"/>
+                </a:solidFill>
+                <a:latin typeface="Fira Sans"/>
+              </a:rPr>
+              <a:t>Ocho equipos, en el orden en que se ofrezcan. Máximo 10 minutos por equipo; el tiempo se controla. Después, preguntas de la profesora y del curso.</a:t>
+            </a:r>
+          </a:p>
+          <a:p>
+            <a:pPr>
+              <a:lnSpc>
+                <a:spcPct val="112000"/>
+              </a:lnSpc>
+              <a:spcAft>
+                <a:spcPts val="900"/>
+              </a:spcAft>
+            </a:pPr>
+            <a:r>
+              <a:rPr sz="1800" b="1">
+                <a:solidFill>
+                  <a:srgbClr val="E0A437"/>
+                </a:solidFill>
+                <a:latin typeface="Fira Sans"/>
+              </a:rPr>
+              <a:t>▸ </a:t>
+            </a:r>
+            <a:r>
+              <a:rPr sz="1800" b="0">
+                <a:solidFill>
+                  <a:srgbClr val="000000"/>
+                </a:solidFill>
+                <a:latin typeface="Fira Sans"/>
+              </a:rPr>
+              <a:t>Se evalúa el avance, no un resultado final: el modelo es un primer intento. La exigencia está en el tiempo, la claridad, la explicación de los gráficos y las relaciones, y en advertir qué falta o qué no tiene sentido.</a:t>
+            </a:r>
+          </a:p>
+          <a:p>
+            <a:pPr>
+              <a:lnSpc>
+                <a:spcPct val="112000"/>
+              </a:lnSpc>
+              <a:spcAft>
+                <a:spcPts val="900"/>
+              </a:spcAft>
+            </a:pPr>
+            <a:r>
+              <a:rPr sz="1800" b="1">
+                <a:solidFill>
+                  <a:srgbClr val="E0A437"/>
+                </a:solidFill>
+                <a:latin typeface="Fira Sans"/>
+              </a:rPr>
+              <a:t>▸ </a:t>
+            </a:r>
+            <a:r>
+              <a:rPr sz="1800" b="0">
+                <a:solidFill>
+                  <a:srgbClr val="000000"/>
+                </a:solidFill>
+                <a:latin typeface="Fira Sans"/>
+              </a:rPr>
+              <a:t>Las slides, en PDF, al Aula hasta las 20:30: un envío por equipo con los nombres.</a:t>
+            </a:r>
+          </a:p>
+          <a:p>
+            <a:pPr>
+              <a:lnSpc>
+                <a:spcPct val="112000"/>
+              </a:lnSpc>
+              <a:spcAft>
+                <a:spcPts val="900"/>
+              </a:spcAft>
+            </a:pPr>
+            <a:r>
+              <a:rPr sz="1800" b="1">
+                <a:solidFill>
+                  <a:srgbClr val="E0A437"/>
+                </a:solidFill>
+                <a:latin typeface="Fira Sans"/>
+              </a:rPr>
+              <a:t>▸ </a:t>
+            </a:r>
+            <a:r>
+              <a:rPr sz="1800" b="0">
+                <a:solidFill>
+                  <a:srgbClr val="000000"/>
+                </a:solidFill>
+                <a:latin typeface="Fira Sans"/>
+              </a:rPr>
+              <a:t>El informe escrito, el viernes 25 de septiembre por el Aula: máximo 7 páginas, con su rúbrica publicada.</a:t>
+            </a:r>
+          </a:p>
+        </p:txBody>
+      </p:sp>
+    </p:spTree>
+  </p:cSld>
+  <p:clrMapOvr>
+    <a:masterClrMapping/>
+  </p:clrMapOvr>
+</p:sld>
+</file>
+
+<file path=ppt/slides/slide33.xml><?xml version="1.0" encoding="utf-8"?>
 <p:sld xmlns:a="http://schemas.openxmlformats.org/drawingml/2006/main" xmlns:p="http://schemas.openxmlformats.org/presentationml/2006/main" xmlns:r="http://schemas.openxmlformats.org/officeDocument/2006/relationships">
   <p:cSld>
     <p:spTree>

</xml_diff>

<commit_message>
Clase 8: el puntaje ponderado antes que el calculo del 99,8% (slides 14 y 15 intercambiadas)
Co-Authored-By: Claude Fable 5.1 <noreply@anthropic.com>
</commit_message>
<xml_diff>
--- a/presentaciones/clase08_componentes_principales.pptx
+++ b/presentaciones/clase08_componentes_principales.pptx
@@ -4318,14 +4318,14 @@
                 </a:solidFill>
                 <a:latin typeface="Fira Sans"/>
               </a:rPr>
-              <a:t>De dónde sale el 99,8%</a:t>
+              <a:t>En la práctica: un puntaje ponderado por jugador</a:t>
             </a:r>
           </a:p>
         </p:txBody>
       </p:sp>
       <p:pic>
         <p:nvPicPr>
-          <p:cNvPr id="4" name="Picture 3" descr="c8_01d_calculo_pve.png"/>
+          <p:cNvPr id="4" name="Picture 3" descr="c8_01b_puntaje_ponderado.png"/>
           <p:cNvPicPr>
             <a:picLocks noChangeAspect="1"/>
           </p:cNvPicPr>
@@ -4339,8 +4339,8 @@
         </p:blipFill>
         <p:spPr>
           <a:xfrm>
-            <a:off x="1840230" y="1143000"/>
-            <a:ext cx="5463540" cy="2331720"/>
+            <a:off x="699515" y="1261139"/>
+            <a:ext cx="7744968" cy="2607505"/>
           </a:xfrm>
           <a:prstGeom prst="rect">
             <a:avLst/>
@@ -4355,8 +4355,8 @@
         </p:nvSpPr>
         <p:spPr>
           <a:xfrm>
-            <a:off x="704088" y="3611879"/>
-            <a:ext cx="7744968" cy="1280160"/>
+            <a:off x="704088" y="4005804"/>
+            <a:ext cx="7744968" cy="768096"/>
           </a:xfrm>
           <a:prstGeom prst="rect">
             <a:avLst/>
@@ -4376,7 +4376,7 @@
                 </a:solidFill>
                 <a:latin typeface="Fira Sans"/>
               </a:rPr>
-              <a:t>La variación de una coordenada se mide con su varianza. Las dos variables estandarizadas tienen varianza 1 y 1: la variación total es 2. Las dos coordenadas nuevas reparten esa misma variación, 1,995 y 0,005, que también suman 2. La parte de la primera es 1,995 / 2 = 99,8%; la de la segunda, 0,005 / 2 = 0,2%. Con 16 variables es lo mismo: la variación total es 16 y cada componente se lleva una parte.</a:t>
+              <a:t>La posición sobre la diagonal se calcula como un puntaje ponderado, igual que el de la admisión universitaria: cada variable entra con un peso y sale un número por jugador. Aquí los pesos no los fija nadie: se calculan para que ese número separe a los jugadores lo más posible.</a:t>
             </a:r>
           </a:p>
         </p:txBody>
@@ -4472,14 +4472,14 @@
                 </a:solidFill>
                 <a:latin typeface="Fira Sans"/>
               </a:rPr>
-              <a:t>En la práctica: un puntaje ponderado por jugador</a:t>
+              <a:t>De dónde sale el 99,8%</a:t>
             </a:r>
           </a:p>
         </p:txBody>
       </p:sp>
       <p:pic>
         <p:nvPicPr>
-          <p:cNvPr id="4" name="Picture 3" descr="c8_01b_puntaje_ponderado.png"/>
+          <p:cNvPr id="4" name="Picture 3" descr="c8_01d_calculo_pve.png"/>
           <p:cNvPicPr>
             <a:picLocks noChangeAspect="1"/>
           </p:cNvPicPr>
@@ -4493,8 +4493,8 @@
         </p:blipFill>
         <p:spPr>
           <a:xfrm>
-            <a:off x="699515" y="1261139"/>
-            <a:ext cx="7744968" cy="2607505"/>
+            <a:off x="1840230" y="1143000"/>
+            <a:ext cx="5463540" cy="2331720"/>
           </a:xfrm>
           <a:prstGeom prst="rect">
             <a:avLst/>
@@ -4509,8 +4509,8 @@
         </p:nvSpPr>
         <p:spPr>
           <a:xfrm>
-            <a:off x="704088" y="4005804"/>
-            <a:ext cx="7744968" cy="768096"/>
+            <a:off x="704088" y="3611879"/>
+            <a:ext cx="7744968" cy="1280160"/>
           </a:xfrm>
           <a:prstGeom prst="rect">
             <a:avLst/>
@@ -4530,7 +4530,7 @@
                 </a:solidFill>
                 <a:latin typeface="Fira Sans"/>
               </a:rPr>
-              <a:t>La posición sobre la diagonal se calcula como un puntaje ponderado, igual que el de la admisión universitaria: cada variable entra con un peso y sale un número por jugador. Aquí los pesos no los fija nadie: se calculan para que ese número separe a los jugadores lo más posible.</a:t>
+              <a:t>La variación de una coordenada se mide con su varianza. Las dos variables estandarizadas tienen varianza 1 y 1: la variación total es 2. Las dos coordenadas nuevas reparten esa misma variación, 1,995 y 0,005, que también suman 2. La parte de la primera es 1,995 / 2 = 99,8%; la de la segunda, 0,005 / 2 = 0,2%. Con 16 variables es lo mismo: la variación total es 16 y cada componente se lleva una parte.</a:t>
             </a:r>
           </a:p>
         </p:txBody>

</xml_diff>

<commit_message>
Clase 8: tres variables, el codo en dos slides y la seccion 2 reordenada (34 slides)
Revision de Daniela: (1) que pasa con tres variables: slide nueva con
turnos, hits y outs de defensa (tres ejes, 66,7 / 33,1 / 0,2%; con dos
se conserva el 99,8%) y la misma cuenta en el notebook; (2) la frase del
99,8% pasa a la slide de su calculo; (3) la slide de las cuatro
direcciones se elimina; (4) 'en la slide del codo, habria que dejar 10
componentes?': el scree plot va en dos slides, el codo (barras de antes
y despues del quiebre) y con cuantas quedarse (acumulado: con 10 de 16
casi no se reduce nada).

Co-Authored-By: Claude Fable 5.1 <noreply@anthropic.com>
</commit_message>
<xml_diff>
--- a/presentaciones/clase08_componentes_principales.pptx
+++ b/presentaciones/clase08_componentes_principales.pptx
@@ -38,6 +38,7 @@
     <p:sldId id="286" r:id="rId37"/>
     <p:sldId id="287" r:id="rId38"/>
     <p:sldId id="288" r:id="rId39"/>
+    <p:sldId id="289" r:id="rId40"/>
   </p:sldIdLst>
   <p:sldSz cx="9144000" cy="5138928" type="screen4x3"/>
   <p:notesSz cx="6858000" cy="9144000"/>
@@ -3836,14 +3837,14 @@
                 </a:solidFill>
                 <a:latin typeface="Fira Sans"/>
               </a:rPr>
-              <a:t>Cuánto se conserva y cuánto se pierde</a:t>
+              <a:t>Es un cambio de ejes: las dos componentes</a:t>
             </a:r>
           </a:p>
         </p:txBody>
       </p:sp>
       <p:pic>
         <p:nvPicPr>
-          <p:cNvPr id="4" name="Picture 3" descr="c8_01_dos_variables.png"/>
+          <p:cNvPr id="4" name="Picture 3" descr="c8_01c_componentes.png"/>
           <p:cNvPicPr>
             <a:picLocks noChangeAspect="1"/>
           </p:cNvPicPr>
@@ -3858,7 +3859,7 @@
         <p:spPr>
           <a:xfrm>
             <a:off x="320040" y="1097280"/>
-            <a:ext cx="3689622" cy="3886200"/>
+            <a:ext cx="4032615" cy="3886200"/>
           </a:xfrm>
           <a:prstGeom prst="rect">
             <a:avLst/>
@@ -3873,8 +3874,8 @@
         </p:nvSpPr>
         <p:spPr>
           <a:xfrm>
-            <a:off x="4238261" y="1325880"/>
-            <a:ext cx="4585698" cy="3566160"/>
+            <a:off x="4581254" y="1325880"/>
+            <a:ext cx="4242705" cy="3566160"/>
           </a:xfrm>
           <a:prstGeom prst="rect">
             <a:avLst/>
@@ -3911,7 +3912,7 @@
                 </a:solidFill>
                 <a:latin typeface="Fira Sans"/>
               </a:rPr>
-              <a:t>Para cada dirección que pasa por el centro se mide cuánto se dispersan los puntos a lo largo de ella.</a:t>
+              <a:t>Un cambio de sistema de referencia: en vez de turnos y hits, dos ejes nuevos girados 45°, la diagonal y su perpendicular, con el mismo centro.</a:t>
             </a:r>
           </a:p>
           <a:p>
@@ -3939,7 +3940,7 @@
                 </a:solidFill>
                 <a:latin typeface="Fira Sans"/>
               </a:rPr>
-              <a:t>Horizontal 1,00; vertical 1,00; diagonal 1,41, la mayor de todas; perpendicular a la diagonal 0,07.</a:t>
+              <a:t>Cada jugador tiene dos coordenadas nuevas. A pasa de (−1,16; −1,11) a (−1,60; 0,03); C, de (1,51; 1,33) a (2,01; −0,13).</a:t>
             </a:r>
           </a:p>
           <a:p>
@@ -3967,7 +3968,35 @@
                 </a:solidFill>
                 <a:latin typeface="Fira Sans"/>
               </a:rPr>
-              <a:t>Quedarse con la posición sobre la diagonal conserva el 99,8% de la variación de los datos y pierde el 0,2%.</a:t>
+              <a:t>La segunda coordenada es casi 0 para todos: es lo que se descarta al quedarse con un solo número.</a:t>
+            </a:r>
+          </a:p>
+          <a:p>
+            <a:pPr>
+              <a:lnSpc>
+                <a:spcPct val="112000"/>
+              </a:lnSpc>
+              <a:spcAft>
+                <a:spcPts val="900"/>
+              </a:spcAft>
+            </a:pPr>
+            <a:r>
+              <a:rPr sz="1500" b="1">
+                <a:solidFill>
+                  <a:srgbClr val="E0A437"/>
+                </a:solidFill>
+                <a:latin typeface="Fira Sans"/>
+              </a:rPr>
+              <a:t>▸ </a:t>
+            </a:r>
+            <a:r>
+              <a:rPr sz="1500" b="0">
+                <a:solidFill>
+                  <a:srgbClr val="000000"/>
+                </a:solidFill>
+                <a:latin typeface="Fira Sans"/>
+              </a:rPr>
+              <a:t>El primer eje se llama primera componente principal; el segundo, segunda.</a:t>
             </a:r>
           </a:p>
         </p:txBody>
@@ -4063,14 +4092,14 @@
                 </a:solidFill>
                 <a:latin typeface="Fira Sans"/>
               </a:rPr>
-              <a:t>Es un cambio de ejes: las dos componentes</a:t>
+              <a:t>En la práctica: un puntaje ponderado por jugador</a:t>
             </a:r>
           </a:p>
         </p:txBody>
       </p:sp>
       <p:pic>
         <p:nvPicPr>
-          <p:cNvPr id="4" name="Picture 3" descr="c8_01c_componentes.png"/>
+          <p:cNvPr id="4" name="Picture 3" descr="c8_01b_puntaje_ponderado.png"/>
           <p:cNvPicPr>
             <a:picLocks noChangeAspect="1"/>
           </p:cNvPicPr>
@@ -4084,8 +4113,8 @@
         </p:blipFill>
         <p:spPr>
           <a:xfrm>
-            <a:off x="320040" y="1097280"/>
-            <a:ext cx="4032615" cy="3886200"/>
+            <a:off x="699515" y="1261139"/>
+            <a:ext cx="7744968" cy="2607505"/>
           </a:xfrm>
           <a:prstGeom prst="rect">
             <a:avLst/>
@@ -4100,8 +4129,8 @@
         </p:nvSpPr>
         <p:spPr>
           <a:xfrm>
-            <a:off x="4581254" y="1325880"/>
-            <a:ext cx="4242705" cy="3566160"/>
+            <a:off x="704088" y="4005804"/>
+            <a:ext cx="7744968" cy="768096"/>
           </a:xfrm>
           <a:prstGeom prst="rect">
             <a:avLst/>
@@ -4114,115 +4143,14 @@
           </a:bodyPr>
           <a:lstStyle/>
           <a:p>
-            <a:pPr>
-              <a:lnSpc>
-                <a:spcPct val="112000"/>
-              </a:lnSpc>
-              <a:spcAft>
-                <a:spcPts val="900"/>
-              </a:spcAft>
-            </a:pPr>
-            <a:r>
-              <a:rPr sz="1500" b="1">
-                <a:solidFill>
-                  <a:srgbClr val="E0A437"/>
-                </a:solidFill>
-                <a:latin typeface="Fira Sans"/>
-              </a:rPr>
-              <a:t>▸ </a:t>
-            </a:r>
-            <a:r>
-              <a:rPr sz="1500" b="1">
-                <a:solidFill>
-                  <a:srgbClr val="1D3557"/>
-                </a:solidFill>
-                <a:latin typeface="Fira Sans"/>
-              </a:rPr>
-              <a:t>Un cambio de sistema de referencia: en vez de turnos y hits, dos ejes nuevos girados 45°, la diagonal y su perpendicular, con el mismo centro.</a:t>
-            </a:r>
-          </a:p>
-          <a:p>
-            <a:pPr>
-              <a:lnSpc>
-                <a:spcPct val="112000"/>
-              </a:lnSpc>
-              <a:spcAft>
-                <a:spcPts val="900"/>
-              </a:spcAft>
-            </a:pPr>
-            <a:r>
-              <a:rPr sz="1500" b="1">
-                <a:solidFill>
-                  <a:srgbClr val="E0A437"/>
-                </a:solidFill>
-                <a:latin typeface="Fira Sans"/>
-              </a:rPr>
-              <a:t>▸ </a:t>
-            </a:r>
-            <a:r>
-              <a:rPr sz="1500" b="0">
-                <a:solidFill>
-                  <a:srgbClr val="000000"/>
-                </a:solidFill>
-                <a:latin typeface="Fira Sans"/>
-              </a:rPr>
-              <a:t>Cada jugador tiene dos coordenadas nuevas. A pasa de (−1,16; −1,11) a (−1,60; 0,03); C, de (1,51; 1,33) a (2,01; −0,13).</a:t>
-            </a:r>
-          </a:p>
-          <a:p>
-            <a:pPr>
-              <a:lnSpc>
-                <a:spcPct val="112000"/>
-              </a:lnSpc>
-              <a:spcAft>
-                <a:spcPts val="900"/>
-              </a:spcAft>
-            </a:pPr>
-            <a:r>
-              <a:rPr sz="1500" b="1">
-                <a:solidFill>
-                  <a:srgbClr val="E0A437"/>
-                </a:solidFill>
-                <a:latin typeface="Fira Sans"/>
-              </a:rPr>
-              <a:t>▸ </a:t>
-            </a:r>
-            <a:r>
-              <a:rPr sz="1500" b="0">
-                <a:solidFill>
-                  <a:srgbClr val="000000"/>
-                </a:solidFill>
-                <a:latin typeface="Fira Sans"/>
-              </a:rPr>
-              <a:t>La segunda coordenada es casi 0 para todos: es lo que se descarta al quedarse con un solo número.</a:t>
-            </a:r>
-          </a:p>
-          <a:p>
-            <a:pPr>
-              <a:lnSpc>
-                <a:spcPct val="112000"/>
-              </a:lnSpc>
-              <a:spcAft>
-                <a:spcPts val="900"/>
-              </a:spcAft>
-            </a:pPr>
-            <a:r>
-              <a:rPr sz="1500" b="1">
-                <a:solidFill>
-                  <a:srgbClr val="E0A437"/>
-                </a:solidFill>
-                <a:latin typeface="Fira Sans"/>
-              </a:rPr>
-              <a:t>▸ </a:t>
-            </a:r>
-            <a:r>
-              <a:rPr sz="1500" b="0">
-                <a:solidFill>
-                  <a:srgbClr val="000000"/>
-                </a:solidFill>
-                <a:latin typeface="Fira Sans"/>
-              </a:rPr>
-              <a:t>El primer eje se llama primera componente principal; el segundo, segunda.</a:t>
+            <a:r>
+              <a:rPr sz="1300" b="0">
+                <a:solidFill>
+                  <a:srgbClr val="333333"/>
+                </a:solidFill>
+                <a:latin typeface="Fira Sans"/>
+              </a:rPr>
+              <a:t>La posición sobre la diagonal se calcula como un puntaje ponderado, igual que el de la admisión universitaria: cada variable entra con un peso y sale un número por jugador. Aquí los pesos no los fija nadie: se calculan para que ese número separe a los jugadores lo más posible.</a:t>
             </a:r>
           </a:p>
         </p:txBody>
@@ -4318,14 +4246,14 @@
                 </a:solidFill>
                 <a:latin typeface="Fira Sans"/>
               </a:rPr>
-              <a:t>En la práctica: un puntaje ponderado por jugador</a:t>
+              <a:t>Cuánto se conserva y cuánto se pierde</a:t>
             </a:r>
           </a:p>
         </p:txBody>
       </p:sp>
       <p:pic>
         <p:nvPicPr>
-          <p:cNvPr id="4" name="Picture 3" descr="c8_01b_puntaje_ponderado.png"/>
+          <p:cNvPr id="4" name="Picture 3" descr="c8_01d_calculo_pve.png"/>
           <p:cNvPicPr>
             <a:picLocks noChangeAspect="1"/>
           </p:cNvPicPr>
@@ -4339,8 +4267,8 @@
         </p:blipFill>
         <p:spPr>
           <a:xfrm>
-            <a:off x="699515" y="1261139"/>
-            <a:ext cx="7744968" cy="2607505"/>
+            <a:off x="1540270" y="1143000"/>
+            <a:ext cx="6063458" cy="2587752"/>
           </a:xfrm>
           <a:prstGeom prst="rect">
             <a:avLst/>
@@ -4355,8 +4283,8 @@
         </p:nvSpPr>
         <p:spPr>
           <a:xfrm>
-            <a:off x="704088" y="4005804"/>
-            <a:ext cx="7744968" cy="768096"/>
+            <a:off x="704088" y="3867912"/>
+            <a:ext cx="7744968" cy="1024128"/>
           </a:xfrm>
           <a:prstGeom prst="rect">
             <a:avLst/>
@@ -4376,7 +4304,7 @@
                 </a:solidFill>
                 <a:latin typeface="Fira Sans"/>
               </a:rPr>
-              <a:t>La posición sobre la diagonal se calcula como un puntaje ponderado, igual que el de la admisión universitaria: cada variable entra con un peso y sale un número por jugador. Aquí los pesos no los fija nadie: se calculan para que ese número separe a los jugadores lo más posible.</a:t>
+              <a:t>Quedarse con la posición sobre la diagonal conserva el 99,8% de la variación de los datos y pierde el 0,2%. Sale de las varianzas: las dos variables estandarizadas tienen 1 y 1 (total 2); las dos coordenadas nuevas reparten esa misma variación, 1,995 y 0,005; 1,995 / 2 = 99,8% y 0,005 / 2 = 0,2%. Con 16 variables, la variación total es 16 y cada componente se lleva una parte.</a:t>
             </a:r>
           </a:p>
         </p:txBody>
@@ -4472,14 +4400,121 @@
                 </a:solidFill>
                 <a:latin typeface="Fira Sans"/>
               </a:rPr>
-              <a:t>De dónde sale el 99,8%</a:t>
+              <a:t>El análisis de componentes principales</a:t>
+            </a:r>
+          </a:p>
+        </p:txBody>
+      </p:sp>
+      <p:sp>
+        <p:nvSpPr>
+          <p:cNvPr id="4" name="TextBox 3"/>
+          <p:cNvSpPr txBox="1"/>
+          <p:nvPr/>
+        </p:nvSpPr>
+        <p:spPr>
+          <a:xfrm>
+            <a:off x="502920" y="1252728"/>
+            <a:ext cx="4023360" cy="3200400"/>
+          </a:xfrm>
+          <a:prstGeom prst="rect">
+            <a:avLst/>
+          </a:prstGeom>
+          <a:noFill/>
+        </p:spPr>
+        <p:txBody>
+          <a:bodyPr wrap="square">
+            <a:spAutoFit/>
+          </a:bodyPr>
+          <a:lstStyle/>
+          <a:p>
+            <a:pPr>
+              <a:lnSpc>
+                <a:spcPct val="112000"/>
+              </a:lnSpc>
+              <a:spcAft>
+                <a:spcPts val="900"/>
+              </a:spcAft>
+            </a:pPr>
+            <a:r>
+              <a:rPr sz="1500" b="1">
+                <a:solidFill>
+                  <a:srgbClr val="E0A437"/>
+                </a:solidFill>
+                <a:latin typeface="Fira Sans"/>
+              </a:rPr>
+              <a:t>▸ </a:t>
+            </a:r>
+            <a:r>
+              <a:rPr sz="1500" b="1">
+                <a:solidFill>
+                  <a:srgbClr val="1D3557"/>
+                </a:solidFill>
+                <a:latin typeface="Fira Sans"/>
+              </a:rPr>
+              <a:t>Busca la dirección en que los datos más se dispersan (la primera componente), luego la que más se dispersa entre las perpendiculares (la segunda), y así hasta tener tantas como variables.</a:t>
+            </a:r>
+          </a:p>
+          <a:p>
+            <a:pPr>
+              <a:lnSpc>
+                <a:spcPct val="112000"/>
+              </a:lnSpc>
+              <a:spcAft>
+                <a:spcPts val="900"/>
+              </a:spcAft>
+            </a:pPr>
+            <a:r>
+              <a:rPr sz="1500" b="1">
+                <a:solidFill>
+                  <a:srgbClr val="E0A437"/>
+                </a:solidFill>
+                <a:latin typeface="Fira Sans"/>
+              </a:rPr>
+              <a:t>▸ </a:t>
+            </a:r>
+            <a:r>
+              <a:rPr sz="1500" b="0">
+                <a:solidFill>
+                  <a:srgbClr val="000000"/>
+                </a:solidFill>
+                <a:latin typeface="Fira Sans"/>
+              </a:rPr>
+              <a:t>Cada componente es una variable nueva: un puntaje ponderado de las originales, con una parte de la variación total.</a:t>
+            </a:r>
+          </a:p>
+          <a:p>
+            <a:pPr>
+              <a:lnSpc>
+                <a:spcPct val="112000"/>
+              </a:lnSpc>
+              <a:spcAft>
+                <a:spcPts val="900"/>
+              </a:spcAft>
+            </a:pPr>
+            <a:r>
+              <a:rPr sz="1500" b="1">
+                <a:solidFill>
+                  <a:srgbClr val="E0A437"/>
+                </a:solidFill>
+                <a:latin typeface="Fira Sans"/>
+              </a:rPr>
+              <a:t>▸ </a:t>
+            </a:r>
+            <a:r>
+              <a:rPr sz="1500" b="0">
+                <a:solidFill>
+                  <a:srgbClr val="000000"/>
+                </a:solidFill>
+                <a:latin typeface="Fira Sans"/>
+              </a:rPr>
+              <a:t>No usa ninguna respuesta Y: es un método no supervisado (James et al., 2013, p. 375).</a:t>
             </a:r>
           </a:p>
         </p:txBody>
       </p:sp>
       <p:pic>
         <p:nvPicPr>
-          <p:cNvPr id="4" name="Picture 3" descr="c8_01d_calculo_pve.png"/>
+          <p:cNvPr id="5" name="Picture 4" descr="c8_01c_componentes.png"/>
           <p:cNvPicPr>
             <a:picLocks noChangeAspect="1"/>
           </p:cNvPicPr>
@@ -4493,48 +4528,14 @@
         </p:blipFill>
         <p:spPr>
           <a:xfrm>
-            <a:off x="1840230" y="1143000"/>
-            <a:ext cx="5463540" cy="2331720"/>
+            <a:off x="4892040" y="1371600"/>
+            <a:ext cx="3840480" cy="3701041"/>
           </a:xfrm>
           <a:prstGeom prst="rect">
             <a:avLst/>
           </a:prstGeom>
         </p:spPr>
       </p:pic>
-      <p:sp>
-        <p:nvSpPr>
-          <p:cNvPr id="5" name="TextBox 4"/>
-          <p:cNvSpPr txBox="1"/>
-          <p:nvPr/>
-        </p:nvSpPr>
-        <p:spPr>
-          <a:xfrm>
-            <a:off x="704088" y="3611879"/>
-            <a:ext cx="7744968" cy="1280160"/>
-          </a:xfrm>
-          <a:prstGeom prst="rect">
-            <a:avLst/>
-          </a:prstGeom>
-          <a:noFill/>
-        </p:spPr>
-        <p:txBody>
-          <a:bodyPr wrap="square">
-            <a:spAutoFit/>
-          </a:bodyPr>
-          <a:lstStyle/>
-          <a:p>
-            <a:r>
-              <a:rPr sz="1300" b="0">
-                <a:solidFill>
-                  <a:srgbClr val="333333"/>
-                </a:solidFill>
-                <a:latin typeface="Fira Sans"/>
-              </a:rPr>
-              <a:t>La variación de una coordenada se mide con su varianza. Las dos variables estandarizadas tienen varianza 1 y 1: la variación total es 2. Las dos coordenadas nuevas reparten esa misma variación, 1,995 y 0,005, que también suman 2. La parte de la primera es 1,995 / 2 = 99,8%; la de la segunda, 0,005 / 2 = 0,2%. Con 16 variables es lo mismo: la variación total es 16 y cada componente se lleva una parte.</a:t>
-            </a:r>
-          </a:p>
-        </p:txBody>
-      </p:sp>
     </p:spTree>
   </p:cSld>
   <p:clrMapOvr>
@@ -4626,7 +4627,7 @@
                 </a:solidFill>
                 <a:latin typeface="Fira Sans"/>
               </a:rPr>
-              <a:t>El análisis de componentes principales</a:t>
+              <a:t>¿Para qué sirve?</a:t>
             </a:r>
           </a:p>
         </p:txBody>
@@ -4639,8 +4640,8 @@
         </p:nvSpPr>
         <p:spPr>
           <a:xfrm>
-            <a:off x="502920" y="1252728"/>
-            <a:ext cx="4023360" cy="3200400"/>
+            <a:off x="704088" y="1353312"/>
+            <a:ext cx="7744968" cy="3300984"/>
           </a:xfrm>
           <a:prstGeom prst="rect">
             <a:avLst/>
@@ -4662,7 +4663,7 @@
               </a:spcAft>
             </a:pPr>
             <a:r>
-              <a:rPr sz="1500" b="1">
+              <a:rPr sz="1800" b="1">
                 <a:solidFill>
                   <a:srgbClr val="E0A437"/>
                 </a:solidFill>
@@ -4671,13 +4672,13 @@
               <a:t>▸ </a:t>
             </a:r>
             <a:r>
-              <a:rPr sz="1500" b="1">
+              <a:rPr sz="1800" b="1">
                 <a:solidFill>
                   <a:srgbClr val="1D3557"/>
                 </a:solidFill>
                 <a:latin typeface="Fira Sans"/>
               </a:rPr>
-              <a:t>Busca la dirección en que los datos más se dispersan (la primera componente), luego la que más se dispersa entre las perpendiculares (la segunda), y así hasta tener tantas como variables.</a:t>
+              <a:t>Para mirar los datos: con 16 variables hay 120 gráficos de dispersión posibles; con dos componentes, uno solo.</a:t>
             </a:r>
           </a:p>
           <a:p>
@@ -4690,7 +4691,7 @@
               </a:spcAft>
             </a:pPr>
             <a:r>
-              <a:rPr sz="1500" b="1">
+              <a:rPr sz="1800" b="1">
                 <a:solidFill>
                   <a:srgbClr val="E0A437"/>
                 </a:solidFill>
@@ -4699,13 +4700,13 @@
               <a:t>▸ </a:t>
             </a:r>
             <a:r>
-              <a:rPr sz="1500" b="0">
+              <a:rPr sz="1800" b="0">
                 <a:solidFill>
                   <a:srgbClr val="000000"/>
                 </a:solidFill>
                 <a:latin typeface="Fira Sans"/>
               </a:rPr>
-              <a:t>Cada componente es una variable nueva: un puntaje ponderado de las originales, con una parte de la variación total.</a:t>
+              <a:t>Para entregarle a un modelo menos entradas: las componentes reemplazan a un grupo de variables que se repiten.</a:t>
             </a:r>
           </a:p>
           <a:p>
@@ -4718,7 +4719,7 @@
               </a:spcAft>
             </a:pPr>
             <a:r>
-              <a:rPr sz="1500" b="1">
+              <a:rPr sz="1800" b="1">
                 <a:solidFill>
                   <a:srgbClr val="E0A437"/>
                 </a:solidFill>
@@ -4727,41 +4728,45 @@
               <a:t>▸ </a:t>
             </a:r>
             <a:r>
-              <a:rPr sz="1500" b="0">
+              <a:rPr sz="1800" b="0">
                 <a:solidFill>
                   <a:srgbClr val="000000"/>
                 </a:solidFill>
                 <a:latin typeface="Fira Sans"/>
               </a:rPr>
-              <a:t>No usa ninguna respuesta Y: es un método no supervisado (James et al., 2013, p. 375).</a:t>
-            </a:r>
-          </a:p>
-        </p:txBody>
-      </p:sp>
-      <p:pic>
-        <p:nvPicPr>
-          <p:cNvPr id="5" name="Picture 4" descr="c8_01c_componentes.png"/>
-          <p:cNvPicPr>
-            <a:picLocks noChangeAspect="1"/>
-          </p:cNvPicPr>
-          <p:nvPr/>
-        </p:nvPicPr>
-        <p:blipFill>
-          <a:blip r:embed="rId2"/>
-          <a:stretch>
-            <a:fillRect/>
-          </a:stretch>
-        </p:blipFill>
-        <p:spPr>
-          <a:xfrm>
-            <a:off x="4892040" y="1371600"/>
-            <a:ext cx="3840480" cy="3701041"/>
-          </a:xfrm>
-          <a:prstGeom prst="rect">
-            <a:avLst/>
-          </a:prstGeom>
-        </p:spPr>
-      </p:pic>
+              <a:t>Para entender de qué está hecha la variación: qué variables se mueven juntas y cuánto pesa cada grupo.</a:t>
+            </a:r>
+          </a:p>
+          <a:p>
+            <a:pPr>
+              <a:lnSpc>
+                <a:spcPct val="112000"/>
+              </a:lnSpc>
+              <a:spcAft>
+                <a:spcPts val="900"/>
+              </a:spcAft>
+            </a:pPr>
+            <a:r>
+              <a:rPr sz="1800" b="1">
+                <a:solidFill>
+                  <a:srgbClr val="E0A437"/>
+                </a:solidFill>
+                <a:latin typeface="Fira Sans"/>
+              </a:rPr>
+              <a:t>▸ </a:t>
+            </a:r>
+            <a:r>
+              <a:rPr sz="1800" b="0">
+                <a:solidFill>
+                  <a:srgbClr val="000000"/>
+                </a:solidFill>
+                <a:latin typeface="Fira Sans"/>
+              </a:rPr>
+              <a:t>Lo que no hace: no elige variables ni las descarta, y no sabe qué se quiere predecir.</a:t>
+            </a:r>
+          </a:p>
+        </p:txBody>
+      </p:sp>
     </p:spTree>
   </p:cSld>
   <p:clrMapOvr>
@@ -4853,21 +4858,45 @@
                 </a:solidFill>
                 <a:latin typeface="Fira Sans"/>
               </a:rPr>
-              <a:t>¿Para qué sirve?</a:t>
-            </a:r>
-          </a:p>
-        </p:txBody>
-      </p:sp>
-      <p:sp>
-        <p:nvSpPr>
-          <p:cNvPr id="4" name="TextBox 3"/>
+              <a:t>Con tres variables: tres ejes, y se decide cuántos conservar</a:t>
+            </a:r>
+          </a:p>
+        </p:txBody>
+      </p:sp>
+      <p:pic>
+        <p:nvPicPr>
+          <p:cNvPr id="4" name="Picture 3" descr="c8_01e_tres_variables.png"/>
+          <p:cNvPicPr>
+            <a:picLocks noChangeAspect="1"/>
+          </p:cNvPicPr>
+          <p:nvPr/>
+        </p:nvPicPr>
+        <p:blipFill>
+          <a:blip r:embed="rId2"/>
+          <a:stretch>
+            <a:fillRect/>
+          </a:stretch>
+        </p:blipFill>
+        <p:spPr>
+          <a:xfrm>
+            <a:off x="1906591" y="1143000"/>
+            <a:ext cx="5330816" cy="2331720"/>
+          </a:xfrm>
+          <a:prstGeom prst="rect">
+            <a:avLst/>
+          </a:prstGeom>
+        </p:spPr>
+      </p:pic>
+      <p:sp>
+        <p:nvSpPr>
+          <p:cNvPr id="5" name="TextBox 4"/>
           <p:cNvSpPr txBox="1"/>
           <p:nvPr/>
         </p:nvSpPr>
         <p:spPr>
           <a:xfrm>
-            <a:off x="704088" y="1353312"/>
-            <a:ext cx="7744968" cy="3300984"/>
+            <a:off x="704088" y="3611879"/>
+            <a:ext cx="7744968" cy="1280160"/>
           </a:xfrm>
           <a:prstGeom prst="rect">
             <a:avLst/>
@@ -4880,115 +4909,14 @@
           </a:bodyPr>
           <a:lstStyle/>
           <a:p>
-            <a:pPr>
-              <a:lnSpc>
-                <a:spcPct val="112000"/>
-              </a:lnSpc>
-              <a:spcAft>
-                <a:spcPts val="900"/>
-              </a:spcAft>
-            </a:pPr>
-            <a:r>
-              <a:rPr sz="1800" b="1">
-                <a:solidFill>
-                  <a:srgbClr val="E0A437"/>
-                </a:solidFill>
-                <a:latin typeface="Fira Sans"/>
-              </a:rPr>
-              <a:t>▸ </a:t>
-            </a:r>
-            <a:r>
-              <a:rPr sz="1800" b="1">
-                <a:solidFill>
-                  <a:srgbClr val="1D3557"/>
-                </a:solidFill>
-                <a:latin typeface="Fira Sans"/>
-              </a:rPr>
-              <a:t>Para mirar los datos: con 16 variables hay 120 gráficos de dispersión posibles; con dos componentes, uno solo.</a:t>
-            </a:r>
-          </a:p>
-          <a:p>
-            <a:pPr>
-              <a:lnSpc>
-                <a:spcPct val="112000"/>
-              </a:lnSpc>
-              <a:spcAft>
-                <a:spcPts val="900"/>
-              </a:spcAft>
-            </a:pPr>
-            <a:r>
-              <a:rPr sz="1800" b="1">
-                <a:solidFill>
-                  <a:srgbClr val="E0A437"/>
-                </a:solidFill>
-                <a:latin typeface="Fira Sans"/>
-              </a:rPr>
-              <a:t>▸ </a:t>
-            </a:r>
-            <a:r>
-              <a:rPr sz="1800" b="0">
-                <a:solidFill>
-                  <a:srgbClr val="000000"/>
-                </a:solidFill>
-                <a:latin typeface="Fira Sans"/>
-              </a:rPr>
-              <a:t>Para entregarle a un modelo menos entradas: las componentes reemplazan a un grupo de variables que se repiten.</a:t>
-            </a:r>
-          </a:p>
-          <a:p>
-            <a:pPr>
-              <a:lnSpc>
-                <a:spcPct val="112000"/>
-              </a:lnSpc>
-              <a:spcAft>
-                <a:spcPts val="900"/>
-              </a:spcAft>
-            </a:pPr>
-            <a:r>
-              <a:rPr sz="1800" b="1">
-                <a:solidFill>
-                  <a:srgbClr val="E0A437"/>
-                </a:solidFill>
-                <a:latin typeface="Fira Sans"/>
-              </a:rPr>
-              <a:t>▸ </a:t>
-            </a:r>
-            <a:r>
-              <a:rPr sz="1800" b="0">
-                <a:solidFill>
-                  <a:srgbClr val="000000"/>
-                </a:solidFill>
-                <a:latin typeface="Fira Sans"/>
-              </a:rPr>
-              <a:t>Para entender de qué está hecha la variación: qué variables se mueven juntas y cuánto pesa cada grupo.</a:t>
-            </a:r>
-          </a:p>
-          <a:p>
-            <a:pPr>
-              <a:lnSpc>
-                <a:spcPct val="112000"/>
-              </a:lnSpc>
-              <a:spcAft>
-                <a:spcPts val="900"/>
-              </a:spcAft>
-            </a:pPr>
-            <a:r>
-              <a:rPr sz="1800" b="1">
-                <a:solidFill>
-                  <a:srgbClr val="E0A437"/>
-                </a:solidFill>
-                <a:latin typeface="Fira Sans"/>
-              </a:rPr>
-              <a:t>▸ </a:t>
-            </a:r>
-            <a:r>
-              <a:rPr sz="1800" b="0">
-                <a:solidFill>
-                  <a:srgbClr val="000000"/>
-                </a:solidFill>
-                <a:latin typeface="Fira Sans"/>
-              </a:rPr>
-              <a:t>Lo que no hace: no elige variables ni las descarta, y no sabe qué se quiere predecir.</a:t>
+            <a:r>
+              <a:rPr sz="1300" b="0">
+                <a:solidFill>
+                  <a:srgbClr val="333333"/>
+                </a:solidFill>
+                <a:latin typeface="Fira Sans"/>
+              </a:rPr>
+              <a:t>Siempre salen tantos ejes como variables. Aquí se agrega una tercera que no tiene que ver con las otras dos, los outs de defensa: el primer eje junta turnos y hits (66,7%), el segundo es la defensa (33,1%) y el tercero, la diferencia entre turnos y hits, casi nada (0,2%). Con dos ejes se conserva el 99,8% y el tercero se descarta. Si las tres variables dijeran cosas distintas, harían falta los tres.</a:t>
             </a:r>
           </a:p>
         </p:txBody>
@@ -5730,14 +5658,14 @@
                 </a:solidFill>
                 <a:latin typeface="Fira Sans"/>
               </a:rPr>
-              <a:t>Cuánta variación explica cada componente</a:t>
+              <a:t>Cuánto explica cada componente: el codo</a:t>
             </a:r>
           </a:p>
         </p:txBody>
       </p:sp>
       <p:pic>
         <p:nvPicPr>
-          <p:cNvPr id="4" name="Picture 3" descr="c8_03_scree.png"/>
+          <p:cNvPr id="4" name="Picture 3" descr="c8_03a_codo.png"/>
           <p:cNvPicPr>
             <a:picLocks noChangeAspect="1"/>
           </p:cNvPicPr>
@@ -5751,8 +5679,8 @@
         </p:blipFill>
         <p:spPr>
           <a:xfrm>
-            <a:off x="2337301" y="1143000"/>
-            <a:ext cx="4469397" cy="2587752"/>
+            <a:off x="2076158" y="1143000"/>
+            <a:ext cx="4991682" cy="2843784"/>
           </a:xfrm>
           <a:prstGeom prst="rect">
             <a:avLst/>
@@ -5767,8 +5695,8 @@
         </p:nvSpPr>
         <p:spPr>
           <a:xfrm>
-            <a:off x="704088" y="3867912"/>
-            <a:ext cx="7744968" cy="1024128"/>
+            <a:off x="704088" y="4123944"/>
+            <a:ext cx="7744968" cy="768096"/>
           </a:xfrm>
           <a:prstGeom prst="rect">
             <a:avLst/>
@@ -5788,7 +5716,7 @@
                 </a:solidFill>
                 <a:latin typeface="Fira Sans"/>
               </a:rPr>
-              <a:t>La primera componente explica el 45,3% de la variación de las 16 variables; la segunda, el 25,7%; la tercera, el 10,8%. Dos componentes reúnen el 71% y tres, el 82%. Para decidir cuántas conservar se mira dónde la curva deja de caer (el codo); no hay una regla objetiva, depende del uso (James et al., 2013, p. 384).</a:t>
+              <a:t>Las barras caen fuerte al principio (45,3%, 25,7%, 10,8%) y desde la cuarta quedan casi planas (5,4%, 4,4%, 3,2%...). Ese quiebre es el codo. Se conservan las componentes de antes del codo, que son las que explican mucho cada una: aquí, dos o tres.</a:t>
             </a:r>
           </a:p>
         </p:txBody>
@@ -5884,14 +5812,14 @@
                 </a:solidFill>
                 <a:latin typeface="Fira Sans"/>
               </a:rPr>
-              <a:t>De qué está hecha cada componente: los pesos</a:t>
+              <a:t>¿Con cuántas quedarse?</a:t>
             </a:r>
           </a:p>
         </p:txBody>
       </p:sp>
       <p:pic>
         <p:nvPicPr>
-          <p:cNvPr id="4" name="Picture 3" descr="c8_04_pesos.png"/>
+          <p:cNvPr id="4" name="Picture 3" descr="c8_03b_acumulado.png"/>
           <p:cNvPicPr>
             <a:picLocks noChangeAspect="1"/>
           </p:cNvPicPr>
@@ -5905,8 +5833,8 @@
         </p:blipFill>
         <p:spPr>
           <a:xfrm>
-            <a:off x="2196563" y="1143000"/>
-            <a:ext cx="4750872" cy="2587752"/>
+            <a:off x="2233760" y="1143000"/>
+            <a:ext cx="4676478" cy="2587752"/>
           </a:xfrm>
           <a:prstGeom prst="rect">
             <a:avLst/>
@@ -5942,7 +5870,7 @@
                 </a:solidFill>
                 <a:latin typeface="Fira Sans"/>
               </a:rPr>
-              <a:t>Primera componente: las siete variables de la carrera pesan casi lo mismo (0,29 a 0,34), las de la temporada la mitad (0,19 a 0,23) y la defensa no cuenta: mide cuánta carrera lleva el jugador. Segunda componente: la temporada 1986 pesa positivo (0,24 a 0,39) y la carrera negativo (−0,12 a −0,26): separa a quien rindió este año más de lo que dice su carrera.</a:t>
+              <a:t>El acumulado dice cuánto se conserva con cada cantidad: con dos componentes, el 71%; con tres, el 82%; con cinco, el 92%; con diez, el 99%. Conservar diez de dieciséis casi no reduce nada: el codo sugiere dos o tres. No hay una regla objetiva: depende de cuánta variación se acepte perder y para qué se usen las componentes (James et al., 2013, p. 384).</a:t>
             </a:r>
           </a:p>
         </p:txBody>
@@ -6038,14 +5966,14 @@
                 </a:solidFill>
                 <a:latin typeface="Fira Sans"/>
               </a:rPr>
-              <a:t>Los 263 jugadores en dos componentes</a:t>
+              <a:t>De qué está hecha cada componente: los pesos</a:t>
             </a:r>
           </a:p>
         </p:txBody>
       </p:sp>
       <p:pic>
         <p:nvPicPr>
-          <p:cNvPr id="4" name="Picture 3" descr="c8_05_jugadores.png"/>
+          <p:cNvPr id="4" name="Picture 3" descr="c8_04_pesos.png"/>
           <p:cNvPicPr>
             <a:picLocks noChangeAspect="1"/>
           </p:cNvPicPr>
@@ -6059,8 +5987,8 @@
         </p:blipFill>
         <p:spPr>
           <a:xfrm>
-            <a:off x="2699826" y="1143000"/>
-            <a:ext cx="3744346" cy="2587751"/>
+            <a:off x="2196563" y="1143000"/>
+            <a:ext cx="4750872" cy="2587752"/>
           </a:xfrm>
           <a:prstGeom prst="rect">
             <a:avLst/>
@@ -6096,7 +6024,7 @@
                 </a:solidFill>
                 <a:latin typeface="Fira Sans"/>
               </a:rPr>
-              <a:t>Cada punto es un jugador y el color, su salario de 1987, que PCA no usó. El salario crece hacia la derecha (correlación 0,64 con la primera componente) y casi nada hacia arriba (0,11 con la segunda): la carrera pesa en el salario; la última temporada, poco. Dos ejes muestran lo que en 16 variables había que leer coeficiente por coeficiente.</a:t>
+              <a:t>Primera componente: las siete variables de la carrera pesan casi lo mismo (0,29 a 0,34), las de la temporada la mitad (0,19 a 0,23) y la defensa no cuenta: mide cuánta carrera lleva el jugador. Segunda componente: la temporada 1986 pesa positivo (0,24 a 0,39) y la carrera negativo (−0,12 a −0,26): separa a quien rindió este año más de lo que dice su carrera.</a:t>
             </a:r>
           </a:p>
         </p:txBody>
@@ -6192,14 +6120,14 @@
                 </a:solidFill>
                 <a:latin typeface="Fira Sans"/>
               </a:rPr>
-              <a:t>El mismo cálculo con las flores de la clase 2</a:t>
+              <a:t>Los 263 jugadores en dos componentes</a:t>
             </a:r>
           </a:p>
         </p:txBody>
       </p:sp>
       <p:pic>
         <p:nvPicPr>
-          <p:cNvPr id="4" name="Picture 3" descr="c8_06_iris.png"/>
+          <p:cNvPr id="4" name="Picture 3" descr="c8_05_jugadores.png"/>
           <p:cNvPicPr>
             <a:picLocks noChangeAspect="1"/>
           </p:cNvPicPr>
@@ -6213,8 +6141,8 @@
         </p:blipFill>
         <p:spPr>
           <a:xfrm>
-            <a:off x="2906606" y="1143000"/>
-            <a:ext cx="3330786" cy="2587751"/>
+            <a:off x="2699826" y="1143000"/>
+            <a:ext cx="3744346" cy="2587751"/>
           </a:xfrm>
           <a:prstGeom prst="rect">
             <a:avLst/>
@@ -6250,7 +6178,7 @@
                 </a:solidFill>
                 <a:latin typeface="Fira Sans"/>
               </a:rPr>
-              <a:t>Las cuatro medidas de iris se resumen en dos componentes que reúnen el 96% de la variación. La primera (73%) pesa casi igual el largo y el ancho del pétalo y el largo del sépalo (0,52 a 0,58): el tamaño de la flor. La segunda (23%) es casi solo el ancho del sépalo (0,92). PCA no conoce la especie y aun así las tres quedan separadas a lo largo de la primera componente.</a:t>
+              <a:t>Cada punto es un jugador y el color, su salario de 1987, que PCA no usó. El salario crece hacia la derecha (correlación 0,64 con la primera componente) y casi nada hacia arriba (0,11 con la segunda): la carrera pesa en el salario; la última temporada, poco. Dos ejes muestran lo que en 16 variables había que leer coeficiente por coeficiente.</a:t>
             </a:r>
           </a:p>
         </p:txBody>
@@ -6288,7 +6216,7 @@
             <a:avLst/>
           </a:prstGeom>
           <a:solidFill>
-            <a:srgbClr val="1D3557"/>
+            <a:srgbClr val="FAFBFC"/>
           </a:solidFill>
           <a:ln>
             <a:noFill/>
@@ -6325,8 +6253,8 @@
         </p:nvSpPr>
         <p:spPr>
           <a:xfrm>
-            <a:off x="603504" y="1847088"/>
-            <a:ext cx="7946136" cy="1399032"/>
+            <a:off x="402336" y="301752"/>
+            <a:ext cx="8348472" cy="795528"/>
           </a:xfrm>
           <a:prstGeom prst="rect">
             <a:avLst/>
@@ -6340,24 +6268,71 @@
           <a:lstStyle/>
           <a:p>
             <a:r>
-              <a:rPr sz="3400" b="1">
-                <a:solidFill>
-                  <a:srgbClr val="FFFFFF"/>
-                </a:solidFill>
-                <a:latin typeface="Fira Sans"/>
-              </a:rPr>
-              <a:t>4. Cuándo</a:t>
-            </a:r>
-          </a:p>
-          <a:p>
-            <a:r>
-              <a:rPr sz="1800" b="0">
-                <a:solidFill>
-                  <a:srgbClr val="E0A437"/>
-                </a:solidFill>
-                <a:latin typeface="Fira Sans"/>
-              </a:rPr>
-              <a:t>Cuándo conviene y cuándo no</a:t>
+              <a:rPr sz="2800" b="1">
+                <a:solidFill>
+                  <a:srgbClr val="0F0F0F"/>
+                </a:solidFill>
+                <a:latin typeface="Fira Sans"/>
+              </a:rPr>
+              <a:t>El mismo cálculo con las flores de la clase 2</a:t>
+            </a:r>
+          </a:p>
+        </p:txBody>
+      </p:sp>
+      <p:pic>
+        <p:nvPicPr>
+          <p:cNvPr id="4" name="Picture 3" descr="c8_06_iris.png"/>
+          <p:cNvPicPr>
+            <a:picLocks noChangeAspect="1"/>
+          </p:cNvPicPr>
+          <p:nvPr/>
+        </p:nvPicPr>
+        <p:blipFill>
+          <a:blip r:embed="rId2"/>
+          <a:stretch>
+            <a:fillRect/>
+          </a:stretch>
+        </p:blipFill>
+        <p:spPr>
+          <a:xfrm>
+            <a:off x="2906606" y="1143000"/>
+            <a:ext cx="3330786" cy="2587751"/>
+          </a:xfrm>
+          <a:prstGeom prst="rect">
+            <a:avLst/>
+          </a:prstGeom>
+        </p:spPr>
+      </p:pic>
+      <p:sp>
+        <p:nvSpPr>
+          <p:cNvPr id="5" name="TextBox 4"/>
+          <p:cNvSpPr txBox="1"/>
+          <p:nvPr/>
+        </p:nvSpPr>
+        <p:spPr>
+          <a:xfrm>
+            <a:off x="704088" y="3867912"/>
+            <a:ext cx="7744968" cy="1024128"/>
+          </a:xfrm>
+          <a:prstGeom prst="rect">
+            <a:avLst/>
+          </a:prstGeom>
+          <a:noFill/>
+        </p:spPr>
+        <p:txBody>
+          <a:bodyPr wrap="square">
+            <a:spAutoFit/>
+          </a:bodyPr>
+          <a:lstStyle/>
+          <a:p>
+            <a:r>
+              <a:rPr sz="1300" b="0">
+                <a:solidFill>
+                  <a:srgbClr val="333333"/>
+                </a:solidFill>
+                <a:latin typeface="Fira Sans"/>
+              </a:rPr>
+              <a:t>Las cuatro medidas de iris se resumen en dos componentes que reúnen el 96% de la variación. La primera (73%) pesa casi igual el largo y el ancho del pétalo y el largo del sépalo (0,52 a 0,58): el tamaño de la flor. La segunda (23%) es casi solo el ancho del sépalo (0,92). PCA no conoce la especie y aun así las tres quedan separadas a lo largo de la primera componente.</a:t>
             </a:r>
           </a:p>
         </p:txBody>
@@ -6395,7 +6370,7 @@
             <a:avLst/>
           </a:prstGeom>
           <a:solidFill>
-            <a:srgbClr val="FAFBFC"/>
+            <a:srgbClr val="1D3557"/>
           </a:solidFill>
           <a:ln>
             <a:noFill/>
@@ -6432,8 +6407,8 @@
         </p:nvSpPr>
         <p:spPr>
           <a:xfrm>
-            <a:off x="402336" y="301752"/>
-            <a:ext cx="8348472" cy="795528"/>
+            <a:off x="603504" y="1847088"/>
+            <a:ext cx="7946136" cy="1399032"/>
           </a:xfrm>
           <a:prstGeom prst="rect">
             <a:avLst/>
@@ -6447,120 +6422,24 @@
           <a:lstStyle/>
           <a:p>
             <a:r>
-              <a:rPr sz="2800" b="1">
-                <a:solidFill>
-                  <a:srgbClr val="0F0F0F"/>
-                </a:solidFill>
-                <a:latin typeface="Fira Sans"/>
-              </a:rPr>
-              <a:t>¿Cuándo conviene?</a:t>
-            </a:r>
-          </a:p>
-        </p:txBody>
-      </p:sp>
-      <p:sp>
-        <p:nvSpPr>
-          <p:cNvPr id="4" name="TextBox 3"/>
-          <p:cNvSpPr txBox="1"/>
-          <p:nvPr/>
-        </p:nvSpPr>
-        <p:spPr>
-          <a:xfrm>
-            <a:off x="704088" y="1353312"/>
-            <a:ext cx="7744968" cy="3300984"/>
-          </a:xfrm>
-          <a:prstGeom prst="rect">
-            <a:avLst/>
-          </a:prstGeom>
-          <a:noFill/>
-        </p:spPr>
-        <p:txBody>
-          <a:bodyPr wrap="square">
-            <a:spAutoFit/>
-          </a:bodyPr>
-          <a:lstStyle/>
-          <a:p>
-            <a:pPr>
-              <a:lnSpc>
-                <a:spcPct val="112000"/>
-              </a:lnSpc>
-              <a:spcAft>
-                <a:spcPts val="900"/>
-              </a:spcAft>
-            </a:pPr>
-            <a:r>
-              <a:rPr sz="1800" b="1">
+              <a:rPr sz="3400" b="1">
+                <a:solidFill>
+                  <a:srgbClr val="FFFFFF"/>
+                </a:solidFill>
+                <a:latin typeface="Fira Sans"/>
+              </a:rPr>
+              <a:t>4. Cuándo</a:t>
+            </a:r>
+          </a:p>
+          <a:p>
+            <a:r>
+              <a:rPr sz="1800" b="0">
                 <a:solidFill>
                   <a:srgbClr val="E0A437"/>
                 </a:solidFill>
                 <a:latin typeface="Fira Sans"/>
               </a:rPr>
-              <a:t>▸ </a:t>
-            </a:r>
-            <a:r>
-              <a:rPr sz="1800" b="1">
-                <a:solidFill>
-                  <a:srgbClr val="1D3557"/>
-                </a:solidFill>
-                <a:latin typeface="Fira Sans"/>
-              </a:rPr>
-              <a:t>Con muchas variables numéricas que se correlacionan en bloques, como en la matriz de la clase 7.</a:t>
-            </a:r>
-          </a:p>
-          <a:p>
-            <a:pPr>
-              <a:lnSpc>
-                <a:spcPct val="112000"/>
-              </a:lnSpc>
-              <a:spcAft>
-                <a:spcPts val="900"/>
-              </a:spcAft>
-            </a:pPr>
-            <a:r>
-              <a:rPr sz="1800" b="1">
-                <a:solidFill>
-                  <a:srgbClr val="E0A437"/>
-                </a:solidFill>
-                <a:latin typeface="Fira Sans"/>
-              </a:rPr>
-              <a:t>▸ </a:t>
-            </a:r>
-            <a:r>
-              <a:rPr sz="1800" b="0">
-                <a:solidFill>
-                  <a:srgbClr val="000000"/>
-                </a:solidFill>
-                <a:latin typeface="Fira Sans"/>
-              </a:rPr>
-              <a:t>Para mirar los datos en un plano, o para entregarle a un modelo menos entradas.</a:t>
-            </a:r>
-          </a:p>
-          <a:p>
-            <a:pPr>
-              <a:lnSpc>
-                <a:spcPct val="112000"/>
-              </a:lnSpc>
-              <a:spcAft>
-                <a:spcPts val="900"/>
-              </a:spcAft>
-            </a:pPr>
-            <a:r>
-              <a:rPr sz="1800" b="1">
-                <a:solidFill>
-                  <a:srgbClr val="E0A437"/>
-                </a:solidFill>
-                <a:latin typeface="Fira Sans"/>
-              </a:rPr>
-              <a:t>▸ </a:t>
-            </a:r>
-            <a:r>
-              <a:rPr sz="1800" b="0">
-                <a:solidFill>
-                  <a:srgbClr val="000000"/>
-                </a:solidFill>
-                <a:latin typeface="Fira Sans"/>
-              </a:rPr>
-              <a:t>No aporta si las variables son pocas y distintas entre sí: no hay nada que resumir.</a:t>
+              <a:t>Cuándo conviene y cuándo no</a:t>
             </a:r>
           </a:p>
         </p:txBody>
@@ -6656,7 +6535,7 @@
                 </a:solidFill>
                 <a:latin typeface="Fira Sans"/>
               </a:rPr>
-              <a:t>Tres precauciones</a:t>
+              <a:t>¿Cuándo conviene?</a:t>
             </a:r>
           </a:p>
         </p:txBody>
@@ -6707,7 +6586,7 @@
                 </a:solidFill>
                 <a:latin typeface="Fira Sans"/>
               </a:rPr>
-              <a:t>Las variables categóricas (las dummies de la clase 6) no entran bien en el cálculo: se dejan fuera o se tratan aparte.</a:t>
+              <a:t>Con muchas variables numéricas que se correlacionan en bloques, como en la matriz de la clase 7.</a:t>
             </a:r>
           </a:p>
           <a:p>
@@ -6735,7 +6614,7 @@
                 </a:solidFill>
                 <a:latin typeface="Fira Sans"/>
               </a:rPr>
-              <a:t>Las componentes no siempre tienen una lectura clara. Aquí sí (la carrera; la temporada frente a la carrera), pero no está garantizado.</a:t>
+              <a:t>Para mirar los datos en un plano, o para entregarle a un modelo menos entradas.</a:t>
             </a:r>
           </a:p>
           <a:p>
@@ -6763,7 +6642,7 @@
                 </a:solidFill>
                 <a:latin typeface="Fira Sans"/>
               </a:rPr>
-              <a:t>Es no supervisado: la dirección de más variación no es necesariamente la que mejor predice la respuesta. Ridge y Lasso eligen mirando Y; PCA no la mira.</a:t>
+              <a:t>No aporta si las variables son pocas y distintas entre sí: no hay nada que resumir.</a:t>
             </a:r>
           </a:p>
         </p:txBody>
@@ -6859,124 +6738,21 @@
                 </a:solidFill>
                 <a:latin typeface="Fira Sans"/>
               </a:rPr>
-              <a:t>En el código: cinco líneas</a:t>
-            </a:r>
-          </a:p>
-        </p:txBody>
-      </p:sp>
-      <p:sp>
-        <p:nvSpPr>
-          <p:cNvPr id="4" name="Rectangle 3"/>
-          <p:cNvSpPr/>
-          <p:nvPr/>
-        </p:nvSpPr>
-        <p:spPr>
-          <a:xfrm>
-            <a:off x="704088" y="1280160"/>
-            <a:ext cx="7744968" cy="2880360"/>
-          </a:xfrm>
-          <a:prstGeom prst="rect">
-            <a:avLst/>
-          </a:prstGeom>
-          <a:solidFill>
-            <a:srgbClr val="F0F2F5"/>
-          </a:solidFill>
-          <a:ln>
-            <a:solidFill>
-              <a:srgbClr val="D8DDE3"/>
-            </a:solidFill>
-          </a:ln>
-          <a:effectLst/>
-        </p:spPr>
-        <p:style>
-          <a:lnRef idx="1">
-            <a:schemeClr val="accent1"/>
-          </a:lnRef>
-          <a:fillRef idx="3">
-            <a:schemeClr val="accent1"/>
-          </a:fillRef>
-          <a:effectRef idx="2">
-            <a:schemeClr val="accent1"/>
-          </a:effectRef>
-          <a:fontRef idx="minor">
-            <a:schemeClr val="lt1"/>
-          </a:fontRef>
-        </p:style>
-        <p:txBody>
-          <a:bodyPr rtlCol="0" anchor="ctr" wrap="square" lIns="228600" tIns="137160"/>
-          <a:lstStyle/>
-          <a:p>
-            <a:pPr/>
-            <a:r>
-              <a:rPr sz="1500" b="0">
-                <a:solidFill>
-                  <a:srgbClr val="1D3557"/>
-                </a:solidFill>
-                <a:latin typeface="Menlo"/>
-              </a:rPr>
-              <a:t>Z = StandardScaler().fit_transform(X)  # 1. estandarizar</a:t>
-            </a:r>
-          </a:p>
-          <a:p>
-            <a:pPr/>
-            <a:r>
-              <a:rPr sz="1500" b="0">
-                <a:solidFill>
-                  <a:srgbClr val="1D3557"/>
-                </a:solidFill>
-                <a:latin typeface="Menlo"/>
-              </a:rPr>
-              <a:t>pca = PCA().fit(Z)                     # 2. las componentes</a:t>
-            </a:r>
-          </a:p>
-          <a:p>
-            <a:pPr/>
-            <a:r>
-              <a:rPr sz="1500" b="0">
-                <a:solidFill>
-                  <a:srgbClr val="1D3557"/>
-                </a:solidFill>
-                <a:latin typeface="Menlo"/>
-              </a:rPr>
-              <a:t>pca.explained_variance_ratio_          # 3. cuánto explica</a:t>
-            </a:r>
-          </a:p>
-          <a:p>
-            <a:pPr/>
-            <a:r>
-              <a:rPr sz="1500" b="0">
-                <a:solidFill>
-                  <a:srgbClr val="1D3557"/>
-                </a:solidFill>
-                <a:latin typeface="Menlo"/>
-              </a:rPr>
-              <a:t>pca.components_                        # 4. los pesos</a:t>
-            </a:r>
-          </a:p>
-          <a:p>
-            <a:pPr/>
-            <a:r>
-              <a:rPr sz="1500" b="0">
-                <a:solidFill>
-                  <a:srgbClr val="1D3557"/>
-                </a:solidFill>
-                <a:latin typeface="Menlo"/>
-              </a:rPr>
-              <a:t>puntajes = pca.transform(Z)            # 5. los puntajes</a:t>
-            </a:r>
-          </a:p>
-        </p:txBody>
-      </p:sp>
-      <p:sp>
-        <p:nvSpPr>
-          <p:cNvPr id="5" name="TextBox 4"/>
+              <a:t>Tres precauciones</a:t>
+            </a:r>
+          </a:p>
+        </p:txBody>
+      </p:sp>
+      <p:sp>
+        <p:nvSpPr>
+          <p:cNvPr id="4" name="TextBox 3"/>
           <p:cNvSpPr txBox="1"/>
           <p:nvPr/>
         </p:nvSpPr>
         <p:spPr>
           <a:xfrm>
-            <a:off x="704088" y="4389120"/>
-            <a:ext cx="7744968" cy="1097280"/>
+            <a:off x="704088" y="1353312"/>
+            <a:ext cx="7744968" cy="3300984"/>
           </a:xfrm>
           <a:prstGeom prst="rect">
             <a:avLst/>
@@ -6998,7 +6774,7 @@
               </a:spcAft>
             </a:pPr>
             <a:r>
-              <a:rPr sz="1600" b="1">
+              <a:rPr sz="1800" b="1">
                 <a:solidFill>
                   <a:srgbClr val="E0A437"/>
                 </a:solidFill>
@@ -7007,13 +6783,69 @@
               <a:t>▸ </a:t>
             </a:r>
             <a:r>
-              <a:rPr sz="1600" b="0">
+              <a:rPr sz="1800" b="1">
+                <a:solidFill>
+                  <a:srgbClr val="1D3557"/>
+                </a:solidFill>
+                <a:latin typeface="Fira Sans"/>
+              </a:rPr>
+              <a:t>Las variables categóricas (las dummies de la clase 6) no entran bien en el cálculo: se dejan fuera o se tratan aparte.</a:t>
+            </a:r>
+          </a:p>
+          <a:p>
+            <a:pPr>
+              <a:lnSpc>
+                <a:spcPct val="112000"/>
+              </a:lnSpc>
+              <a:spcAft>
+                <a:spcPts val="900"/>
+              </a:spcAft>
+            </a:pPr>
+            <a:r>
+              <a:rPr sz="1800" b="1">
+                <a:solidFill>
+                  <a:srgbClr val="E0A437"/>
+                </a:solidFill>
+                <a:latin typeface="Fira Sans"/>
+              </a:rPr>
+              <a:t>▸ </a:t>
+            </a:r>
+            <a:r>
+              <a:rPr sz="1800" b="0">
                 <a:solidFill>
                   <a:srgbClr val="000000"/>
                 </a:solidFill>
                 <a:latin typeface="Fira Sans"/>
               </a:rPr>
-              <a:t>El ejemplo completo, con las tablas de pesos y los gráficos de la clase, está en el notebook 08_componentes_principales.ipynb.</a:t>
+              <a:t>Las componentes no siempre tienen una lectura clara. Aquí sí (la carrera; la temporada frente a la carrera), pero no está garantizado.</a:t>
+            </a:r>
+          </a:p>
+          <a:p>
+            <a:pPr>
+              <a:lnSpc>
+                <a:spcPct val="112000"/>
+              </a:lnSpc>
+              <a:spcAft>
+                <a:spcPts val="900"/>
+              </a:spcAft>
+            </a:pPr>
+            <a:r>
+              <a:rPr sz="1800" b="1">
+                <a:solidFill>
+                  <a:srgbClr val="E0A437"/>
+                </a:solidFill>
+                <a:latin typeface="Fira Sans"/>
+              </a:rPr>
+              <a:t>▸ </a:t>
+            </a:r>
+            <a:r>
+              <a:rPr sz="1800" b="0">
+                <a:solidFill>
+                  <a:srgbClr val="000000"/>
+                </a:solidFill>
+                <a:latin typeface="Fira Sans"/>
+              </a:rPr>
+              <a:t>Es no supervisado: la dirección de más variación no es necesariamente la que mejor predice la respuesta. Ridge y Lasso eligen mirando Y; PCA no la mira.</a:t>
             </a:r>
           </a:p>
         </p:txBody>
@@ -7051,7 +6883,7 @@
             <a:avLst/>
           </a:prstGeom>
           <a:solidFill>
-            <a:srgbClr val="1D3557"/>
+            <a:srgbClr val="FAFBFC"/>
           </a:solidFill>
           <a:ln>
             <a:noFill/>
@@ -7088,8 +6920,8 @@
         </p:nvSpPr>
         <p:spPr>
           <a:xfrm>
-            <a:off x="603504" y="1847088"/>
-            <a:ext cx="7946136" cy="1399032"/>
+            <a:off x="402336" y="301752"/>
+            <a:ext cx="8348472" cy="795528"/>
           </a:xfrm>
           <a:prstGeom prst="rect">
             <a:avLst/>
@@ -7103,24 +6935,167 @@
           <a:lstStyle/>
           <a:p>
             <a:r>
-              <a:rPr sz="3400" b="1">
-                <a:solidFill>
-                  <a:srgbClr val="FFFFFF"/>
-                </a:solidFill>
-                <a:latin typeface="Fira Sans"/>
-              </a:rPr>
-              <a:t>5. Cierre del módulo</a:t>
-            </a:r>
-          </a:p>
-          <a:p>
-            <a:r>
-              <a:rPr sz="1800" b="0">
+              <a:rPr sz="2800" b="1">
+                <a:solidFill>
+                  <a:srgbClr val="0F0F0F"/>
+                </a:solidFill>
+                <a:latin typeface="Fira Sans"/>
+              </a:rPr>
+              <a:t>En el código: cinco líneas</a:t>
+            </a:r>
+          </a:p>
+        </p:txBody>
+      </p:sp>
+      <p:sp>
+        <p:nvSpPr>
+          <p:cNvPr id="4" name="Rectangle 3"/>
+          <p:cNvSpPr/>
+          <p:nvPr/>
+        </p:nvSpPr>
+        <p:spPr>
+          <a:xfrm>
+            <a:off x="704088" y="1280160"/>
+            <a:ext cx="7744968" cy="2880360"/>
+          </a:xfrm>
+          <a:prstGeom prst="rect">
+            <a:avLst/>
+          </a:prstGeom>
+          <a:solidFill>
+            <a:srgbClr val="F0F2F5"/>
+          </a:solidFill>
+          <a:ln>
+            <a:solidFill>
+              <a:srgbClr val="D8DDE3"/>
+            </a:solidFill>
+          </a:ln>
+          <a:effectLst/>
+        </p:spPr>
+        <p:style>
+          <a:lnRef idx="1">
+            <a:schemeClr val="accent1"/>
+          </a:lnRef>
+          <a:fillRef idx="3">
+            <a:schemeClr val="accent1"/>
+          </a:fillRef>
+          <a:effectRef idx="2">
+            <a:schemeClr val="accent1"/>
+          </a:effectRef>
+          <a:fontRef idx="minor">
+            <a:schemeClr val="lt1"/>
+          </a:fontRef>
+        </p:style>
+        <p:txBody>
+          <a:bodyPr rtlCol="0" anchor="ctr" wrap="square" lIns="228600" tIns="137160"/>
+          <a:lstStyle/>
+          <a:p>
+            <a:pPr/>
+            <a:r>
+              <a:rPr sz="1500" b="0">
+                <a:solidFill>
+                  <a:srgbClr val="1D3557"/>
+                </a:solidFill>
+                <a:latin typeface="Menlo"/>
+              </a:rPr>
+              <a:t>Z = StandardScaler().fit_transform(X)  # 1. estandarizar</a:t>
+            </a:r>
+          </a:p>
+          <a:p>
+            <a:pPr/>
+            <a:r>
+              <a:rPr sz="1500" b="0">
+                <a:solidFill>
+                  <a:srgbClr val="1D3557"/>
+                </a:solidFill>
+                <a:latin typeface="Menlo"/>
+              </a:rPr>
+              <a:t>pca = PCA().fit(Z)                     # 2. las componentes</a:t>
+            </a:r>
+          </a:p>
+          <a:p>
+            <a:pPr/>
+            <a:r>
+              <a:rPr sz="1500" b="0">
+                <a:solidFill>
+                  <a:srgbClr val="1D3557"/>
+                </a:solidFill>
+                <a:latin typeface="Menlo"/>
+              </a:rPr>
+              <a:t>pca.explained_variance_ratio_          # 3. cuánto explica</a:t>
+            </a:r>
+          </a:p>
+          <a:p>
+            <a:pPr/>
+            <a:r>
+              <a:rPr sz="1500" b="0">
+                <a:solidFill>
+                  <a:srgbClr val="1D3557"/>
+                </a:solidFill>
+                <a:latin typeface="Menlo"/>
+              </a:rPr>
+              <a:t>pca.components_                        # 4. los pesos</a:t>
+            </a:r>
+          </a:p>
+          <a:p>
+            <a:pPr/>
+            <a:r>
+              <a:rPr sz="1500" b="0">
+                <a:solidFill>
+                  <a:srgbClr val="1D3557"/>
+                </a:solidFill>
+                <a:latin typeface="Menlo"/>
+              </a:rPr>
+              <a:t>puntajes = pca.transform(Z)            # 5. los puntajes</a:t>
+            </a:r>
+          </a:p>
+        </p:txBody>
+      </p:sp>
+      <p:sp>
+        <p:nvSpPr>
+          <p:cNvPr id="5" name="TextBox 4"/>
+          <p:cNvSpPr txBox="1"/>
+          <p:nvPr/>
+        </p:nvSpPr>
+        <p:spPr>
+          <a:xfrm>
+            <a:off x="704088" y="4389120"/>
+            <a:ext cx="7744968" cy="1097280"/>
+          </a:xfrm>
+          <a:prstGeom prst="rect">
+            <a:avLst/>
+          </a:prstGeom>
+          <a:noFill/>
+        </p:spPr>
+        <p:txBody>
+          <a:bodyPr wrap="square">
+            <a:spAutoFit/>
+          </a:bodyPr>
+          <a:lstStyle/>
+          <a:p>
+            <a:pPr>
+              <a:lnSpc>
+                <a:spcPct val="112000"/>
+              </a:lnSpc>
+              <a:spcAft>
+                <a:spcPts val="900"/>
+              </a:spcAft>
+            </a:pPr>
+            <a:r>
+              <a:rPr sz="1600" b="1">
                 <a:solidFill>
                   <a:srgbClr val="E0A437"/>
                 </a:solidFill>
                 <a:latin typeface="Fira Sans"/>
               </a:rPr>
-              <a:t>Ocho clases, un hilo</a:t>
+              <a:t>▸ </a:t>
+            </a:r>
+            <a:r>
+              <a:rPr sz="1600" b="0">
+                <a:solidFill>
+                  <a:srgbClr val="000000"/>
+                </a:solidFill>
+                <a:latin typeface="Fira Sans"/>
+              </a:rPr>
+              <a:t>El ejemplo completo, con las tablas de pesos y los gráficos de la clase, está en el notebook 08_componentes_principales.ipynb.</a:t>
             </a:r>
           </a:p>
         </p:txBody>
@@ -7417,7 +7392,7 @@
             <a:avLst/>
           </a:prstGeom>
           <a:solidFill>
-            <a:srgbClr val="FAFBFC"/>
+            <a:srgbClr val="1D3557"/>
           </a:solidFill>
           <a:ln>
             <a:noFill/>
@@ -7454,8 +7429,8 @@
         </p:nvSpPr>
         <p:spPr>
           <a:xfrm>
-            <a:off x="402336" y="301752"/>
-            <a:ext cx="8348472" cy="795528"/>
+            <a:off x="603504" y="1847088"/>
+            <a:ext cx="7946136" cy="1399032"/>
           </a:xfrm>
           <a:prstGeom prst="rect">
             <a:avLst/>
@@ -7469,71 +7444,24 @@
           <a:lstStyle/>
           <a:p>
             <a:r>
-              <a:rPr sz="2800" b="1">
-                <a:solidFill>
-                  <a:srgbClr val="0F0F0F"/>
-                </a:solidFill>
-                <a:latin typeface="Fira Sans"/>
-              </a:rPr>
-              <a:t>El módulo en una página</a:t>
-            </a:r>
-          </a:p>
-        </p:txBody>
-      </p:sp>
-      <p:pic>
-        <p:nvPicPr>
-          <p:cNvPr id="4" name="Picture 3" descr="c8_07_mapa_modulo.png"/>
-          <p:cNvPicPr>
-            <a:picLocks noChangeAspect="1"/>
-          </p:cNvPicPr>
-          <p:nvPr/>
-        </p:nvPicPr>
-        <p:blipFill>
-          <a:blip r:embed="rId2"/>
-          <a:stretch>
-            <a:fillRect/>
-          </a:stretch>
-        </p:blipFill>
-        <p:spPr>
-          <a:xfrm>
-            <a:off x="1029546" y="1143000"/>
-            <a:ext cx="7084906" cy="3099816"/>
-          </a:xfrm>
-          <a:prstGeom prst="rect">
-            <a:avLst/>
-          </a:prstGeom>
-        </p:spPr>
-      </p:pic>
-      <p:sp>
-        <p:nvSpPr>
-          <p:cNvPr id="5" name="TextBox 4"/>
-          <p:cNvSpPr txBox="1"/>
-          <p:nvPr/>
-        </p:nvSpPr>
-        <p:spPr>
-          <a:xfrm>
-            <a:off x="704088" y="4379976"/>
-            <a:ext cx="7744968" cy="512064"/>
-          </a:xfrm>
-          <a:prstGeom prst="rect">
-            <a:avLst/>
-          </a:prstGeom>
-          <a:noFill/>
-        </p:spPr>
-        <p:txBody>
-          <a:bodyPr wrap="square">
-            <a:spAutoFit/>
-          </a:bodyPr>
-          <a:lstStyle/>
-          <a:p>
-            <a:r>
-              <a:rPr sz="1300" b="0">
-                <a:solidFill>
-                  <a:srgbClr val="333333"/>
-                </a:solidFill>
-                <a:latin typeface="Fira Sans"/>
-              </a:rPr>
-              <a:t>Cada clase dejó una idea. Juntas, son lo que el módulo enseñó: cómo se llega de una pregunta y unos datos a un resultado, y cómo se lee ese resultado con su incertidumbre.</a:t>
+              <a:rPr sz="3400" b="1">
+                <a:solidFill>
+                  <a:srgbClr val="FFFFFF"/>
+                </a:solidFill>
+                <a:latin typeface="Fira Sans"/>
+              </a:rPr>
+              <a:t>5. Cierre del módulo</a:t>
+            </a:r>
+          </a:p>
+          <a:p>
+            <a:r>
+              <a:rPr sz="1800" b="0">
+                <a:solidFill>
+                  <a:srgbClr val="E0A437"/>
+                </a:solidFill>
+                <a:latin typeface="Fira Sans"/>
+              </a:rPr>
+              <a:t>Ocho clases, un hilo</a:t>
             </a:r>
           </a:p>
         </p:txBody>
@@ -7629,21 +7557,45 @@
                 </a:solidFill>
                 <a:latin typeface="Fira Sans"/>
               </a:rPr>
-              <a:t>Lo que sigue en el diplomado</a:t>
-            </a:r>
-          </a:p>
-        </p:txBody>
-      </p:sp>
-      <p:sp>
-        <p:nvSpPr>
-          <p:cNvPr id="4" name="TextBox 3"/>
+              <a:t>El módulo en una página</a:t>
+            </a:r>
+          </a:p>
+        </p:txBody>
+      </p:sp>
+      <p:pic>
+        <p:nvPicPr>
+          <p:cNvPr id="4" name="Picture 3" descr="c8_07_mapa_modulo.png"/>
+          <p:cNvPicPr>
+            <a:picLocks noChangeAspect="1"/>
+          </p:cNvPicPr>
+          <p:nvPr/>
+        </p:nvPicPr>
+        <p:blipFill>
+          <a:blip r:embed="rId2"/>
+          <a:stretch>
+            <a:fillRect/>
+          </a:stretch>
+        </p:blipFill>
+        <p:spPr>
+          <a:xfrm>
+            <a:off x="1029546" y="1143000"/>
+            <a:ext cx="7084906" cy="3099816"/>
+          </a:xfrm>
+          <a:prstGeom prst="rect">
+            <a:avLst/>
+          </a:prstGeom>
+        </p:spPr>
+      </p:pic>
+      <p:sp>
+        <p:nvSpPr>
+          <p:cNvPr id="5" name="TextBox 4"/>
           <p:cNvSpPr txBox="1"/>
           <p:nvPr/>
         </p:nvSpPr>
         <p:spPr>
           <a:xfrm>
-            <a:off x="704088" y="1353312"/>
-            <a:ext cx="7744968" cy="3300984"/>
+            <a:off x="704088" y="4379976"/>
+            <a:ext cx="7744968" cy="512064"/>
           </a:xfrm>
           <a:prstGeom prst="rect">
             <a:avLst/>
@@ -7656,115 +7608,14 @@
           </a:bodyPr>
           <a:lstStyle/>
           <a:p>
-            <a:pPr>
-              <a:lnSpc>
-                <a:spcPct val="112000"/>
-              </a:lnSpc>
-              <a:spcAft>
-                <a:spcPts val="900"/>
-              </a:spcAft>
-            </a:pPr>
-            <a:r>
-              <a:rPr sz="1800" b="1">
-                <a:solidFill>
-                  <a:srgbClr val="E0A437"/>
-                </a:solidFill>
-                <a:latin typeface="Fira Sans"/>
-              </a:rPr>
-              <a:t>▸ </a:t>
-            </a:r>
-            <a:r>
-              <a:rPr sz="1800" b="1">
-                <a:solidFill>
-                  <a:srgbClr val="1D3557"/>
-                </a:solidFill>
-                <a:latin typeface="Fira Sans"/>
-              </a:rPr>
-              <a:t>Módulo 2, Visualización e Inteligencia de Negocios: visualización efectiva, narrativas con datos y métricas de negocio.</a:t>
-            </a:r>
-          </a:p>
-          <a:p>
-            <a:pPr>
-              <a:lnSpc>
-                <a:spcPct val="112000"/>
-              </a:lnSpc>
-              <a:spcAft>
-                <a:spcPts val="900"/>
-              </a:spcAft>
-            </a:pPr>
-            <a:r>
-              <a:rPr sz="1800" b="1">
-                <a:solidFill>
-                  <a:srgbClr val="E0A437"/>
-                </a:solidFill>
-                <a:latin typeface="Fira Sans"/>
-              </a:rPr>
-              <a:t>▸ </a:t>
-            </a:r>
-            <a:r>
-              <a:rPr sz="1800" b="0">
-                <a:solidFill>
-                  <a:srgbClr val="000000"/>
-                </a:solidFill>
-                <a:latin typeface="Fira Sans"/>
-              </a:rPr>
-              <a:t>Módulo 3, Machine Learning para la Toma de Decisiones: aprendizaje supervisado y no supervisado (clustering y PCA en profundidad), evaluación de modelos, redes neuronales y explicabilidad.</a:t>
-            </a:r>
-          </a:p>
-          <a:p>
-            <a:pPr>
-              <a:lnSpc>
-                <a:spcPct val="112000"/>
-              </a:lnSpc>
-              <a:spcAft>
-                <a:spcPts val="900"/>
-              </a:spcAft>
-            </a:pPr>
-            <a:r>
-              <a:rPr sz="1800" b="1">
-                <a:solidFill>
-                  <a:srgbClr val="E0A437"/>
-                </a:solidFill>
-                <a:latin typeface="Fira Sans"/>
-              </a:rPr>
-              <a:t>▸ </a:t>
-            </a:r>
-            <a:r>
-              <a:rPr sz="1800" b="0">
-                <a:solidFill>
-                  <a:srgbClr val="000000"/>
-                </a:solidFill>
-                <a:latin typeface="Fira Sans"/>
-              </a:rPr>
-              <a:t>El Capstone continúa en esos módulos: el primer modelo de hoy es el punto de partida.</a:t>
-            </a:r>
-          </a:p>
-          <a:p>
-            <a:pPr>
-              <a:lnSpc>
-                <a:spcPct val="112000"/>
-              </a:lnSpc>
-              <a:spcAft>
-                <a:spcPts val="900"/>
-              </a:spcAft>
-            </a:pPr>
-            <a:r>
-              <a:rPr sz="1800" b="1">
-                <a:solidFill>
-                  <a:srgbClr val="E0A437"/>
-                </a:solidFill>
-                <a:latin typeface="Fira Sans"/>
-              </a:rPr>
-              <a:t>▸ </a:t>
-            </a:r>
-            <a:r>
-              <a:rPr sz="1800" b="0">
-                <a:solidFill>
-                  <a:srgbClr val="000000"/>
-                </a:solidFill>
-                <a:latin typeface="Fira Sans"/>
-              </a:rPr>
-              <a:t>Lo que se lleva de aquí: leer un resultado con su incertidumbre, juzgar un modelo en datos que no vio, y distinguir describir de encontrar una relación.</a:t>
+            <a:r>
+              <a:rPr sz="1300" b="0">
+                <a:solidFill>
+                  <a:srgbClr val="333333"/>
+                </a:solidFill>
+                <a:latin typeface="Fira Sans"/>
+              </a:rPr>
+              <a:t>Cada clase dejó una idea. Juntas, son lo que el módulo enseñó: cómo se llega de una pregunta y unos datos a un resultado, y cómo se lee ese resultado con su incertidumbre.</a:t>
             </a:r>
           </a:p>
         </p:txBody>
@@ -7860,7 +7711,7 @@
                 </a:solidFill>
                 <a:latin typeface="Fira Sans"/>
               </a:rPr>
-              <a:t>Ahora: las presentaciones del avance</a:t>
+              <a:t>Lo que sigue en el diplomado</a:t>
             </a:r>
           </a:p>
         </p:txBody>
@@ -7911,7 +7762,7 @@
                 </a:solidFill>
                 <a:latin typeface="Fira Sans"/>
               </a:rPr>
-              <a:t>Ocho equipos, en el orden en que se ofrezcan. Máximo 10 minutos por equipo; el tiempo se controla. Después, preguntas de la profesora y del curso.</a:t>
+              <a:t>Módulo 2, Visualización e Inteligencia de Negocios: visualización efectiva, narrativas con datos y métricas de negocio.</a:t>
             </a:r>
           </a:p>
           <a:p>
@@ -7939,7 +7790,7 @@
                 </a:solidFill>
                 <a:latin typeface="Fira Sans"/>
               </a:rPr>
-              <a:t>Se evalúa el avance, no un resultado final: el modelo es un primer intento. La exigencia está en el tiempo, la claridad, la explicación de los gráficos y las relaciones, y en advertir qué falta o qué no tiene sentido.</a:t>
+              <a:t>Módulo 3, Machine Learning para la Toma de Decisiones: aprendizaje supervisado y no supervisado (clustering y PCA en profundidad), evaluación de modelos, redes neuronales y explicabilidad.</a:t>
             </a:r>
           </a:p>
           <a:p>
@@ -7967,7 +7818,7 @@
                 </a:solidFill>
                 <a:latin typeface="Fira Sans"/>
               </a:rPr>
-              <a:t>Las slides, en PDF, al Aula hasta las 20:30: un envío por equipo con los nombres.</a:t>
+              <a:t>El Capstone continúa en esos módulos: el primer modelo de hoy es el punto de partida.</a:t>
             </a:r>
           </a:p>
           <a:p>
@@ -7995,7 +7846,7 @@
                 </a:solidFill>
                 <a:latin typeface="Fira Sans"/>
               </a:rPr>
-              <a:t>El informe escrito, el viernes 25 de septiembre por el Aula: máximo 7 páginas, con su rúbrica publicada.</a:t>
+              <a:t>Lo que se lleva de aquí: leer un resultado con su incertidumbre, juzgar un modelo en datos que no vio, y distinguir describir de encontrar una relación.</a:t>
             </a:r>
           </a:p>
         </p:txBody>
@@ -8009,6 +7860,237 @@
 </file>
 
 <file path=ppt/slides/slide33.xml><?xml version="1.0" encoding="utf-8"?>
+<p:sld xmlns:a="http://schemas.openxmlformats.org/drawingml/2006/main" xmlns:p="http://schemas.openxmlformats.org/presentationml/2006/main" xmlns:r="http://schemas.openxmlformats.org/officeDocument/2006/relationships">
+  <p:cSld>
+    <p:spTree>
+      <p:nvGrpSpPr>
+        <p:cNvPr id="1" name=""/>
+        <p:cNvGrpSpPr/>
+        <p:nvPr/>
+      </p:nvGrpSpPr>
+      <p:grpSpPr/>
+      <p:sp>
+        <p:nvSpPr>
+          <p:cNvPr id="2" name="Rectangle 1"/>
+          <p:cNvSpPr/>
+          <p:nvPr/>
+        </p:nvSpPr>
+        <p:spPr>
+          <a:xfrm>
+            <a:off x="0" y="0"/>
+            <a:ext cx="9144000" cy="5138928"/>
+          </a:xfrm>
+          <a:prstGeom prst="rect">
+            <a:avLst/>
+          </a:prstGeom>
+          <a:solidFill>
+            <a:srgbClr val="FAFBFC"/>
+          </a:solidFill>
+          <a:ln>
+            <a:noFill/>
+          </a:ln>
+          <a:effectLst/>
+        </p:spPr>
+        <p:style>
+          <a:lnRef idx="1">
+            <a:schemeClr val="accent1"/>
+          </a:lnRef>
+          <a:fillRef idx="3">
+            <a:schemeClr val="accent1"/>
+          </a:fillRef>
+          <a:effectRef idx="2">
+            <a:schemeClr val="accent1"/>
+          </a:effectRef>
+          <a:fontRef idx="minor">
+            <a:schemeClr val="lt1"/>
+          </a:fontRef>
+        </p:style>
+        <p:txBody>
+          <a:bodyPr rtlCol="0" anchor="ctr"/>
+          <a:lstStyle/>
+          <a:p>
+            <a:pPr algn="ctr"/>
+          </a:p>
+        </p:txBody>
+      </p:sp>
+      <p:sp>
+        <p:nvSpPr>
+          <p:cNvPr id="3" name="TextBox 2"/>
+          <p:cNvSpPr txBox="1"/>
+          <p:nvPr/>
+        </p:nvSpPr>
+        <p:spPr>
+          <a:xfrm>
+            <a:off x="402336" y="301752"/>
+            <a:ext cx="8348472" cy="795528"/>
+          </a:xfrm>
+          <a:prstGeom prst="rect">
+            <a:avLst/>
+          </a:prstGeom>
+          <a:noFill/>
+        </p:spPr>
+        <p:txBody>
+          <a:bodyPr wrap="square">
+            <a:spAutoFit/>
+          </a:bodyPr>
+          <a:lstStyle/>
+          <a:p>
+            <a:r>
+              <a:rPr sz="2800" b="1">
+                <a:solidFill>
+                  <a:srgbClr val="0F0F0F"/>
+                </a:solidFill>
+                <a:latin typeface="Fira Sans"/>
+              </a:rPr>
+              <a:t>Ahora: las presentaciones del avance</a:t>
+            </a:r>
+          </a:p>
+        </p:txBody>
+      </p:sp>
+      <p:sp>
+        <p:nvSpPr>
+          <p:cNvPr id="4" name="TextBox 3"/>
+          <p:cNvSpPr txBox="1"/>
+          <p:nvPr/>
+        </p:nvSpPr>
+        <p:spPr>
+          <a:xfrm>
+            <a:off x="704088" y="1353312"/>
+            <a:ext cx="7744968" cy="3300984"/>
+          </a:xfrm>
+          <a:prstGeom prst="rect">
+            <a:avLst/>
+          </a:prstGeom>
+          <a:noFill/>
+        </p:spPr>
+        <p:txBody>
+          <a:bodyPr wrap="square">
+            <a:spAutoFit/>
+          </a:bodyPr>
+          <a:lstStyle/>
+          <a:p>
+            <a:pPr>
+              <a:lnSpc>
+                <a:spcPct val="112000"/>
+              </a:lnSpc>
+              <a:spcAft>
+                <a:spcPts val="900"/>
+              </a:spcAft>
+            </a:pPr>
+            <a:r>
+              <a:rPr sz="1800" b="1">
+                <a:solidFill>
+                  <a:srgbClr val="E0A437"/>
+                </a:solidFill>
+                <a:latin typeface="Fira Sans"/>
+              </a:rPr>
+              <a:t>▸ </a:t>
+            </a:r>
+            <a:r>
+              <a:rPr sz="1800" b="1">
+                <a:solidFill>
+                  <a:srgbClr val="1D3557"/>
+                </a:solidFill>
+                <a:latin typeface="Fira Sans"/>
+              </a:rPr>
+              <a:t>Ocho equipos, en el orden en que se ofrezcan. Máximo 10 minutos por equipo; el tiempo se controla. Después, preguntas de la profesora y del curso.</a:t>
+            </a:r>
+          </a:p>
+          <a:p>
+            <a:pPr>
+              <a:lnSpc>
+                <a:spcPct val="112000"/>
+              </a:lnSpc>
+              <a:spcAft>
+                <a:spcPts val="900"/>
+              </a:spcAft>
+            </a:pPr>
+            <a:r>
+              <a:rPr sz="1800" b="1">
+                <a:solidFill>
+                  <a:srgbClr val="E0A437"/>
+                </a:solidFill>
+                <a:latin typeface="Fira Sans"/>
+              </a:rPr>
+              <a:t>▸ </a:t>
+            </a:r>
+            <a:r>
+              <a:rPr sz="1800" b="0">
+                <a:solidFill>
+                  <a:srgbClr val="000000"/>
+                </a:solidFill>
+                <a:latin typeface="Fira Sans"/>
+              </a:rPr>
+              <a:t>Se evalúa el avance, no un resultado final: el modelo es un primer intento. La exigencia está en el tiempo, la claridad, la explicación de los gráficos y las relaciones, y en advertir qué falta o qué no tiene sentido.</a:t>
+            </a:r>
+          </a:p>
+          <a:p>
+            <a:pPr>
+              <a:lnSpc>
+                <a:spcPct val="112000"/>
+              </a:lnSpc>
+              <a:spcAft>
+                <a:spcPts val="900"/>
+              </a:spcAft>
+            </a:pPr>
+            <a:r>
+              <a:rPr sz="1800" b="1">
+                <a:solidFill>
+                  <a:srgbClr val="E0A437"/>
+                </a:solidFill>
+                <a:latin typeface="Fira Sans"/>
+              </a:rPr>
+              <a:t>▸ </a:t>
+            </a:r>
+            <a:r>
+              <a:rPr sz="1800" b="0">
+                <a:solidFill>
+                  <a:srgbClr val="000000"/>
+                </a:solidFill>
+                <a:latin typeface="Fira Sans"/>
+              </a:rPr>
+              <a:t>Las slides, en PDF, al Aula hasta las 20:30: un envío por equipo con los nombres.</a:t>
+            </a:r>
+          </a:p>
+          <a:p>
+            <a:pPr>
+              <a:lnSpc>
+                <a:spcPct val="112000"/>
+              </a:lnSpc>
+              <a:spcAft>
+                <a:spcPts val="900"/>
+              </a:spcAft>
+            </a:pPr>
+            <a:r>
+              <a:rPr sz="1800" b="1">
+                <a:solidFill>
+                  <a:srgbClr val="E0A437"/>
+                </a:solidFill>
+                <a:latin typeface="Fira Sans"/>
+              </a:rPr>
+              <a:t>▸ </a:t>
+            </a:r>
+            <a:r>
+              <a:rPr sz="1800" b="0">
+                <a:solidFill>
+                  <a:srgbClr val="000000"/>
+                </a:solidFill>
+                <a:latin typeface="Fira Sans"/>
+              </a:rPr>
+              <a:t>El informe escrito, el viernes 25 de septiembre por el Aula: máximo 7 páginas, con su rúbrica publicada.</a:t>
+            </a:r>
+          </a:p>
+        </p:txBody>
+      </p:sp>
+    </p:spTree>
+  </p:cSld>
+  <p:clrMapOvr>
+    <a:masterClrMapping/>
+  </p:clrMapOvr>
+</p:sld>
+</file>
+
+<file path=ppt/slides/slide34.xml><?xml version="1.0" encoding="utf-8"?>
 <p:sld xmlns:a="http://schemas.openxmlformats.org/drawingml/2006/main" xmlns:p="http://schemas.openxmlformats.org/presentationml/2006/main" xmlns:r="http://schemas.openxmlformats.org/officeDocument/2006/relationships">
   <p:cSld>
     <p:spTree>

</xml_diff>

<commit_message>
Clase 8: de donde salen los pesos (35 slides)
Revision de Daniela: en la slide de iris aparecian pesos que no estaban
en ninguna figura y el deck no decia de donde salen. Ahora la slide del
puntaje ponderado dice que los pesos 0,707 y 0,707 son la direccion de
la diagonal (un paso de 1 sobre ella avanza 0,707 en cada variable),
hay una slide nueva 'De donde salen los pesos' (con 2 variables y con
16: cuanto avanza cada variable en un paso de 1 sobre el eje, cuadrados
que suman 1), y la figura de iris muestra sus pesos junto a las flores.
El notebook agrega la misma idea y la comprobacion de que los pesos al
cuadrado suman 1.

Co-Authored-By: Claude Fable 5.1 <noreply@anthropic.com>
</commit_message>
<xml_diff>
--- a/presentaciones/clase08_componentes_principales.pptx
+++ b/presentaciones/clase08_componentes_principales.pptx
@@ -39,6 +39,7 @@
     <p:sldId id="287" r:id="rId38"/>
     <p:sldId id="288" r:id="rId39"/>
     <p:sldId id="289" r:id="rId40"/>
+    <p:sldId id="290" r:id="rId41"/>
   </p:sldIdLst>
   <p:sldSz cx="9144000" cy="5138928" type="screen4x3"/>
   <p:notesSz cx="6858000" cy="9144000"/>
@@ -4113,8 +4114,8 @@
         </p:blipFill>
         <p:spPr>
           <a:xfrm>
-            <a:off x="699515" y="1261139"/>
-            <a:ext cx="7744968" cy="2607505"/>
+            <a:off x="1099936" y="1143000"/>
+            <a:ext cx="6944127" cy="2587752"/>
           </a:xfrm>
           <a:prstGeom prst="rect">
             <a:avLst/>
@@ -4129,8 +4130,8 @@
         </p:nvSpPr>
         <p:spPr>
           <a:xfrm>
-            <a:off x="704088" y="4005804"/>
-            <a:ext cx="7744968" cy="768096"/>
+            <a:off x="704088" y="3867912"/>
+            <a:ext cx="7744968" cy="1024128"/>
           </a:xfrm>
           <a:prstGeom prst="rect">
             <a:avLst/>
@@ -4150,7 +4151,7 @@
                 </a:solidFill>
                 <a:latin typeface="Fira Sans"/>
               </a:rPr>
-              <a:t>La posición sobre la diagonal se calcula como un puntaje ponderado, igual que el de la admisión universitaria: cada variable entra con un peso y sale un número por jugador. Aquí los pesos no los fija nadie: se calculan para que ese número separe a los jugadores lo más posible.</a:t>
+              <a:t>Un puntaje ponderado, como el de la admisión universitaria: cada variable entra con un peso y sale un número por jugador. Los pesos son la dirección de la diagonal: un paso de 1 sobre ella avanza 0,707 en turnos y 0,707 en hits. Por eso no los fija nadie: los fija la dirección en que los puntos más se dispersan.</a:t>
             </a:r>
           </a:p>
         </p:txBody>
@@ -5966,14 +5967,14 @@
                 </a:solidFill>
                 <a:latin typeface="Fira Sans"/>
               </a:rPr>
-              <a:t>De qué está hecha cada componente: los pesos</a:t>
+              <a:t>De dónde salen los pesos</a:t>
             </a:r>
           </a:p>
         </p:txBody>
       </p:sp>
       <p:pic>
         <p:nvPicPr>
-          <p:cNvPr id="4" name="Picture 3" descr="c8_04_pesos.png"/>
+          <p:cNvPr id="4" name="Picture 3" descr="c8_04a_direccion.png"/>
           <p:cNvPicPr>
             <a:picLocks noChangeAspect="1"/>
           </p:cNvPicPr>
@@ -5987,8 +5988,8 @@
         </p:blipFill>
         <p:spPr>
           <a:xfrm>
-            <a:off x="2196563" y="1143000"/>
-            <a:ext cx="4750872" cy="2587752"/>
+            <a:off x="699515" y="1153192"/>
+            <a:ext cx="7744968" cy="3079431"/>
           </a:xfrm>
           <a:prstGeom prst="rect">
             <a:avLst/>
@@ -6003,8 +6004,8 @@
         </p:nvSpPr>
         <p:spPr>
           <a:xfrm>
-            <a:off x="704088" y="3867912"/>
-            <a:ext cx="7744968" cy="1024128"/>
+            <a:off x="704088" y="4369783"/>
+            <a:ext cx="7744968" cy="512064"/>
           </a:xfrm>
           <a:prstGeom prst="rect">
             <a:avLst/>
@@ -6024,7 +6025,7 @@
                 </a:solidFill>
                 <a:latin typeface="Fira Sans"/>
               </a:rPr>
-              <a:t>Primera componente: las siete variables de la carrera pesan casi lo mismo (0,29 a 0,34), las de la temporada la mitad (0,19 a 0,23) y la defensa no cuenta: mide cuánta carrera lleva el jugador. Segunda componente: la temporada 1986 pesa positivo (0,24 a 0,39) y la carrera negativo (−0,12 a −0,26): separa a quien rindió este año más de lo que dice su carrera.</a:t>
+              <a:t>Los pesos de una componente son la dirección de su eje: cuánto avanza cada variable en un paso de 1 sobre él. Con dos variables, 0,707 y 0,707; con dieciséis, dieciséis pesos cuyos cuadrados suman 1.</a:t>
             </a:r>
           </a:p>
         </p:txBody>
@@ -6120,14 +6121,14 @@
                 </a:solidFill>
                 <a:latin typeface="Fira Sans"/>
               </a:rPr>
-              <a:t>Los 263 jugadores en dos componentes</a:t>
+              <a:t>De qué está hecha cada componente: los pesos</a:t>
             </a:r>
           </a:p>
         </p:txBody>
       </p:sp>
       <p:pic>
         <p:nvPicPr>
-          <p:cNvPr id="4" name="Picture 3" descr="c8_05_jugadores.png"/>
+          <p:cNvPr id="4" name="Picture 3" descr="c8_04_pesos.png"/>
           <p:cNvPicPr>
             <a:picLocks noChangeAspect="1"/>
           </p:cNvPicPr>
@@ -6141,8 +6142,8 @@
         </p:blipFill>
         <p:spPr>
           <a:xfrm>
-            <a:off x="2699826" y="1143000"/>
-            <a:ext cx="3744346" cy="2587751"/>
+            <a:off x="1433764" y="1143000"/>
+            <a:ext cx="6276471" cy="2843784"/>
           </a:xfrm>
           <a:prstGeom prst="rect">
             <a:avLst/>
@@ -6157,8 +6158,8 @@
         </p:nvSpPr>
         <p:spPr>
           <a:xfrm>
-            <a:off x="704088" y="3867912"/>
-            <a:ext cx="7744968" cy="1024128"/>
+            <a:off x="704088" y="4123944"/>
+            <a:ext cx="7744968" cy="768096"/>
           </a:xfrm>
           <a:prstGeom prst="rect">
             <a:avLst/>
@@ -6178,7 +6179,7 @@
                 </a:solidFill>
                 <a:latin typeface="Fira Sans"/>
               </a:rPr>
-              <a:t>Cada punto es un jugador y el color, su salario de 1987, que PCA no usó. El salario crece hacia la derecha (correlación 0,64 con la primera componente) y casi nada hacia arriba (0,11 con la segunda): la carrera pesa en el salario; la última temporada, poco. Dos ejes muestran lo que en 16 variables había que leer coeficiente por coeficiente.</a:t>
+              <a:t>1.ª componente: la carrera pesa 0,29 a 0,34, la temporada 1986 la mitad (0,19 a 0,23) y la defensa nada: cuánta carrera lleva el jugador. 2.ª: la temporada positiva (0,24 a 0,39) y la carrera negativa (−0,12 a −0,26): quien rindió este año más de lo que dice su carrera.</a:t>
             </a:r>
           </a:p>
         </p:txBody>
@@ -6274,14 +6275,14 @@
                 </a:solidFill>
                 <a:latin typeface="Fira Sans"/>
               </a:rPr>
-              <a:t>El mismo cálculo con las flores de la clase 2</a:t>
+              <a:t>Los 263 jugadores en dos componentes</a:t>
             </a:r>
           </a:p>
         </p:txBody>
       </p:sp>
       <p:pic>
         <p:nvPicPr>
-          <p:cNvPr id="4" name="Picture 3" descr="c8_06_iris.png"/>
+          <p:cNvPr id="4" name="Picture 3" descr="c8_05_jugadores.png"/>
           <p:cNvPicPr>
             <a:picLocks noChangeAspect="1"/>
           </p:cNvPicPr>
@@ -6295,8 +6296,8 @@
         </p:blipFill>
         <p:spPr>
           <a:xfrm>
-            <a:off x="2906606" y="1143000"/>
-            <a:ext cx="3330786" cy="2587751"/>
+            <a:off x="2699826" y="1143000"/>
+            <a:ext cx="3744346" cy="2587751"/>
           </a:xfrm>
           <a:prstGeom prst="rect">
             <a:avLst/>
@@ -6332,7 +6333,7 @@
                 </a:solidFill>
                 <a:latin typeface="Fira Sans"/>
               </a:rPr>
-              <a:t>Las cuatro medidas de iris se resumen en dos componentes que reúnen el 96% de la variación. La primera (73%) pesa casi igual el largo y el ancho del pétalo y el largo del sépalo (0,52 a 0,58): el tamaño de la flor. La segunda (23%) es casi solo el ancho del sépalo (0,92). PCA no conoce la especie y aun así las tres quedan separadas a lo largo de la primera componente.</a:t>
+              <a:t>Cada punto es un jugador y el color, su salario de 1987, que PCA no usó. El salario crece hacia la derecha (correlación 0,64 con la primera componente) y casi nada hacia arriba (0,11 con la segunda): la carrera pesa en el salario; la última temporada, poco. Dos ejes muestran lo que en 16 variables había que leer coeficiente por coeficiente.</a:t>
             </a:r>
           </a:p>
         </p:txBody>
@@ -6370,7 +6371,7 @@
             <a:avLst/>
           </a:prstGeom>
           <a:solidFill>
-            <a:srgbClr val="1D3557"/>
+            <a:srgbClr val="FAFBFC"/>
           </a:solidFill>
           <a:ln>
             <a:noFill/>
@@ -6407,8 +6408,8 @@
         </p:nvSpPr>
         <p:spPr>
           <a:xfrm>
-            <a:off x="603504" y="1847088"/>
-            <a:ext cx="7946136" cy="1399032"/>
+            <a:off x="402336" y="301752"/>
+            <a:ext cx="8348472" cy="795528"/>
           </a:xfrm>
           <a:prstGeom prst="rect">
             <a:avLst/>
@@ -6422,24 +6423,71 @@
           <a:lstStyle/>
           <a:p>
             <a:r>
-              <a:rPr sz="3400" b="1">
-                <a:solidFill>
-                  <a:srgbClr val="FFFFFF"/>
-                </a:solidFill>
-                <a:latin typeface="Fira Sans"/>
-              </a:rPr>
-              <a:t>4. Cuándo</a:t>
-            </a:r>
-          </a:p>
-          <a:p>
-            <a:r>
-              <a:rPr sz="1800" b="0">
-                <a:solidFill>
-                  <a:srgbClr val="E0A437"/>
-                </a:solidFill>
-                <a:latin typeface="Fira Sans"/>
-              </a:rPr>
-              <a:t>Cuándo conviene y cuándo no</a:t>
+              <a:rPr sz="2800" b="1">
+                <a:solidFill>
+                  <a:srgbClr val="0F0F0F"/>
+                </a:solidFill>
+                <a:latin typeface="Fira Sans"/>
+              </a:rPr>
+              <a:t>El mismo cálculo con iris (clase 2)</a:t>
+            </a:r>
+          </a:p>
+        </p:txBody>
+      </p:sp>
+      <p:pic>
+        <p:nvPicPr>
+          <p:cNvPr id="4" name="Picture 3" descr="c8_06_iris.png"/>
+          <p:cNvPicPr>
+            <a:picLocks noChangeAspect="1"/>
+          </p:cNvPicPr>
+          <p:nvPr/>
+        </p:nvPicPr>
+        <p:blipFill>
+          <a:blip r:embed="rId2"/>
+          <a:stretch>
+            <a:fillRect/>
+          </a:stretch>
+        </p:blipFill>
+        <p:spPr>
+          <a:xfrm>
+            <a:off x="780288" y="1143000"/>
+            <a:ext cx="7583423" cy="2843784"/>
+          </a:xfrm>
+          <a:prstGeom prst="rect">
+            <a:avLst/>
+          </a:prstGeom>
+        </p:spPr>
+      </p:pic>
+      <p:sp>
+        <p:nvSpPr>
+          <p:cNvPr id="5" name="TextBox 4"/>
+          <p:cNvSpPr txBox="1"/>
+          <p:nvPr/>
+        </p:nvSpPr>
+        <p:spPr>
+          <a:xfrm>
+            <a:off x="704088" y="4123944"/>
+            <a:ext cx="7744968" cy="768096"/>
+          </a:xfrm>
+          <a:prstGeom prst="rect">
+            <a:avLst/>
+          </a:prstGeom>
+          <a:noFill/>
+        </p:spPr>
+        <p:txBody>
+          <a:bodyPr wrap="square">
+            <a:spAutoFit/>
+          </a:bodyPr>
+          <a:lstStyle/>
+          <a:p>
+            <a:r>
+              <a:rPr sz="1300" b="0">
+                <a:solidFill>
+                  <a:srgbClr val="333333"/>
+                </a:solidFill>
+                <a:latin typeface="Fira Sans"/>
+              </a:rPr>
+              <a:t>Las cuatro medidas se resumen en dos componentes con el 96% de la variación. Los pesos (izquierda) dicen qué es cada eje: el tamaño de la flor y el ancho del sépalo. Sin conocer la especie, las tres quedan separadas a lo largo del primero.</a:t>
             </a:r>
           </a:p>
         </p:txBody>
@@ -6477,7 +6525,7 @@
             <a:avLst/>
           </a:prstGeom>
           <a:solidFill>
-            <a:srgbClr val="FAFBFC"/>
+            <a:srgbClr val="1D3557"/>
           </a:solidFill>
           <a:ln>
             <a:noFill/>
@@ -6514,8 +6562,8 @@
         </p:nvSpPr>
         <p:spPr>
           <a:xfrm>
-            <a:off x="402336" y="301752"/>
-            <a:ext cx="8348472" cy="795528"/>
+            <a:off x="603504" y="1847088"/>
+            <a:ext cx="7946136" cy="1399032"/>
           </a:xfrm>
           <a:prstGeom prst="rect">
             <a:avLst/>
@@ -6529,120 +6577,24 @@
           <a:lstStyle/>
           <a:p>
             <a:r>
-              <a:rPr sz="2800" b="1">
-                <a:solidFill>
-                  <a:srgbClr val="0F0F0F"/>
-                </a:solidFill>
-                <a:latin typeface="Fira Sans"/>
-              </a:rPr>
-              <a:t>¿Cuándo conviene?</a:t>
-            </a:r>
-          </a:p>
-        </p:txBody>
-      </p:sp>
-      <p:sp>
-        <p:nvSpPr>
-          <p:cNvPr id="4" name="TextBox 3"/>
-          <p:cNvSpPr txBox="1"/>
-          <p:nvPr/>
-        </p:nvSpPr>
-        <p:spPr>
-          <a:xfrm>
-            <a:off x="704088" y="1353312"/>
-            <a:ext cx="7744968" cy="3300984"/>
-          </a:xfrm>
-          <a:prstGeom prst="rect">
-            <a:avLst/>
-          </a:prstGeom>
-          <a:noFill/>
-        </p:spPr>
-        <p:txBody>
-          <a:bodyPr wrap="square">
-            <a:spAutoFit/>
-          </a:bodyPr>
-          <a:lstStyle/>
-          <a:p>
-            <a:pPr>
-              <a:lnSpc>
-                <a:spcPct val="112000"/>
-              </a:lnSpc>
-              <a:spcAft>
-                <a:spcPts val="900"/>
-              </a:spcAft>
-            </a:pPr>
-            <a:r>
-              <a:rPr sz="1800" b="1">
+              <a:rPr sz="3400" b="1">
+                <a:solidFill>
+                  <a:srgbClr val="FFFFFF"/>
+                </a:solidFill>
+                <a:latin typeface="Fira Sans"/>
+              </a:rPr>
+              <a:t>4. Cuándo</a:t>
+            </a:r>
+          </a:p>
+          <a:p>
+            <a:r>
+              <a:rPr sz="1800" b="0">
                 <a:solidFill>
                   <a:srgbClr val="E0A437"/>
                 </a:solidFill>
                 <a:latin typeface="Fira Sans"/>
               </a:rPr>
-              <a:t>▸ </a:t>
-            </a:r>
-            <a:r>
-              <a:rPr sz="1800" b="1">
-                <a:solidFill>
-                  <a:srgbClr val="1D3557"/>
-                </a:solidFill>
-                <a:latin typeface="Fira Sans"/>
-              </a:rPr>
-              <a:t>Con muchas variables numéricas que se correlacionan en bloques, como en la matriz de la clase 7.</a:t>
-            </a:r>
-          </a:p>
-          <a:p>
-            <a:pPr>
-              <a:lnSpc>
-                <a:spcPct val="112000"/>
-              </a:lnSpc>
-              <a:spcAft>
-                <a:spcPts val="900"/>
-              </a:spcAft>
-            </a:pPr>
-            <a:r>
-              <a:rPr sz="1800" b="1">
-                <a:solidFill>
-                  <a:srgbClr val="E0A437"/>
-                </a:solidFill>
-                <a:latin typeface="Fira Sans"/>
-              </a:rPr>
-              <a:t>▸ </a:t>
-            </a:r>
-            <a:r>
-              <a:rPr sz="1800" b="0">
-                <a:solidFill>
-                  <a:srgbClr val="000000"/>
-                </a:solidFill>
-                <a:latin typeface="Fira Sans"/>
-              </a:rPr>
-              <a:t>Para mirar los datos en un plano, o para entregarle a un modelo menos entradas.</a:t>
-            </a:r>
-          </a:p>
-          <a:p>
-            <a:pPr>
-              <a:lnSpc>
-                <a:spcPct val="112000"/>
-              </a:lnSpc>
-              <a:spcAft>
-                <a:spcPts val="900"/>
-              </a:spcAft>
-            </a:pPr>
-            <a:r>
-              <a:rPr sz="1800" b="1">
-                <a:solidFill>
-                  <a:srgbClr val="E0A437"/>
-                </a:solidFill>
-                <a:latin typeface="Fira Sans"/>
-              </a:rPr>
-              <a:t>▸ </a:t>
-            </a:r>
-            <a:r>
-              <a:rPr sz="1800" b="0">
-                <a:solidFill>
-                  <a:srgbClr val="000000"/>
-                </a:solidFill>
-                <a:latin typeface="Fira Sans"/>
-              </a:rPr>
-              <a:t>No aporta si las variables son pocas y distintas entre sí: no hay nada que resumir.</a:t>
+              <a:t>Cuándo conviene y cuándo no</a:t>
             </a:r>
           </a:p>
         </p:txBody>
@@ -6738,7 +6690,7 @@
                 </a:solidFill>
                 <a:latin typeface="Fira Sans"/>
               </a:rPr>
-              <a:t>Tres precauciones</a:t>
+              <a:t>¿Cuándo conviene?</a:t>
             </a:r>
           </a:p>
         </p:txBody>
@@ -6789,7 +6741,7 @@
                 </a:solidFill>
                 <a:latin typeface="Fira Sans"/>
               </a:rPr>
-              <a:t>Las variables categóricas (las dummies de la clase 6) no entran bien en el cálculo: se dejan fuera o se tratan aparte.</a:t>
+              <a:t>Con muchas variables numéricas que se correlacionan en bloques, como en la matriz de la clase 7.</a:t>
             </a:r>
           </a:p>
           <a:p>
@@ -6817,7 +6769,7 @@
                 </a:solidFill>
                 <a:latin typeface="Fira Sans"/>
               </a:rPr>
-              <a:t>Las componentes no siempre tienen una lectura clara. Aquí sí (la carrera; la temporada frente a la carrera), pero no está garantizado.</a:t>
+              <a:t>Para mirar los datos en un plano, o para entregarle a un modelo menos entradas.</a:t>
             </a:r>
           </a:p>
           <a:p>
@@ -6845,7 +6797,7 @@
                 </a:solidFill>
                 <a:latin typeface="Fira Sans"/>
               </a:rPr>
-              <a:t>Es no supervisado: la dirección de más variación no es necesariamente la que mejor predice la respuesta. Ridge y Lasso eligen mirando Y; PCA no la mira.</a:t>
+              <a:t>No aporta si las variables son pocas y distintas entre sí: no hay nada que resumir.</a:t>
             </a:r>
           </a:p>
         </p:txBody>
@@ -6941,124 +6893,21 @@
                 </a:solidFill>
                 <a:latin typeface="Fira Sans"/>
               </a:rPr>
-              <a:t>En el código: cinco líneas</a:t>
-            </a:r>
-          </a:p>
-        </p:txBody>
-      </p:sp>
-      <p:sp>
-        <p:nvSpPr>
-          <p:cNvPr id="4" name="Rectangle 3"/>
-          <p:cNvSpPr/>
-          <p:nvPr/>
-        </p:nvSpPr>
-        <p:spPr>
-          <a:xfrm>
-            <a:off x="704088" y="1280160"/>
-            <a:ext cx="7744968" cy="2880360"/>
-          </a:xfrm>
-          <a:prstGeom prst="rect">
-            <a:avLst/>
-          </a:prstGeom>
-          <a:solidFill>
-            <a:srgbClr val="F0F2F5"/>
-          </a:solidFill>
-          <a:ln>
-            <a:solidFill>
-              <a:srgbClr val="D8DDE3"/>
-            </a:solidFill>
-          </a:ln>
-          <a:effectLst/>
-        </p:spPr>
-        <p:style>
-          <a:lnRef idx="1">
-            <a:schemeClr val="accent1"/>
-          </a:lnRef>
-          <a:fillRef idx="3">
-            <a:schemeClr val="accent1"/>
-          </a:fillRef>
-          <a:effectRef idx="2">
-            <a:schemeClr val="accent1"/>
-          </a:effectRef>
-          <a:fontRef idx="minor">
-            <a:schemeClr val="lt1"/>
-          </a:fontRef>
-        </p:style>
-        <p:txBody>
-          <a:bodyPr rtlCol="0" anchor="ctr" wrap="square" lIns="228600" tIns="137160"/>
-          <a:lstStyle/>
-          <a:p>
-            <a:pPr/>
-            <a:r>
-              <a:rPr sz="1500" b="0">
-                <a:solidFill>
-                  <a:srgbClr val="1D3557"/>
-                </a:solidFill>
-                <a:latin typeface="Menlo"/>
-              </a:rPr>
-              <a:t>Z = StandardScaler().fit_transform(X)  # 1. estandarizar</a:t>
-            </a:r>
-          </a:p>
-          <a:p>
-            <a:pPr/>
-            <a:r>
-              <a:rPr sz="1500" b="0">
-                <a:solidFill>
-                  <a:srgbClr val="1D3557"/>
-                </a:solidFill>
-                <a:latin typeface="Menlo"/>
-              </a:rPr>
-              <a:t>pca = PCA().fit(Z)                     # 2. las componentes</a:t>
-            </a:r>
-          </a:p>
-          <a:p>
-            <a:pPr/>
-            <a:r>
-              <a:rPr sz="1500" b="0">
-                <a:solidFill>
-                  <a:srgbClr val="1D3557"/>
-                </a:solidFill>
-                <a:latin typeface="Menlo"/>
-              </a:rPr>
-              <a:t>pca.explained_variance_ratio_          # 3. cuánto explica</a:t>
-            </a:r>
-          </a:p>
-          <a:p>
-            <a:pPr/>
-            <a:r>
-              <a:rPr sz="1500" b="0">
-                <a:solidFill>
-                  <a:srgbClr val="1D3557"/>
-                </a:solidFill>
-                <a:latin typeface="Menlo"/>
-              </a:rPr>
-              <a:t>pca.components_                        # 4. los pesos</a:t>
-            </a:r>
-          </a:p>
-          <a:p>
-            <a:pPr/>
-            <a:r>
-              <a:rPr sz="1500" b="0">
-                <a:solidFill>
-                  <a:srgbClr val="1D3557"/>
-                </a:solidFill>
-                <a:latin typeface="Menlo"/>
-              </a:rPr>
-              <a:t>puntajes = pca.transform(Z)            # 5. los puntajes</a:t>
-            </a:r>
-          </a:p>
-        </p:txBody>
-      </p:sp>
-      <p:sp>
-        <p:nvSpPr>
-          <p:cNvPr id="5" name="TextBox 4"/>
+              <a:t>Tres precauciones</a:t>
+            </a:r>
+          </a:p>
+        </p:txBody>
+      </p:sp>
+      <p:sp>
+        <p:nvSpPr>
+          <p:cNvPr id="4" name="TextBox 3"/>
           <p:cNvSpPr txBox="1"/>
           <p:nvPr/>
         </p:nvSpPr>
         <p:spPr>
           <a:xfrm>
-            <a:off x="704088" y="4389120"/>
-            <a:ext cx="7744968" cy="1097280"/>
+            <a:off x="704088" y="1353312"/>
+            <a:ext cx="7744968" cy="3300984"/>
           </a:xfrm>
           <a:prstGeom prst="rect">
             <a:avLst/>
@@ -7080,7 +6929,7 @@
               </a:spcAft>
             </a:pPr>
             <a:r>
-              <a:rPr sz="1600" b="1">
+              <a:rPr sz="1800" b="1">
                 <a:solidFill>
                   <a:srgbClr val="E0A437"/>
                 </a:solidFill>
@@ -7089,13 +6938,69 @@
               <a:t>▸ </a:t>
             </a:r>
             <a:r>
-              <a:rPr sz="1600" b="0">
+              <a:rPr sz="1800" b="1">
+                <a:solidFill>
+                  <a:srgbClr val="1D3557"/>
+                </a:solidFill>
+                <a:latin typeface="Fira Sans"/>
+              </a:rPr>
+              <a:t>Las variables categóricas (las dummies de la clase 6) no entran bien en el cálculo: se dejan fuera o se tratan aparte.</a:t>
+            </a:r>
+          </a:p>
+          <a:p>
+            <a:pPr>
+              <a:lnSpc>
+                <a:spcPct val="112000"/>
+              </a:lnSpc>
+              <a:spcAft>
+                <a:spcPts val="900"/>
+              </a:spcAft>
+            </a:pPr>
+            <a:r>
+              <a:rPr sz="1800" b="1">
+                <a:solidFill>
+                  <a:srgbClr val="E0A437"/>
+                </a:solidFill>
+                <a:latin typeface="Fira Sans"/>
+              </a:rPr>
+              <a:t>▸ </a:t>
+            </a:r>
+            <a:r>
+              <a:rPr sz="1800" b="0">
                 <a:solidFill>
                   <a:srgbClr val="000000"/>
                 </a:solidFill>
                 <a:latin typeface="Fira Sans"/>
               </a:rPr>
-              <a:t>El ejemplo completo, con las tablas de pesos y los gráficos de la clase, está en el notebook 08_componentes_principales.ipynb.</a:t>
+              <a:t>Las componentes no siempre tienen una lectura clara. Aquí sí (la carrera; la temporada frente a la carrera), pero no está garantizado.</a:t>
+            </a:r>
+          </a:p>
+          <a:p>
+            <a:pPr>
+              <a:lnSpc>
+                <a:spcPct val="112000"/>
+              </a:lnSpc>
+              <a:spcAft>
+                <a:spcPts val="900"/>
+              </a:spcAft>
+            </a:pPr>
+            <a:r>
+              <a:rPr sz="1800" b="1">
+                <a:solidFill>
+                  <a:srgbClr val="E0A437"/>
+                </a:solidFill>
+                <a:latin typeface="Fira Sans"/>
+              </a:rPr>
+              <a:t>▸ </a:t>
+            </a:r>
+            <a:r>
+              <a:rPr sz="1800" b="0">
+                <a:solidFill>
+                  <a:srgbClr val="000000"/>
+                </a:solidFill>
+                <a:latin typeface="Fira Sans"/>
+              </a:rPr>
+              <a:t>Es no supervisado: la dirección de más variación no es necesariamente la que mejor predice la respuesta. Ridge y Lasso eligen mirando Y; PCA no la mira.</a:t>
             </a:r>
           </a:p>
         </p:txBody>
@@ -7392,7 +7297,7 @@
             <a:avLst/>
           </a:prstGeom>
           <a:solidFill>
-            <a:srgbClr val="1D3557"/>
+            <a:srgbClr val="FAFBFC"/>
           </a:solidFill>
           <a:ln>
             <a:noFill/>
@@ -7429,8 +7334,8 @@
         </p:nvSpPr>
         <p:spPr>
           <a:xfrm>
-            <a:off x="603504" y="1847088"/>
-            <a:ext cx="7946136" cy="1399032"/>
+            <a:off x="402336" y="301752"/>
+            <a:ext cx="8348472" cy="795528"/>
           </a:xfrm>
           <a:prstGeom prst="rect">
             <a:avLst/>
@@ -7444,24 +7349,167 @@
           <a:lstStyle/>
           <a:p>
             <a:r>
-              <a:rPr sz="3400" b="1">
-                <a:solidFill>
-                  <a:srgbClr val="FFFFFF"/>
-                </a:solidFill>
-                <a:latin typeface="Fira Sans"/>
-              </a:rPr>
-              <a:t>5. Cierre del módulo</a:t>
-            </a:r>
-          </a:p>
-          <a:p>
-            <a:r>
-              <a:rPr sz="1800" b="0">
+              <a:rPr sz="2800" b="1">
+                <a:solidFill>
+                  <a:srgbClr val="0F0F0F"/>
+                </a:solidFill>
+                <a:latin typeface="Fira Sans"/>
+              </a:rPr>
+              <a:t>En el código: cinco líneas</a:t>
+            </a:r>
+          </a:p>
+        </p:txBody>
+      </p:sp>
+      <p:sp>
+        <p:nvSpPr>
+          <p:cNvPr id="4" name="Rectangle 3"/>
+          <p:cNvSpPr/>
+          <p:nvPr/>
+        </p:nvSpPr>
+        <p:spPr>
+          <a:xfrm>
+            <a:off x="704088" y="1280160"/>
+            <a:ext cx="7744968" cy="2880360"/>
+          </a:xfrm>
+          <a:prstGeom prst="rect">
+            <a:avLst/>
+          </a:prstGeom>
+          <a:solidFill>
+            <a:srgbClr val="F0F2F5"/>
+          </a:solidFill>
+          <a:ln>
+            <a:solidFill>
+              <a:srgbClr val="D8DDE3"/>
+            </a:solidFill>
+          </a:ln>
+          <a:effectLst/>
+        </p:spPr>
+        <p:style>
+          <a:lnRef idx="1">
+            <a:schemeClr val="accent1"/>
+          </a:lnRef>
+          <a:fillRef idx="3">
+            <a:schemeClr val="accent1"/>
+          </a:fillRef>
+          <a:effectRef idx="2">
+            <a:schemeClr val="accent1"/>
+          </a:effectRef>
+          <a:fontRef idx="minor">
+            <a:schemeClr val="lt1"/>
+          </a:fontRef>
+        </p:style>
+        <p:txBody>
+          <a:bodyPr rtlCol="0" anchor="ctr" wrap="square" lIns="228600" tIns="137160"/>
+          <a:lstStyle/>
+          <a:p>
+            <a:pPr/>
+            <a:r>
+              <a:rPr sz="1500" b="0">
+                <a:solidFill>
+                  <a:srgbClr val="1D3557"/>
+                </a:solidFill>
+                <a:latin typeface="Menlo"/>
+              </a:rPr>
+              <a:t>Z = StandardScaler().fit_transform(X)  # 1. estandarizar</a:t>
+            </a:r>
+          </a:p>
+          <a:p>
+            <a:pPr/>
+            <a:r>
+              <a:rPr sz="1500" b="0">
+                <a:solidFill>
+                  <a:srgbClr val="1D3557"/>
+                </a:solidFill>
+                <a:latin typeface="Menlo"/>
+              </a:rPr>
+              <a:t>pca = PCA().fit(Z)                     # 2. las componentes</a:t>
+            </a:r>
+          </a:p>
+          <a:p>
+            <a:pPr/>
+            <a:r>
+              <a:rPr sz="1500" b="0">
+                <a:solidFill>
+                  <a:srgbClr val="1D3557"/>
+                </a:solidFill>
+                <a:latin typeface="Menlo"/>
+              </a:rPr>
+              <a:t>pca.explained_variance_ratio_          # 3. cuánto explica</a:t>
+            </a:r>
+          </a:p>
+          <a:p>
+            <a:pPr/>
+            <a:r>
+              <a:rPr sz="1500" b="0">
+                <a:solidFill>
+                  <a:srgbClr val="1D3557"/>
+                </a:solidFill>
+                <a:latin typeface="Menlo"/>
+              </a:rPr>
+              <a:t>pca.components_                        # 4. los pesos</a:t>
+            </a:r>
+          </a:p>
+          <a:p>
+            <a:pPr/>
+            <a:r>
+              <a:rPr sz="1500" b="0">
+                <a:solidFill>
+                  <a:srgbClr val="1D3557"/>
+                </a:solidFill>
+                <a:latin typeface="Menlo"/>
+              </a:rPr>
+              <a:t>puntajes = pca.transform(Z)            # 5. los puntajes</a:t>
+            </a:r>
+          </a:p>
+        </p:txBody>
+      </p:sp>
+      <p:sp>
+        <p:nvSpPr>
+          <p:cNvPr id="5" name="TextBox 4"/>
+          <p:cNvSpPr txBox="1"/>
+          <p:nvPr/>
+        </p:nvSpPr>
+        <p:spPr>
+          <a:xfrm>
+            <a:off x="704088" y="4389120"/>
+            <a:ext cx="7744968" cy="1097280"/>
+          </a:xfrm>
+          <a:prstGeom prst="rect">
+            <a:avLst/>
+          </a:prstGeom>
+          <a:noFill/>
+        </p:spPr>
+        <p:txBody>
+          <a:bodyPr wrap="square">
+            <a:spAutoFit/>
+          </a:bodyPr>
+          <a:lstStyle/>
+          <a:p>
+            <a:pPr>
+              <a:lnSpc>
+                <a:spcPct val="112000"/>
+              </a:lnSpc>
+              <a:spcAft>
+                <a:spcPts val="900"/>
+              </a:spcAft>
+            </a:pPr>
+            <a:r>
+              <a:rPr sz="1600" b="1">
                 <a:solidFill>
                   <a:srgbClr val="E0A437"/>
                 </a:solidFill>
                 <a:latin typeface="Fira Sans"/>
               </a:rPr>
-              <a:t>Ocho clases, un hilo</a:t>
+              <a:t>▸ </a:t>
+            </a:r>
+            <a:r>
+              <a:rPr sz="1600" b="0">
+                <a:solidFill>
+                  <a:srgbClr val="000000"/>
+                </a:solidFill>
+                <a:latin typeface="Fira Sans"/>
+              </a:rPr>
+              <a:t>El ejemplo completo, con las tablas de pesos y los gráficos de la clase, está en el notebook 08_componentes_principales.ipynb.</a:t>
             </a:r>
           </a:p>
         </p:txBody>
@@ -7499,7 +7547,7 @@
             <a:avLst/>
           </a:prstGeom>
           <a:solidFill>
-            <a:srgbClr val="FAFBFC"/>
+            <a:srgbClr val="1D3557"/>
           </a:solidFill>
           <a:ln>
             <a:noFill/>
@@ -7536,8 +7584,8 @@
         </p:nvSpPr>
         <p:spPr>
           <a:xfrm>
-            <a:off x="402336" y="301752"/>
-            <a:ext cx="8348472" cy="795528"/>
+            <a:off x="603504" y="1847088"/>
+            <a:ext cx="7946136" cy="1399032"/>
           </a:xfrm>
           <a:prstGeom prst="rect">
             <a:avLst/>
@@ -7551,71 +7599,24 @@
           <a:lstStyle/>
           <a:p>
             <a:r>
-              <a:rPr sz="2800" b="1">
-                <a:solidFill>
-                  <a:srgbClr val="0F0F0F"/>
-                </a:solidFill>
-                <a:latin typeface="Fira Sans"/>
-              </a:rPr>
-              <a:t>El módulo en una página</a:t>
-            </a:r>
-          </a:p>
-        </p:txBody>
-      </p:sp>
-      <p:pic>
-        <p:nvPicPr>
-          <p:cNvPr id="4" name="Picture 3" descr="c8_07_mapa_modulo.png"/>
-          <p:cNvPicPr>
-            <a:picLocks noChangeAspect="1"/>
-          </p:cNvPicPr>
-          <p:nvPr/>
-        </p:nvPicPr>
-        <p:blipFill>
-          <a:blip r:embed="rId2"/>
-          <a:stretch>
-            <a:fillRect/>
-          </a:stretch>
-        </p:blipFill>
-        <p:spPr>
-          <a:xfrm>
-            <a:off x="1029546" y="1143000"/>
-            <a:ext cx="7084906" cy="3099816"/>
-          </a:xfrm>
-          <a:prstGeom prst="rect">
-            <a:avLst/>
-          </a:prstGeom>
-        </p:spPr>
-      </p:pic>
-      <p:sp>
-        <p:nvSpPr>
-          <p:cNvPr id="5" name="TextBox 4"/>
-          <p:cNvSpPr txBox="1"/>
-          <p:nvPr/>
-        </p:nvSpPr>
-        <p:spPr>
-          <a:xfrm>
-            <a:off x="704088" y="4379976"/>
-            <a:ext cx="7744968" cy="512064"/>
-          </a:xfrm>
-          <a:prstGeom prst="rect">
-            <a:avLst/>
-          </a:prstGeom>
-          <a:noFill/>
-        </p:spPr>
-        <p:txBody>
-          <a:bodyPr wrap="square">
-            <a:spAutoFit/>
-          </a:bodyPr>
-          <a:lstStyle/>
-          <a:p>
-            <a:r>
-              <a:rPr sz="1300" b="0">
-                <a:solidFill>
-                  <a:srgbClr val="333333"/>
-                </a:solidFill>
-                <a:latin typeface="Fira Sans"/>
-              </a:rPr>
-              <a:t>Cada clase dejó una idea. Juntas, son lo que el módulo enseñó: cómo se llega de una pregunta y unos datos a un resultado, y cómo se lee ese resultado con su incertidumbre.</a:t>
+              <a:rPr sz="3400" b="1">
+                <a:solidFill>
+                  <a:srgbClr val="FFFFFF"/>
+                </a:solidFill>
+                <a:latin typeface="Fira Sans"/>
+              </a:rPr>
+              <a:t>5. Cierre del módulo</a:t>
+            </a:r>
+          </a:p>
+          <a:p>
+            <a:r>
+              <a:rPr sz="1800" b="0">
+                <a:solidFill>
+                  <a:srgbClr val="E0A437"/>
+                </a:solidFill>
+                <a:latin typeface="Fira Sans"/>
+              </a:rPr>
+              <a:t>Ocho clases, un hilo</a:t>
             </a:r>
           </a:p>
         </p:txBody>
@@ -7711,21 +7712,45 @@
                 </a:solidFill>
                 <a:latin typeface="Fira Sans"/>
               </a:rPr>
-              <a:t>Lo que sigue en el diplomado</a:t>
-            </a:r>
-          </a:p>
-        </p:txBody>
-      </p:sp>
-      <p:sp>
-        <p:nvSpPr>
-          <p:cNvPr id="4" name="TextBox 3"/>
+              <a:t>El módulo en una página</a:t>
+            </a:r>
+          </a:p>
+        </p:txBody>
+      </p:sp>
+      <p:pic>
+        <p:nvPicPr>
+          <p:cNvPr id="4" name="Picture 3" descr="c8_07_mapa_modulo.png"/>
+          <p:cNvPicPr>
+            <a:picLocks noChangeAspect="1"/>
+          </p:cNvPicPr>
+          <p:nvPr/>
+        </p:nvPicPr>
+        <p:blipFill>
+          <a:blip r:embed="rId2"/>
+          <a:stretch>
+            <a:fillRect/>
+          </a:stretch>
+        </p:blipFill>
+        <p:spPr>
+          <a:xfrm>
+            <a:off x="1029546" y="1143000"/>
+            <a:ext cx="7084906" cy="3099816"/>
+          </a:xfrm>
+          <a:prstGeom prst="rect">
+            <a:avLst/>
+          </a:prstGeom>
+        </p:spPr>
+      </p:pic>
+      <p:sp>
+        <p:nvSpPr>
+          <p:cNvPr id="5" name="TextBox 4"/>
           <p:cNvSpPr txBox="1"/>
           <p:nvPr/>
         </p:nvSpPr>
         <p:spPr>
           <a:xfrm>
-            <a:off x="704088" y="1353312"/>
-            <a:ext cx="7744968" cy="3300984"/>
+            <a:off x="704088" y="4379976"/>
+            <a:ext cx="7744968" cy="512064"/>
           </a:xfrm>
           <a:prstGeom prst="rect">
             <a:avLst/>
@@ -7738,115 +7763,14 @@
           </a:bodyPr>
           <a:lstStyle/>
           <a:p>
-            <a:pPr>
-              <a:lnSpc>
-                <a:spcPct val="112000"/>
-              </a:lnSpc>
-              <a:spcAft>
-                <a:spcPts val="900"/>
-              </a:spcAft>
-            </a:pPr>
-            <a:r>
-              <a:rPr sz="1800" b="1">
-                <a:solidFill>
-                  <a:srgbClr val="E0A437"/>
-                </a:solidFill>
-                <a:latin typeface="Fira Sans"/>
-              </a:rPr>
-              <a:t>▸ </a:t>
-            </a:r>
-            <a:r>
-              <a:rPr sz="1800" b="1">
-                <a:solidFill>
-                  <a:srgbClr val="1D3557"/>
-                </a:solidFill>
-                <a:latin typeface="Fira Sans"/>
-              </a:rPr>
-              <a:t>Módulo 2, Visualización e Inteligencia de Negocios: visualización efectiva, narrativas con datos y métricas de negocio.</a:t>
-            </a:r>
-          </a:p>
-          <a:p>
-            <a:pPr>
-              <a:lnSpc>
-                <a:spcPct val="112000"/>
-              </a:lnSpc>
-              <a:spcAft>
-                <a:spcPts val="900"/>
-              </a:spcAft>
-            </a:pPr>
-            <a:r>
-              <a:rPr sz="1800" b="1">
-                <a:solidFill>
-                  <a:srgbClr val="E0A437"/>
-                </a:solidFill>
-                <a:latin typeface="Fira Sans"/>
-              </a:rPr>
-              <a:t>▸ </a:t>
-            </a:r>
-            <a:r>
-              <a:rPr sz="1800" b="0">
-                <a:solidFill>
-                  <a:srgbClr val="000000"/>
-                </a:solidFill>
-                <a:latin typeface="Fira Sans"/>
-              </a:rPr>
-              <a:t>Módulo 3, Machine Learning para la Toma de Decisiones: aprendizaje supervisado y no supervisado (clustering y PCA en profundidad), evaluación de modelos, redes neuronales y explicabilidad.</a:t>
-            </a:r>
-          </a:p>
-          <a:p>
-            <a:pPr>
-              <a:lnSpc>
-                <a:spcPct val="112000"/>
-              </a:lnSpc>
-              <a:spcAft>
-                <a:spcPts val="900"/>
-              </a:spcAft>
-            </a:pPr>
-            <a:r>
-              <a:rPr sz="1800" b="1">
-                <a:solidFill>
-                  <a:srgbClr val="E0A437"/>
-                </a:solidFill>
-                <a:latin typeface="Fira Sans"/>
-              </a:rPr>
-              <a:t>▸ </a:t>
-            </a:r>
-            <a:r>
-              <a:rPr sz="1800" b="0">
-                <a:solidFill>
-                  <a:srgbClr val="000000"/>
-                </a:solidFill>
-                <a:latin typeface="Fira Sans"/>
-              </a:rPr>
-              <a:t>El Capstone continúa en esos módulos: el primer modelo de hoy es el punto de partida.</a:t>
-            </a:r>
-          </a:p>
-          <a:p>
-            <a:pPr>
-              <a:lnSpc>
-                <a:spcPct val="112000"/>
-              </a:lnSpc>
-              <a:spcAft>
-                <a:spcPts val="900"/>
-              </a:spcAft>
-            </a:pPr>
-            <a:r>
-              <a:rPr sz="1800" b="1">
-                <a:solidFill>
-                  <a:srgbClr val="E0A437"/>
-                </a:solidFill>
-                <a:latin typeface="Fira Sans"/>
-              </a:rPr>
-              <a:t>▸ </a:t>
-            </a:r>
-            <a:r>
-              <a:rPr sz="1800" b="0">
-                <a:solidFill>
-                  <a:srgbClr val="000000"/>
-                </a:solidFill>
-                <a:latin typeface="Fira Sans"/>
-              </a:rPr>
-              <a:t>Lo que se lleva de aquí: leer un resultado con su incertidumbre, juzgar un modelo en datos que no vio, y distinguir describir de encontrar una relación.</a:t>
+            <a:r>
+              <a:rPr sz="1300" b="0">
+                <a:solidFill>
+                  <a:srgbClr val="333333"/>
+                </a:solidFill>
+                <a:latin typeface="Fira Sans"/>
+              </a:rPr>
+              <a:t>Cada clase dejó una idea. Juntas, son lo que el módulo enseñó: cómo se llega de una pregunta y unos datos a un resultado, y cómo se lee ese resultado con su incertidumbre.</a:t>
             </a:r>
           </a:p>
         </p:txBody>
@@ -7942,7 +7866,7 @@
                 </a:solidFill>
                 <a:latin typeface="Fira Sans"/>
               </a:rPr>
-              <a:t>Ahora: las presentaciones del avance</a:t>
+              <a:t>Lo que sigue en el diplomado</a:t>
             </a:r>
           </a:p>
         </p:txBody>
@@ -7993,7 +7917,7 @@
                 </a:solidFill>
                 <a:latin typeface="Fira Sans"/>
               </a:rPr>
-              <a:t>Ocho equipos, en el orden en que se ofrezcan. Máximo 10 minutos por equipo; el tiempo se controla. Después, preguntas de la profesora y del curso.</a:t>
+              <a:t>Módulo 2, Visualización e Inteligencia de Negocios: visualización efectiva, narrativas con datos y métricas de negocio.</a:t>
             </a:r>
           </a:p>
           <a:p>
@@ -8021,7 +7945,7 @@
                 </a:solidFill>
                 <a:latin typeface="Fira Sans"/>
               </a:rPr>
-              <a:t>Se evalúa el avance, no un resultado final: el modelo es un primer intento. La exigencia está en el tiempo, la claridad, la explicación de los gráficos y las relaciones, y en advertir qué falta o qué no tiene sentido.</a:t>
+              <a:t>Módulo 3, Machine Learning para la Toma de Decisiones: aprendizaje supervisado y no supervisado (clustering y PCA en profundidad), evaluación de modelos, redes neuronales y explicabilidad.</a:t>
             </a:r>
           </a:p>
           <a:p>
@@ -8049,7 +7973,7 @@
                 </a:solidFill>
                 <a:latin typeface="Fira Sans"/>
               </a:rPr>
-              <a:t>Las slides, en PDF, al Aula hasta las 20:30: un envío por equipo con los nombres.</a:t>
+              <a:t>El Capstone continúa en esos módulos: el primer modelo de hoy es el punto de partida.</a:t>
             </a:r>
           </a:p>
           <a:p>
@@ -8077,7 +8001,7 @@
                 </a:solidFill>
                 <a:latin typeface="Fira Sans"/>
               </a:rPr>
-              <a:t>El informe escrito, el viernes 25 de septiembre por el Aula: máximo 7 páginas, con su rúbrica publicada.</a:t>
+              <a:t>Lo que se lleva de aquí: leer un resultado con su incertidumbre, juzgar un modelo en datos que no vio, y distinguir describir de encontrar una relación.</a:t>
             </a:r>
           </a:p>
         </p:txBody>
@@ -8091,6 +8015,237 @@
 </file>
 
 <file path=ppt/slides/slide34.xml><?xml version="1.0" encoding="utf-8"?>
+<p:sld xmlns:a="http://schemas.openxmlformats.org/drawingml/2006/main" xmlns:p="http://schemas.openxmlformats.org/presentationml/2006/main" xmlns:r="http://schemas.openxmlformats.org/officeDocument/2006/relationships">
+  <p:cSld>
+    <p:spTree>
+      <p:nvGrpSpPr>
+        <p:cNvPr id="1" name=""/>
+        <p:cNvGrpSpPr/>
+        <p:nvPr/>
+      </p:nvGrpSpPr>
+      <p:grpSpPr/>
+      <p:sp>
+        <p:nvSpPr>
+          <p:cNvPr id="2" name="Rectangle 1"/>
+          <p:cNvSpPr/>
+          <p:nvPr/>
+        </p:nvSpPr>
+        <p:spPr>
+          <a:xfrm>
+            <a:off x="0" y="0"/>
+            <a:ext cx="9144000" cy="5138928"/>
+          </a:xfrm>
+          <a:prstGeom prst="rect">
+            <a:avLst/>
+          </a:prstGeom>
+          <a:solidFill>
+            <a:srgbClr val="FAFBFC"/>
+          </a:solidFill>
+          <a:ln>
+            <a:noFill/>
+          </a:ln>
+          <a:effectLst/>
+        </p:spPr>
+        <p:style>
+          <a:lnRef idx="1">
+            <a:schemeClr val="accent1"/>
+          </a:lnRef>
+          <a:fillRef idx="3">
+            <a:schemeClr val="accent1"/>
+          </a:fillRef>
+          <a:effectRef idx="2">
+            <a:schemeClr val="accent1"/>
+          </a:effectRef>
+          <a:fontRef idx="minor">
+            <a:schemeClr val="lt1"/>
+          </a:fontRef>
+        </p:style>
+        <p:txBody>
+          <a:bodyPr rtlCol="0" anchor="ctr"/>
+          <a:lstStyle/>
+          <a:p>
+            <a:pPr algn="ctr"/>
+          </a:p>
+        </p:txBody>
+      </p:sp>
+      <p:sp>
+        <p:nvSpPr>
+          <p:cNvPr id="3" name="TextBox 2"/>
+          <p:cNvSpPr txBox="1"/>
+          <p:nvPr/>
+        </p:nvSpPr>
+        <p:spPr>
+          <a:xfrm>
+            <a:off x="402336" y="301752"/>
+            <a:ext cx="8348472" cy="795528"/>
+          </a:xfrm>
+          <a:prstGeom prst="rect">
+            <a:avLst/>
+          </a:prstGeom>
+          <a:noFill/>
+        </p:spPr>
+        <p:txBody>
+          <a:bodyPr wrap="square">
+            <a:spAutoFit/>
+          </a:bodyPr>
+          <a:lstStyle/>
+          <a:p>
+            <a:r>
+              <a:rPr sz="2800" b="1">
+                <a:solidFill>
+                  <a:srgbClr val="0F0F0F"/>
+                </a:solidFill>
+                <a:latin typeface="Fira Sans"/>
+              </a:rPr>
+              <a:t>Ahora: las presentaciones del avance</a:t>
+            </a:r>
+          </a:p>
+        </p:txBody>
+      </p:sp>
+      <p:sp>
+        <p:nvSpPr>
+          <p:cNvPr id="4" name="TextBox 3"/>
+          <p:cNvSpPr txBox="1"/>
+          <p:nvPr/>
+        </p:nvSpPr>
+        <p:spPr>
+          <a:xfrm>
+            <a:off x="704088" y="1353312"/>
+            <a:ext cx="7744968" cy="3300984"/>
+          </a:xfrm>
+          <a:prstGeom prst="rect">
+            <a:avLst/>
+          </a:prstGeom>
+          <a:noFill/>
+        </p:spPr>
+        <p:txBody>
+          <a:bodyPr wrap="square">
+            <a:spAutoFit/>
+          </a:bodyPr>
+          <a:lstStyle/>
+          <a:p>
+            <a:pPr>
+              <a:lnSpc>
+                <a:spcPct val="112000"/>
+              </a:lnSpc>
+              <a:spcAft>
+                <a:spcPts val="900"/>
+              </a:spcAft>
+            </a:pPr>
+            <a:r>
+              <a:rPr sz="1800" b="1">
+                <a:solidFill>
+                  <a:srgbClr val="E0A437"/>
+                </a:solidFill>
+                <a:latin typeface="Fira Sans"/>
+              </a:rPr>
+              <a:t>▸ </a:t>
+            </a:r>
+            <a:r>
+              <a:rPr sz="1800" b="1">
+                <a:solidFill>
+                  <a:srgbClr val="1D3557"/>
+                </a:solidFill>
+                <a:latin typeface="Fira Sans"/>
+              </a:rPr>
+              <a:t>Ocho equipos, en el orden en que se ofrezcan. Máximo 10 minutos por equipo; el tiempo se controla. Después, preguntas de la profesora y del curso.</a:t>
+            </a:r>
+          </a:p>
+          <a:p>
+            <a:pPr>
+              <a:lnSpc>
+                <a:spcPct val="112000"/>
+              </a:lnSpc>
+              <a:spcAft>
+                <a:spcPts val="900"/>
+              </a:spcAft>
+            </a:pPr>
+            <a:r>
+              <a:rPr sz="1800" b="1">
+                <a:solidFill>
+                  <a:srgbClr val="E0A437"/>
+                </a:solidFill>
+                <a:latin typeface="Fira Sans"/>
+              </a:rPr>
+              <a:t>▸ </a:t>
+            </a:r>
+            <a:r>
+              <a:rPr sz="1800" b="0">
+                <a:solidFill>
+                  <a:srgbClr val="000000"/>
+                </a:solidFill>
+                <a:latin typeface="Fira Sans"/>
+              </a:rPr>
+              <a:t>Se evalúa el avance, no un resultado final: el modelo es un primer intento. La exigencia está en el tiempo, la claridad, la explicación de los gráficos y las relaciones, y en advertir qué falta o qué no tiene sentido.</a:t>
+            </a:r>
+          </a:p>
+          <a:p>
+            <a:pPr>
+              <a:lnSpc>
+                <a:spcPct val="112000"/>
+              </a:lnSpc>
+              <a:spcAft>
+                <a:spcPts val="900"/>
+              </a:spcAft>
+            </a:pPr>
+            <a:r>
+              <a:rPr sz="1800" b="1">
+                <a:solidFill>
+                  <a:srgbClr val="E0A437"/>
+                </a:solidFill>
+                <a:latin typeface="Fira Sans"/>
+              </a:rPr>
+              <a:t>▸ </a:t>
+            </a:r>
+            <a:r>
+              <a:rPr sz="1800" b="0">
+                <a:solidFill>
+                  <a:srgbClr val="000000"/>
+                </a:solidFill>
+                <a:latin typeface="Fira Sans"/>
+              </a:rPr>
+              <a:t>Las slides, en PDF, al Aula hasta las 20:30: un envío por equipo con los nombres.</a:t>
+            </a:r>
+          </a:p>
+          <a:p>
+            <a:pPr>
+              <a:lnSpc>
+                <a:spcPct val="112000"/>
+              </a:lnSpc>
+              <a:spcAft>
+                <a:spcPts val="900"/>
+              </a:spcAft>
+            </a:pPr>
+            <a:r>
+              <a:rPr sz="1800" b="1">
+                <a:solidFill>
+                  <a:srgbClr val="E0A437"/>
+                </a:solidFill>
+                <a:latin typeface="Fira Sans"/>
+              </a:rPr>
+              <a:t>▸ </a:t>
+            </a:r>
+            <a:r>
+              <a:rPr sz="1800" b="0">
+                <a:solidFill>
+                  <a:srgbClr val="000000"/>
+                </a:solidFill>
+                <a:latin typeface="Fira Sans"/>
+              </a:rPr>
+              <a:t>El informe escrito, el viernes 25 de septiembre por el Aula: máximo 7 páginas, con su rúbrica publicada.</a:t>
+            </a:r>
+          </a:p>
+        </p:txBody>
+      </p:sp>
+    </p:spTree>
+  </p:cSld>
+  <p:clrMapOvr>
+    <a:masterClrMapping/>
+  </p:clrMapOvr>
+</p:sld>
+</file>
+
+<file path=ppt/slides/slide35.xml><?xml version="1.0" encoding="utf-8"?>
 <p:sld xmlns:a="http://schemas.openxmlformats.org/drawingml/2006/main" xmlns:p="http://schemas.openxmlformats.org/presentationml/2006/main" xmlns:r="http://schemas.openxmlformats.org/officeDocument/2006/relationships">
   <p:cSld>
     <p:spTree>

</xml_diff>

<commit_message>
Clase 8: el salario con pocas componentes en vez de iris; signos tal como vienen; ediciones de Daniela
Daniela pregunto que pasa si se usa PCA en la regresion del beisbol con
pocas componentes, para cerrar la clase: con el reparto de la clase 7,
el salario predicho con 1, 2 o 3 componentes tiene RMSE de prueba 321
(minimos cuadrados con las 16 variables 347, con las 19 342; Lasso 325;
Ridge 316); con 2 componentes le gana a minimos cuadrados en 17 de 20
repartos. Slide 26 nueva (reemplaza a iris, que ella no va a usar) y
seccion 8 del notebook con la misma cuenta. La celda que acomodaba los
signos de las cargas se elimino: se usan tal como los entrega
scikit-learn, que ya coinciden con las slides. Ediciones suyas sin
guardar, recuperadas del respaldo de VS Code: sin el grafico de las
flechas y la celda de las tres variables partida en dos.

Co-Authored-By: Claude Fable 5.1 <noreply@anthropic.com>
</commit_message>
<xml_diff>
--- a/presentaciones/clase08_componentes_principales.pptx
+++ b/presentaciones/clase08_componentes_principales.pptx
@@ -6429,14 +6429,14 @@
                 </a:solidFill>
                 <a:latin typeface="Fira Sans"/>
               </a:rPr>
-              <a:t>El mismo cálculo con iris (clase 2)</a:t>
+              <a:t>El salario con pocas componentes</a:t>
             </a:r>
           </a:p>
         </p:txBody>
       </p:sp>
       <p:pic>
         <p:nvPicPr>
-          <p:cNvPr id="4" name="Picture 3" descr="c8_06_iris.png"/>
+          <p:cNvPr id="4" name="Picture 3" descr="c8_09_pcr.png"/>
           <p:cNvPicPr>
             <a:picLocks noChangeAspect="1"/>
           </p:cNvPicPr>
@@ -6450,8 +6450,8 @@
         </p:blipFill>
         <p:spPr>
           <a:xfrm>
-            <a:off x="780288" y="1143000"/>
-            <a:ext cx="7583423" cy="2843784"/>
+            <a:off x="320040" y="1097280"/>
+            <a:ext cx="3567691" cy="3886200"/>
           </a:xfrm>
           <a:prstGeom prst="rect">
             <a:avLst/>
@@ -6466,8 +6466,8 @@
         </p:nvSpPr>
         <p:spPr>
           <a:xfrm>
-            <a:off x="704088" y="4123944"/>
-            <a:ext cx="7744968" cy="768096"/>
+            <a:off x="4116330" y="1325880"/>
+            <a:ext cx="4707629" cy="3566160"/>
           </a:xfrm>
           <a:prstGeom prst="rect">
             <a:avLst/>
@@ -6480,14 +6480,87 @@
           </a:bodyPr>
           <a:lstStyle/>
           <a:p>
-            <a:r>
-              <a:rPr sz="1300" b="0">
-                <a:solidFill>
-                  <a:srgbClr val="333333"/>
-                </a:solidFill>
-                <a:latin typeface="Fira Sans"/>
-              </a:rPr>
-              <a:t>Las cuatro medidas se resumen en dos componentes con el 96% de la variación. Los pesos (izquierda) dicen qué es cada eje: el tamaño de la flor y el ancho del sépalo. Sin conocer la especie, las tres quedan separadas a lo largo del primero.</a:t>
+            <a:pPr>
+              <a:lnSpc>
+                <a:spcPct val="112000"/>
+              </a:lnSpc>
+              <a:spcAft>
+                <a:spcPts val="900"/>
+              </a:spcAft>
+            </a:pPr>
+            <a:r>
+              <a:rPr sz="1500" b="1">
+                <a:solidFill>
+                  <a:srgbClr val="E0A437"/>
+                </a:solidFill>
+                <a:latin typeface="Fira Sans"/>
+              </a:rPr>
+              <a:t>▸ </a:t>
+            </a:r>
+            <a:r>
+              <a:rPr sz="1500" b="1">
+                <a:solidFill>
+                  <a:srgbClr val="1D3557"/>
+                </a:solidFill>
+                <a:latin typeface="Fira Sans"/>
+              </a:rPr>
+              <a:t>Con el reparto de la clase 7 (131 y 132 jugadores), el salario se predice con las primeras k componentes. Con 1, 2 o 3, el error de prueba es 321.</a:t>
+            </a:r>
+          </a:p>
+          <a:p>
+            <a:pPr>
+              <a:lnSpc>
+                <a:spcPct val="112000"/>
+              </a:lnSpc>
+              <a:spcAft>
+                <a:spcPts val="900"/>
+              </a:spcAft>
+            </a:pPr>
+            <a:r>
+              <a:rPr sz="1500" b="1">
+                <a:solidFill>
+                  <a:srgbClr val="E0A437"/>
+                </a:solidFill>
+                <a:latin typeface="Fira Sans"/>
+              </a:rPr>
+              <a:t>▸ </a:t>
+            </a:r>
+            <a:r>
+              <a:rPr sz="1500" b="0">
+                <a:solidFill>
+                  <a:srgbClr val="000000"/>
+                </a:solidFill>
+                <a:latin typeface="Fira Sans"/>
+              </a:rPr>
+              <a:t>Mínimos cuadrados con las mismas 16 variables da 347 y con las 19, 342; Lasso 325 y Ridge 316.</a:t>
+            </a:r>
+          </a:p>
+          <a:p>
+            <a:pPr>
+              <a:lnSpc>
+                <a:spcPct val="112000"/>
+              </a:lnSpc>
+              <a:spcAft>
+                <a:spcPts val="900"/>
+              </a:spcAft>
+            </a:pPr>
+            <a:r>
+              <a:rPr sz="1500" b="1">
+                <a:solidFill>
+                  <a:srgbClr val="E0A437"/>
+                </a:solidFill>
+                <a:latin typeface="Fira Sans"/>
+              </a:rPr>
+              <a:t>▸ </a:t>
+            </a:r>
+            <a:r>
+              <a:rPr sz="1500" b="0">
+                <a:solidFill>
+                  <a:srgbClr val="000000"/>
+                </a:solidFill>
+                <a:latin typeface="Fira Sans"/>
+              </a:rPr>
+              <a:t>Dos números por jugador predicen casi tan bien como el mejor modelo de la clase 7 (en 20 repartos le gana a mínimos cuadrados en 17): es la regresión sobre componentes principales (James et al., 2013, sección 6.3.1).</a:t>
             </a:r>
           </a:p>
         </p:txBody>
@@ -8370,7 +8443,7 @@
                 </a:solidFill>
                 <a:latin typeface="Fira Sans"/>
               </a:rPr>
-              <a:t>James, G., Witten, D., Hastie, T. y Tibshirani, R. (2013). An Introduction to Statistical Learning. Springer. Sección 10.2, pp. 374 a 385: qué es una componente principal, por qué estandarizar, la proporción de variación explicada y cuántas componentes usar. PDF gratuito en statlearning.com.</a:t>
+              <a:t>James, G., Witten, D., Hastie, T. y Tibshirani, R. (2013). An Introduction to Statistical Learning. Springer. Sección 10.2, pp. 374 a 385: qué es una componente principal, por qué estandarizar, la proporción de variación explicada y cuántas componentes usar; sección 6.3.1, regresión sobre componentes principales. PDF gratuito en statlearning.com.</a:t>
             </a:r>
           </a:p>
           <a:p>
@@ -8427,7 +8500,7 @@
                 </a:solidFill>
                 <a:latin typeface="Fira Sans"/>
               </a:rPr>
-              <a:t>Datos: Hitters, del libro de James et al. (statlearning.com), e iris (Fisher, 1936), incluido en scikit-learn.</a:t>
+              <a:t>Datos: Hitters, del libro de James et al. (statlearning.com).</a:t>
             </a:r>
           </a:p>
         </p:txBody>

</xml_diff>

<commit_message>
Clase 8: sin la slide de lo que sigue en el diplomado (34 slides)
Co-Authored-By: Claude Fable 5.1 <noreply@anthropic.com>
</commit_message>
<xml_diff>
--- a/presentaciones/clase08_componentes_principales.pptx
+++ b/presentaciones/clase08_componentes_principales.pptx
@@ -39,7 +39,6 @@
     <p:sldId id="287" r:id="rId38"/>
     <p:sldId id="288" r:id="rId39"/>
     <p:sldId id="289" r:id="rId40"/>
-    <p:sldId id="290" r:id="rId41"/>
   </p:sldIdLst>
   <p:sldSz cx="9144000" cy="5138928" type="screen4x3"/>
   <p:notesSz cx="6858000" cy="9144000"/>
@@ -7939,7 +7938,7 @@
                 </a:solidFill>
                 <a:latin typeface="Fira Sans"/>
               </a:rPr>
-              <a:t>Lo que sigue en el diplomado</a:t>
+              <a:t>Ahora: las presentaciones del avance</a:t>
             </a:r>
           </a:p>
         </p:txBody>
@@ -7990,7 +7989,7 @@
                 </a:solidFill>
                 <a:latin typeface="Fira Sans"/>
               </a:rPr>
-              <a:t>Módulo 2, Visualización e Inteligencia de Negocios: visualización efectiva, narrativas con datos y métricas de negocio.</a:t>
+              <a:t>Ocho equipos, en el orden en que se ofrezcan. Máximo 10 minutos por equipo; el tiempo se controla. Después, preguntas de la profesora y del curso.</a:t>
             </a:r>
           </a:p>
           <a:p>
@@ -8018,7 +8017,7 @@
                 </a:solidFill>
                 <a:latin typeface="Fira Sans"/>
               </a:rPr>
-              <a:t>Módulo 3, Machine Learning para la Toma de Decisiones: aprendizaje supervisado y no supervisado (clustering y PCA en profundidad), evaluación de modelos, redes neuronales y explicabilidad.</a:t>
+              <a:t>Se evalúa el avance, no un resultado final: el modelo es un primer intento. La exigencia está en el tiempo, la claridad, la explicación de los gráficos y las relaciones, y en advertir qué falta o qué no tiene sentido.</a:t>
             </a:r>
           </a:p>
           <a:p>
@@ -8046,7 +8045,7 @@
                 </a:solidFill>
                 <a:latin typeface="Fira Sans"/>
               </a:rPr>
-              <a:t>El Capstone continúa en esos módulos: el primer modelo de hoy es el punto de partida.</a:t>
+              <a:t>Las slides, en PDF, al Aula hasta las 20:30: un envío por equipo con los nombres.</a:t>
             </a:r>
           </a:p>
           <a:p>
@@ -8074,7 +8073,7 @@
                 </a:solidFill>
                 <a:latin typeface="Fira Sans"/>
               </a:rPr>
-              <a:t>Lo que se lleva de aquí: leer un resultado con su incertidumbre, juzgar un modelo en datos que no vio, y distinguir describir de encontrar una relación.</a:t>
+              <a:t>El informe escrito, el viernes 25 de septiembre por el Aula: máximo 7 páginas, con su rúbrica publicada.</a:t>
             </a:r>
           </a:p>
         </p:txBody>
@@ -8088,237 +8087,6 @@
 </file>
 
 <file path=ppt/slides/slide34.xml><?xml version="1.0" encoding="utf-8"?>
-<p:sld xmlns:a="http://schemas.openxmlformats.org/drawingml/2006/main" xmlns:p="http://schemas.openxmlformats.org/presentationml/2006/main" xmlns:r="http://schemas.openxmlformats.org/officeDocument/2006/relationships">
-  <p:cSld>
-    <p:spTree>
-      <p:nvGrpSpPr>
-        <p:cNvPr id="1" name=""/>
-        <p:cNvGrpSpPr/>
-        <p:nvPr/>
-      </p:nvGrpSpPr>
-      <p:grpSpPr/>
-      <p:sp>
-        <p:nvSpPr>
-          <p:cNvPr id="2" name="Rectangle 1"/>
-          <p:cNvSpPr/>
-          <p:nvPr/>
-        </p:nvSpPr>
-        <p:spPr>
-          <a:xfrm>
-            <a:off x="0" y="0"/>
-            <a:ext cx="9144000" cy="5138928"/>
-          </a:xfrm>
-          <a:prstGeom prst="rect">
-            <a:avLst/>
-          </a:prstGeom>
-          <a:solidFill>
-            <a:srgbClr val="FAFBFC"/>
-          </a:solidFill>
-          <a:ln>
-            <a:noFill/>
-          </a:ln>
-          <a:effectLst/>
-        </p:spPr>
-        <p:style>
-          <a:lnRef idx="1">
-            <a:schemeClr val="accent1"/>
-          </a:lnRef>
-          <a:fillRef idx="3">
-            <a:schemeClr val="accent1"/>
-          </a:fillRef>
-          <a:effectRef idx="2">
-            <a:schemeClr val="accent1"/>
-          </a:effectRef>
-          <a:fontRef idx="minor">
-            <a:schemeClr val="lt1"/>
-          </a:fontRef>
-        </p:style>
-        <p:txBody>
-          <a:bodyPr rtlCol="0" anchor="ctr"/>
-          <a:lstStyle/>
-          <a:p>
-            <a:pPr algn="ctr"/>
-          </a:p>
-        </p:txBody>
-      </p:sp>
-      <p:sp>
-        <p:nvSpPr>
-          <p:cNvPr id="3" name="TextBox 2"/>
-          <p:cNvSpPr txBox="1"/>
-          <p:nvPr/>
-        </p:nvSpPr>
-        <p:spPr>
-          <a:xfrm>
-            <a:off x="402336" y="301752"/>
-            <a:ext cx="8348472" cy="795528"/>
-          </a:xfrm>
-          <a:prstGeom prst="rect">
-            <a:avLst/>
-          </a:prstGeom>
-          <a:noFill/>
-        </p:spPr>
-        <p:txBody>
-          <a:bodyPr wrap="square">
-            <a:spAutoFit/>
-          </a:bodyPr>
-          <a:lstStyle/>
-          <a:p>
-            <a:r>
-              <a:rPr sz="2800" b="1">
-                <a:solidFill>
-                  <a:srgbClr val="0F0F0F"/>
-                </a:solidFill>
-                <a:latin typeface="Fira Sans"/>
-              </a:rPr>
-              <a:t>Ahora: las presentaciones del avance</a:t>
-            </a:r>
-          </a:p>
-        </p:txBody>
-      </p:sp>
-      <p:sp>
-        <p:nvSpPr>
-          <p:cNvPr id="4" name="TextBox 3"/>
-          <p:cNvSpPr txBox="1"/>
-          <p:nvPr/>
-        </p:nvSpPr>
-        <p:spPr>
-          <a:xfrm>
-            <a:off x="704088" y="1353312"/>
-            <a:ext cx="7744968" cy="3300984"/>
-          </a:xfrm>
-          <a:prstGeom prst="rect">
-            <a:avLst/>
-          </a:prstGeom>
-          <a:noFill/>
-        </p:spPr>
-        <p:txBody>
-          <a:bodyPr wrap="square">
-            <a:spAutoFit/>
-          </a:bodyPr>
-          <a:lstStyle/>
-          <a:p>
-            <a:pPr>
-              <a:lnSpc>
-                <a:spcPct val="112000"/>
-              </a:lnSpc>
-              <a:spcAft>
-                <a:spcPts val="900"/>
-              </a:spcAft>
-            </a:pPr>
-            <a:r>
-              <a:rPr sz="1800" b="1">
-                <a:solidFill>
-                  <a:srgbClr val="E0A437"/>
-                </a:solidFill>
-                <a:latin typeface="Fira Sans"/>
-              </a:rPr>
-              <a:t>▸ </a:t>
-            </a:r>
-            <a:r>
-              <a:rPr sz="1800" b="1">
-                <a:solidFill>
-                  <a:srgbClr val="1D3557"/>
-                </a:solidFill>
-                <a:latin typeface="Fira Sans"/>
-              </a:rPr>
-              <a:t>Ocho equipos, en el orden en que se ofrezcan. Máximo 10 minutos por equipo; el tiempo se controla. Después, preguntas de la profesora y del curso.</a:t>
-            </a:r>
-          </a:p>
-          <a:p>
-            <a:pPr>
-              <a:lnSpc>
-                <a:spcPct val="112000"/>
-              </a:lnSpc>
-              <a:spcAft>
-                <a:spcPts val="900"/>
-              </a:spcAft>
-            </a:pPr>
-            <a:r>
-              <a:rPr sz="1800" b="1">
-                <a:solidFill>
-                  <a:srgbClr val="E0A437"/>
-                </a:solidFill>
-                <a:latin typeface="Fira Sans"/>
-              </a:rPr>
-              <a:t>▸ </a:t>
-            </a:r>
-            <a:r>
-              <a:rPr sz="1800" b="0">
-                <a:solidFill>
-                  <a:srgbClr val="000000"/>
-                </a:solidFill>
-                <a:latin typeface="Fira Sans"/>
-              </a:rPr>
-              <a:t>Se evalúa el avance, no un resultado final: el modelo es un primer intento. La exigencia está en el tiempo, la claridad, la explicación de los gráficos y las relaciones, y en advertir qué falta o qué no tiene sentido.</a:t>
-            </a:r>
-          </a:p>
-          <a:p>
-            <a:pPr>
-              <a:lnSpc>
-                <a:spcPct val="112000"/>
-              </a:lnSpc>
-              <a:spcAft>
-                <a:spcPts val="900"/>
-              </a:spcAft>
-            </a:pPr>
-            <a:r>
-              <a:rPr sz="1800" b="1">
-                <a:solidFill>
-                  <a:srgbClr val="E0A437"/>
-                </a:solidFill>
-                <a:latin typeface="Fira Sans"/>
-              </a:rPr>
-              <a:t>▸ </a:t>
-            </a:r>
-            <a:r>
-              <a:rPr sz="1800" b="0">
-                <a:solidFill>
-                  <a:srgbClr val="000000"/>
-                </a:solidFill>
-                <a:latin typeface="Fira Sans"/>
-              </a:rPr>
-              <a:t>Las slides, en PDF, al Aula hasta las 20:30: un envío por equipo con los nombres.</a:t>
-            </a:r>
-          </a:p>
-          <a:p>
-            <a:pPr>
-              <a:lnSpc>
-                <a:spcPct val="112000"/>
-              </a:lnSpc>
-              <a:spcAft>
-                <a:spcPts val="900"/>
-              </a:spcAft>
-            </a:pPr>
-            <a:r>
-              <a:rPr sz="1800" b="1">
-                <a:solidFill>
-                  <a:srgbClr val="E0A437"/>
-                </a:solidFill>
-                <a:latin typeface="Fira Sans"/>
-              </a:rPr>
-              <a:t>▸ </a:t>
-            </a:r>
-            <a:r>
-              <a:rPr sz="1800" b="0">
-                <a:solidFill>
-                  <a:srgbClr val="000000"/>
-                </a:solidFill>
-                <a:latin typeface="Fira Sans"/>
-              </a:rPr>
-              <a:t>El informe escrito, el viernes 25 de septiembre por el Aula: máximo 7 páginas, con su rúbrica publicada.</a:t>
-            </a:r>
-          </a:p>
-        </p:txBody>
-      </p:sp>
-    </p:spTree>
-  </p:cSld>
-  <p:clrMapOvr>
-    <a:masterClrMapping/>
-  </p:clrMapOvr>
-</p:sld>
-</file>
-
-<file path=ppt/slides/slide35.xml><?xml version="1.0" encoding="utf-8"?>
 <p:sld xmlns:a="http://schemas.openxmlformats.org/drawingml/2006/main" xmlns:p="http://schemas.openxmlformats.org/presentationml/2006/main" xmlns:r="http://schemas.openxmlformats.org/officeDocument/2006/relationships">
   <p:cSld>
     <p:spTree>

</xml_diff>

<commit_message>
Clase 8: el paso de largo 1 y sus dos catetos en una slide propia; los 16 pesos en la siguiente (35 slides)
Revision de Daniela: en la slide de los pesos no se distinguia que era
el 1 y que era el 0,707. El triangulo va ahora solo y grande: la flecha
azul es el paso de largo 1 (su punta toca el arco de distancia 1), los
catetos de 0,707 en turnos y 0,707 en hits son los pesos, marcas 0,
0,707 y 1 en los ejes. Las 16 barras del primer eje pasan a la slide
siguiente.

Co-Authored-By: Claude Fable 5.1 <noreply@anthropic.com>
</commit_message>
<xml_diff>
--- a/presentaciones/clase08_componentes_principales.pptx
+++ b/presentaciones/clase08_componentes_principales.pptx
@@ -39,6 +39,7 @@
     <p:sldId id="287" r:id="rId38"/>
     <p:sldId id="288" r:id="rId39"/>
     <p:sldId id="289" r:id="rId40"/>
+    <p:sldId id="290" r:id="rId41"/>
   </p:sldIdLst>
   <p:sldSz cx="9144000" cy="5138928" type="screen4x3"/>
   <p:notesSz cx="6858000" cy="9144000"/>
@@ -5966,14 +5967,14 @@
                 </a:solidFill>
                 <a:latin typeface="Fira Sans"/>
               </a:rPr>
-              <a:t>De dónde salen los pesos</a:t>
+              <a:t>De dónde salen los pesos: con dos variables</a:t>
             </a:r>
           </a:p>
         </p:txBody>
       </p:sp>
       <p:pic>
         <p:nvPicPr>
-          <p:cNvPr id="4" name="Picture 3" descr="c8_04a_direccion.png"/>
+          <p:cNvPr id="4" name="Picture 3" descr="c8_04a_triangulo.png"/>
           <p:cNvPicPr>
             <a:picLocks noChangeAspect="1"/>
           </p:cNvPicPr>
@@ -5987,8 +5988,8 @@
         </p:blipFill>
         <p:spPr>
           <a:xfrm>
-            <a:off x="699515" y="1153192"/>
-            <a:ext cx="7744968" cy="3079431"/>
+            <a:off x="320040" y="1097280"/>
+            <a:ext cx="3314447" cy="3886200"/>
           </a:xfrm>
           <a:prstGeom prst="rect">
             <a:avLst/>
@@ -6003,8 +6004,8 @@
         </p:nvSpPr>
         <p:spPr>
           <a:xfrm>
-            <a:off x="704088" y="4369783"/>
-            <a:ext cx="7744968" cy="512064"/>
+            <a:off x="3863087" y="1325880"/>
+            <a:ext cx="4960872" cy="3566160"/>
           </a:xfrm>
           <a:prstGeom prst="rect">
             <a:avLst/>
@@ -6017,14 +6018,87 @@
           </a:bodyPr>
           <a:lstStyle/>
           <a:p>
-            <a:r>
-              <a:rPr sz="1300" b="0">
-                <a:solidFill>
-                  <a:srgbClr val="333333"/>
-                </a:solidFill>
-                <a:latin typeface="Fira Sans"/>
-              </a:rPr>
-              <a:t>Los pesos de una componente son la dirección de su eje: cuánto avanza cada variable en un paso de 1 sobre él. Con dos variables, 0,707 y 0,707; con dieciséis, dieciséis pesos cuyos cuadrados suman 1.</a:t>
+            <a:pPr>
+              <a:lnSpc>
+                <a:spcPct val="112000"/>
+              </a:lnSpc>
+              <a:spcAft>
+                <a:spcPts val="900"/>
+              </a:spcAft>
+            </a:pPr>
+            <a:r>
+              <a:rPr sz="1500" b="1">
+                <a:solidFill>
+                  <a:srgbClr val="E0A437"/>
+                </a:solidFill>
+                <a:latin typeface="Fira Sans"/>
+              </a:rPr>
+              <a:t>▸ </a:t>
+            </a:r>
+            <a:r>
+              <a:rPr sz="1500" b="1">
+                <a:solidFill>
+                  <a:srgbClr val="1D3557"/>
+                </a:solidFill>
+                <a:latin typeface="Fira Sans"/>
+              </a:rPr>
+              <a:t>La flecha azul es un paso de largo 1 sobre el eje nuevo: su punta queda a distancia 1 del centro.</a:t>
+            </a:r>
+          </a:p>
+          <a:p>
+            <a:pPr>
+              <a:lnSpc>
+                <a:spcPct val="112000"/>
+              </a:lnSpc>
+              <a:spcAft>
+                <a:spcPts val="900"/>
+              </a:spcAft>
+            </a:pPr>
+            <a:r>
+              <a:rPr sz="1500" b="1">
+                <a:solidFill>
+                  <a:srgbClr val="E0A437"/>
+                </a:solidFill>
+                <a:latin typeface="Fira Sans"/>
+              </a:rPr>
+              <a:t>▸ </a:t>
+            </a:r>
+            <a:r>
+              <a:rPr sz="1500" b="0">
+                <a:solidFill>
+                  <a:srgbClr val="000000"/>
+                </a:solidFill>
+                <a:latin typeface="Fira Sans"/>
+              </a:rPr>
+              <a:t>En ese paso, turnos avanza 0,707 y hits avanza 0,707: los dos catetos del triángulo (0,707² + 0,707² = 1²).</a:t>
+            </a:r>
+          </a:p>
+          <a:p>
+            <a:pPr>
+              <a:lnSpc>
+                <a:spcPct val="112000"/>
+              </a:lnSpc>
+              <a:spcAft>
+                <a:spcPts val="900"/>
+              </a:spcAft>
+            </a:pPr>
+            <a:r>
+              <a:rPr sz="1500" b="1">
+                <a:solidFill>
+                  <a:srgbClr val="E0A437"/>
+                </a:solidFill>
+                <a:latin typeface="Fira Sans"/>
+              </a:rPr>
+              <a:t>▸ </a:t>
+            </a:r>
+            <a:r>
+              <a:rPr sz="1500" b="0">
+                <a:solidFill>
+                  <a:srgbClr val="000000"/>
+                </a:solidFill>
+                <a:latin typeface="Fira Sans"/>
+              </a:rPr>
+              <a:t>Esos dos números son los pesos de la primera componente: cuánto avanza cada variable en un paso de 1 sobre el eje.</a:t>
             </a:r>
           </a:p>
         </p:txBody>
@@ -6120,14 +6194,14 @@
                 </a:solidFill>
                 <a:latin typeface="Fira Sans"/>
               </a:rPr>
-              <a:t>De qué está hecha cada componente: los pesos</a:t>
+              <a:t>Con 16 variables: los 16 pesos del 1.º eje</a:t>
             </a:r>
           </a:p>
         </p:txBody>
       </p:sp>
       <p:pic>
         <p:nvPicPr>
-          <p:cNvPr id="4" name="Picture 3" descr="c8_04_pesos.png"/>
+          <p:cNvPr id="4" name="Picture 3" descr="c8_04b_16pesos.png"/>
           <p:cNvPicPr>
             <a:picLocks noChangeAspect="1"/>
           </p:cNvPicPr>
@@ -6141,8 +6215,8 @@
         </p:blipFill>
         <p:spPr>
           <a:xfrm>
-            <a:off x="1433764" y="1143000"/>
-            <a:ext cx="6276471" cy="2843784"/>
+            <a:off x="2307211" y="1143000"/>
+            <a:ext cx="4529577" cy="2843784"/>
           </a:xfrm>
           <a:prstGeom prst="rect">
             <a:avLst/>
@@ -6178,7 +6252,7 @@
                 </a:solidFill>
                 <a:latin typeface="Fira Sans"/>
               </a:rPr>
-              <a:t>1.ª componente: la carrera pesa 0,29 a 0,34, la temporada 1986 la mitad (0,19 a 0,23) y la defensa nada: cuánta carrera lleva el jugador. 2.ª: la temporada positiva (0,24 a 0,39) y la carrera negativa (−0,12 a −0,26): quien rindió este año más de lo que dice su carrera.</a:t>
+              <a:t>Lo mismo en 16 dimensiones, donde ya no se puede dibujar: un paso de 1 sobre el primer eje avanza 0,33 en turnos_carrera, 0,33 en hits_carrera, 0,20 en turnos de 1986, 0,08 en outs de defensa y casi nada en errores. Son dieciséis catetos cuyos cuadrados suman 1.</a:t>
             </a:r>
           </a:p>
         </p:txBody>
@@ -6274,14 +6348,14 @@
                 </a:solidFill>
                 <a:latin typeface="Fira Sans"/>
               </a:rPr>
-              <a:t>Los 263 jugadores en dos componentes</a:t>
+              <a:t>De qué está hecha cada componente: los pesos</a:t>
             </a:r>
           </a:p>
         </p:txBody>
       </p:sp>
       <p:pic>
         <p:nvPicPr>
-          <p:cNvPr id="4" name="Picture 3" descr="c8_05_jugadores.png"/>
+          <p:cNvPr id="4" name="Picture 3" descr="c8_04_pesos.png"/>
           <p:cNvPicPr>
             <a:picLocks noChangeAspect="1"/>
           </p:cNvPicPr>
@@ -6295,8 +6369,8 @@
         </p:blipFill>
         <p:spPr>
           <a:xfrm>
-            <a:off x="2699826" y="1143000"/>
-            <a:ext cx="3744346" cy="2587751"/>
+            <a:off x="1433764" y="1143000"/>
+            <a:ext cx="6276471" cy="2843784"/>
           </a:xfrm>
           <a:prstGeom prst="rect">
             <a:avLst/>
@@ -6311,8 +6385,8 @@
         </p:nvSpPr>
         <p:spPr>
           <a:xfrm>
-            <a:off x="704088" y="3867912"/>
-            <a:ext cx="7744968" cy="1024128"/>
+            <a:off x="704088" y="4123944"/>
+            <a:ext cx="7744968" cy="768096"/>
           </a:xfrm>
           <a:prstGeom prst="rect">
             <a:avLst/>
@@ -6332,7 +6406,7 @@
                 </a:solidFill>
                 <a:latin typeface="Fira Sans"/>
               </a:rPr>
-              <a:t>Cada punto es un jugador y el color, su salario de 1987, que PCA no usó. El salario crece hacia la derecha (correlación 0,64 con la primera componente) y casi nada hacia arriba (0,11 con la segunda): la carrera pesa en el salario; la última temporada, poco. Dos ejes muestran lo que en 16 variables había que leer coeficiente por coeficiente.</a:t>
+              <a:t>1.ª componente: la carrera pesa 0,29 a 0,34, la temporada 1986 la mitad (0,19 a 0,23) y la defensa nada: cuánta carrera lleva el jugador. 2.ª: la temporada positiva (0,24 a 0,39) y la carrera negativa (−0,12 a −0,26): quien rindió este año más de lo que dice su carrera.</a:t>
             </a:r>
           </a:p>
         </p:txBody>
@@ -6428,14 +6502,14 @@
                 </a:solidFill>
                 <a:latin typeface="Fira Sans"/>
               </a:rPr>
-              <a:t>El salario con pocas componentes</a:t>
+              <a:t>Los 263 jugadores en dos componentes</a:t>
             </a:r>
           </a:p>
         </p:txBody>
       </p:sp>
       <p:pic>
         <p:nvPicPr>
-          <p:cNvPr id="4" name="Picture 3" descr="c8_09_pcr.png"/>
+          <p:cNvPr id="4" name="Picture 3" descr="c8_05_jugadores.png"/>
           <p:cNvPicPr>
             <a:picLocks noChangeAspect="1"/>
           </p:cNvPicPr>
@@ -6449,8 +6523,8 @@
         </p:blipFill>
         <p:spPr>
           <a:xfrm>
-            <a:off x="320040" y="1097280"/>
-            <a:ext cx="3567691" cy="3886200"/>
+            <a:off x="2699826" y="1143000"/>
+            <a:ext cx="3744346" cy="2587751"/>
           </a:xfrm>
           <a:prstGeom prst="rect">
             <a:avLst/>
@@ -6465,8 +6539,8 @@
         </p:nvSpPr>
         <p:spPr>
           <a:xfrm>
-            <a:off x="4116330" y="1325880"/>
-            <a:ext cx="4707629" cy="3566160"/>
+            <a:off x="704088" y="3867912"/>
+            <a:ext cx="7744968" cy="1024128"/>
           </a:xfrm>
           <a:prstGeom prst="rect">
             <a:avLst/>
@@ -6479,87 +6553,14 @@
           </a:bodyPr>
           <a:lstStyle/>
           <a:p>
-            <a:pPr>
-              <a:lnSpc>
-                <a:spcPct val="112000"/>
-              </a:lnSpc>
-              <a:spcAft>
-                <a:spcPts val="900"/>
-              </a:spcAft>
-            </a:pPr>
-            <a:r>
-              <a:rPr sz="1500" b="1">
-                <a:solidFill>
-                  <a:srgbClr val="E0A437"/>
-                </a:solidFill>
-                <a:latin typeface="Fira Sans"/>
-              </a:rPr>
-              <a:t>▸ </a:t>
-            </a:r>
-            <a:r>
-              <a:rPr sz="1500" b="1">
-                <a:solidFill>
-                  <a:srgbClr val="1D3557"/>
-                </a:solidFill>
-                <a:latin typeface="Fira Sans"/>
-              </a:rPr>
-              <a:t>Con el reparto de la clase 7 (131 y 132 jugadores), el salario se predice con las primeras k componentes. Con 1, 2 o 3, el error de prueba es 321.</a:t>
-            </a:r>
-          </a:p>
-          <a:p>
-            <a:pPr>
-              <a:lnSpc>
-                <a:spcPct val="112000"/>
-              </a:lnSpc>
-              <a:spcAft>
-                <a:spcPts val="900"/>
-              </a:spcAft>
-            </a:pPr>
-            <a:r>
-              <a:rPr sz="1500" b="1">
-                <a:solidFill>
-                  <a:srgbClr val="E0A437"/>
-                </a:solidFill>
-                <a:latin typeface="Fira Sans"/>
-              </a:rPr>
-              <a:t>▸ </a:t>
-            </a:r>
-            <a:r>
-              <a:rPr sz="1500" b="0">
-                <a:solidFill>
-                  <a:srgbClr val="000000"/>
-                </a:solidFill>
-                <a:latin typeface="Fira Sans"/>
-              </a:rPr>
-              <a:t>Mínimos cuadrados con las mismas 16 variables da 347 y con las 19, 342; Lasso 325 y Ridge 316.</a:t>
-            </a:r>
-          </a:p>
-          <a:p>
-            <a:pPr>
-              <a:lnSpc>
-                <a:spcPct val="112000"/>
-              </a:lnSpc>
-              <a:spcAft>
-                <a:spcPts val="900"/>
-              </a:spcAft>
-            </a:pPr>
-            <a:r>
-              <a:rPr sz="1500" b="1">
-                <a:solidFill>
-                  <a:srgbClr val="E0A437"/>
-                </a:solidFill>
-                <a:latin typeface="Fira Sans"/>
-              </a:rPr>
-              <a:t>▸ </a:t>
-            </a:r>
-            <a:r>
-              <a:rPr sz="1500" b="0">
-                <a:solidFill>
-                  <a:srgbClr val="000000"/>
-                </a:solidFill>
-                <a:latin typeface="Fira Sans"/>
-              </a:rPr>
-              <a:t>Dos números por jugador predicen casi tan bien como el mejor modelo de la clase 7 (en 20 repartos le gana a mínimos cuadrados en 17): es la regresión sobre componentes principales (James et al., 2013, sección 6.3.1).</a:t>
+            <a:r>
+              <a:rPr sz="1300" b="0">
+                <a:solidFill>
+                  <a:srgbClr val="333333"/>
+                </a:solidFill>
+                <a:latin typeface="Fira Sans"/>
+              </a:rPr>
+              <a:t>Cada punto es un jugador y el color, su salario de 1987, que PCA no usó. El salario crece hacia la derecha (correlación 0,64 con la primera componente) y casi nada hacia arriba (0,11 con la segunda): la carrera pesa en el salario; la última temporada, poco. Dos ejes muestran lo que en 16 variables había que leer coeficiente por coeficiente.</a:t>
             </a:r>
           </a:p>
         </p:txBody>
@@ -6597,7 +6598,7 @@
             <a:avLst/>
           </a:prstGeom>
           <a:solidFill>
-            <a:srgbClr val="1D3557"/>
+            <a:srgbClr val="FAFBFC"/>
           </a:solidFill>
           <a:ln>
             <a:noFill/>
@@ -6634,8 +6635,8 @@
         </p:nvSpPr>
         <p:spPr>
           <a:xfrm>
-            <a:off x="603504" y="1847088"/>
-            <a:ext cx="7946136" cy="1399032"/>
+            <a:off x="402336" y="301752"/>
+            <a:ext cx="8348472" cy="795528"/>
           </a:xfrm>
           <a:prstGeom prst="rect">
             <a:avLst/>
@@ -6649,24 +6650,144 @@
           <a:lstStyle/>
           <a:p>
             <a:r>
-              <a:rPr sz="3400" b="1">
-                <a:solidFill>
-                  <a:srgbClr val="FFFFFF"/>
-                </a:solidFill>
-                <a:latin typeface="Fira Sans"/>
-              </a:rPr>
-              <a:t>4. Cuándo</a:t>
-            </a:r>
-          </a:p>
-          <a:p>
-            <a:r>
-              <a:rPr sz="1800" b="0">
+              <a:rPr sz="2800" b="1">
+                <a:solidFill>
+                  <a:srgbClr val="0F0F0F"/>
+                </a:solidFill>
+                <a:latin typeface="Fira Sans"/>
+              </a:rPr>
+              <a:t>El salario con pocas componentes</a:t>
+            </a:r>
+          </a:p>
+        </p:txBody>
+      </p:sp>
+      <p:pic>
+        <p:nvPicPr>
+          <p:cNvPr id="4" name="Picture 3" descr="c8_09_pcr.png"/>
+          <p:cNvPicPr>
+            <a:picLocks noChangeAspect="1"/>
+          </p:cNvPicPr>
+          <p:nvPr/>
+        </p:nvPicPr>
+        <p:blipFill>
+          <a:blip r:embed="rId2"/>
+          <a:stretch>
+            <a:fillRect/>
+          </a:stretch>
+        </p:blipFill>
+        <p:spPr>
+          <a:xfrm>
+            <a:off x="320040" y="1097280"/>
+            <a:ext cx="3567691" cy="3886200"/>
+          </a:xfrm>
+          <a:prstGeom prst="rect">
+            <a:avLst/>
+          </a:prstGeom>
+        </p:spPr>
+      </p:pic>
+      <p:sp>
+        <p:nvSpPr>
+          <p:cNvPr id="5" name="TextBox 4"/>
+          <p:cNvSpPr txBox="1"/>
+          <p:nvPr/>
+        </p:nvSpPr>
+        <p:spPr>
+          <a:xfrm>
+            <a:off x="4116330" y="1325880"/>
+            <a:ext cx="4707629" cy="3566160"/>
+          </a:xfrm>
+          <a:prstGeom prst="rect">
+            <a:avLst/>
+          </a:prstGeom>
+          <a:noFill/>
+        </p:spPr>
+        <p:txBody>
+          <a:bodyPr wrap="square">
+            <a:spAutoFit/>
+          </a:bodyPr>
+          <a:lstStyle/>
+          <a:p>
+            <a:pPr>
+              <a:lnSpc>
+                <a:spcPct val="112000"/>
+              </a:lnSpc>
+              <a:spcAft>
+                <a:spcPts val="900"/>
+              </a:spcAft>
+            </a:pPr>
+            <a:r>
+              <a:rPr sz="1500" b="1">
                 <a:solidFill>
                   <a:srgbClr val="E0A437"/>
                 </a:solidFill>
                 <a:latin typeface="Fira Sans"/>
               </a:rPr>
-              <a:t>Cuándo conviene y cuándo no</a:t>
+              <a:t>▸ </a:t>
+            </a:r>
+            <a:r>
+              <a:rPr sz="1500" b="1">
+                <a:solidFill>
+                  <a:srgbClr val="1D3557"/>
+                </a:solidFill>
+                <a:latin typeface="Fira Sans"/>
+              </a:rPr>
+              <a:t>Con el reparto de la clase 7 (131 y 132 jugadores), el salario se predice con las primeras k componentes. Con 1, 2 o 3, el error de prueba es 321.</a:t>
+            </a:r>
+          </a:p>
+          <a:p>
+            <a:pPr>
+              <a:lnSpc>
+                <a:spcPct val="112000"/>
+              </a:lnSpc>
+              <a:spcAft>
+                <a:spcPts val="900"/>
+              </a:spcAft>
+            </a:pPr>
+            <a:r>
+              <a:rPr sz="1500" b="1">
+                <a:solidFill>
+                  <a:srgbClr val="E0A437"/>
+                </a:solidFill>
+                <a:latin typeface="Fira Sans"/>
+              </a:rPr>
+              <a:t>▸ </a:t>
+            </a:r>
+            <a:r>
+              <a:rPr sz="1500" b="0">
+                <a:solidFill>
+                  <a:srgbClr val="000000"/>
+                </a:solidFill>
+                <a:latin typeface="Fira Sans"/>
+              </a:rPr>
+              <a:t>Mínimos cuadrados con las mismas 16 variables da 347 y con las 19, 342; Lasso 325 y Ridge 316.</a:t>
+            </a:r>
+          </a:p>
+          <a:p>
+            <a:pPr>
+              <a:lnSpc>
+                <a:spcPct val="112000"/>
+              </a:lnSpc>
+              <a:spcAft>
+                <a:spcPts val="900"/>
+              </a:spcAft>
+            </a:pPr>
+            <a:r>
+              <a:rPr sz="1500" b="1">
+                <a:solidFill>
+                  <a:srgbClr val="E0A437"/>
+                </a:solidFill>
+                <a:latin typeface="Fira Sans"/>
+              </a:rPr>
+              <a:t>▸ </a:t>
+            </a:r>
+            <a:r>
+              <a:rPr sz="1500" b="0">
+                <a:solidFill>
+                  <a:srgbClr val="000000"/>
+                </a:solidFill>
+                <a:latin typeface="Fira Sans"/>
+              </a:rPr>
+              <a:t>Dos números por jugador predicen casi tan bien como el mejor modelo de la clase 7 (en 20 repartos le gana a mínimos cuadrados en 17): es la regresión sobre componentes principales (James et al., 2013, sección 6.3.1).</a:t>
             </a:r>
           </a:p>
         </p:txBody>
@@ -6704,7 +6825,7 @@
             <a:avLst/>
           </a:prstGeom>
           <a:solidFill>
-            <a:srgbClr val="FAFBFC"/>
+            <a:srgbClr val="1D3557"/>
           </a:solidFill>
           <a:ln>
             <a:noFill/>
@@ -6741,8 +6862,8 @@
         </p:nvSpPr>
         <p:spPr>
           <a:xfrm>
-            <a:off x="402336" y="301752"/>
-            <a:ext cx="8348472" cy="795528"/>
+            <a:off x="603504" y="1847088"/>
+            <a:ext cx="7946136" cy="1399032"/>
           </a:xfrm>
           <a:prstGeom prst="rect">
             <a:avLst/>
@@ -6756,120 +6877,24 @@
           <a:lstStyle/>
           <a:p>
             <a:r>
-              <a:rPr sz="2800" b="1">
-                <a:solidFill>
-                  <a:srgbClr val="0F0F0F"/>
-                </a:solidFill>
-                <a:latin typeface="Fira Sans"/>
-              </a:rPr>
-              <a:t>¿Cuándo conviene?</a:t>
-            </a:r>
-          </a:p>
-        </p:txBody>
-      </p:sp>
-      <p:sp>
-        <p:nvSpPr>
-          <p:cNvPr id="4" name="TextBox 3"/>
-          <p:cNvSpPr txBox="1"/>
-          <p:nvPr/>
-        </p:nvSpPr>
-        <p:spPr>
-          <a:xfrm>
-            <a:off x="704088" y="1353312"/>
-            <a:ext cx="7744968" cy="3300984"/>
-          </a:xfrm>
-          <a:prstGeom prst="rect">
-            <a:avLst/>
-          </a:prstGeom>
-          <a:noFill/>
-        </p:spPr>
-        <p:txBody>
-          <a:bodyPr wrap="square">
-            <a:spAutoFit/>
-          </a:bodyPr>
-          <a:lstStyle/>
-          <a:p>
-            <a:pPr>
-              <a:lnSpc>
-                <a:spcPct val="112000"/>
-              </a:lnSpc>
-              <a:spcAft>
-                <a:spcPts val="900"/>
-              </a:spcAft>
-            </a:pPr>
-            <a:r>
-              <a:rPr sz="1800" b="1">
+              <a:rPr sz="3400" b="1">
+                <a:solidFill>
+                  <a:srgbClr val="FFFFFF"/>
+                </a:solidFill>
+                <a:latin typeface="Fira Sans"/>
+              </a:rPr>
+              <a:t>4. Cuándo</a:t>
+            </a:r>
+          </a:p>
+          <a:p>
+            <a:r>
+              <a:rPr sz="1800" b="0">
                 <a:solidFill>
                   <a:srgbClr val="E0A437"/>
                 </a:solidFill>
                 <a:latin typeface="Fira Sans"/>
               </a:rPr>
-              <a:t>▸ </a:t>
-            </a:r>
-            <a:r>
-              <a:rPr sz="1800" b="1">
-                <a:solidFill>
-                  <a:srgbClr val="1D3557"/>
-                </a:solidFill>
-                <a:latin typeface="Fira Sans"/>
-              </a:rPr>
-              <a:t>Con muchas variables numéricas que se correlacionan en bloques, como en la matriz de la clase 7.</a:t>
-            </a:r>
-          </a:p>
-          <a:p>
-            <a:pPr>
-              <a:lnSpc>
-                <a:spcPct val="112000"/>
-              </a:lnSpc>
-              <a:spcAft>
-                <a:spcPts val="900"/>
-              </a:spcAft>
-            </a:pPr>
-            <a:r>
-              <a:rPr sz="1800" b="1">
-                <a:solidFill>
-                  <a:srgbClr val="E0A437"/>
-                </a:solidFill>
-                <a:latin typeface="Fira Sans"/>
-              </a:rPr>
-              <a:t>▸ </a:t>
-            </a:r>
-            <a:r>
-              <a:rPr sz="1800" b="0">
-                <a:solidFill>
-                  <a:srgbClr val="000000"/>
-                </a:solidFill>
-                <a:latin typeface="Fira Sans"/>
-              </a:rPr>
-              <a:t>Para mirar los datos en un plano, o para entregarle a un modelo menos entradas.</a:t>
-            </a:r>
-          </a:p>
-          <a:p>
-            <a:pPr>
-              <a:lnSpc>
-                <a:spcPct val="112000"/>
-              </a:lnSpc>
-              <a:spcAft>
-                <a:spcPts val="900"/>
-              </a:spcAft>
-            </a:pPr>
-            <a:r>
-              <a:rPr sz="1800" b="1">
-                <a:solidFill>
-                  <a:srgbClr val="E0A437"/>
-                </a:solidFill>
-                <a:latin typeface="Fira Sans"/>
-              </a:rPr>
-              <a:t>▸ </a:t>
-            </a:r>
-            <a:r>
-              <a:rPr sz="1800" b="0">
-                <a:solidFill>
-                  <a:srgbClr val="000000"/>
-                </a:solidFill>
-                <a:latin typeface="Fira Sans"/>
-              </a:rPr>
-              <a:t>No aporta si las variables son pocas y distintas entre sí: no hay nada que resumir.</a:t>
+              <a:t>Cuándo conviene y cuándo no</a:t>
             </a:r>
           </a:p>
         </p:txBody>
@@ -6965,7 +6990,7 @@
                 </a:solidFill>
                 <a:latin typeface="Fira Sans"/>
               </a:rPr>
-              <a:t>Tres precauciones</a:t>
+              <a:t>¿Cuándo conviene?</a:t>
             </a:r>
           </a:p>
         </p:txBody>
@@ -7016,7 +7041,7 @@
                 </a:solidFill>
                 <a:latin typeface="Fira Sans"/>
               </a:rPr>
-              <a:t>Las variables categóricas (las dummies de la clase 6) no entran bien en el cálculo: se dejan fuera o se tratan aparte.</a:t>
+              <a:t>Con muchas variables numéricas que se correlacionan en bloques, como en la matriz de la clase 7.</a:t>
             </a:r>
           </a:p>
           <a:p>
@@ -7044,7 +7069,7 @@
                 </a:solidFill>
                 <a:latin typeface="Fira Sans"/>
               </a:rPr>
-              <a:t>Las componentes no siempre tienen una lectura clara. Aquí sí (la carrera; la temporada frente a la carrera), pero no está garantizado.</a:t>
+              <a:t>Para mirar los datos en un plano, o para entregarle a un modelo menos entradas.</a:t>
             </a:r>
           </a:p>
           <a:p>
@@ -7072,7 +7097,7 @@
                 </a:solidFill>
                 <a:latin typeface="Fira Sans"/>
               </a:rPr>
-              <a:t>Es no supervisado: la dirección de más variación no es necesariamente la que mejor predice la respuesta. Ridge y Lasso eligen mirando Y; PCA no la mira.</a:t>
+              <a:t>No aporta si las variables son pocas y distintas entre sí: no hay nada que resumir.</a:t>
             </a:r>
           </a:p>
         </p:txBody>
@@ -7427,124 +7452,21 @@
                 </a:solidFill>
                 <a:latin typeface="Fira Sans"/>
               </a:rPr>
-              <a:t>En el código: cinco líneas</a:t>
-            </a:r>
-          </a:p>
-        </p:txBody>
-      </p:sp>
-      <p:sp>
-        <p:nvSpPr>
-          <p:cNvPr id="4" name="Rectangle 3"/>
-          <p:cNvSpPr/>
-          <p:nvPr/>
-        </p:nvSpPr>
-        <p:spPr>
-          <a:xfrm>
-            <a:off x="704088" y="1280160"/>
-            <a:ext cx="7744968" cy="2880360"/>
-          </a:xfrm>
-          <a:prstGeom prst="rect">
-            <a:avLst/>
-          </a:prstGeom>
-          <a:solidFill>
-            <a:srgbClr val="F0F2F5"/>
-          </a:solidFill>
-          <a:ln>
-            <a:solidFill>
-              <a:srgbClr val="D8DDE3"/>
-            </a:solidFill>
-          </a:ln>
-          <a:effectLst/>
-        </p:spPr>
-        <p:style>
-          <a:lnRef idx="1">
-            <a:schemeClr val="accent1"/>
-          </a:lnRef>
-          <a:fillRef idx="3">
-            <a:schemeClr val="accent1"/>
-          </a:fillRef>
-          <a:effectRef idx="2">
-            <a:schemeClr val="accent1"/>
-          </a:effectRef>
-          <a:fontRef idx="minor">
-            <a:schemeClr val="lt1"/>
-          </a:fontRef>
-        </p:style>
-        <p:txBody>
-          <a:bodyPr rtlCol="0" anchor="ctr" wrap="square" lIns="228600" tIns="137160"/>
-          <a:lstStyle/>
-          <a:p>
-            <a:pPr/>
-            <a:r>
-              <a:rPr sz="1500" b="0">
-                <a:solidFill>
-                  <a:srgbClr val="1D3557"/>
-                </a:solidFill>
-                <a:latin typeface="Menlo"/>
-              </a:rPr>
-              <a:t>Z = StandardScaler().fit_transform(X)  # 1. estandarizar</a:t>
-            </a:r>
-          </a:p>
-          <a:p>
-            <a:pPr/>
-            <a:r>
-              <a:rPr sz="1500" b="0">
-                <a:solidFill>
-                  <a:srgbClr val="1D3557"/>
-                </a:solidFill>
-                <a:latin typeface="Menlo"/>
-              </a:rPr>
-              <a:t>pca = PCA().fit(Z)                     # 2. las componentes</a:t>
-            </a:r>
-          </a:p>
-          <a:p>
-            <a:pPr/>
-            <a:r>
-              <a:rPr sz="1500" b="0">
-                <a:solidFill>
-                  <a:srgbClr val="1D3557"/>
-                </a:solidFill>
-                <a:latin typeface="Menlo"/>
-              </a:rPr>
-              <a:t>pca.explained_variance_ratio_          # 3. cuánto explica</a:t>
-            </a:r>
-          </a:p>
-          <a:p>
-            <a:pPr/>
-            <a:r>
-              <a:rPr sz="1500" b="0">
-                <a:solidFill>
-                  <a:srgbClr val="1D3557"/>
-                </a:solidFill>
-                <a:latin typeface="Menlo"/>
-              </a:rPr>
-              <a:t>pca.components_                        # 4. los pesos</a:t>
-            </a:r>
-          </a:p>
-          <a:p>
-            <a:pPr/>
-            <a:r>
-              <a:rPr sz="1500" b="0">
-                <a:solidFill>
-                  <a:srgbClr val="1D3557"/>
-                </a:solidFill>
-                <a:latin typeface="Menlo"/>
-              </a:rPr>
-              <a:t>puntajes = pca.transform(Z)            # 5. los puntajes</a:t>
-            </a:r>
-          </a:p>
-        </p:txBody>
-      </p:sp>
-      <p:sp>
-        <p:nvSpPr>
-          <p:cNvPr id="5" name="TextBox 4"/>
+              <a:t>Tres precauciones</a:t>
+            </a:r>
+          </a:p>
+        </p:txBody>
+      </p:sp>
+      <p:sp>
+        <p:nvSpPr>
+          <p:cNvPr id="4" name="TextBox 3"/>
           <p:cNvSpPr txBox="1"/>
           <p:nvPr/>
         </p:nvSpPr>
         <p:spPr>
           <a:xfrm>
-            <a:off x="704088" y="4389120"/>
-            <a:ext cx="7744968" cy="1097280"/>
+            <a:off x="704088" y="1353312"/>
+            <a:ext cx="7744968" cy="3300984"/>
           </a:xfrm>
           <a:prstGeom prst="rect">
             <a:avLst/>
@@ -7566,7 +7488,7 @@
               </a:spcAft>
             </a:pPr>
             <a:r>
-              <a:rPr sz="1600" b="1">
+              <a:rPr sz="1800" b="1">
                 <a:solidFill>
                   <a:srgbClr val="E0A437"/>
                 </a:solidFill>
@@ -7575,13 +7497,69 @@
               <a:t>▸ </a:t>
             </a:r>
             <a:r>
-              <a:rPr sz="1600" b="0">
+              <a:rPr sz="1800" b="1">
+                <a:solidFill>
+                  <a:srgbClr val="1D3557"/>
+                </a:solidFill>
+                <a:latin typeface="Fira Sans"/>
+              </a:rPr>
+              <a:t>Las variables categóricas (las dummies de la clase 6) no entran bien en el cálculo: se dejan fuera o se tratan aparte.</a:t>
+            </a:r>
+          </a:p>
+          <a:p>
+            <a:pPr>
+              <a:lnSpc>
+                <a:spcPct val="112000"/>
+              </a:lnSpc>
+              <a:spcAft>
+                <a:spcPts val="900"/>
+              </a:spcAft>
+            </a:pPr>
+            <a:r>
+              <a:rPr sz="1800" b="1">
+                <a:solidFill>
+                  <a:srgbClr val="E0A437"/>
+                </a:solidFill>
+                <a:latin typeface="Fira Sans"/>
+              </a:rPr>
+              <a:t>▸ </a:t>
+            </a:r>
+            <a:r>
+              <a:rPr sz="1800" b="0">
                 <a:solidFill>
                   <a:srgbClr val="000000"/>
                 </a:solidFill>
                 <a:latin typeface="Fira Sans"/>
               </a:rPr>
-              <a:t>El ejemplo completo, con las tablas de pesos y los gráficos de la clase, está en el notebook 08_componentes_principales.ipynb.</a:t>
+              <a:t>Las componentes no siempre tienen una lectura clara. Aquí sí (la carrera; la temporada frente a la carrera), pero no está garantizado.</a:t>
+            </a:r>
+          </a:p>
+          <a:p>
+            <a:pPr>
+              <a:lnSpc>
+                <a:spcPct val="112000"/>
+              </a:lnSpc>
+              <a:spcAft>
+                <a:spcPts val="900"/>
+              </a:spcAft>
+            </a:pPr>
+            <a:r>
+              <a:rPr sz="1800" b="1">
+                <a:solidFill>
+                  <a:srgbClr val="E0A437"/>
+                </a:solidFill>
+                <a:latin typeface="Fira Sans"/>
+              </a:rPr>
+              <a:t>▸ </a:t>
+            </a:r>
+            <a:r>
+              <a:rPr sz="1800" b="0">
+                <a:solidFill>
+                  <a:srgbClr val="000000"/>
+                </a:solidFill>
+                <a:latin typeface="Fira Sans"/>
+              </a:rPr>
+              <a:t>Es no supervisado: la dirección de más variación no es necesariamente la que mejor predice la respuesta. Ridge y Lasso eligen mirando Y; PCA no la mira.</a:t>
             </a:r>
           </a:p>
         </p:txBody>
@@ -7619,7 +7597,7 @@
             <a:avLst/>
           </a:prstGeom>
           <a:solidFill>
-            <a:srgbClr val="1D3557"/>
+            <a:srgbClr val="FAFBFC"/>
           </a:solidFill>
           <a:ln>
             <a:noFill/>
@@ -7656,8 +7634,8 @@
         </p:nvSpPr>
         <p:spPr>
           <a:xfrm>
-            <a:off x="603504" y="1847088"/>
-            <a:ext cx="7946136" cy="1399032"/>
+            <a:off x="402336" y="301752"/>
+            <a:ext cx="8348472" cy="795528"/>
           </a:xfrm>
           <a:prstGeom prst="rect">
             <a:avLst/>
@@ -7671,24 +7649,167 @@
           <a:lstStyle/>
           <a:p>
             <a:r>
-              <a:rPr sz="3400" b="1">
-                <a:solidFill>
-                  <a:srgbClr val="FFFFFF"/>
-                </a:solidFill>
-                <a:latin typeface="Fira Sans"/>
-              </a:rPr>
-              <a:t>5. Cierre del módulo</a:t>
-            </a:r>
-          </a:p>
-          <a:p>
-            <a:r>
-              <a:rPr sz="1800" b="0">
+              <a:rPr sz="2800" b="1">
+                <a:solidFill>
+                  <a:srgbClr val="0F0F0F"/>
+                </a:solidFill>
+                <a:latin typeface="Fira Sans"/>
+              </a:rPr>
+              <a:t>En el código: cinco líneas</a:t>
+            </a:r>
+          </a:p>
+        </p:txBody>
+      </p:sp>
+      <p:sp>
+        <p:nvSpPr>
+          <p:cNvPr id="4" name="Rectangle 3"/>
+          <p:cNvSpPr/>
+          <p:nvPr/>
+        </p:nvSpPr>
+        <p:spPr>
+          <a:xfrm>
+            <a:off x="704088" y="1280160"/>
+            <a:ext cx="7744968" cy="2880360"/>
+          </a:xfrm>
+          <a:prstGeom prst="rect">
+            <a:avLst/>
+          </a:prstGeom>
+          <a:solidFill>
+            <a:srgbClr val="F0F2F5"/>
+          </a:solidFill>
+          <a:ln>
+            <a:solidFill>
+              <a:srgbClr val="D8DDE3"/>
+            </a:solidFill>
+          </a:ln>
+          <a:effectLst/>
+        </p:spPr>
+        <p:style>
+          <a:lnRef idx="1">
+            <a:schemeClr val="accent1"/>
+          </a:lnRef>
+          <a:fillRef idx="3">
+            <a:schemeClr val="accent1"/>
+          </a:fillRef>
+          <a:effectRef idx="2">
+            <a:schemeClr val="accent1"/>
+          </a:effectRef>
+          <a:fontRef idx="minor">
+            <a:schemeClr val="lt1"/>
+          </a:fontRef>
+        </p:style>
+        <p:txBody>
+          <a:bodyPr rtlCol="0" anchor="ctr" wrap="square" lIns="228600" tIns="137160"/>
+          <a:lstStyle/>
+          <a:p>
+            <a:pPr/>
+            <a:r>
+              <a:rPr sz="1500" b="0">
+                <a:solidFill>
+                  <a:srgbClr val="1D3557"/>
+                </a:solidFill>
+                <a:latin typeface="Menlo"/>
+              </a:rPr>
+              <a:t>Z = StandardScaler().fit_transform(X)  # 1. estandarizar</a:t>
+            </a:r>
+          </a:p>
+          <a:p>
+            <a:pPr/>
+            <a:r>
+              <a:rPr sz="1500" b="0">
+                <a:solidFill>
+                  <a:srgbClr val="1D3557"/>
+                </a:solidFill>
+                <a:latin typeface="Menlo"/>
+              </a:rPr>
+              <a:t>pca = PCA().fit(Z)                     # 2. las componentes</a:t>
+            </a:r>
+          </a:p>
+          <a:p>
+            <a:pPr/>
+            <a:r>
+              <a:rPr sz="1500" b="0">
+                <a:solidFill>
+                  <a:srgbClr val="1D3557"/>
+                </a:solidFill>
+                <a:latin typeface="Menlo"/>
+              </a:rPr>
+              <a:t>pca.explained_variance_ratio_          # 3. cuánto explica</a:t>
+            </a:r>
+          </a:p>
+          <a:p>
+            <a:pPr/>
+            <a:r>
+              <a:rPr sz="1500" b="0">
+                <a:solidFill>
+                  <a:srgbClr val="1D3557"/>
+                </a:solidFill>
+                <a:latin typeface="Menlo"/>
+              </a:rPr>
+              <a:t>pca.components_                        # 4. los pesos</a:t>
+            </a:r>
+          </a:p>
+          <a:p>
+            <a:pPr/>
+            <a:r>
+              <a:rPr sz="1500" b="0">
+                <a:solidFill>
+                  <a:srgbClr val="1D3557"/>
+                </a:solidFill>
+                <a:latin typeface="Menlo"/>
+              </a:rPr>
+              <a:t>puntajes = pca.transform(Z)            # 5. los puntajes</a:t>
+            </a:r>
+          </a:p>
+        </p:txBody>
+      </p:sp>
+      <p:sp>
+        <p:nvSpPr>
+          <p:cNvPr id="5" name="TextBox 4"/>
+          <p:cNvSpPr txBox="1"/>
+          <p:nvPr/>
+        </p:nvSpPr>
+        <p:spPr>
+          <a:xfrm>
+            <a:off x="704088" y="4389120"/>
+            <a:ext cx="7744968" cy="1097280"/>
+          </a:xfrm>
+          <a:prstGeom prst="rect">
+            <a:avLst/>
+          </a:prstGeom>
+          <a:noFill/>
+        </p:spPr>
+        <p:txBody>
+          <a:bodyPr wrap="square">
+            <a:spAutoFit/>
+          </a:bodyPr>
+          <a:lstStyle/>
+          <a:p>
+            <a:pPr>
+              <a:lnSpc>
+                <a:spcPct val="112000"/>
+              </a:lnSpc>
+              <a:spcAft>
+                <a:spcPts val="900"/>
+              </a:spcAft>
+            </a:pPr>
+            <a:r>
+              <a:rPr sz="1600" b="1">
                 <a:solidFill>
                   <a:srgbClr val="E0A437"/>
                 </a:solidFill>
                 <a:latin typeface="Fira Sans"/>
               </a:rPr>
-              <a:t>Ocho clases, un hilo</a:t>
+              <a:t>▸ </a:t>
+            </a:r>
+            <a:r>
+              <a:rPr sz="1600" b="0">
+                <a:solidFill>
+                  <a:srgbClr val="000000"/>
+                </a:solidFill>
+                <a:latin typeface="Fira Sans"/>
+              </a:rPr>
+              <a:t>El ejemplo completo, con las tablas de pesos y los gráficos de la clase, está en el notebook 08_componentes_principales.ipynb.</a:t>
             </a:r>
           </a:p>
         </p:txBody>
@@ -7726,7 +7847,7 @@
             <a:avLst/>
           </a:prstGeom>
           <a:solidFill>
-            <a:srgbClr val="FAFBFC"/>
+            <a:srgbClr val="1D3557"/>
           </a:solidFill>
           <a:ln>
             <a:noFill/>
@@ -7763,8 +7884,8 @@
         </p:nvSpPr>
         <p:spPr>
           <a:xfrm>
-            <a:off x="402336" y="301752"/>
-            <a:ext cx="8348472" cy="795528"/>
+            <a:off x="603504" y="1847088"/>
+            <a:ext cx="7946136" cy="1399032"/>
           </a:xfrm>
           <a:prstGeom prst="rect">
             <a:avLst/>
@@ -7778,71 +7899,24 @@
           <a:lstStyle/>
           <a:p>
             <a:r>
-              <a:rPr sz="2800" b="1">
-                <a:solidFill>
-                  <a:srgbClr val="0F0F0F"/>
-                </a:solidFill>
-                <a:latin typeface="Fira Sans"/>
-              </a:rPr>
-              <a:t>El módulo en una página</a:t>
-            </a:r>
-          </a:p>
-        </p:txBody>
-      </p:sp>
-      <p:pic>
-        <p:nvPicPr>
-          <p:cNvPr id="4" name="Picture 3" descr="c8_07_mapa_modulo.png"/>
-          <p:cNvPicPr>
-            <a:picLocks noChangeAspect="1"/>
-          </p:cNvPicPr>
-          <p:nvPr/>
-        </p:nvPicPr>
-        <p:blipFill>
-          <a:blip r:embed="rId2"/>
-          <a:stretch>
-            <a:fillRect/>
-          </a:stretch>
-        </p:blipFill>
-        <p:spPr>
-          <a:xfrm>
-            <a:off x="1029546" y="1143000"/>
-            <a:ext cx="7084906" cy="3099816"/>
-          </a:xfrm>
-          <a:prstGeom prst="rect">
-            <a:avLst/>
-          </a:prstGeom>
-        </p:spPr>
-      </p:pic>
-      <p:sp>
-        <p:nvSpPr>
-          <p:cNvPr id="5" name="TextBox 4"/>
-          <p:cNvSpPr txBox="1"/>
-          <p:nvPr/>
-        </p:nvSpPr>
-        <p:spPr>
-          <a:xfrm>
-            <a:off x="704088" y="4379976"/>
-            <a:ext cx="7744968" cy="512064"/>
-          </a:xfrm>
-          <a:prstGeom prst="rect">
-            <a:avLst/>
-          </a:prstGeom>
-          <a:noFill/>
-        </p:spPr>
-        <p:txBody>
-          <a:bodyPr wrap="square">
-            <a:spAutoFit/>
-          </a:bodyPr>
-          <a:lstStyle/>
-          <a:p>
-            <a:r>
-              <a:rPr sz="1300" b="0">
-                <a:solidFill>
-                  <a:srgbClr val="333333"/>
-                </a:solidFill>
-                <a:latin typeface="Fira Sans"/>
-              </a:rPr>
-              <a:t>Cada clase dejó una idea. Juntas, son lo que el módulo enseñó: cómo se llega de una pregunta y unos datos a un resultado, y cómo se lee ese resultado con su incertidumbre.</a:t>
+              <a:rPr sz="3400" b="1">
+                <a:solidFill>
+                  <a:srgbClr val="FFFFFF"/>
+                </a:solidFill>
+                <a:latin typeface="Fira Sans"/>
+              </a:rPr>
+              <a:t>5. Cierre del módulo</a:t>
+            </a:r>
+          </a:p>
+          <a:p>
+            <a:r>
+              <a:rPr sz="1800" b="0">
+                <a:solidFill>
+                  <a:srgbClr val="E0A437"/>
+                </a:solidFill>
+                <a:latin typeface="Fira Sans"/>
+              </a:rPr>
+              <a:t>Ocho clases, un hilo</a:t>
             </a:r>
           </a:p>
         </p:txBody>
@@ -7938,21 +8012,45 @@
                 </a:solidFill>
                 <a:latin typeface="Fira Sans"/>
               </a:rPr>
-              <a:t>Ahora: las presentaciones del avance</a:t>
-            </a:r>
-          </a:p>
-        </p:txBody>
-      </p:sp>
-      <p:sp>
-        <p:nvSpPr>
-          <p:cNvPr id="4" name="TextBox 3"/>
+              <a:t>El módulo en una página</a:t>
+            </a:r>
+          </a:p>
+        </p:txBody>
+      </p:sp>
+      <p:pic>
+        <p:nvPicPr>
+          <p:cNvPr id="4" name="Picture 3" descr="c8_07_mapa_modulo.png"/>
+          <p:cNvPicPr>
+            <a:picLocks noChangeAspect="1"/>
+          </p:cNvPicPr>
+          <p:nvPr/>
+        </p:nvPicPr>
+        <p:blipFill>
+          <a:blip r:embed="rId2"/>
+          <a:stretch>
+            <a:fillRect/>
+          </a:stretch>
+        </p:blipFill>
+        <p:spPr>
+          <a:xfrm>
+            <a:off x="1029546" y="1143000"/>
+            <a:ext cx="7084906" cy="3099816"/>
+          </a:xfrm>
+          <a:prstGeom prst="rect">
+            <a:avLst/>
+          </a:prstGeom>
+        </p:spPr>
+      </p:pic>
+      <p:sp>
+        <p:nvSpPr>
+          <p:cNvPr id="5" name="TextBox 4"/>
           <p:cNvSpPr txBox="1"/>
           <p:nvPr/>
         </p:nvSpPr>
         <p:spPr>
           <a:xfrm>
-            <a:off x="704088" y="1353312"/>
-            <a:ext cx="7744968" cy="3300984"/>
+            <a:off x="704088" y="4379976"/>
+            <a:ext cx="7744968" cy="512064"/>
           </a:xfrm>
           <a:prstGeom prst="rect">
             <a:avLst/>
@@ -7965,115 +8063,14 @@
           </a:bodyPr>
           <a:lstStyle/>
           <a:p>
-            <a:pPr>
-              <a:lnSpc>
-                <a:spcPct val="112000"/>
-              </a:lnSpc>
-              <a:spcAft>
-                <a:spcPts val="900"/>
-              </a:spcAft>
-            </a:pPr>
-            <a:r>
-              <a:rPr sz="1800" b="1">
-                <a:solidFill>
-                  <a:srgbClr val="E0A437"/>
-                </a:solidFill>
-                <a:latin typeface="Fira Sans"/>
-              </a:rPr>
-              <a:t>▸ </a:t>
-            </a:r>
-            <a:r>
-              <a:rPr sz="1800" b="1">
-                <a:solidFill>
-                  <a:srgbClr val="1D3557"/>
-                </a:solidFill>
-                <a:latin typeface="Fira Sans"/>
-              </a:rPr>
-              <a:t>Ocho equipos, en el orden en que se ofrezcan. Máximo 10 minutos por equipo; el tiempo se controla. Después, preguntas de la profesora y del curso.</a:t>
-            </a:r>
-          </a:p>
-          <a:p>
-            <a:pPr>
-              <a:lnSpc>
-                <a:spcPct val="112000"/>
-              </a:lnSpc>
-              <a:spcAft>
-                <a:spcPts val="900"/>
-              </a:spcAft>
-            </a:pPr>
-            <a:r>
-              <a:rPr sz="1800" b="1">
-                <a:solidFill>
-                  <a:srgbClr val="E0A437"/>
-                </a:solidFill>
-                <a:latin typeface="Fira Sans"/>
-              </a:rPr>
-              <a:t>▸ </a:t>
-            </a:r>
-            <a:r>
-              <a:rPr sz="1800" b="0">
-                <a:solidFill>
-                  <a:srgbClr val="000000"/>
-                </a:solidFill>
-                <a:latin typeface="Fira Sans"/>
-              </a:rPr>
-              <a:t>Se evalúa el avance, no un resultado final: el modelo es un primer intento. La exigencia está en el tiempo, la claridad, la explicación de los gráficos y las relaciones, y en advertir qué falta o qué no tiene sentido.</a:t>
-            </a:r>
-          </a:p>
-          <a:p>
-            <a:pPr>
-              <a:lnSpc>
-                <a:spcPct val="112000"/>
-              </a:lnSpc>
-              <a:spcAft>
-                <a:spcPts val="900"/>
-              </a:spcAft>
-            </a:pPr>
-            <a:r>
-              <a:rPr sz="1800" b="1">
-                <a:solidFill>
-                  <a:srgbClr val="E0A437"/>
-                </a:solidFill>
-                <a:latin typeface="Fira Sans"/>
-              </a:rPr>
-              <a:t>▸ </a:t>
-            </a:r>
-            <a:r>
-              <a:rPr sz="1800" b="0">
-                <a:solidFill>
-                  <a:srgbClr val="000000"/>
-                </a:solidFill>
-                <a:latin typeface="Fira Sans"/>
-              </a:rPr>
-              <a:t>Las slides, en PDF, al Aula hasta las 20:30: un envío por equipo con los nombres.</a:t>
-            </a:r>
-          </a:p>
-          <a:p>
-            <a:pPr>
-              <a:lnSpc>
-                <a:spcPct val="112000"/>
-              </a:lnSpc>
-              <a:spcAft>
-                <a:spcPts val="900"/>
-              </a:spcAft>
-            </a:pPr>
-            <a:r>
-              <a:rPr sz="1800" b="1">
-                <a:solidFill>
-                  <a:srgbClr val="E0A437"/>
-                </a:solidFill>
-                <a:latin typeface="Fira Sans"/>
-              </a:rPr>
-              <a:t>▸ </a:t>
-            </a:r>
-            <a:r>
-              <a:rPr sz="1800" b="0">
-                <a:solidFill>
-                  <a:srgbClr val="000000"/>
-                </a:solidFill>
-                <a:latin typeface="Fira Sans"/>
-              </a:rPr>
-              <a:t>El informe escrito, el viernes 25 de septiembre por el Aula: máximo 7 páginas, con su rúbrica publicada.</a:t>
+            <a:r>
+              <a:rPr sz="1300" b="0">
+                <a:solidFill>
+                  <a:srgbClr val="333333"/>
+                </a:solidFill>
+                <a:latin typeface="Fira Sans"/>
+              </a:rPr>
+              <a:t>Cada clase dejó una idea. Juntas, son lo que el módulo enseñó: cómo se llega de una pregunta y unos datos a un resultado, y cómo se lee ese resultado con su incertidumbre.</a:t>
             </a:r>
           </a:p>
         </p:txBody>
@@ -8087,6 +8084,237 @@
 </file>
 
 <file path=ppt/slides/slide34.xml><?xml version="1.0" encoding="utf-8"?>
+<p:sld xmlns:a="http://schemas.openxmlformats.org/drawingml/2006/main" xmlns:p="http://schemas.openxmlformats.org/presentationml/2006/main" xmlns:r="http://schemas.openxmlformats.org/officeDocument/2006/relationships">
+  <p:cSld>
+    <p:spTree>
+      <p:nvGrpSpPr>
+        <p:cNvPr id="1" name=""/>
+        <p:cNvGrpSpPr/>
+        <p:nvPr/>
+      </p:nvGrpSpPr>
+      <p:grpSpPr/>
+      <p:sp>
+        <p:nvSpPr>
+          <p:cNvPr id="2" name="Rectangle 1"/>
+          <p:cNvSpPr/>
+          <p:nvPr/>
+        </p:nvSpPr>
+        <p:spPr>
+          <a:xfrm>
+            <a:off x="0" y="0"/>
+            <a:ext cx="9144000" cy="5138928"/>
+          </a:xfrm>
+          <a:prstGeom prst="rect">
+            <a:avLst/>
+          </a:prstGeom>
+          <a:solidFill>
+            <a:srgbClr val="FAFBFC"/>
+          </a:solidFill>
+          <a:ln>
+            <a:noFill/>
+          </a:ln>
+          <a:effectLst/>
+        </p:spPr>
+        <p:style>
+          <a:lnRef idx="1">
+            <a:schemeClr val="accent1"/>
+          </a:lnRef>
+          <a:fillRef idx="3">
+            <a:schemeClr val="accent1"/>
+          </a:fillRef>
+          <a:effectRef idx="2">
+            <a:schemeClr val="accent1"/>
+          </a:effectRef>
+          <a:fontRef idx="minor">
+            <a:schemeClr val="lt1"/>
+          </a:fontRef>
+        </p:style>
+        <p:txBody>
+          <a:bodyPr rtlCol="0" anchor="ctr"/>
+          <a:lstStyle/>
+          <a:p>
+            <a:pPr algn="ctr"/>
+          </a:p>
+        </p:txBody>
+      </p:sp>
+      <p:sp>
+        <p:nvSpPr>
+          <p:cNvPr id="3" name="TextBox 2"/>
+          <p:cNvSpPr txBox="1"/>
+          <p:nvPr/>
+        </p:nvSpPr>
+        <p:spPr>
+          <a:xfrm>
+            <a:off x="402336" y="301752"/>
+            <a:ext cx="8348472" cy="795528"/>
+          </a:xfrm>
+          <a:prstGeom prst="rect">
+            <a:avLst/>
+          </a:prstGeom>
+          <a:noFill/>
+        </p:spPr>
+        <p:txBody>
+          <a:bodyPr wrap="square">
+            <a:spAutoFit/>
+          </a:bodyPr>
+          <a:lstStyle/>
+          <a:p>
+            <a:r>
+              <a:rPr sz="2800" b="1">
+                <a:solidFill>
+                  <a:srgbClr val="0F0F0F"/>
+                </a:solidFill>
+                <a:latin typeface="Fira Sans"/>
+              </a:rPr>
+              <a:t>Ahora: las presentaciones del avance</a:t>
+            </a:r>
+          </a:p>
+        </p:txBody>
+      </p:sp>
+      <p:sp>
+        <p:nvSpPr>
+          <p:cNvPr id="4" name="TextBox 3"/>
+          <p:cNvSpPr txBox="1"/>
+          <p:nvPr/>
+        </p:nvSpPr>
+        <p:spPr>
+          <a:xfrm>
+            <a:off x="704088" y="1353312"/>
+            <a:ext cx="7744968" cy="3300984"/>
+          </a:xfrm>
+          <a:prstGeom prst="rect">
+            <a:avLst/>
+          </a:prstGeom>
+          <a:noFill/>
+        </p:spPr>
+        <p:txBody>
+          <a:bodyPr wrap="square">
+            <a:spAutoFit/>
+          </a:bodyPr>
+          <a:lstStyle/>
+          <a:p>
+            <a:pPr>
+              <a:lnSpc>
+                <a:spcPct val="112000"/>
+              </a:lnSpc>
+              <a:spcAft>
+                <a:spcPts val="900"/>
+              </a:spcAft>
+            </a:pPr>
+            <a:r>
+              <a:rPr sz="1800" b="1">
+                <a:solidFill>
+                  <a:srgbClr val="E0A437"/>
+                </a:solidFill>
+                <a:latin typeface="Fira Sans"/>
+              </a:rPr>
+              <a:t>▸ </a:t>
+            </a:r>
+            <a:r>
+              <a:rPr sz="1800" b="1">
+                <a:solidFill>
+                  <a:srgbClr val="1D3557"/>
+                </a:solidFill>
+                <a:latin typeface="Fira Sans"/>
+              </a:rPr>
+              <a:t>Ocho equipos, en el orden en que se ofrezcan. Máximo 10 minutos por equipo; el tiempo se controla. Después, preguntas de la profesora y del curso.</a:t>
+            </a:r>
+          </a:p>
+          <a:p>
+            <a:pPr>
+              <a:lnSpc>
+                <a:spcPct val="112000"/>
+              </a:lnSpc>
+              <a:spcAft>
+                <a:spcPts val="900"/>
+              </a:spcAft>
+            </a:pPr>
+            <a:r>
+              <a:rPr sz="1800" b="1">
+                <a:solidFill>
+                  <a:srgbClr val="E0A437"/>
+                </a:solidFill>
+                <a:latin typeface="Fira Sans"/>
+              </a:rPr>
+              <a:t>▸ </a:t>
+            </a:r>
+            <a:r>
+              <a:rPr sz="1800" b="0">
+                <a:solidFill>
+                  <a:srgbClr val="000000"/>
+                </a:solidFill>
+                <a:latin typeface="Fira Sans"/>
+              </a:rPr>
+              <a:t>Se evalúa el avance, no un resultado final: el modelo es un primer intento. La exigencia está en el tiempo, la claridad, la explicación de los gráficos y las relaciones, y en advertir qué falta o qué no tiene sentido.</a:t>
+            </a:r>
+          </a:p>
+          <a:p>
+            <a:pPr>
+              <a:lnSpc>
+                <a:spcPct val="112000"/>
+              </a:lnSpc>
+              <a:spcAft>
+                <a:spcPts val="900"/>
+              </a:spcAft>
+            </a:pPr>
+            <a:r>
+              <a:rPr sz="1800" b="1">
+                <a:solidFill>
+                  <a:srgbClr val="E0A437"/>
+                </a:solidFill>
+                <a:latin typeface="Fira Sans"/>
+              </a:rPr>
+              <a:t>▸ </a:t>
+            </a:r>
+            <a:r>
+              <a:rPr sz="1800" b="0">
+                <a:solidFill>
+                  <a:srgbClr val="000000"/>
+                </a:solidFill>
+                <a:latin typeface="Fira Sans"/>
+              </a:rPr>
+              <a:t>Las slides, en PDF, al Aula hasta las 20:30: un envío por equipo con los nombres.</a:t>
+            </a:r>
+          </a:p>
+          <a:p>
+            <a:pPr>
+              <a:lnSpc>
+                <a:spcPct val="112000"/>
+              </a:lnSpc>
+              <a:spcAft>
+                <a:spcPts val="900"/>
+              </a:spcAft>
+            </a:pPr>
+            <a:r>
+              <a:rPr sz="1800" b="1">
+                <a:solidFill>
+                  <a:srgbClr val="E0A437"/>
+                </a:solidFill>
+                <a:latin typeface="Fira Sans"/>
+              </a:rPr>
+              <a:t>▸ </a:t>
+            </a:r>
+            <a:r>
+              <a:rPr sz="1800" b="0">
+                <a:solidFill>
+                  <a:srgbClr val="000000"/>
+                </a:solidFill>
+                <a:latin typeface="Fira Sans"/>
+              </a:rPr>
+              <a:t>El informe escrito, el viernes 25 de septiembre por el Aula: máximo 7 páginas, con su rúbrica publicada.</a:t>
+            </a:r>
+          </a:p>
+        </p:txBody>
+      </p:sp>
+    </p:spTree>
+  </p:cSld>
+  <p:clrMapOvr>
+    <a:masterClrMapping/>
+  </p:clrMapOvr>
+</p:sld>
+</file>
+
+<file path=ppt/slides/slide35.xml><?xml version="1.0" encoding="utf-8"?>
 <p:sld xmlns:a="http://schemas.openxmlformats.org/drawingml/2006/main" xmlns:p="http://schemas.openxmlformats.org/presentationml/2006/main" xmlns:r="http://schemas.openxmlformats.org/officeDocument/2006/relationships">
   <p:cSld>
     <p:spTree>

</xml_diff>

<commit_message>
Clase 8: anexo con la componente de un jugador paso a paso (41 slides)
Cinco slides despues de las referencias, que no se exponen: la posicion
del jugador en la regla, el camino en dos tramos, la sombra de cada
tramo sobre el eje, por que se multiplica por 0,707 y la cuenta completa.

Co-Authored-By: Claude Fable 5.1 <noreply@anthropic.com>
</commit_message>
<xml_diff>
--- a/presentaciones/clase08_componentes_principales.pptx
+++ b/presentaciones/clase08_componentes_principales.pptx
@@ -40,6 +40,12 @@
     <p:sldId id="288" r:id="rId39"/>
     <p:sldId id="289" r:id="rId40"/>
     <p:sldId id="290" r:id="rId41"/>
+    <p:sldId id="291" r:id="rId42"/>
+    <p:sldId id="292" r:id="rId43"/>
+    <p:sldId id="293" r:id="rId44"/>
+    <p:sldId id="294" r:id="rId45"/>
+    <p:sldId id="295" r:id="rId46"/>
+    <p:sldId id="296" r:id="rId47"/>
   </p:sldIdLst>
   <p:sldSz cx="9144000" cy="5138928" type="screen4x3"/>
   <p:notesSz cx="6858000" cy="9144000"/>
@@ -8509,6 +8515,766 @@
 </p:sld>
 </file>
 
+<file path=ppt/slides/slide36.xml><?xml version="1.0" encoding="utf-8"?>
+<p:sld xmlns:a="http://schemas.openxmlformats.org/drawingml/2006/main" xmlns:p="http://schemas.openxmlformats.org/presentationml/2006/main" xmlns:r="http://schemas.openxmlformats.org/officeDocument/2006/relationships">
+  <p:cSld>
+    <p:spTree>
+      <p:nvGrpSpPr>
+        <p:cNvPr id="1" name=""/>
+        <p:cNvGrpSpPr/>
+        <p:nvPr/>
+      </p:nvGrpSpPr>
+      <p:grpSpPr/>
+      <p:sp>
+        <p:nvSpPr>
+          <p:cNvPr id="2" name="Rectangle 1"/>
+          <p:cNvSpPr/>
+          <p:nvPr/>
+        </p:nvSpPr>
+        <p:spPr>
+          <a:xfrm>
+            <a:off x="0" y="0"/>
+            <a:ext cx="9144000" cy="5138928"/>
+          </a:xfrm>
+          <a:prstGeom prst="rect">
+            <a:avLst/>
+          </a:prstGeom>
+          <a:solidFill>
+            <a:srgbClr val="1D3557"/>
+          </a:solidFill>
+          <a:ln>
+            <a:noFill/>
+          </a:ln>
+          <a:effectLst/>
+        </p:spPr>
+        <p:style>
+          <a:lnRef idx="1">
+            <a:schemeClr val="accent1"/>
+          </a:lnRef>
+          <a:fillRef idx="3">
+            <a:schemeClr val="accent1"/>
+          </a:fillRef>
+          <a:effectRef idx="2">
+            <a:schemeClr val="accent1"/>
+          </a:effectRef>
+          <a:fontRef idx="minor">
+            <a:schemeClr val="lt1"/>
+          </a:fontRef>
+        </p:style>
+        <p:txBody>
+          <a:bodyPr rtlCol="0" anchor="ctr"/>
+          <a:lstStyle/>
+          <a:p>
+            <a:pPr algn="ctr"/>
+          </a:p>
+        </p:txBody>
+      </p:sp>
+      <p:sp>
+        <p:nvSpPr>
+          <p:cNvPr id="3" name="TextBox 2"/>
+          <p:cNvSpPr txBox="1"/>
+          <p:nvPr/>
+        </p:nvSpPr>
+        <p:spPr>
+          <a:xfrm>
+            <a:off x="603504" y="1847088"/>
+            <a:ext cx="7946136" cy="1399032"/>
+          </a:xfrm>
+          <a:prstGeom prst="rect">
+            <a:avLst/>
+          </a:prstGeom>
+          <a:noFill/>
+        </p:spPr>
+        <p:txBody>
+          <a:bodyPr wrap="square">
+            <a:spAutoFit/>
+          </a:bodyPr>
+          <a:lstStyle/>
+          <a:p>
+            <a:r>
+              <a:rPr sz="3400" b="1">
+                <a:solidFill>
+                  <a:srgbClr val="FFFFFF"/>
+                </a:solidFill>
+                <a:latin typeface="Fira Sans"/>
+              </a:rPr>
+              <a:t>Anexo</a:t>
+            </a:r>
+          </a:p>
+          <a:p>
+            <a:r>
+              <a:rPr sz="1800" b="0">
+                <a:solidFill>
+                  <a:srgbClr val="E0A437"/>
+                </a:solidFill>
+                <a:latin typeface="Fira Sans"/>
+              </a:rPr>
+              <a:t>Cómo se calcula la componente de un jugador, paso a paso</a:t>
+            </a:r>
+          </a:p>
+        </p:txBody>
+      </p:sp>
+    </p:spTree>
+  </p:cSld>
+  <p:clrMapOvr>
+    <a:masterClrMapping/>
+  </p:clrMapOvr>
+</p:sld>
+</file>
+
+<file path=ppt/slides/slide37.xml><?xml version="1.0" encoding="utf-8"?>
+<p:sld xmlns:a="http://schemas.openxmlformats.org/drawingml/2006/main" xmlns:p="http://schemas.openxmlformats.org/presentationml/2006/main" xmlns:r="http://schemas.openxmlformats.org/officeDocument/2006/relationships">
+  <p:cSld>
+    <p:spTree>
+      <p:nvGrpSpPr>
+        <p:cNvPr id="1" name=""/>
+        <p:cNvGrpSpPr/>
+        <p:nvPr/>
+      </p:nvGrpSpPr>
+      <p:grpSpPr/>
+      <p:sp>
+        <p:nvSpPr>
+          <p:cNvPr id="2" name="Rectangle 1"/>
+          <p:cNvSpPr/>
+          <p:nvPr/>
+        </p:nvSpPr>
+        <p:spPr>
+          <a:xfrm>
+            <a:off x="0" y="0"/>
+            <a:ext cx="9144000" cy="5138928"/>
+          </a:xfrm>
+          <a:prstGeom prst="rect">
+            <a:avLst/>
+          </a:prstGeom>
+          <a:solidFill>
+            <a:srgbClr val="FAFBFC"/>
+          </a:solidFill>
+          <a:ln>
+            <a:noFill/>
+          </a:ln>
+          <a:effectLst/>
+        </p:spPr>
+        <p:style>
+          <a:lnRef idx="1">
+            <a:schemeClr val="accent1"/>
+          </a:lnRef>
+          <a:fillRef idx="3">
+            <a:schemeClr val="accent1"/>
+          </a:fillRef>
+          <a:effectRef idx="2">
+            <a:schemeClr val="accent1"/>
+          </a:effectRef>
+          <a:fontRef idx="minor">
+            <a:schemeClr val="lt1"/>
+          </a:fontRef>
+        </p:style>
+        <p:txBody>
+          <a:bodyPr rtlCol="0" anchor="ctr"/>
+          <a:lstStyle/>
+          <a:p>
+            <a:pPr algn="ctr"/>
+          </a:p>
+        </p:txBody>
+      </p:sp>
+      <p:sp>
+        <p:nvSpPr>
+          <p:cNvPr id="3" name="TextBox 2"/>
+          <p:cNvSpPr txBox="1"/>
+          <p:nvPr/>
+        </p:nvSpPr>
+        <p:spPr>
+          <a:xfrm>
+            <a:off x="402336" y="301752"/>
+            <a:ext cx="8348472" cy="795528"/>
+          </a:xfrm>
+          <a:prstGeom prst="rect">
+            <a:avLst/>
+          </a:prstGeom>
+          <a:noFill/>
+        </p:spPr>
+        <p:txBody>
+          <a:bodyPr wrap="square">
+            <a:spAutoFit/>
+          </a:bodyPr>
+          <a:lstStyle/>
+          <a:p>
+            <a:r>
+              <a:rPr sz="2800" b="1">
+                <a:solidFill>
+                  <a:srgbClr val="0F0F0F"/>
+                </a:solidFill>
+                <a:latin typeface="Fira Sans"/>
+              </a:rPr>
+              <a:t>Anexo 1. El jugador y su posición en el eje</a:t>
+            </a:r>
+          </a:p>
+        </p:txBody>
+      </p:sp>
+      <p:pic>
+        <p:nvPicPr>
+          <p:cNvPr id="4" name="Picture 3" descr="c8_anexo_1_posicion.png"/>
+          <p:cNvPicPr>
+            <a:picLocks noChangeAspect="1"/>
+          </p:cNvPicPr>
+          <p:nvPr/>
+        </p:nvPicPr>
+        <p:blipFill>
+          <a:blip r:embed="rId2"/>
+          <a:stretch>
+            <a:fillRect/>
+          </a:stretch>
+        </p:blipFill>
+        <p:spPr>
+          <a:xfrm>
+            <a:off x="320040" y="1097280"/>
+            <a:ext cx="3756280" cy="3886200"/>
+          </a:xfrm>
+          <a:prstGeom prst="rect">
+            <a:avLst/>
+          </a:prstGeom>
+        </p:spPr>
+      </p:pic>
+      <p:sp>
+        <p:nvSpPr>
+          <p:cNvPr id="5" name="TextBox 4"/>
+          <p:cNvSpPr txBox="1"/>
+          <p:nvPr/>
+        </p:nvSpPr>
+        <p:spPr>
+          <a:xfrm>
+            <a:off x="4304920" y="1325880"/>
+            <a:ext cx="4519039" cy="3566160"/>
+          </a:xfrm>
+          <a:prstGeom prst="rect">
+            <a:avLst/>
+          </a:prstGeom>
+          <a:noFill/>
+        </p:spPr>
+        <p:txBody>
+          <a:bodyPr wrap="square">
+            <a:spAutoFit/>
+          </a:bodyPr>
+          <a:lstStyle/>
+          <a:p>
+            <a:pPr>
+              <a:lnSpc>
+                <a:spcPct val="112000"/>
+              </a:lnSpc>
+              <a:spcAft>
+                <a:spcPts val="900"/>
+              </a:spcAft>
+            </a:pPr>
+            <a:r>
+              <a:rPr sz="1500" b="1">
+                <a:solidFill>
+                  <a:srgbClr val="E0A437"/>
+                </a:solidFill>
+                <a:latin typeface="Fira Sans"/>
+              </a:rPr>
+              <a:t>▸ </a:t>
+            </a:r>
+            <a:r>
+              <a:rPr sz="1500" b="1">
+                <a:solidFill>
+                  <a:srgbClr val="1D3557"/>
+                </a:solidFill>
+                <a:latin typeface="Fira Sans"/>
+              </a:rPr>
+              <a:t>Un jugador con 5.409 turnos y 1.338 hits en la carrera: estandarizado, queda en (1,21; 0,95).</a:t>
+            </a:r>
+          </a:p>
+          <a:p>
+            <a:pPr>
+              <a:lnSpc>
+                <a:spcPct val="112000"/>
+              </a:lnSpc>
+              <a:spcAft>
+                <a:spcPts val="900"/>
+              </a:spcAft>
+            </a:pPr>
+            <a:r>
+              <a:rPr sz="1500" b="1">
+                <a:solidFill>
+                  <a:srgbClr val="E0A437"/>
+                </a:solidFill>
+                <a:latin typeface="Fira Sans"/>
+              </a:rPr>
+              <a:t>▸ </a:t>
+            </a:r>
+            <a:r>
+              <a:rPr sz="1500" b="0">
+                <a:solidFill>
+                  <a:srgbClr val="000000"/>
+                </a:solidFill>
+                <a:latin typeface="Fira Sans"/>
+              </a:rPr>
+              <a:t>Del punto se baja la perpendicular al eje nuevo y se lee la regla: 1,53.</a:t>
+            </a:r>
+          </a:p>
+          <a:p>
+            <a:pPr>
+              <a:lnSpc>
+                <a:spcPct val="112000"/>
+              </a:lnSpc>
+              <a:spcAft>
+                <a:spcPts val="900"/>
+              </a:spcAft>
+            </a:pPr>
+            <a:r>
+              <a:rPr sz="1500" b="1">
+                <a:solidFill>
+                  <a:srgbClr val="E0A437"/>
+                </a:solidFill>
+                <a:latin typeface="Fira Sans"/>
+              </a:rPr>
+              <a:t>▸ </a:t>
+            </a:r>
+            <a:r>
+              <a:rPr sz="1500" b="0">
+                <a:solidFill>
+                  <a:srgbClr val="000000"/>
+                </a:solidFill>
+                <a:latin typeface="Fira Sans"/>
+              </a:rPr>
+              <a:t>Ese número es su primera componente. Lo que sigue muestra de dónde sale el 1,53 sin mirar el dibujo.</a:t>
+            </a:r>
+          </a:p>
+        </p:txBody>
+      </p:sp>
+    </p:spTree>
+  </p:cSld>
+  <p:clrMapOvr>
+    <a:masterClrMapping/>
+  </p:clrMapOvr>
+</p:sld>
+</file>
+
+<file path=ppt/slides/slide38.xml><?xml version="1.0" encoding="utf-8"?>
+<p:sld xmlns:a="http://schemas.openxmlformats.org/drawingml/2006/main" xmlns:p="http://schemas.openxmlformats.org/presentationml/2006/main" xmlns:r="http://schemas.openxmlformats.org/officeDocument/2006/relationships">
+  <p:cSld>
+    <p:spTree>
+      <p:nvGrpSpPr>
+        <p:cNvPr id="1" name=""/>
+        <p:cNvGrpSpPr/>
+        <p:nvPr/>
+      </p:nvGrpSpPr>
+      <p:grpSpPr/>
+      <p:sp>
+        <p:nvSpPr>
+          <p:cNvPr id="2" name="Rectangle 1"/>
+          <p:cNvSpPr/>
+          <p:nvPr/>
+        </p:nvSpPr>
+        <p:spPr>
+          <a:xfrm>
+            <a:off x="0" y="0"/>
+            <a:ext cx="9144000" cy="5138928"/>
+          </a:xfrm>
+          <a:prstGeom prst="rect">
+            <a:avLst/>
+          </a:prstGeom>
+          <a:solidFill>
+            <a:srgbClr val="FAFBFC"/>
+          </a:solidFill>
+          <a:ln>
+            <a:noFill/>
+          </a:ln>
+          <a:effectLst/>
+        </p:spPr>
+        <p:style>
+          <a:lnRef idx="1">
+            <a:schemeClr val="accent1"/>
+          </a:lnRef>
+          <a:fillRef idx="3">
+            <a:schemeClr val="accent1"/>
+          </a:fillRef>
+          <a:effectRef idx="2">
+            <a:schemeClr val="accent1"/>
+          </a:effectRef>
+          <a:fontRef idx="minor">
+            <a:schemeClr val="lt1"/>
+          </a:fontRef>
+        </p:style>
+        <p:txBody>
+          <a:bodyPr rtlCol="0" anchor="ctr"/>
+          <a:lstStyle/>
+          <a:p>
+            <a:pPr algn="ctr"/>
+          </a:p>
+        </p:txBody>
+      </p:sp>
+      <p:sp>
+        <p:nvSpPr>
+          <p:cNvPr id="3" name="TextBox 2"/>
+          <p:cNvSpPr txBox="1"/>
+          <p:nvPr/>
+        </p:nvSpPr>
+        <p:spPr>
+          <a:xfrm>
+            <a:off x="402336" y="301752"/>
+            <a:ext cx="8348472" cy="795528"/>
+          </a:xfrm>
+          <a:prstGeom prst="rect">
+            <a:avLst/>
+          </a:prstGeom>
+          <a:noFill/>
+        </p:spPr>
+        <p:txBody>
+          <a:bodyPr wrap="square">
+            <a:spAutoFit/>
+          </a:bodyPr>
+          <a:lstStyle/>
+          <a:p>
+            <a:r>
+              <a:rPr sz="2800" b="1">
+                <a:solidFill>
+                  <a:srgbClr val="0F0F0F"/>
+                </a:solidFill>
+                <a:latin typeface="Fira Sans"/>
+              </a:rPr>
+              <a:t>Anexo 2. Del centro al jugador en dos tramos</a:t>
+            </a:r>
+          </a:p>
+        </p:txBody>
+      </p:sp>
+      <p:pic>
+        <p:nvPicPr>
+          <p:cNvPr id="4" name="Picture 3" descr="c8_anexo_2_tramos.png"/>
+          <p:cNvPicPr>
+            <a:picLocks noChangeAspect="1"/>
+          </p:cNvPicPr>
+          <p:nvPr/>
+        </p:nvPicPr>
+        <p:blipFill>
+          <a:blip r:embed="rId2"/>
+          <a:stretch>
+            <a:fillRect/>
+          </a:stretch>
+        </p:blipFill>
+        <p:spPr>
+          <a:xfrm>
+            <a:off x="320040" y="1097280"/>
+            <a:ext cx="3756280" cy="3886200"/>
+          </a:xfrm>
+          <a:prstGeom prst="rect">
+            <a:avLst/>
+          </a:prstGeom>
+        </p:spPr>
+      </p:pic>
+      <p:sp>
+        <p:nvSpPr>
+          <p:cNvPr id="5" name="TextBox 4"/>
+          <p:cNvSpPr txBox="1"/>
+          <p:nvPr/>
+        </p:nvSpPr>
+        <p:spPr>
+          <a:xfrm>
+            <a:off x="4304920" y="1325880"/>
+            <a:ext cx="4519039" cy="3566160"/>
+          </a:xfrm>
+          <a:prstGeom prst="rect">
+            <a:avLst/>
+          </a:prstGeom>
+          <a:noFill/>
+        </p:spPr>
+        <p:txBody>
+          <a:bodyPr wrap="square">
+            <a:spAutoFit/>
+          </a:bodyPr>
+          <a:lstStyle/>
+          <a:p>
+            <a:pPr>
+              <a:lnSpc>
+                <a:spcPct val="112000"/>
+              </a:lnSpc>
+              <a:spcAft>
+                <a:spcPts val="900"/>
+              </a:spcAft>
+            </a:pPr>
+            <a:r>
+              <a:rPr sz="1500" b="1">
+                <a:solidFill>
+                  <a:srgbClr val="E0A437"/>
+                </a:solidFill>
+                <a:latin typeface="Fira Sans"/>
+              </a:rPr>
+              <a:t>▸ </a:t>
+            </a:r>
+            <a:r>
+              <a:rPr sz="1500" b="1">
+                <a:solidFill>
+                  <a:srgbClr val="1D3557"/>
+                </a:solidFill>
+                <a:latin typeface="Fira Sans"/>
+              </a:rPr>
+              <a:t>Para llegar al jugador se camina primero 1,21 por turnos y después 0,95 por hits.</a:t>
+            </a:r>
+          </a:p>
+          <a:p>
+            <a:pPr>
+              <a:lnSpc>
+                <a:spcPct val="112000"/>
+              </a:lnSpc>
+              <a:spcAft>
+                <a:spcPts val="900"/>
+              </a:spcAft>
+            </a:pPr>
+            <a:r>
+              <a:rPr sz="1500" b="1">
+                <a:solidFill>
+                  <a:srgbClr val="E0A437"/>
+                </a:solidFill>
+                <a:latin typeface="Fira Sans"/>
+              </a:rPr>
+              <a:t>▸ </a:t>
+            </a:r>
+            <a:r>
+              <a:rPr sz="1500" b="0">
+                <a:solidFill>
+                  <a:srgbClr val="000000"/>
+                </a:solidFill>
+                <a:latin typeface="Fira Sans"/>
+              </a:rPr>
+              <a:t>Los dos tramos son sus dos coordenadas estandarizadas.</a:t>
+            </a:r>
+          </a:p>
+        </p:txBody>
+      </p:sp>
+    </p:spTree>
+  </p:cSld>
+  <p:clrMapOvr>
+    <a:masterClrMapping/>
+  </p:clrMapOvr>
+</p:sld>
+</file>
+
+<file path=ppt/slides/slide39.xml><?xml version="1.0" encoding="utf-8"?>
+<p:sld xmlns:a="http://schemas.openxmlformats.org/drawingml/2006/main" xmlns:p="http://schemas.openxmlformats.org/presentationml/2006/main" xmlns:r="http://schemas.openxmlformats.org/officeDocument/2006/relationships">
+  <p:cSld>
+    <p:spTree>
+      <p:nvGrpSpPr>
+        <p:cNvPr id="1" name=""/>
+        <p:cNvGrpSpPr/>
+        <p:nvPr/>
+      </p:nvGrpSpPr>
+      <p:grpSpPr/>
+      <p:sp>
+        <p:nvSpPr>
+          <p:cNvPr id="2" name="Rectangle 1"/>
+          <p:cNvSpPr/>
+          <p:nvPr/>
+        </p:nvSpPr>
+        <p:spPr>
+          <a:xfrm>
+            <a:off x="0" y="0"/>
+            <a:ext cx="9144000" cy="5138928"/>
+          </a:xfrm>
+          <a:prstGeom prst="rect">
+            <a:avLst/>
+          </a:prstGeom>
+          <a:solidFill>
+            <a:srgbClr val="FAFBFC"/>
+          </a:solidFill>
+          <a:ln>
+            <a:noFill/>
+          </a:ln>
+          <a:effectLst/>
+        </p:spPr>
+        <p:style>
+          <a:lnRef idx="1">
+            <a:schemeClr val="accent1"/>
+          </a:lnRef>
+          <a:fillRef idx="3">
+            <a:schemeClr val="accent1"/>
+          </a:fillRef>
+          <a:effectRef idx="2">
+            <a:schemeClr val="accent1"/>
+          </a:effectRef>
+          <a:fontRef idx="minor">
+            <a:schemeClr val="lt1"/>
+          </a:fontRef>
+        </p:style>
+        <p:txBody>
+          <a:bodyPr rtlCol="0" anchor="ctr"/>
+          <a:lstStyle/>
+          <a:p>
+            <a:pPr algn="ctr"/>
+          </a:p>
+        </p:txBody>
+      </p:sp>
+      <p:sp>
+        <p:nvSpPr>
+          <p:cNvPr id="3" name="TextBox 2"/>
+          <p:cNvSpPr txBox="1"/>
+          <p:nvPr/>
+        </p:nvSpPr>
+        <p:spPr>
+          <a:xfrm>
+            <a:off x="402336" y="301752"/>
+            <a:ext cx="8348472" cy="795528"/>
+          </a:xfrm>
+          <a:prstGeom prst="rect">
+            <a:avLst/>
+          </a:prstGeom>
+          <a:noFill/>
+        </p:spPr>
+        <p:txBody>
+          <a:bodyPr wrap="square">
+            <a:spAutoFit/>
+          </a:bodyPr>
+          <a:lstStyle/>
+          <a:p>
+            <a:r>
+              <a:rPr sz="2800" b="1">
+                <a:solidFill>
+                  <a:srgbClr val="0F0F0F"/>
+                </a:solidFill>
+                <a:latin typeface="Fira Sans"/>
+              </a:rPr>
+              <a:t>Anexo 3. Cada tramo proyecta su sombra</a:t>
+            </a:r>
+          </a:p>
+        </p:txBody>
+      </p:sp>
+      <p:pic>
+        <p:nvPicPr>
+          <p:cNvPr id="4" name="Picture 3" descr="c8_anexo_3_sombras.png"/>
+          <p:cNvPicPr>
+            <a:picLocks noChangeAspect="1"/>
+          </p:cNvPicPr>
+          <p:nvPr/>
+        </p:nvPicPr>
+        <p:blipFill>
+          <a:blip r:embed="rId2"/>
+          <a:stretch>
+            <a:fillRect/>
+          </a:stretch>
+        </p:blipFill>
+        <p:spPr>
+          <a:xfrm>
+            <a:off x="320040" y="1097280"/>
+            <a:ext cx="3756280" cy="3886200"/>
+          </a:xfrm>
+          <a:prstGeom prst="rect">
+            <a:avLst/>
+          </a:prstGeom>
+        </p:spPr>
+      </p:pic>
+      <p:sp>
+        <p:nvSpPr>
+          <p:cNvPr id="5" name="TextBox 4"/>
+          <p:cNvSpPr txBox="1"/>
+          <p:nvPr/>
+        </p:nvSpPr>
+        <p:spPr>
+          <a:xfrm>
+            <a:off x="4304920" y="1325880"/>
+            <a:ext cx="4519039" cy="3566160"/>
+          </a:xfrm>
+          <a:prstGeom prst="rect">
+            <a:avLst/>
+          </a:prstGeom>
+          <a:noFill/>
+        </p:spPr>
+        <p:txBody>
+          <a:bodyPr wrap="square">
+            <a:spAutoFit/>
+          </a:bodyPr>
+          <a:lstStyle/>
+          <a:p>
+            <a:pPr>
+              <a:lnSpc>
+                <a:spcPct val="112000"/>
+              </a:lnSpc>
+              <a:spcAft>
+                <a:spcPts val="900"/>
+              </a:spcAft>
+            </a:pPr>
+            <a:r>
+              <a:rPr sz="1500" b="1">
+                <a:solidFill>
+                  <a:srgbClr val="E0A437"/>
+                </a:solidFill>
+                <a:latin typeface="Fira Sans"/>
+              </a:rPr>
+              <a:t>▸ </a:t>
+            </a:r>
+            <a:r>
+              <a:rPr sz="1500" b="1">
+                <a:solidFill>
+                  <a:srgbClr val="1D3557"/>
+                </a:solidFill>
+                <a:latin typeface="Fira Sans"/>
+              </a:rPr>
+              <a:t>Sombra del tramo 1 sobre el eje: 1,21 × 0,707 = 0,85.</a:t>
+            </a:r>
+          </a:p>
+          <a:p>
+            <a:pPr>
+              <a:lnSpc>
+                <a:spcPct val="112000"/>
+              </a:lnSpc>
+              <a:spcAft>
+                <a:spcPts val="900"/>
+              </a:spcAft>
+            </a:pPr>
+            <a:r>
+              <a:rPr sz="1500" b="1">
+                <a:solidFill>
+                  <a:srgbClr val="E0A437"/>
+                </a:solidFill>
+                <a:latin typeface="Fira Sans"/>
+              </a:rPr>
+              <a:t>▸ </a:t>
+            </a:r>
+            <a:r>
+              <a:rPr sz="1500" b="0">
+                <a:solidFill>
+                  <a:srgbClr val="000000"/>
+                </a:solidFill>
+                <a:latin typeface="Fira Sans"/>
+              </a:rPr>
+              <a:t>Sombra del tramo 2: 0,95 × 0,707 = 0,67.</a:t>
+            </a:r>
+          </a:p>
+          <a:p>
+            <a:pPr>
+              <a:lnSpc>
+                <a:spcPct val="112000"/>
+              </a:lnSpc>
+              <a:spcAft>
+                <a:spcPts val="900"/>
+              </a:spcAft>
+            </a:pPr>
+            <a:r>
+              <a:rPr sz="1500" b="1">
+                <a:solidFill>
+                  <a:srgbClr val="E0A437"/>
+                </a:solidFill>
+                <a:latin typeface="Fira Sans"/>
+              </a:rPr>
+              <a:t>▸ </a:t>
+            </a:r>
+            <a:r>
+              <a:rPr sz="1500" b="0">
+                <a:solidFill>
+                  <a:srgbClr val="000000"/>
+                </a:solidFill>
+                <a:latin typeface="Fira Sans"/>
+              </a:rPr>
+              <a:t>Las sombras se ponen una a continuación de la otra y suman 0,85 + 0,67 = 1,53: el mismo número del anexo 1.</a:t>
+            </a:r>
+          </a:p>
+        </p:txBody>
+      </p:sp>
+    </p:spTree>
+  </p:cSld>
+  <p:clrMapOvr>
+    <a:masterClrMapping/>
+  </p:clrMapOvr>
+</p:sld>
+</file>
+
 <file path=ppt/slides/slide4.xml><?xml version="1.0" encoding="utf-8"?>
 <p:sld xmlns:a="http://schemas.openxmlformats.org/drawingml/2006/main" xmlns:p="http://schemas.openxmlformats.org/presentationml/2006/main" xmlns:r="http://schemas.openxmlformats.org/officeDocument/2006/relationships">
   <p:cSld>
@@ -8728,6 +9494,464 @@
                 <a:latin typeface="Fira Sans"/>
               </a:rPr>
               <a:t>Con los números del béisbol de la clase 7: 16 variables que, en lo esencial, son dos.</a:t>
+            </a:r>
+          </a:p>
+        </p:txBody>
+      </p:sp>
+    </p:spTree>
+  </p:cSld>
+  <p:clrMapOvr>
+    <a:masterClrMapping/>
+  </p:clrMapOvr>
+</p:sld>
+</file>
+
+<file path=ppt/slides/slide40.xml><?xml version="1.0" encoding="utf-8"?>
+<p:sld xmlns:a="http://schemas.openxmlformats.org/drawingml/2006/main" xmlns:p="http://schemas.openxmlformats.org/presentationml/2006/main" xmlns:r="http://schemas.openxmlformats.org/officeDocument/2006/relationships">
+  <p:cSld>
+    <p:spTree>
+      <p:nvGrpSpPr>
+        <p:cNvPr id="1" name=""/>
+        <p:cNvGrpSpPr/>
+        <p:nvPr/>
+      </p:nvGrpSpPr>
+      <p:grpSpPr/>
+      <p:sp>
+        <p:nvSpPr>
+          <p:cNvPr id="2" name="Rectangle 1"/>
+          <p:cNvSpPr/>
+          <p:nvPr/>
+        </p:nvSpPr>
+        <p:spPr>
+          <a:xfrm>
+            <a:off x="0" y="0"/>
+            <a:ext cx="9144000" cy="5138928"/>
+          </a:xfrm>
+          <a:prstGeom prst="rect">
+            <a:avLst/>
+          </a:prstGeom>
+          <a:solidFill>
+            <a:srgbClr val="FAFBFC"/>
+          </a:solidFill>
+          <a:ln>
+            <a:noFill/>
+          </a:ln>
+          <a:effectLst/>
+        </p:spPr>
+        <p:style>
+          <a:lnRef idx="1">
+            <a:schemeClr val="accent1"/>
+          </a:lnRef>
+          <a:fillRef idx="3">
+            <a:schemeClr val="accent1"/>
+          </a:fillRef>
+          <a:effectRef idx="2">
+            <a:schemeClr val="accent1"/>
+          </a:effectRef>
+          <a:fontRef idx="minor">
+            <a:schemeClr val="lt1"/>
+          </a:fontRef>
+        </p:style>
+        <p:txBody>
+          <a:bodyPr rtlCol="0" anchor="ctr"/>
+          <a:lstStyle/>
+          <a:p>
+            <a:pPr algn="ctr"/>
+          </a:p>
+        </p:txBody>
+      </p:sp>
+      <p:sp>
+        <p:nvSpPr>
+          <p:cNvPr id="3" name="TextBox 2"/>
+          <p:cNvSpPr txBox="1"/>
+          <p:nvPr/>
+        </p:nvSpPr>
+        <p:spPr>
+          <a:xfrm>
+            <a:off x="402336" y="301752"/>
+            <a:ext cx="8348472" cy="795528"/>
+          </a:xfrm>
+          <a:prstGeom prst="rect">
+            <a:avLst/>
+          </a:prstGeom>
+          <a:noFill/>
+        </p:spPr>
+        <p:txBody>
+          <a:bodyPr wrap="square">
+            <a:spAutoFit/>
+          </a:bodyPr>
+          <a:lstStyle/>
+          <a:p>
+            <a:r>
+              <a:rPr sz="2800" b="1">
+                <a:solidFill>
+                  <a:srgbClr val="0F0F0F"/>
+                </a:solidFill>
+                <a:latin typeface="Fira Sans"/>
+              </a:rPr>
+              <a:t>Anexo 4. Por qué se multiplica por 0,707</a:t>
+            </a:r>
+          </a:p>
+        </p:txBody>
+      </p:sp>
+      <p:pic>
+        <p:nvPicPr>
+          <p:cNvPr id="4" name="Picture 3" descr="c8_anexo_4_por_que.png"/>
+          <p:cNvPicPr>
+            <a:picLocks noChangeAspect="1"/>
+          </p:cNvPicPr>
+          <p:nvPr/>
+        </p:nvPicPr>
+        <p:blipFill>
+          <a:blip r:embed="rId2"/>
+          <a:stretch>
+            <a:fillRect/>
+          </a:stretch>
+        </p:blipFill>
+        <p:spPr>
+          <a:xfrm>
+            <a:off x="320040" y="1097280"/>
+            <a:ext cx="3812608" cy="3886200"/>
+          </a:xfrm>
+          <a:prstGeom prst="rect">
+            <a:avLst/>
+          </a:prstGeom>
+        </p:spPr>
+      </p:pic>
+      <p:sp>
+        <p:nvSpPr>
+          <p:cNvPr id="5" name="TextBox 4"/>
+          <p:cNvSpPr txBox="1"/>
+          <p:nvPr/>
+        </p:nvSpPr>
+        <p:spPr>
+          <a:xfrm>
+            <a:off x="4361248" y="1325880"/>
+            <a:ext cx="4462711" cy="3566160"/>
+          </a:xfrm>
+          <a:prstGeom prst="rect">
+            <a:avLst/>
+          </a:prstGeom>
+          <a:noFill/>
+        </p:spPr>
+        <p:txBody>
+          <a:bodyPr wrap="square">
+            <a:spAutoFit/>
+          </a:bodyPr>
+          <a:lstStyle/>
+          <a:p>
+            <a:pPr>
+              <a:lnSpc>
+                <a:spcPct val="112000"/>
+              </a:lnSpc>
+              <a:spcAft>
+                <a:spcPts val="900"/>
+              </a:spcAft>
+            </a:pPr>
+            <a:r>
+              <a:rPr sz="1500" b="1">
+                <a:solidFill>
+                  <a:srgbClr val="E0A437"/>
+                </a:solidFill>
+                <a:latin typeface="Fira Sans"/>
+              </a:rPr>
+              <a:t>▸ </a:t>
+            </a:r>
+            <a:r>
+              <a:rPr sz="1500" b="1">
+                <a:solidFill>
+                  <a:srgbClr val="1D3557"/>
+                </a:solidFill>
+                <a:latin typeface="Fira Sans"/>
+              </a:rPr>
+              <a:t>El eje va a 45°. Un tramo de largo 1 en turnos proyecta sobre él una sombra de cos 45° = 0,707; un tramo de 1,21 proyecta 1,21 veces eso.</a:t>
+            </a:r>
+          </a:p>
+          <a:p>
+            <a:pPr>
+              <a:lnSpc>
+                <a:spcPct val="112000"/>
+              </a:lnSpc>
+              <a:spcAft>
+                <a:spcPts val="900"/>
+              </a:spcAft>
+            </a:pPr>
+            <a:r>
+              <a:rPr sz="1500" b="1">
+                <a:solidFill>
+                  <a:srgbClr val="E0A437"/>
+                </a:solidFill>
+                <a:latin typeface="Fira Sans"/>
+              </a:rPr>
+              <a:t>▸ </a:t>
+            </a:r>
+            <a:r>
+              <a:rPr sz="1500" b="0">
+                <a:solidFill>
+                  <a:srgbClr val="000000"/>
+                </a:solidFill>
+                <a:latin typeface="Fira Sans"/>
+              </a:rPr>
+              <a:t>Con hits pasa lo mismo, porque el eje también está a 45° de ese lado.</a:t>
+            </a:r>
+          </a:p>
+          <a:p>
+            <a:pPr>
+              <a:lnSpc>
+                <a:spcPct val="112000"/>
+              </a:lnSpc>
+              <a:spcAft>
+                <a:spcPts val="900"/>
+              </a:spcAft>
+            </a:pPr>
+            <a:r>
+              <a:rPr sz="1500" b="1">
+                <a:solidFill>
+                  <a:srgbClr val="E0A437"/>
+                </a:solidFill>
+                <a:latin typeface="Fira Sans"/>
+              </a:rPr>
+              <a:t>▸ </a:t>
+            </a:r>
+            <a:r>
+              <a:rPr sz="1500" b="0">
+                <a:solidFill>
+                  <a:srgbClr val="000000"/>
+                </a:solidFill>
+                <a:latin typeface="Fira Sans"/>
+              </a:rPr>
+              <a:t>Si el eje se inclinara más hacia turnos, el peso de turnos sería mayor que el de hits: los pesos son los cosenos de esos dos ángulos.</a:t>
+            </a:r>
+          </a:p>
+        </p:txBody>
+      </p:sp>
+    </p:spTree>
+  </p:cSld>
+  <p:clrMapOvr>
+    <a:masterClrMapping/>
+  </p:clrMapOvr>
+</p:sld>
+</file>
+
+<file path=ppt/slides/slide41.xml><?xml version="1.0" encoding="utf-8"?>
+<p:sld xmlns:a="http://schemas.openxmlformats.org/drawingml/2006/main" xmlns:p="http://schemas.openxmlformats.org/presentationml/2006/main" xmlns:r="http://schemas.openxmlformats.org/officeDocument/2006/relationships">
+  <p:cSld>
+    <p:spTree>
+      <p:nvGrpSpPr>
+        <p:cNvPr id="1" name=""/>
+        <p:cNvGrpSpPr/>
+        <p:nvPr/>
+      </p:nvGrpSpPr>
+      <p:grpSpPr/>
+      <p:sp>
+        <p:nvSpPr>
+          <p:cNvPr id="2" name="Rectangle 1"/>
+          <p:cNvSpPr/>
+          <p:nvPr/>
+        </p:nvSpPr>
+        <p:spPr>
+          <a:xfrm>
+            <a:off x="0" y="0"/>
+            <a:ext cx="9144000" cy="5138928"/>
+          </a:xfrm>
+          <a:prstGeom prst="rect">
+            <a:avLst/>
+          </a:prstGeom>
+          <a:solidFill>
+            <a:srgbClr val="FAFBFC"/>
+          </a:solidFill>
+          <a:ln>
+            <a:noFill/>
+          </a:ln>
+          <a:effectLst/>
+        </p:spPr>
+        <p:style>
+          <a:lnRef idx="1">
+            <a:schemeClr val="accent1"/>
+          </a:lnRef>
+          <a:fillRef idx="3">
+            <a:schemeClr val="accent1"/>
+          </a:fillRef>
+          <a:effectRef idx="2">
+            <a:schemeClr val="accent1"/>
+          </a:effectRef>
+          <a:fontRef idx="minor">
+            <a:schemeClr val="lt1"/>
+          </a:fontRef>
+        </p:style>
+        <p:txBody>
+          <a:bodyPr rtlCol="0" anchor="ctr"/>
+          <a:lstStyle/>
+          <a:p>
+            <a:pPr algn="ctr"/>
+          </a:p>
+        </p:txBody>
+      </p:sp>
+      <p:sp>
+        <p:nvSpPr>
+          <p:cNvPr id="3" name="TextBox 2"/>
+          <p:cNvSpPr txBox="1"/>
+          <p:nvPr/>
+        </p:nvSpPr>
+        <p:spPr>
+          <a:xfrm>
+            <a:off x="402336" y="301752"/>
+            <a:ext cx="8348472" cy="795528"/>
+          </a:xfrm>
+          <a:prstGeom prst="rect">
+            <a:avLst/>
+          </a:prstGeom>
+          <a:noFill/>
+        </p:spPr>
+        <p:txBody>
+          <a:bodyPr wrap="square">
+            <a:spAutoFit/>
+          </a:bodyPr>
+          <a:lstStyle/>
+          <a:p>
+            <a:r>
+              <a:rPr sz="2800" b="1">
+                <a:solidFill>
+                  <a:srgbClr val="0F0F0F"/>
+                </a:solidFill>
+                <a:latin typeface="Fira Sans"/>
+              </a:rPr>
+              <a:t>Anexo 5. La cuenta completa, sin dibujo</a:t>
+            </a:r>
+          </a:p>
+        </p:txBody>
+      </p:sp>
+      <p:sp>
+        <p:nvSpPr>
+          <p:cNvPr id="4" name="TextBox 3"/>
+          <p:cNvSpPr txBox="1"/>
+          <p:nvPr/>
+        </p:nvSpPr>
+        <p:spPr>
+          <a:xfrm>
+            <a:off x="704088" y="1353312"/>
+            <a:ext cx="7744968" cy="3300984"/>
+          </a:xfrm>
+          <a:prstGeom prst="rect">
+            <a:avLst/>
+          </a:prstGeom>
+          <a:noFill/>
+        </p:spPr>
+        <p:txBody>
+          <a:bodyPr wrap="square">
+            <a:spAutoFit/>
+          </a:bodyPr>
+          <a:lstStyle/>
+          <a:p>
+            <a:pPr>
+              <a:lnSpc>
+                <a:spcPct val="112000"/>
+              </a:lnSpc>
+              <a:spcAft>
+                <a:spcPts val="900"/>
+              </a:spcAft>
+            </a:pPr>
+            <a:r>
+              <a:rPr sz="1800" b="1">
+                <a:solidFill>
+                  <a:srgbClr val="E0A437"/>
+                </a:solidFill>
+                <a:latin typeface="Fira Sans"/>
+              </a:rPr>
+              <a:t>▸ </a:t>
+            </a:r>
+            <a:r>
+              <a:rPr sz="1800" b="1">
+                <a:solidFill>
+                  <a:srgbClr val="1D3557"/>
+                </a:solidFill>
+                <a:latin typeface="Fira Sans"/>
+              </a:rPr>
+              <a:t>componente = 0,707 × z(turnos) + 0,707 × z(hits) = 0,707 × 1,21 + 0,707 × 0,95 = 0,85 + 0,67 = 1,53.</a:t>
+            </a:r>
+          </a:p>
+          <a:p>
+            <a:pPr>
+              <a:lnSpc>
+                <a:spcPct val="112000"/>
+              </a:lnSpc>
+              <a:spcAft>
+                <a:spcPts val="900"/>
+              </a:spcAft>
+            </a:pPr>
+            <a:r>
+              <a:rPr sz="1800" b="1">
+                <a:solidFill>
+                  <a:srgbClr val="E0A437"/>
+                </a:solidFill>
+                <a:latin typeface="Fira Sans"/>
+              </a:rPr>
+              <a:t>▸ </a:t>
+            </a:r>
+            <a:r>
+              <a:rPr sz="1800" b="0">
+                <a:solidFill>
+                  <a:srgbClr val="000000"/>
+                </a:solidFill>
+                <a:latin typeface="Fira Sans"/>
+              </a:rPr>
+              <a:t>Es la fórmula del puntaje ponderado: cada peso dice cuánto vale, hacia el eje nuevo, cada unidad de esa variable; se multiplica por las unidades que el jugador tiene y se suman los aportes.</a:t>
+            </a:r>
+          </a:p>
+          <a:p>
+            <a:pPr>
+              <a:lnSpc>
+                <a:spcPct val="112000"/>
+              </a:lnSpc>
+              <a:spcAft>
+                <a:spcPts val="900"/>
+              </a:spcAft>
+            </a:pPr>
+            <a:r>
+              <a:rPr sz="1800" b="1">
+                <a:solidFill>
+                  <a:srgbClr val="E0A437"/>
+                </a:solidFill>
+                <a:latin typeface="Fira Sans"/>
+              </a:rPr>
+              <a:t>▸ </a:t>
+            </a:r>
+            <a:r>
+              <a:rPr sz="1800" b="0">
+                <a:solidFill>
+                  <a:srgbClr val="000000"/>
+                </a:solidFill>
+                <a:latin typeface="Fira Sans"/>
+              </a:rPr>
+              <a:t>Con 16 variables el camino tiene 16 tramos y la suma, 16 términos: ya no hay dibujo donde leer la regla, y la cuenta es la forma de leerla.</a:t>
+            </a:r>
+          </a:p>
+          <a:p>
+            <a:pPr>
+              <a:lnSpc>
+                <a:spcPct val="112000"/>
+              </a:lnSpc>
+              <a:spcAft>
+                <a:spcPts val="900"/>
+              </a:spcAft>
+            </a:pPr>
+            <a:r>
+              <a:rPr sz="1800" b="1">
+                <a:solidFill>
+                  <a:srgbClr val="E0A437"/>
+                </a:solidFill>
+                <a:latin typeface="Fira Sans"/>
+              </a:rPr>
+              <a:t>▸ </a:t>
+            </a:r>
+            <a:r>
+              <a:rPr sz="1800" b="0">
+                <a:solidFill>
+                  <a:srgbClr val="000000"/>
+                </a:solidFill>
+                <a:latin typeface="Fira Sans"/>
+              </a:rPr>
+              <a:t>En scikit-learn, pca.components_ son los pesos y pca.transform(Z) hace esta cuenta para cada jugador.</a:t>
             </a:r>
           </a:p>
         </p:txBody>

</xml_diff>